<commit_message>
Vista PPT: todos los textos editables, mover, tamaño, negrita, cursiva y fuente; letras parecidas a las de la plantilla
</commit_message>
<xml_diff>
--- a/lib/plantilla_reporte.pptx
+++ b/lib/plantilla_reporte.pptx
@@ -8467,31 +8467,7 @@
                   <a:schemeClr val="tx1"/>
                 </a:solidFill>
               </a:rPr>
-              <a:t>Aseguramiento</a:t>
-            </a:r>
-            <a:r>
-              <a:rPr lang="en-US" altLang="ko-KR" b="1" dirty="0">
-                <a:solidFill>
-                  <a:schemeClr val="tx1"/>
-                </a:solidFill>
-              </a:rPr>
-              <a:t> de la </a:t>
-            </a:r>
-            <a:r>
-              <a:rPr lang="en-US" altLang="ko-KR" b="1" dirty="0" err="1">
-                <a:solidFill>
-                  <a:schemeClr val="tx1"/>
-                </a:solidFill>
-              </a:rPr>
-              <a:t>Calidad</a:t>
-            </a:r>
-            <a:r>
-              <a:rPr lang="en-US" altLang="ko-KR" b="1" dirty="0">
-                <a:solidFill>
-                  <a:schemeClr val="tx1"/>
-                </a:solidFill>
-              </a:rPr>
-              <a:t> </a:t>
+              <a:t>{{#F3}}</a:t>
             </a:r>
           </a:p>
           <a:p>
@@ -8507,7 +8483,7 @@
                   <a:schemeClr val="tx1"/>
                 </a:solidFill>
               </a:rPr>
-              <a:t>Fresco</a:t>
+              <a:t>{{#F4}}</a:t>
             </a:r>
           </a:p>
         </p:txBody>
@@ -8951,19 +8927,7 @@
                 <a:cs typeface="Candara"/>
                 <a:sym typeface="Candara"/>
               </a:rPr>
-              <a:t>2. Indicadores de </a:t>
-            </a:r>
-            <a:r>
-              <a:rPr lang="es-MX" sz="2000" b="1" i="1" dirty="0">
-                <a:solidFill>
-                  <a:srgbClr val="12781C"/>
-                </a:solidFill>
-                <a:latin typeface="Candara"/>
-                <a:ea typeface="Candara"/>
-                <a:cs typeface="Candara"/>
-                <a:sym typeface="Candara"/>
-              </a:rPr>
-              <a:t>Calidad MMPP   - OLMOS</a:t>
+              <a:t>{{#F211}}</a:t>
             </a:r>
             <a:endParaRPr kumimoji="0" lang="en-US" sz="1800" b="0" i="0" u="none" strike="noStrike" kern="0" cap="none" spc="0" normalizeH="0" baseline="0" noProof="0" dirty="0">
               <a:ln>
@@ -9232,16 +9196,7 @@
                     </a:solidFill>
                     <a:latin typeface="Abadi ExtraLight" panose="020B0204020104020204" pitchFamily="34" charset="0"/>
                   </a:rPr>
-                  <a:t>S</a:t>
-                </a:r>
-                <a:r>
-                  <a:rPr lang="es-PE" sz="1100" b="1" u="sng" dirty="0">
-                    <a:solidFill>
-                      <a:srgbClr val="000000"/>
-                    </a:solidFill>
-                    <a:latin typeface="Abadi ExtraLight" panose="020B0204020104020204" pitchFamily="34" charset="0"/>
-                  </a:rPr>
-                  <a:t>EMAFORIZACIÓN ELASMOSPALPUS</a:t>
+                  <a:t>{{#F212}}</a:t>
                 </a:r>
                 <a:endParaRPr kumimoji="0" lang="es-PE" sz="1100" b="1" i="0" u="sng" strike="noStrike" kern="1200" cap="none" spc="0" normalizeH="0" baseline="0" noProof="0" dirty="0">
                   <a:ln>
@@ -9317,7 +9272,7 @@
                   </a:solidFill>
                   <a:latin typeface="Calibri" panose="020F0502020204030204"/>
                 </a:rPr>
-                <a:t>FITOSANITARIOS</a:t>
+                <a:t>{{#F213}}</a:t>
               </a:r>
               <a:endParaRPr kumimoji="0" lang="es-PE" sz="1800" b="1" i="0" u="none" strike="noStrike" kern="1200" cap="none" spc="0" normalizeH="0" baseline="0" noProof="0" dirty="0">
                 <a:ln>
@@ -9397,7 +9352,7 @@
                 <a:ea typeface="+mn-ea"/>
                 <a:cs typeface="+mn-cs"/>
               </a:rPr>
-              <a:t>{{#F126}}</a:t>
+              <a:t>{{#F214}}</a:t>
             </a:r>
             <a:endParaRPr kumimoji="0" lang="es-PE" sz="1400" b="0" i="0" u="none" strike="noStrike" kern="1200" cap="none" spc="0" normalizeH="0" baseline="0" noProof="0" dirty="0">
               <a:ln>
@@ -9472,7 +9427,7 @@
                 </a:solidFill>
                 <a:latin typeface="Calibri" panose="020F0502020204030204"/>
               </a:rPr>
-              <a:t>CALIDADES Y CALIBRES</a:t>
+              <a:t>{{#F215}}</a:t>
             </a:r>
             <a:endParaRPr kumimoji="0" lang="es-PE" sz="1800" b="1" i="0" u="none" strike="noStrike" kern="1200" cap="none" spc="0" normalizeH="0" baseline="0" noProof="0" dirty="0">
               <a:ln>
@@ -9551,7 +9506,7 @@
                 <a:ea typeface="+mn-ea"/>
                 <a:cs typeface="+mn-cs"/>
               </a:rPr>
-              <a:t>{{#F127}}</a:t>
+              <a:t>{{#F216}}</a:t>
             </a:r>
             <a:endParaRPr kumimoji="0" lang="es-PE" sz="1400" b="0" i="0" u="none" strike="noStrike" kern="1200" cap="none" spc="0" normalizeH="0" baseline="0" noProof="0" dirty="0">
               <a:ln>
@@ -9706,7 +9661,7 @@
                 <a:ea typeface="+mn-ea"/>
                 <a:cs typeface="+mn-cs"/>
               </a:rPr>
-              <a:t>POSTURAS</a:t>
+              <a:t>{{#F217}}</a:t>
             </a:r>
             <a:endParaRPr kumimoji="0" lang="es-PE" sz="1100" b="1" i="0" u="sng" strike="noStrike" kern="1200" cap="none" spc="0" normalizeH="0" baseline="0" noProof="0" dirty="0">
               <a:ln>
@@ -9853,7 +9808,7 @@
                 </a:solidFill>
                 <a:latin typeface="Abadi ExtraLight" panose="020B0204020104020204" pitchFamily="34" charset="0"/>
               </a:rPr>
-              <a:t>LEPIDOPTERA</a:t>
+              <a:t>{{#F218}}</a:t>
             </a:r>
             <a:endParaRPr kumimoji="0" lang="es-PE" sz="1100" b="1" i="0" u="sng" strike="noStrike" kern="1200" cap="none" spc="0" normalizeH="0" baseline="0" noProof="0" dirty="0">
               <a:ln>
@@ -10008,7 +9963,7 @@
                 <a:ea typeface="+mn-ea"/>
                 <a:cs typeface="+mn-cs"/>
               </a:rPr>
-              <a:t>PRODIPLOSIS</a:t>
+              <a:t>{{#F219}}</a:t>
             </a:r>
             <a:endParaRPr kumimoji="0" lang="es-PE" sz="1100" b="1" i="0" u="sng" strike="noStrike" kern="1200" cap="none" spc="0" normalizeH="0" baseline="0" noProof="0" dirty="0">
               <a:ln>
@@ -10079,7 +10034,7 @@
                 </a:solidFill>
                 <a:latin typeface="Abadi ExtraLight" panose="020B0204020104020204" pitchFamily="34" charset="0"/>
               </a:rPr>
-              <a:t>{{#F112}}</a:t>
+              <a:t>{{#F197}}</a:t>
             </a:r>
             <a:endParaRPr kumimoji="0" lang="es-PE" sz="1800" b="1" i="0" u="none" strike="noStrike" kern="1200" cap="none" spc="0" normalizeH="0" baseline="0" noProof="0" dirty="0">
               <a:ln>
@@ -10150,7 +10105,7 @@
                 </a:solidFill>
                 <a:latin typeface="Abadi ExtraLight" panose="020B0204020104020204" pitchFamily="34" charset="0"/>
               </a:rPr>
-              <a:t>{{#F113}}</a:t>
+              <a:t>{{#F198}}</a:t>
             </a:r>
             <a:endParaRPr kumimoji="0" lang="es-PE" sz="1800" b="1" i="0" u="none" strike="noStrike" kern="1200" cap="none" spc="0" normalizeH="0" baseline="0" noProof="0" dirty="0">
               <a:ln>
@@ -10221,7 +10176,7 @@
                 </a:solidFill>
                 <a:latin typeface="Abadi ExtraLight" panose="020B0204020104020204" pitchFamily="34" charset="0"/>
               </a:rPr>
-              <a:t>{{#F114}}</a:t>
+              <a:t>{{#F199}}</a:t>
             </a:r>
             <a:endParaRPr kumimoji="0" lang="es-PE" sz="1800" b="1" i="0" u="none" strike="noStrike" kern="1200" cap="none" spc="0" normalizeH="0" baseline="0" noProof="0" dirty="0">
               <a:ln>
@@ -10292,7 +10247,7 @@
                 </a:solidFill>
                 <a:latin typeface="Abadi ExtraLight" panose="020B0204020104020204" pitchFamily="34" charset="0"/>
               </a:rPr>
-              <a:t>{{#F115}}</a:t>
+              <a:t>{{#F200}}</a:t>
             </a:r>
             <a:endParaRPr kumimoji="0" lang="es-PE" sz="1800" b="1" i="0" u="none" strike="noStrike" kern="1200" cap="none" spc="0" normalizeH="0" baseline="0" noProof="0" dirty="0">
               <a:ln>
@@ -10363,7 +10318,7 @@
                 </a:solidFill>
                 <a:latin typeface="Abadi ExtraLight" panose="020B0204020104020204" pitchFamily="34" charset="0"/>
               </a:rPr>
-              <a:t>{{#F116}}</a:t>
+              <a:t>{{#F201}}</a:t>
             </a:r>
             <a:endParaRPr kumimoji="0" lang="es-PE" sz="1800" b="1" i="0" u="none" strike="noStrike" kern="1200" cap="none" spc="0" normalizeH="0" baseline="0" noProof="0" dirty="0">
               <a:ln>
@@ -10434,7 +10389,7 @@
                 </a:solidFill>
                 <a:latin typeface="Abadi ExtraLight" panose="020B0204020104020204" pitchFamily="34" charset="0"/>
               </a:rPr>
-              <a:t>{{#F117}}</a:t>
+              <a:t>{{#F202}}</a:t>
             </a:r>
             <a:endParaRPr kumimoji="0" lang="es-PE" sz="1800" b="1" i="0" u="none" strike="noStrike" kern="1200" cap="none" spc="0" normalizeH="0" baseline="0" noProof="0" dirty="0">
               <a:ln>
@@ -10505,7 +10460,7 @@
                 </a:solidFill>
                 <a:latin typeface="Abadi ExtraLight" panose="020B0204020104020204" pitchFamily="34" charset="0"/>
               </a:rPr>
-              <a:t>{{#F118}}</a:t>
+              <a:t>{{#F203}}</a:t>
             </a:r>
             <a:endParaRPr kumimoji="0" lang="es-PE" sz="1800" b="1" i="0" u="none" strike="noStrike" kern="1200" cap="none" spc="0" normalizeH="0" baseline="0" noProof="0" dirty="0">
               <a:ln>
@@ -10576,7 +10531,7 @@
                 </a:solidFill>
                 <a:latin typeface="Abadi ExtraLight" panose="020B0204020104020204" pitchFamily="34" charset="0"/>
               </a:rPr>
-              <a:t>{{#F119}}</a:t>
+              <a:t>{{#F204}}</a:t>
             </a:r>
             <a:endParaRPr kumimoji="0" lang="es-PE" sz="1800" b="1" i="0" u="none" strike="noStrike" kern="1200" cap="none" spc="0" normalizeH="0" baseline="0" noProof="0" dirty="0">
               <a:ln>
@@ -10657,7 +10612,7 @@
                 <a:ea typeface="+mn-ea"/>
                 <a:cs typeface="+mn-cs"/>
               </a:rPr>
-              <a:t>{{#F120}}</a:t>
+              <a:t>{{#F205}}</a:t>
             </a:r>
           </a:p>
         </p:txBody>
@@ -10790,7 +10745,7 @@
                 </a:solidFill>
                 <a:latin typeface="Abadi ExtraLight" panose="020B0204020104020204" pitchFamily="34" charset="0"/>
               </a:rPr>
-              <a:t>SMALL</a:t>
+              <a:t>{{#F220}}</a:t>
             </a:r>
             <a:endParaRPr kumimoji="0" lang="es-PE" sz="1400" b="0" i="0" u="sng" strike="noStrike" kern="1200" cap="none" spc="0" normalizeH="0" baseline="0" noProof="0" dirty="0">
               <a:ln>
@@ -10945,25 +10900,7 @@
                 <a:ea typeface="+mn-ea"/>
                 <a:cs typeface="+mn-cs"/>
               </a:rPr>
-              <a:t>L</a:t>
-            </a:r>
-            <a:r>
-              <a:rPr lang="es-MX" sz="1400" u="sng" dirty="0" err="1">
-                <a:solidFill>
-                  <a:srgbClr val="000000"/>
-                </a:solidFill>
-                <a:latin typeface="Abadi ExtraLight" panose="020B0204020104020204" pitchFamily="34" charset="0"/>
-              </a:rPr>
-              <a:t>ong</a:t>
-            </a:r>
-            <a:r>
-              <a:rPr lang="es-MX" sz="1400" u="sng" dirty="0">
-                <a:solidFill>
-                  <a:srgbClr val="000000"/>
-                </a:solidFill>
-                <a:latin typeface="Abadi ExtraLight" panose="020B0204020104020204" pitchFamily="34" charset="0"/>
-              </a:rPr>
-              <a:t> &gt;30</a:t>
+              <a:t>{{#F221}}</a:t>
             </a:r>
             <a:endParaRPr kumimoji="0" lang="es-PE" sz="1400" b="0" i="0" u="sng" strike="noStrike" kern="1200" cap="none" spc="0" normalizeH="0" baseline="0" noProof="0" dirty="0">
               <a:ln>
@@ -11110,7 +11047,7 @@
                 </a:solidFill>
                 <a:latin typeface="Abadi ExtraLight" panose="020B0204020104020204" pitchFamily="34" charset="0"/>
               </a:rPr>
-              <a:t>C- Y Ramas</a:t>
+              <a:t>{{#F222}}</a:t>
             </a:r>
             <a:endParaRPr kumimoji="0" lang="es-PE" sz="1400" b="0" i="0" u="sng" strike="noStrike" kern="1200" cap="none" spc="0" normalizeH="0" baseline="0" noProof="0" dirty="0">
               <a:ln>
@@ -11184,7 +11121,7 @@
                 </a:solidFill>
                 <a:latin typeface="Century Gothic" panose="020B0502020202020204" pitchFamily="34" charset="0"/>
               </a:rPr>
-              <a:t>Acumulado:</a:t>
+              <a:t>{{#F223}}</a:t>
             </a:r>
             <a:endParaRPr kumimoji="0" lang="es-PE" sz="1200" b="1" i="0" u="none" strike="noStrike" kern="1200" cap="none" spc="0" normalizeH="0" baseline="0" noProof="0" dirty="0">
               <a:ln>
@@ -11268,7 +11205,7 @@
                 <a:ea typeface="+mn-ea"/>
                 <a:cs typeface="+mn-cs"/>
               </a:rPr>
-              <a:t>{{#F121}}</a:t>
+              <a:t>{{#F206}}</a:t>
             </a:r>
           </a:p>
         </p:txBody>
@@ -11328,7 +11265,7 @@
                 </a:solidFill>
                 <a:latin typeface="Century Gothic" panose="020B0502020202020204" pitchFamily="34" charset="0"/>
               </a:rPr>
-              <a:t>{{#F128}}</a:t>
+              <a:t>{{#F224}}</a:t>
             </a:r>
             <a:endParaRPr kumimoji="0" lang="es-PE" sz="1200" b="1" i="0" u="none" strike="noStrike" kern="1200" cap="none" spc="0" normalizeH="0" baseline="0" noProof="0" dirty="0">
               <a:ln>
@@ -11412,7 +11349,7 @@
                 <a:ea typeface="+mn-ea"/>
                 <a:cs typeface="+mn-cs"/>
               </a:rPr>
-              <a:t>{{#F122}}</a:t>
+              <a:t>{{#F207}}</a:t>
             </a:r>
           </a:p>
         </p:txBody>
@@ -11472,7 +11409,7 @@
                 </a:solidFill>
                 <a:latin typeface="Century Gothic" panose="020B0502020202020204" pitchFamily="34" charset="0"/>
               </a:rPr>
-              <a:t>Acumulado:</a:t>
+              <a:t>{{#F225}}</a:t>
             </a:r>
             <a:endParaRPr kumimoji="0" lang="es-PE" sz="1200" b="1" i="0" u="none" strike="noStrike" kern="1200" cap="none" spc="0" normalizeH="0" baseline="0" noProof="0" dirty="0">
               <a:ln>
@@ -11556,7 +11493,7 @@
                 <a:ea typeface="+mn-ea"/>
                 <a:cs typeface="+mn-cs"/>
               </a:rPr>
-              <a:t>{{#F123}}</a:t>
+              <a:t>{{#F208}}</a:t>
             </a:r>
           </a:p>
         </p:txBody>
@@ -11616,7 +11553,7 @@
                 </a:solidFill>
                 <a:latin typeface="Century Gothic" panose="020B0502020202020204" pitchFamily="34" charset="0"/>
               </a:rPr>
-              <a:t>{{#F129}}</a:t>
+              <a:t>{{#F226}}</a:t>
             </a:r>
             <a:endParaRPr kumimoji="0" lang="es-PE" sz="1200" b="1" i="0" u="none" strike="noStrike" kern="1200" cap="none" spc="0" normalizeH="0" baseline="0" noProof="0" dirty="0">
               <a:ln>
@@ -11700,7 +11637,7 @@
                 <a:ea typeface="+mn-ea"/>
                 <a:cs typeface="+mn-cs"/>
               </a:rPr>
-              <a:t>{{#F124}}</a:t>
+              <a:t>{{#F209}}</a:t>
             </a:r>
           </a:p>
         </p:txBody>
@@ -11760,7 +11697,7 @@
                 </a:solidFill>
                 <a:latin typeface="Century Gothic" panose="020B0502020202020204" pitchFamily="34" charset="0"/>
               </a:rPr>
-              <a:t>Acumulado:</a:t>
+              <a:t>{{#F227}}</a:t>
             </a:r>
             <a:endParaRPr kumimoji="0" lang="es-PE" sz="1200" b="1" i="0" u="none" strike="noStrike" kern="1200" cap="none" spc="0" normalizeH="0" baseline="0" noProof="0" dirty="0">
               <a:ln>
@@ -11844,7 +11781,7 @@
                 <a:ea typeface="+mn-ea"/>
                 <a:cs typeface="+mn-cs"/>
               </a:rPr>
-              <a:t>{{#F125}}</a:t>
+              <a:t>{{#F210}}</a:t>
             </a:r>
           </a:p>
         </p:txBody>
@@ -11904,7 +11841,7 @@
                 </a:solidFill>
                 <a:latin typeface="Century Gothic" panose="020B0502020202020204" pitchFamily="34" charset="0"/>
               </a:rPr>
-              <a:t>{{#F130}}</a:t>
+              <a:t>{{#F228}}</a:t>
             </a:r>
             <a:endParaRPr kumimoji="0" lang="es-PE" sz="1200" b="1" i="0" u="none" strike="noStrike" kern="1200" cap="none" spc="0" normalizeH="0" baseline="0" noProof="0" dirty="0">
               <a:ln>
@@ -11928,7 +11865,7 @@
       </p:sp>
       <p:sp>
         <p:nvSpPr>
-          <p:cNvPr id="1031" name="Lineas 1031">
+          <p:cNvPr id="1129" name="Lineas 1129">
             <a:extLst>
               <a:ext uri="{FF2B5EF4-FFF2-40B4-BE49-F238E27FC236}">
                 <a16:creationId xmlns:a16="http://schemas.microsoft.com/office/drawing/2014/main" id="{1411DB53-B1E6-1270-3C2B-02D7177B8A2F}"/>
@@ -11976,7 +11913,7 @@
                 </a:solidFill>
                 <a:latin typeface="Abadi ExtraLight" panose="020B0204020104020204" pitchFamily="34" charset="0"/>
               </a:rPr>
-              <a:t>{{#F131}}</a:t>
+              <a:t>{{#F229}}</a:t>
             </a:r>
             <a:endParaRPr kumimoji="0" lang="es-PE" sz="1800" b="1" i="0" u="none" strike="noStrike" kern="1200" cap="none" spc="0" normalizeH="0" baseline="0" noProof="0" dirty="0">
               <a:ln>
@@ -11997,7 +11934,7 @@
       </p:sp>
       <p:sp>
         <p:nvSpPr>
-          <p:cNvPr id="1032" name="Lineas 1032">
+          <p:cNvPr id="1130" name="Lineas 1130">
             <a:extLst>
               <a:ext uri="{FF2B5EF4-FFF2-40B4-BE49-F238E27FC236}">
                 <a16:creationId xmlns:a16="http://schemas.microsoft.com/office/drawing/2014/main" id="{1411DB53-B1E6-1270-3C2B-02D7177B8A2F}"/>
@@ -12045,7 +11982,7 @@
                 </a:solidFill>
                 <a:latin typeface="Abadi ExtraLight" panose="020B0204020104020204" pitchFamily="34" charset="0"/>
               </a:rPr>
-              <a:t>{{#F132}}</a:t>
+              <a:t>{{#F230}}</a:t>
             </a:r>
             <a:endParaRPr kumimoji="0" lang="es-PE" sz="1800" b="1" i="0" u="none" strike="noStrike" kern="1200" cap="none" spc="0" normalizeH="0" baseline="0" noProof="0" dirty="0">
               <a:ln>
@@ -12066,7 +12003,7 @@
       </p:sp>
       <p:sp>
         <p:nvSpPr>
-          <p:cNvPr id="1033" name="Lineas 1033">
+          <p:cNvPr id="1131" name="Lineas 1131">
             <a:extLst>
               <a:ext uri="{FF2B5EF4-FFF2-40B4-BE49-F238E27FC236}">
                 <a16:creationId xmlns:a16="http://schemas.microsoft.com/office/drawing/2014/main" id="{1411DB53-B1E6-1270-3C2B-02D7177B8A2F}"/>
@@ -12114,7 +12051,7 @@
                 </a:solidFill>
                 <a:latin typeface="Abadi ExtraLight" panose="020B0204020104020204" pitchFamily="34" charset="0"/>
               </a:rPr>
-              <a:t>{{#F133}}</a:t>
+              <a:t>{{#F231}}</a:t>
             </a:r>
             <a:endParaRPr kumimoji="0" lang="es-PE" sz="1800" b="1" i="0" u="none" strike="noStrike" kern="1200" cap="none" spc="0" normalizeH="0" baseline="0" noProof="0" dirty="0">
               <a:ln>
@@ -12135,7 +12072,7 @@
       </p:sp>
       <p:sp>
         <p:nvSpPr>
-          <p:cNvPr id="1034" name="Lineas 1034">
+          <p:cNvPr id="1132" name="Lineas 1132">
             <a:extLst>
               <a:ext uri="{FF2B5EF4-FFF2-40B4-BE49-F238E27FC236}">
                 <a16:creationId xmlns:a16="http://schemas.microsoft.com/office/drawing/2014/main" id="{1411DB53-B1E6-1270-3C2B-02D7177B8A2F}"/>
@@ -12183,7 +12120,7 @@
                 </a:solidFill>
                 <a:latin typeface="Abadi ExtraLight" panose="020B0204020104020204" pitchFamily="34" charset="0"/>
               </a:rPr>
-              <a:t>{{#F134}}</a:t>
+              <a:t>{{#F232}}</a:t>
             </a:r>
             <a:endParaRPr kumimoji="0" lang="es-PE" sz="1800" b="1" i="0" u="none" strike="noStrike" kern="1200" cap="none" spc="0" normalizeH="0" baseline="0" noProof="0" dirty="0">
               <a:ln>
@@ -12310,19 +12247,7 @@
                 <a:cs typeface="Candara"/>
                 <a:sym typeface="Candara"/>
               </a:rPr>
-              <a:t>2. Indicadores de </a:t>
-            </a:r>
-            <a:r>
-              <a:rPr lang="es-MX" sz="2000" b="1" i="1" dirty="0">
-                <a:solidFill>
-                  <a:srgbClr val="12781C"/>
-                </a:solidFill>
-                <a:latin typeface="Candara"/>
-                <a:ea typeface="Candara"/>
-                <a:cs typeface="Candara"/>
-                <a:sym typeface="Candara"/>
-              </a:rPr>
-              <a:t>Calidad MMPP   - TERCEROS</a:t>
+              <a:t>{{#F247}}</a:t>
             </a:r>
             <a:endParaRPr kumimoji="0" lang="en-US" sz="1800" b="0" i="0" u="none" strike="noStrike" kern="0" cap="none" spc="0" normalizeH="0" baseline="0" noProof="0" dirty="0">
               <a:ln>
@@ -12591,16 +12516,7 @@
                     </a:solidFill>
                     <a:latin typeface="Abadi ExtraLight" panose="020B0204020104020204" pitchFamily="34" charset="0"/>
                   </a:rPr>
-                  <a:t>S</a:t>
-                </a:r>
-                <a:r>
-                  <a:rPr lang="es-PE" sz="1100" b="1" u="sng" dirty="0">
-                    <a:solidFill>
-                      <a:srgbClr val="000000"/>
-                    </a:solidFill>
-                    <a:latin typeface="Abadi ExtraLight" panose="020B0204020104020204" pitchFamily="34" charset="0"/>
-                  </a:rPr>
-                  <a:t>EMAFORIZACIÓN ELASMOSPALPUS</a:t>
+                  <a:t>{{#F248}}</a:t>
                 </a:r>
                 <a:endParaRPr kumimoji="0" lang="es-PE" sz="1100" b="1" i="0" u="sng" strike="noStrike" kern="1200" cap="none" spc="0" normalizeH="0" baseline="0" noProof="0" dirty="0">
                   <a:ln>
@@ -12676,7 +12592,7 @@
                   </a:solidFill>
                   <a:latin typeface="Calibri" panose="020F0502020204030204"/>
                 </a:rPr>
-                <a:t>FITOSANITARIOS</a:t>
+                <a:t>{{#F249}}</a:t>
               </a:r>
               <a:endParaRPr kumimoji="0" lang="es-PE" sz="1800" b="1" i="0" u="none" strike="noStrike" kern="1200" cap="none" spc="0" normalizeH="0" baseline="0" noProof="0" dirty="0">
                 <a:ln>
@@ -12756,7 +12672,7 @@
                 <a:ea typeface="+mn-ea"/>
                 <a:cs typeface="+mn-cs"/>
               </a:rPr>
-              <a:t>{{#F149}}</a:t>
+              <a:t>{{#F250}}</a:t>
             </a:r>
             <a:endParaRPr kumimoji="0" lang="es-PE" sz="1400" b="0" i="0" u="none" strike="noStrike" kern="1200" cap="none" spc="0" normalizeH="0" baseline="0" noProof="0" dirty="0">
               <a:ln>
@@ -12831,7 +12747,7 @@
                 </a:solidFill>
                 <a:latin typeface="Calibri" panose="020F0502020204030204"/>
               </a:rPr>
-              <a:t>CALIDADES Y CALIBRES</a:t>
+              <a:t>{{#F251}}</a:t>
             </a:r>
             <a:endParaRPr kumimoji="0" lang="es-PE" sz="1800" b="1" i="0" u="none" strike="noStrike" kern="1200" cap="none" spc="0" normalizeH="0" baseline="0" noProof="0" dirty="0">
               <a:ln>
@@ -12910,7 +12826,7 @@
                 <a:ea typeface="+mn-ea"/>
                 <a:cs typeface="+mn-cs"/>
               </a:rPr>
-              <a:t>{{#F150}}</a:t>
+              <a:t>{{#F252}}</a:t>
             </a:r>
             <a:endParaRPr kumimoji="0" lang="es-PE" sz="1400" b="0" i="0" u="none" strike="noStrike" kern="1200" cap="none" spc="0" normalizeH="0" baseline="0" noProof="0" dirty="0">
               <a:ln>
@@ -13065,7 +12981,7 @@
                 <a:ea typeface="+mn-ea"/>
                 <a:cs typeface="+mn-cs"/>
               </a:rPr>
-              <a:t>POSTURAS</a:t>
+              <a:t>{{#F253}}</a:t>
             </a:r>
             <a:endParaRPr kumimoji="0" lang="es-PE" sz="1100" b="1" i="0" u="sng" strike="noStrike" kern="1200" cap="none" spc="0" normalizeH="0" baseline="0" noProof="0" dirty="0">
               <a:ln>
@@ -13212,7 +13128,7 @@
                 </a:solidFill>
                 <a:latin typeface="Abadi ExtraLight" panose="020B0204020104020204" pitchFamily="34" charset="0"/>
               </a:rPr>
-              <a:t>LEPIDOPTERA</a:t>
+              <a:t>{{#F254}}</a:t>
             </a:r>
             <a:endParaRPr kumimoji="0" lang="es-PE" sz="1100" b="1" i="0" u="sng" strike="noStrike" kern="1200" cap="none" spc="0" normalizeH="0" baseline="0" noProof="0" dirty="0">
               <a:ln>
@@ -13367,7 +13283,7 @@
                 <a:ea typeface="+mn-ea"/>
                 <a:cs typeface="+mn-cs"/>
               </a:rPr>
-              <a:t>PRODIPLOSIS</a:t>
+              <a:t>{{#F255}}</a:t>
             </a:r>
             <a:endParaRPr kumimoji="0" lang="es-PE" sz="1100" b="1" i="0" u="sng" strike="noStrike" kern="1200" cap="none" spc="0" normalizeH="0" baseline="0" noProof="0" dirty="0">
               <a:ln>
@@ -13438,7 +13354,7 @@
                 </a:solidFill>
                 <a:latin typeface="Abadi ExtraLight" panose="020B0204020104020204" pitchFamily="34" charset="0"/>
               </a:rPr>
-              <a:t>{{#F135}}</a:t>
+              <a:t>{{#F233}}</a:t>
             </a:r>
             <a:endParaRPr kumimoji="0" lang="es-PE" sz="1800" b="1" i="0" u="none" strike="noStrike" kern="1200" cap="none" spc="0" normalizeH="0" baseline="0" noProof="0" dirty="0">
               <a:ln>
@@ -13509,7 +13425,7 @@
                 </a:solidFill>
                 <a:latin typeface="Abadi ExtraLight" panose="020B0204020104020204" pitchFamily="34" charset="0"/>
               </a:rPr>
-              <a:t>{{#F136}}</a:t>
+              <a:t>{{#F234}}</a:t>
             </a:r>
             <a:endParaRPr kumimoji="0" lang="es-PE" sz="1800" b="1" i="0" u="none" strike="noStrike" kern="1200" cap="none" spc="0" normalizeH="0" baseline="0" noProof="0" dirty="0">
               <a:ln>
@@ -13580,7 +13496,7 @@
                 </a:solidFill>
                 <a:latin typeface="Abadi ExtraLight" panose="020B0204020104020204" pitchFamily="34" charset="0"/>
               </a:rPr>
-              <a:t>{{#F137}}</a:t>
+              <a:t>{{#F235}}</a:t>
             </a:r>
             <a:endParaRPr kumimoji="0" lang="es-PE" sz="1800" b="1" i="0" u="none" strike="noStrike" kern="1200" cap="none" spc="0" normalizeH="0" baseline="0" noProof="0" dirty="0">
               <a:ln>
@@ -13651,7 +13567,7 @@
                 </a:solidFill>
                 <a:latin typeface="Abadi ExtraLight" panose="020B0204020104020204" pitchFamily="34" charset="0"/>
               </a:rPr>
-              <a:t>{{#F138}}</a:t>
+              <a:t>{{#F236}}</a:t>
             </a:r>
             <a:endParaRPr kumimoji="0" lang="es-PE" sz="1800" b="1" i="0" u="none" strike="noStrike" kern="1200" cap="none" spc="0" normalizeH="0" baseline="0" noProof="0" dirty="0">
               <a:ln>
@@ -13722,7 +13638,7 @@
                 </a:solidFill>
                 <a:latin typeface="Abadi ExtraLight" panose="020B0204020104020204" pitchFamily="34" charset="0"/>
               </a:rPr>
-              <a:t>{{#F139}}</a:t>
+              <a:t>{{#F237}}</a:t>
             </a:r>
             <a:endParaRPr kumimoji="0" lang="es-PE" sz="1800" b="1" i="0" u="none" strike="noStrike" kern="1200" cap="none" spc="0" normalizeH="0" baseline="0" noProof="0" dirty="0">
               <a:ln>
@@ -13793,7 +13709,7 @@
                 </a:solidFill>
                 <a:latin typeface="Abadi ExtraLight" panose="020B0204020104020204" pitchFamily="34" charset="0"/>
               </a:rPr>
-              <a:t>{{#F140}}</a:t>
+              <a:t>{{#F238}}</a:t>
             </a:r>
             <a:endParaRPr kumimoji="0" lang="es-PE" sz="1800" b="1" i="0" u="none" strike="noStrike" kern="1200" cap="none" spc="0" normalizeH="0" baseline="0" noProof="0" dirty="0">
               <a:ln>
@@ -13864,7 +13780,7 @@
                 </a:solidFill>
                 <a:latin typeface="Abadi ExtraLight" panose="020B0204020104020204" pitchFamily="34" charset="0"/>
               </a:rPr>
-              <a:t>{{#F141}}</a:t>
+              <a:t>{{#F239}}</a:t>
             </a:r>
             <a:endParaRPr kumimoji="0" lang="es-PE" sz="1800" b="1" i="0" u="none" strike="noStrike" kern="1200" cap="none" spc="0" normalizeH="0" baseline="0" noProof="0" dirty="0">
               <a:ln>
@@ -13935,7 +13851,7 @@
                 </a:solidFill>
                 <a:latin typeface="Abadi ExtraLight" panose="020B0204020104020204" pitchFamily="34" charset="0"/>
               </a:rPr>
-              <a:t>{{#F142}}</a:t>
+              <a:t>{{#F240}}</a:t>
             </a:r>
             <a:endParaRPr kumimoji="0" lang="es-PE" sz="1800" b="1" i="0" u="none" strike="noStrike" kern="1200" cap="none" spc="0" normalizeH="0" baseline="0" noProof="0" dirty="0">
               <a:ln>
@@ -14016,7 +13932,7 @@
                 <a:ea typeface="+mn-ea"/>
                 <a:cs typeface="+mn-cs"/>
               </a:rPr>
-              <a:t>{{#F143}}</a:t>
+              <a:t>{{#F241}}</a:t>
             </a:r>
           </a:p>
         </p:txBody>
@@ -14149,7 +14065,7 @@
                 </a:solidFill>
                 <a:latin typeface="Abadi ExtraLight" panose="020B0204020104020204" pitchFamily="34" charset="0"/>
               </a:rPr>
-              <a:t>SMALL</a:t>
+              <a:t>{{#F256}}</a:t>
             </a:r>
             <a:endParaRPr kumimoji="0" lang="es-PE" sz="1400" b="0" i="0" u="sng" strike="noStrike" kern="1200" cap="none" spc="0" normalizeH="0" baseline="0" noProof="0" dirty="0">
               <a:ln>
@@ -14304,25 +14220,7 @@
                 <a:ea typeface="+mn-ea"/>
                 <a:cs typeface="+mn-cs"/>
               </a:rPr>
-              <a:t>L</a:t>
-            </a:r>
-            <a:r>
-              <a:rPr lang="es-MX" sz="1400" u="sng" dirty="0" err="1">
-                <a:solidFill>
-                  <a:srgbClr val="000000"/>
-                </a:solidFill>
-                <a:latin typeface="Abadi ExtraLight" panose="020B0204020104020204" pitchFamily="34" charset="0"/>
-              </a:rPr>
-              <a:t>ong</a:t>
-            </a:r>
-            <a:r>
-              <a:rPr lang="es-MX" sz="1400" u="sng" dirty="0">
-                <a:solidFill>
-                  <a:srgbClr val="000000"/>
-                </a:solidFill>
-                <a:latin typeface="Abadi ExtraLight" panose="020B0204020104020204" pitchFamily="34" charset="0"/>
-              </a:rPr>
-              <a:t> &gt;30</a:t>
+              <a:t>{{#F257}}</a:t>
             </a:r>
             <a:endParaRPr kumimoji="0" lang="es-PE" sz="1400" b="0" i="0" u="sng" strike="noStrike" kern="1200" cap="none" spc="0" normalizeH="0" baseline="0" noProof="0" dirty="0">
               <a:ln>
@@ -14469,7 +14367,7 @@
                 </a:solidFill>
                 <a:latin typeface="Abadi ExtraLight" panose="020B0204020104020204" pitchFamily="34" charset="0"/>
               </a:rPr>
-              <a:t>C- Y Ramas</a:t>
+              <a:t>{{#F258}}</a:t>
             </a:r>
             <a:endParaRPr kumimoji="0" lang="es-PE" sz="1400" b="0" i="0" u="sng" strike="noStrike" kern="1200" cap="none" spc="0" normalizeH="0" baseline="0" noProof="0" dirty="0">
               <a:ln>
@@ -14543,7 +14441,7 @@
                 </a:solidFill>
                 <a:latin typeface="Century Gothic" panose="020B0502020202020204" pitchFamily="34" charset="0"/>
               </a:rPr>
-              <a:t>Acumulado:</a:t>
+              <a:t>{{#F259}}</a:t>
             </a:r>
             <a:endParaRPr kumimoji="0" lang="es-PE" sz="1200" b="1" i="0" u="none" strike="noStrike" kern="1200" cap="none" spc="0" normalizeH="0" baseline="0" noProof="0" dirty="0">
               <a:ln>
@@ -14627,7 +14525,7 @@
                 <a:ea typeface="+mn-ea"/>
                 <a:cs typeface="+mn-cs"/>
               </a:rPr>
-              <a:t>{{#F144}}</a:t>
+              <a:t>{{#F242}}</a:t>
             </a:r>
           </a:p>
         </p:txBody>
@@ -14687,7 +14585,7 @@
                 </a:solidFill>
                 <a:latin typeface="Century Gothic" panose="020B0502020202020204" pitchFamily="34" charset="0"/>
               </a:rPr>
-              <a:t>{{#F151}}</a:t>
+              <a:t>{{#F260}}</a:t>
             </a:r>
             <a:endParaRPr kumimoji="0" lang="es-PE" sz="1200" b="1" i="0" u="none" strike="noStrike" kern="1200" cap="none" spc="0" normalizeH="0" baseline="0" noProof="0" dirty="0">
               <a:ln>
@@ -14771,7 +14669,7 @@
                 <a:ea typeface="+mn-ea"/>
                 <a:cs typeface="+mn-cs"/>
               </a:rPr>
-              <a:t>{{#F145}}</a:t>
+              <a:t>{{#F243}}</a:t>
             </a:r>
           </a:p>
         </p:txBody>
@@ -14831,7 +14729,7 @@
                 </a:solidFill>
                 <a:latin typeface="Century Gothic" panose="020B0502020202020204" pitchFamily="34" charset="0"/>
               </a:rPr>
-              <a:t>Acumulado:</a:t>
+              <a:t>{{#F261}}</a:t>
             </a:r>
             <a:endParaRPr kumimoji="0" lang="es-PE" sz="1200" b="1" i="0" u="none" strike="noStrike" kern="1200" cap="none" spc="0" normalizeH="0" baseline="0" noProof="0" dirty="0">
               <a:ln>
@@ -14915,7 +14813,7 @@
                 <a:ea typeface="+mn-ea"/>
                 <a:cs typeface="+mn-cs"/>
               </a:rPr>
-              <a:t>{{#F146}}</a:t>
+              <a:t>{{#F244}}</a:t>
             </a:r>
           </a:p>
         </p:txBody>
@@ -14975,7 +14873,7 @@
                 </a:solidFill>
                 <a:latin typeface="Century Gothic" panose="020B0502020202020204" pitchFamily="34" charset="0"/>
               </a:rPr>
-              <a:t>{{#F152}}</a:t>
+              <a:t>{{#F262}}</a:t>
             </a:r>
             <a:endParaRPr kumimoji="0" lang="es-PE" sz="1200" b="1" i="0" u="none" strike="noStrike" kern="1200" cap="none" spc="0" normalizeH="0" baseline="0" noProof="0" dirty="0">
               <a:ln>
@@ -15059,7 +14957,7 @@
                 <a:ea typeface="+mn-ea"/>
                 <a:cs typeface="+mn-cs"/>
               </a:rPr>
-              <a:t>{{#F147}}</a:t>
+              <a:t>{{#F245}}</a:t>
             </a:r>
           </a:p>
         </p:txBody>
@@ -15119,7 +15017,7 @@
                 </a:solidFill>
                 <a:latin typeface="Century Gothic" panose="020B0502020202020204" pitchFamily="34" charset="0"/>
               </a:rPr>
-              <a:t>Acumulado:</a:t>
+              <a:t>{{#F263}}</a:t>
             </a:r>
             <a:endParaRPr kumimoji="0" lang="es-PE" sz="1200" b="1" i="0" u="none" strike="noStrike" kern="1200" cap="none" spc="0" normalizeH="0" baseline="0" noProof="0" dirty="0">
               <a:ln>
@@ -15203,7 +15101,7 @@
                 <a:ea typeface="+mn-ea"/>
                 <a:cs typeface="+mn-cs"/>
               </a:rPr>
-              <a:t>{{#F148}}</a:t>
+              <a:t>{{#F246}}</a:t>
             </a:r>
           </a:p>
         </p:txBody>
@@ -15263,7 +15161,7 @@
                 </a:solidFill>
                 <a:latin typeface="Century Gothic" panose="020B0502020202020204" pitchFamily="34" charset="0"/>
               </a:rPr>
-              <a:t>{{#F153}}</a:t>
+              <a:t>{{#F264}}</a:t>
             </a:r>
             <a:endParaRPr kumimoji="0" lang="es-PE" sz="1200" b="1" i="0" u="none" strike="noStrike" kern="1200" cap="none" spc="0" normalizeH="0" baseline="0" noProof="0" dirty="0">
               <a:ln>
@@ -15287,7 +15185,7 @@
       </p:sp>
       <p:sp>
         <p:nvSpPr>
-          <p:cNvPr id="1054" name="Lineas 1054">
+          <p:cNvPr id="1165" name="Lineas 1165">
             <a:extLst>
               <a:ext uri="{FF2B5EF4-FFF2-40B4-BE49-F238E27FC236}">
                 <a16:creationId xmlns:a16="http://schemas.microsoft.com/office/drawing/2014/main" id="{473DA5A5-E11C-DB40-DF4F-8F3A69757349}"/>
@@ -15335,7 +15233,7 @@
                 </a:solidFill>
                 <a:latin typeface="Abadi ExtraLight" panose="020B0204020104020204" pitchFamily="34" charset="0"/>
               </a:rPr>
-              <a:t>{{#F154}}</a:t>
+              <a:t>{{#F265}}</a:t>
             </a:r>
             <a:endParaRPr kumimoji="0" lang="es-PE" sz="1800" b="1" i="0" u="none" strike="noStrike" kern="1200" cap="none" spc="0" normalizeH="0" baseline="0" noProof="0" dirty="0">
               <a:ln>
@@ -15356,7 +15254,7 @@
       </p:sp>
       <p:sp>
         <p:nvSpPr>
-          <p:cNvPr id="1055" name="Lineas 1055">
+          <p:cNvPr id="1166" name="Lineas 1166">
             <a:extLst>
               <a:ext uri="{FF2B5EF4-FFF2-40B4-BE49-F238E27FC236}">
                 <a16:creationId xmlns:a16="http://schemas.microsoft.com/office/drawing/2014/main" id="{473DA5A5-E11C-DB40-DF4F-8F3A69757349}"/>
@@ -15404,7 +15302,7 @@
                 </a:solidFill>
                 <a:latin typeface="Abadi ExtraLight" panose="020B0204020104020204" pitchFamily="34" charset="0"/>
               </a:rPr>
-              <a:t>{{#F155}}</a:t>
+              <a:t>{{#F266}}</a:t>
             </a:r>
             <a:endParaRPr kumimoji="0" lang="es-PE" sz="1800" b="1" i="0" u="none" strike="noStrike" kern="1200" cap="none" spc="0" normalizeH="0" baseline="0" noProof="0" dirty="0">
               <a:ln>
@@ -15425,7 +15323,7 @@
       </p:sp>
       <p:sp>
         <p:nvSpPr>
-          <p:cNvPr id="1056" name="Lineas 1056">
+          <p:cNvPr id="1167" name="Lineas 1167">
             <a:extLst>
               <a:ext uri="{FF2B5EF4-FFF2-40B4-BE49-F238E27FC236}">
                 <a16:creationId xmlns:a16="http://schemas.microsoft.com/office/drawing/2014/main" id="{473DA5A5-E11C-DB40-DF4F-8F3A69757349}"/>
@@ -15473,7 +15371,7 @@
                 </a:solidFill>
                 <a:latin typeface="Abadi ExtraLight" panose="020B0204020104020204" pitchFamily="34" charset="0"/>
               </a:rPr>
-              <a:t>{{#F156}}</a:t>
+              <a:t>{{#F267}}</a:t>
             </a:r>
             <a:endParaRPr kumimoji="0" lang="es-PE" sz="1800" b="1" i="0" u="none" strike="noStrike" kern="1200" cap="none" spc="0" normalizeH="0" baseline="0" noProof="0" dirty="0">
               <a:ln>
@@ -15494,7 +15392,7 @@
       </p:sp>
       <p:sp>
         <p:nvSpPr>
-          <p:cNvPr id="1057" name="Lineas 1057">
+          <p:cNvPr id="1168" name="Lineas 1168">
             <a:extLst>
               <a:ext uri="{FF2B5EF4-FFF2-40B4-BE49-F238E27FC236}">
                 <a16:creationId xmlns:a16="http://schemas.microsoft.com/office/drawing/2014/main" id="{473DA5A5-E11C-DB40-DF4F-8F3A69757349}"/>
@@ -15542,7 +15440,7 @@
                 </a:solidFill>
                 <a:latin typeface="Abadi ExtraLight" panose="020B0204020104020204" pitchFamily="34" charset="0"/>
               </a:rPr>
-              <a:t>{{#F157}}</a:t>
+              <a:t>{{#F268}}</a:t>
             </a:r>
             <a:endParaRPr kumimoji="0" lang="es-PE" sz="1800" b="1" i="0" u="none" strike="noStrike" kern="1200" cap="none" spc="0" normalizeH="0" baseline="0" noProof="0" dirty="0">
               <a:ln>
@@ -15649,7 +15547,7 @@
                 <a:cs typeface="Candara"/>
                 <a:sym typeface="Candara"/>
               </a:rPr>
-              <a:t>9.  Seguimiento del Inspector de Calidad</a:t>
+              <a:t>{{#F271}}</a:t>
             </a:r>
             <a:endParaRPr lang="en-US" kern="0" dirty="0">
               <a:solidFill>
@@ -15833,7 +15731,7 @@
                 <a:ea typeface="ADLaM Display" panose="02010000000000000000" pitchFamily="2" charset="0"/>
                 <a:cs typeface="ADLaM Display" panose="02010000000000000000" pitchFamily="2" charset="0"/>
               </a:rPr>
-              <a:t>{{#F159}}</a:t>
+              <a:t>{{#F270}}</a:t>
             </a:r>
             <a:endParaRPr lang="es-PE" sz="2000" dirty="0">
               <a:solidFill>
@@ -15990,7 +15888,7 @@
                   <a:latin typeface="Arial" panose="020B0604020202020204" pitchFamily="34" charset="0"/>
                   <a:cs typeface="Arial" panose="020B0604020202020204" pitchFamily="34" charset="0"/>
                 </a:rPr>
-                <a:t>{{#F158}}</a:t>
+                <a:t>{{#F269}}</a:t>
               </a:r>
               <a:endParaRPr lang="es-PE" sz="1600" b="1" dirty="0">
                 <a:solidFill>
@@ -16040,17 +15938,7 @@
                     </a:schemeClr>
                   </a:solidFill>
                 </a:rPr>
-                <a:t>N°</a:t>
-              </a:r>
-              <a:r>
-                <a:rPr lang="es-ES" b="1" dirty="0">
-                  <a:solidFill>
-                    <a:schemeClr val="accent5">
-                      <a:lumMod val="75000"/>
-                    </a:schemeClr>
-                  </a:solidFill>
-                </a:rPr>
-                <a:t> DE INSPECTORES</a:t>
+                <a:t>{{#F272}}</a:t>
               </a:r>
               <a:endParaRPr lang="es-PE" b="1" dirty="0">
                 <a:solidFill>
@@ -16367,7 +16255,7 @@
                   </a:srgbClr>
                 </a:solidFill>
               </a:rPr>
-              <a:t>Danper</a:t>
+              <a:t>{{#F273}}</a:t>
             </a:r>
             <a:endParaRPr lang="es-PE" sz="1400" b="0" dirty="0">
               <a:solidFill>
@@ -16429,7 +16317,7 @@
                   </a:srgbClr>
                 </a:solidFill>
               </a:rPr>
-              <a:t>danper.com</a:t>
+              <a:t>{{#F274}}</a:t>
             </a:r>
             <a:endParaRPr lang="es-PE" sz="1400" b="0" dirty="0">
               <a:solidFill>
@@ -16954,7 +16842,7 @@
                   <a:srgbClr val="080808"/>
                 </a:solidFill>
               </a:rPr>
-              <a:t>{{#F3}}</a:t>
+              <a:t>{{#F5}}</a:t>
             </a:r>
             <a:endParaRPr lang="es-PE" sz="3600" b="1" dirty="0">
               <a:solidFill>
@@ -17000,7 +16888,7 @@
                   <a:srgbClr val="080808"/>
                 </a:solidFill>
               </a:rPr>
-              <a:t>Aseguramiento de la Calidad Fresco</a:t>
+              <a:t>{{#F7}}</a:t>
             </a:r>
           </a:p>
         </p:txBody>
@@ -17852,7 +17740,7 @@
                   <a:srgbClr val="080808"/>
                 </a:solidFill>
               </a:rPr>
-              <a:t>{{#F4}}</a:t>
+              <a:t>{{#F6}}</a:t>
             </a:r>
             <a:endParaRPr lang="es-PE" sz="2000" b="1" dirty="0">
               <a:solidFill>
@@ -17956,7 +17844,7 @@
                 <a:cs typeface="Candara"/>
                 <a:sym typeface="Candara"/>
               </a:rPr>
-              <a:t>1.  Indicadores de Producción</a:t>
+              <a:t>{{#F28}}</a:t>
             </a:r>
             <a:endParaRPr kumimoji="0" lang="en-US" sz="1800" b="0" i="0" u="none" strike="noStrike" kern="0" cap="none" spc="0" normalizeH="0" baseline="0" noProof="0" dirty="0">
               <a:ln>
@@ -18142,7 +18030,7 @@
                   <a:ea typeface="+mn-ea"/>
                   <a:cs typeface="+mn-cs"/>
                 </a:rPr>
-                <a:t>Eficiencia </a:t>
+                <a:t>{{#F29}}</a:t>
               </a:r>
               <a:endParaRPr kumimoji="0" lang="es-PE" sz="1800" b="1" i="0" u="none" strike="noStrike" kern="1200" cap="none" spc="0" normalizeH="0" baseline="0" noProof="0" dirty="0">
                 <a:ln>
@@ -18221,7 +18109,7 @@
                   <a:ea typeface="+mn-ea"/>
                   <a:cs typeface="+mn-cs"/>
                 </a:rPr>
-                <a:t>AVANCE DE CAMPAÑA</a:t>
+                <a:t>{{#F30}}</a:t>
               </a:r>
             </a:p>
           </p:txBody>
@@ -18286,7 +18174,7 @@
                   <a:ea typeface="+mn-ea"/>
                   <a:cs typeface="+mn-cs"/>
                 </a:rPr>
-                <a:t>{{#F25}}</a:t>
+                <a:t>{{#F31}}</a:t>
               </a:r>
               <a:endParaRPr kumimoji="0" lang="es-PE" sz="1800" b="0" i="0" u="sng" strike="noStrike" kern="1200" cap="none" spc="0" normalizeH="0" baseline="0" noProof="0" dirty="0">
                 <a:ln>
@@ -18551,7 +18439,7 @@
                   <a:ea typeface="+mn-ea"/>
                   <a:cs typeface="+mn-cs"/>
                 </a:rPr>
-                <a:t>Aprovechamiento</a:t>
+                <a:t>{{#F32}}</a:t>
               </a:r>
               <a:endParaRPr kumimoji="0" lang="es-PE" sz="1800" b="1" i="0" u="none" strike="noStrike" kern="1200" cap="none" spc="0" normalizeH="0" baseline="0" noProof="0" dirty="0">
                 <a:ln>
@@ -18706,7 +18594,7 @@
                   <a:ea typeface="+mn-ea"/>
                   <a:cs typeface="+mn-cs"/>
                 </a:rPr>
-                <a:t>AVANCE DE CAMPAÑA</a:t>
+                <a:t>{{#F33}}</a:t>
               </a:r>
             </a:p>
           </p:txBody>
@@ -18855,7 +18743,7 @@
                   <a:ea typeface="+mn-ea"/>
                   <a:cs typeface="+mn-cs"/>
                 </a:rPr>
-                <a:t>{{#F26}}</a:t>
+                <a:t>{{#F34}}</a:t>
               </a:r>
               <a:endParaRPr kumimoji="0" lang="es-PE" sz="1800" b="0" i="0" u="sng" strike="noStrike" kern="1200" cap="none" spc="0" normalizeH="0" baseline="0" noProof="0" dirty="0">
                 <a:ln>
@@ -18960,7 +18848,7 @@
                   <a:ea typeface="+mn-ea"/>
                   <a:cs typeface="+mn-cs"/>
                 </a:rPr>
-                <a:t>Rendimiento</a:t>
+                <a:t>{{#F35}}</a:t>
               </a:r>
               <a:endParaRPr kumimoji="0" lang="es-PE" sz="1800" b="1" i="0" u="none" strike="noStrike" kern="1200" cap="none" spc="0" normalizeH="0" baseline="0" noProof="0" dirty="0">
                 <a:ln>
@@ -19199,7 +19087,7 @@
                   <a:ea typeface="+mn-ea"/>
                   <a:cs typeface="+mn-cs"/>
                 </a:rPr>
-                <a:t>AVANCE DE CAMPAÑA</a:t>
+                <a:t>{{#F36}}</a:t>
               </a:r>
             </a:p>
           </p:txBody>
@@ -19264,7 +19152,7 @@
                   <a:ea typeface="+mn-ea"/>
                   <a:cs typeface="+mn-cs"/>
                 </a:rPr>
-                <a:t>{{#F27}}</a:t>
+                <a:t>{{#F37}}</a:t>
               </a:r>
               <a:endParaRPr kumimoji="0" lang="es-PE" sz="1800" b="0" i="0" u="sng" strike="noStrike" kern="1200" cap="none" spc="0" normalizeH="0" baseline="0" noProof="0" dirty="0">
                 <a:ln>
@@ -19407,7 +19295,7 @@
                         <a:srgbClr val="FF0000"/>
                       </a:solidFill>
                     </a:rPr>
-                    <a:t>{{#F5}}</a:t>
+                    <a:t>{{#F8}}</a:t>
                   </a:r>
                   <a:endParaRPr kumimoji="0" lang="es-PE" sz="3600" b="0" i="0" u="none" strike="noStrike" kern="1200" cap="none" spc="0" normalizeH="0" baseline="0" noProof="0" dirty="0">
                     <a:ln>
@@ -19486,7 +19374,7 @@
                       <a:ea typeface="+mn-ea"/>
                       <a:cs typeface="+mn-cs"/>
                     </a:rPr>
-                    <a:t>Objetivo: 0.282</a:t>
+                    <a:t>{{#F38}}</a:t>
                   </a:r>
                 </a:p>
               </p:txBody>
@@ -19551,7 +19439,7 @@
                       <a:ea typeface="+mn-ea"/>
                       <a:cs typeface="+mn-cs"/>
                     </a:rPr>
-                    <a:t>{{#F6}}</a:t>
+                    <a:t>{{#F9}}</a:t>
                   </a:r>
                 </a:p>
               </p:txBody>
@@ -19693,7 +19581,7 @@
                     <a:ea typeface="+mn-ea"/>
                     <a:cs typeface="+mn-cs"/>
                   </a:rPr>
-                  <a:t>AVANCE DE CAMPAÑA</a:t>
+                  <a:t>{{#F39}}</a:t>
                 </a:r>
               </a:p>
             </p:txBody>
@@ -19791,7 +19679,7 @@
                       </a:solidFill>
                       <a:latin typeface="Century Gothic" panose="020B0502020202020204" pitchFamily="34" charset="0"/>
                     </a:rPr>
-                    <a:t>{{#F7}}</a:t>
+                    <a:t>{{#F10}}</a:t>
                   </a:r>
                 </a:p>
               </p:txBody>
@@ -19856,7 +19744,7 @@
                       <a:ea typeface="+mn-ea"/>
                       <a:cs typeface="+mn-cs"/>
                     </a:rPr>
-                    <a:t>Objetivo: 0.282</a:t>
+                    <a:t>{{#F40}}</a:t>
                   </a:r>
                 </a:p>
               </p:txBody>
@@ -19921,7 +19809,7 @@
                       <a:ea typeface="+mn-ea"/>
                       <a:cs typeface="+mn-cs"/>
                     </a:rPr>
-                    <a:t>{{#F8}}</a:t>
+                    <a:t>{{#F11}}</a:t>
                   </a:r>
                 </a:p>
               </p:txBody>
@@ -20071,7 +19959,7 @@
                     <a:ea typeface="+mn-ea"/>
                     <a:cs typeface="+mn-cs"/>
                   </a:rPr>
-                  <a:t>{{#F28}}</a:t>
+                  <a:t>{{#F41}}</a:t>
                 </a:r>
                 <a:endParaRPr kumimoji="0" lang="es-PE" sz="1600" b="0" i="0" u="sng" strike="noStrike" kern="1200" cap="none" spc="0" normalizeH="0" baseline="0" noProof="0" dirty="0">
                   <a:ln>
@@ -20156,7 +20044,7 @@
                   <a:ea typeface="+mn-ea"/>
                   <a:cs typeface="+mn-cs"/>
                 </a:rPr>
-                <a:t>Mano de Obra - Producción</a:t>
+                <a:t>{{#F42}}</a:t>
               </a:r>
               <a:endParaRPr kumimoji="0" lang="es-PE" sz="1800" b="1" i="0" u="none" strike="noStrike" kern="1200" cap="none" spc="0" normalizeH="0" baseline="0" noProof="0" dirty="0">
                 <a:ln>
@@ -20261,7 +20149,7 @@
                   <a:ea typeface="+mn-ea"/>
                   <a:cs typeface="+mn-cs"/>
                 </a:rPr>
-                <a:t>Eficiencia Global</a:t>
+                <a:t>{{#F43}}</a:t>
               </a:r>
               <a:endParaRPr kumimoji="0" lang="es-PE" sz="1800" b="1" i="0" u="none" strike="noStrike" kern="1200" cap="none" spc="0" normalizeH="0" baseline="0" noProof="0" dirty="0">
                 <a:ln>
@@ -20360,33 +20248,7 @@
                     <a:ea typeface="+mn-ea"/>
                     <a:cs typeface="+mn-cs"/>
                   </a:rPr>
-                  <a:t>Objetivo: 8</a:t>
-                </a:r>
-                <a:r>
-                  <a:rPr lang="es-PE" b="1" dirty="0">
-                    <a:solidFill>
-                      <a:srgbClr val="000000"/>
-                    </a:solidFill>
-                    <a:latin typeface="Abadi ExtraLight" panose="020B0204020104020204" pitchFamily="34" charset="0"/>
-                  </a:rPr>
-                  <a:t>3</a:t>
-                </a:r>
-                <a:r>
-                  <a:rPr kumimoji="0" lang="es-PE" sz="1800" b="1" i="0" u="none" strike="noStrike" kern="1200" cap="none" spc="0" normalizeH="0" baseline="0" noProof="0" dirty="0">
-                    <a:ln>
-                      <a:noFill/>
-                    </a:ln>
-                    <a:solidFill>
-                      <a:srgbClr val="000000"/>
-                    </a:solidFill>
-                    <a:effectLst/>
-                    <a:uLnTx/>
-                    <a:uFillTx/>
-                    <a:latin typeface="Abadi ExtraLight" panose="020B0204020104020204" pitchFamily="34" charset="0"/>
-                    <a:ea typeface="+mn-ea"/>
-                    <a:cs typeface="+mn-cs"/>
-                  </a:rPr>
-                  <a:t>,0%</a:t>
+                  <a:t>{{#F44}}</a:t>
                 </a:r>
               </a:p>
             </p:txBody>
@@ -20451,7 +20313,7 @@
                     <a:ea typeface="+mn-ea"/>
                     <a:cs typeface="+mn-cs"/>
                   </a:rPr>
-                  <a:t>{{#F9}}</a:t>
+                  <a:t>{{#F12}}</a:t>
                 </a:r>
               </a:p>
             </p:txBody>
@@ -20592,7 +20454,7 @@
                     <a:ea typeface="+mn-ea"/>
                     <a:cs typeface="+mn-cs"/>
                   </a:rPr>
-                  <a:t>AVANCE DE CAMPAÑA</a:t>
+                  <a:t>{{#F45}}</a:t>
                 </a:r>
               </a:p>
             </p:txBody>
@@ -20762,7 +20624,7 @@
                     <a:ea typeface="+mn-ea"/>
                     <a:cs typeface="+mn-cs"/>
                   </a:rPr>
-                  <a:t>{{#F29}}</a:t>
+                  <a:t>{{#F46}}</a:t>
                 </a:r>
                 <a:endParaRPr kumimoji="0" lang="es-PE" sz="1800" b="0" i="0" u="sng" strike="noStrike" kern="1200" cap="none" spc="0" normalizeH="0" baseline="0" noProof="0" dirty="0">
                   <a:ln>
@@ -20841,33 +20703,7 @@
                     <a:ea typeface="+mn-ea"/>
                     <a:cs typeface="+mn-cs"/>
                   </a:rPr>
-                  <a:t>Objetivo: </a:t>
-                </a:r>
-                <a:r>
-                  <a:rPr lang="es-PE" b="1" dirty="0">
-                    <a:solidFill>
-                      <a:srgbClr val="000000"/>
-                    </a:solidFill>
-                    <a:latin typeface="Abadi ExtraLight" panose="020B0204020104020204" pitchFamily="34" charset="0"/>
-                  </a:rPr>
-                  <a:t>83,</a:t>
-                </a:r>
-                <a:r>
-                  <a:rPr kumimoji="0" lang="es-PE" sz="1800" b="1" i="0" u="none" strike="noStrike" kern="1200" cap="none" spc="0" normalizeH="0" baseline="0" noProof="0" dirty="0">
-                    <a:ln>
-                      <a:noFill/>
-                    </a:ln>
-                    <a:solidFill>
-                      <a:srgbClr val="000000"/>
-                    </a:solidFill>
-                    <a:effectLst/>
-                    <a:uLnTx/>
-                    <a:uFillTx/>
-                    <a:latin typeface="Abadi ExtraLight" panose="020B0204020104020204" pitchFamily="34" charset="0"/>
-                    <a:ea typeface="+mn-ea"/>
-                    <a:cs typeface="+mn-cs"/>
-                  </a:rPr>
-                  <a:t>0%</a:t>
+                  <a:t>{{#F47}}</a:t>
                 </a:r>
               </a:p>
             </p:txBody>
@@ -20932,7 +20768,7 @@
                     <a:ea typeface="+mn-ea"/>
                     <a:cs typeface="+mn-cs"/>
                   </a:rPr>
-                  <a:t>{{#F10}}</a:t>
+                  <a:t>{{#F13}}</a:t>
                 </a:r>
               </a:p>
             </p:txBody>
@@ -20973,7 +20809,7 @@
                   <a:schemeClr val="accent5"/>
                 </a:solidFill>
               </a:rPr>
-              <a:t>{{#F30}}</a:t>
+              <a:t>{{#F48}}</a:t>
             </a:r>
             <a:endParaRPr lang="es-PE" sz="1400" dirty="0">
               <a:solidFill>
@@ -21017,7 +20853,7 @@
                   <a:schemeClr val="accent5"/>
                 </a:solidFill>
               </a:rPr>
-              <a:t>{{#F31}}</a:t>
+              <a:t>{{#F49}}</a:t>
             </a:r>
             <a:endParaRPr lang="es-PE" sz="1400" dirty="0">
               <a:solidFill>
@@ -21061,7 +20897,7 @@
                   <a:schemeClr val="accent5"/>
                 </a:solidFill>
               </a:rPr>
-              <a:t>{{#F32}}</a:t>
+              <a:t>{{#F50}}</a:t>
             </a:r>
             <a:endParaRPr lang="es-PE" sz="1400" dirty="0">
               <a:solidFill>
@@ -21105,7 +20941,7 @@
                   <a:schemeClr val="accent5"/>
                 </a:solidFill>
               </a:rPr>
-              <a:t>{{#F33}}</a:t>
+              <a:t>{{#F51}}</a:t>
             </a:r>
             <a:endParaRPr lang="es-PE" sz="1400" dirty="0">
               <a:solidFill>
@@ -21149,7 +20985,7 @@
                   <a:schemeClr val="accent5"/>
                 </a:solidFill>
               </a:rPr>
-              <a:t>{{#F34}}</a:t>
+              <a:t>{{#F52}}</a:t>
             </a:r>
             <a:endParaRPr lang="es-PE" sz="1400" dirty="0">
               <a:solidFill>
@@ -21189,7 +21025,7 @@
           <a:p>
             <a:r>
               <a:rPr lang="es-MX" sz="1400" dirty="0"/>
-              <a:t>Información extraída de los indicadores de producción. Los datos presentados son considerados solo hasta la última semana cerrada con información completa</a:t>
+              <a:t>{{#F53}}</a:t>
             </a:r>
           </a:p>
           <a:p>
@@ -21250,7 +21086,7 @@
                 </a:solidFill>
                 <a:latin typeface="Aptos Light" panose="020B0004020202020204" pitchFamily="34" charset="0"/>
               </a:rPr>
-              <a:t>{{#F11}}</a:t>
+              <a:t>{{#F14}}</a:t>
             </a:r>
             <a:endParaRPr lang="es-PE" dirty="0">
               <a:solidFill>
@@ -21298,7 +21134,7 @@
                   </a:schemeClr>
                 </a:solidFill>
               </a:rPr>
-              <a:t>Objetivo: 70 %</a:t>
+              <a:t>{{#F54}}</a:t>
             </a:r>
             <a:endParaRPr lang="es-PE" sz="1600" dirty="0">
               <a:solidFill>
@@ -21347,7 +21183,7 @@
                   </a:schemeClr>
                 </a:solidFill>
               </a:rPr>
-              <a:t>{{#F12}}</a:t>
+              <a:t>{{#F15}}</a:t>
             </a:r>
             <a:endParaRPr lang="es-PE" sz="1600" dirty="0">
               <a:solidFill>
@@ -21412,7 +21248,7 @@
                 </a:solidFill>
                 <a:latin typeface="Aptos Light" panose="020B0004020202020204" pitchFamily="34" charset="0"/>
               </a:rPr>
-              <a:t>{{#F13}}</a:t>
+              <a:t>{{#F16}}</a:t>
             </a:r>
             <a:endParaRPr lang="es-PE" dirty="0">
               <a:solidFill>
@@ -21460,7 +21296,7 @@
                   </a:schemeClr>
                 </a:solidFill>
               </a:rPr>
-              <a:t>Objetivo: 70 %</a:t>
+              <a:t>{{#F55}}</a:t>
             </a:r>
             <a:endParaRPr lang="es-PE" sz="1600" dirty="0">
               <a:solidFill>
@@ -21509,7 +21345,7 @@
                   </a:schemeClr>
                 </a:solidFill>
               </a:rPr>
-              <a:t>{{#F14}}</a:t>
+              <a:t>{{#F17}}</a:t>
             </a:r>
             <a:endParaRPr lang="es-PE" sz="1600" dirty="0">
               <a:solidFill>
@@ -21574,7 +21410,7 @@
                 </a:solidFill>
                 <a:latin typeface="Aptos Light" panose="020B0004020202020204" pitchFamily="34" charset="0"/>
               </a:rPr>
-              <a:t>{{#F15}}</a:t>
+              <a:t>{{#F18}}</a:t>
             </a:r>
             <a:endParaRPr lang="es-PE" dirty="0">
               <a:solidFill>
@@ -21622,7 +21458,7 @@
                   </a:schemeClr>
                 </a:solidFill>
               </a:rPr>
-              <a:t>Objetivo: 53.5 %</a:t>
+              <a:t>{{#F56}}</a:t>
             </a:r>
             <a:endParaRPr lang="es-PE" sz="1600" dirty="0">
               <a:solidFill>
@@ -21671,7 +21507,7 @@
                   </a:schemeClr>
                 </a:solidFill>
               </a:rPr>
-              <a:t>{{#F16}}</a:t>
+              <a:t>{{#F19}}</a:t>
             </a:r>
             <a:endParaRPr lang="es-PE" sz="1600" dirty="0">
               <a:solidFill>
@@ -21736,7 +21572,7 @@
                 </a:solidFill>
                 <a:latin typeface="Aptos Light" panose="020B0004020202020204" pitchFamily="34" charset="0"/>
               </a:rPr>
-              <a:t>{{#F17}}</a:t>
+              <a:t>{{#F20}}</a:t>
             </a:r>
             <a:endParaRPr lang="es-PE" dirty="0">
               <a:solidFill>
@@ -21784,7 +21620,7 @@
                   </a:schemeClr>
                 </a:solidFill>
               </a:rPr>
-              <a:t>Objetivo: 53.5 %</a:t>
+              <a:t>{{#F57}}</a:t>
             </a:r>
             <a:endParaRPr lang="es-PE" sz="1600" dirty="0">
               <a:solidFill>
@@ -21833,7 +21669,7 @@
                   </a:schemeClr>
                 </a:solidFill>
               </a:rPr>
-              <a:t>{{#F18}}</a:t>
+              <a:t>{{#F21}}</a:t>
             </a:r>
             <a:endParaRPr lang="es-PE" sz="1600" dirty="0">
               <a:solidFill>
@@ -21898,7 +21734,7 @@
                 </a:solidFill>
                 <a:latin typeface="Aptos Light" panose="020B0004020202020204" pitchFamily="34" charset="0"/>
               </a:rPr>
-              <a:t>{{#F19}}</a:t>
+              <a:t>{{#F22}}</a:t>
             </a:r>
             <a:endParaRPr lang="es-PE" dirty="0">
               <a:solidFill>
@@ -21962,7 +21798,7 @@
                 </a:solidFill>
                 <a:latin typeface="Aptos Light" panose="020B0004020202020204" pitchFamily="34" charset="0"/>
               </a:rPr>
-              <a:t>{{#F20}}</a:t>
+              <a:t>{{#F23}}</a:t>
             </a:r>
             <a:endParaRPr lang="es-PE" dirty="0">
               <a:solidFill>
@@ -22033,7 +21869,7 @@
                 <a:ea typeface="+mn-ea"/>
                 <a:cs typeface="+mn-cs"/>
               </a:rPr>
-              <a:t>Objetivo: 84,0%</a:t>
+              <a:t>{{#F58}}</a:t>
             </a:r>
           </a:p>
         </p:txBody>
@@ -22098,7 +21934,7 @@
                 <a:ea typeface="+mn-ea"/>
                 <a:cs typeface="+mn-cs"/>
               </a:rPr>
-              <a:t>{{#F21}}</a:t>
+              <a:t>{{#F24}}</a:t>
             </a:r>
           </a:p>
         </p:txBody>
@@ -22156,7 +21992,7 @@
                 </a:solidFill>
                 <a:latin typeface="Aptos Light" panose="020B0004020202020204" pitchFamily="34" charset="0"/>
               </a:rPr>
-              <a:t>{{#F22}}</a:t>
+              <a:t>{{#F25}}</a:t>
             </a:r>
             <a:endParaRPr lang="es-PE" dirty="0">
               <a:solidFill>
@@ -22227,7 +22063,7 @@
                 <a:ea typeface="+mn-ea"/>
                 <a:cs typeface="+mn-cs"/>
               </a:rPr>
-              <a:t>Objetivo: 84,0%</a:t>
+              <a:t>{{#F59}}</a:t>
             </a:r>
           </a:p>
         </p:txBody>
@@ -22292,7 +22128,7 @@
                 <a:ea typeface="+mn-ea"/>
                 <a:cs typeface="+mn-cs"/>
               </a:rPr>
-              <a:t>{{#F23}}</a:t>
+              <a:t>{{#F26}}</a:t>
             </a:r>
           </a:p>
         </p:txBody>
@@ -22350,7 +22186,7 @@
                 </a:solidFill>
                 <a:latin typeface="Aptos Light" panose="020B0004020202020204" pitchFamily="34" charset="0"/>
               </a:rPr>
-              <a:t>{{#F24}}</a:t>
+              <a:t>{{#F27}}</a:t>
             </a:r>
             <a:endParaRPr lang="es-PE" dirty="0">
               <a:solidFill>
@@ -22463,55 +22299,7 @@
                 <a:cs typeface="Candara"/>
                 <a:sym typeface="Candara"/>
               </a:rPr>
-              <a:t>2</a:t>
-            </a:r>
-            <a:r>
-              <a:rPr kumimoji="0" lang="es-MX" sz="2000" b="1" i="1" u="none" strike="noStrike" kern="1200" cap="none" spc="0" normalizeH="0" baseline="0" noProof="0" dirty="0">
-                <a:ln>
-                  <a:noFill/>
-                </a:ln>
-                <a:solidFill>
-                  <a:srgbClr val="12781C"/>
-                </a:solidFill>
-                <a:effectLst/>
-                <a:uLnTx/>
-                <a:uFillTx/>
-                <a:latin typeface="Candara"/>
-                <a:ea typeface="Candara"/>
-                <a:cs typeface="Candara"/>
-                <a:sym typeface="Candara"/>
-              </a:rPr>
-              <a:t>. Kilos de </a:t>
-            </a:r>
-            <a:r>
-              <a:rPr lang="es-MX" sz="2000" b="1" i="1" dirty="0">
-                <a:solidFill>
-                  <a:srgbClr val="12781C"/>
-                </a:solidFill>
-                <a:latin typeface="Candara"/>
-                <a:ea typeface="Candara"/>
-                <a:cs typeface="Candara"/>
-                <a:sym typeface="Candara"/>
-              </a:rPr>
-              <a:t>Espárrago</a:t>
-            </a:r>
-            <a:r>
-              <a:rPr kumimoji="0" lang="es-MX" sz="2000" b="1" i="1" u="none" strike="noStrike" kern="1200" cap="none" spc="0" normalizeH="0" baseline="0" noProof="0" dirty="0">
-                <a:ln>
-                  <a:noFill/>
-                </a:ln>
-                <a:solidFill>
-                  <a:srgbClr val="12781C"/>
-                </a:solidFill>
-                <a:effectLst/>
-                <a:uLnTx/>
-                <a:uFillTx/>
-                <a:latin typeface="Candara"/>
-                <a:ea typeface="Candara"/>
-                <a:cs typeface="Candara"/>
-                <a:sym typeface="Candara"/>
-              </a:rPr>
-              <a:t> Recepcionado y Drenado</a:t>
+              <a:t>{{#F72}}</a:t>
             </a:r>
             <a:endParaRPr kumimoji="0" lang="en-US" sz="1800" b="0" i="0" u="none" strike="noStrike" kern="0" cap="none" spc="0" normalizeH="0" baseline="0" noProof="0" dirty="0">
               <a:ln>
@@ -22735,7 +22523,7 @@
                         <a:srgbClr val="002060"/>
                       </a:solidFill>
                     </a:rPr>
-                    <a:t>{{#F35}}</a:t>
+                    <a:t>{{#F60}}</a:t>
                   </a:r>
                   <a:endParaRPr kumimoji="0" lang="es-PE" sz="3600" b="0" i="0" u="none" strike="noStrike" kern="1200" cap="none" spc="0" normalizeH="0" baseline="0" noProof="0" dirty="0">
                     <a:ln>
@@ -22814,7 +22602,7 @@
                       <a:ea typeface="+mn-ea"/>
                       <a:cs typeface="+mn-cs"/>
                     </a:rPr>
-                    <a:t>kilos</a:t>
+                    <a:t>{{#F73}}</a:t>
                   </a:r>
                 </a:p>
               </p:txBody>
@@ -22956,7 +22744,7 @@
                     <a:ea typeface="+mn-ea"/>
                     <a:cs typeface="+mn-cs"/>
                   </a:rPr>
-                  <a:t>PROYECTADOS</a:t>
+                  <a:t>{{#F74}}</a:t>
                 </a:r>
               </a:p>
             </p:txBody>
@@ -23054,7 +22842,7 @@
                       </a:solidFill>
                       <a:latin typeface="Century Gothic" panose="020B0502020202020204" pitchFamily="34" charset="0"/>
                     </a:rPr>
-                    <a:t>{{#F36}}</a:t>
+                    <a:t>{{#F61}}</a:t>
                   </a:r>
                   <a:endParaRPr kumimoji="0" lang="es-PE" sz="4000" b="0" i="0" u="none" strike="noStrike" kern="1200" cap="none" spc="0" normalizeH="0" baseline="0" noProof="0" dirty="0">
                     <a:ln>
@@ -23133,7 +22921,7 @@
                       <a:ea typeface="+mn-ea"/>
                       <a:cs typeface="+mn-cs"/>
                     </a:rPr>
-                    <a:t>kilos</a:t>
+                    <a:t>{{#F75}}</a:t>
                   </a:r>
                   <a:endParaRPr kumimoji="0" lang="es-PE" sz="1800" b="1" i="0" u="none" strike="noStrike" kern="1200" cap="none" spc="0" normalizeH="0" baseline="0" noProof="0" dirty="0">
                     <a:ln>
@@ -23289,7 +23077,7 @@
                     <a:ea typeface="+mn-ea"/>
                     <a:cs typeface="+mn-cs"/>
                   </a:rPr>
-                  <a:t>{{#F47}}</a:t>
+                  <a:t>{{#F76}}</a:t>
                 </a:r>
                 <a:endParaRPr kumimoji="0" lang="es-PE" sz="1400" b="0" i="0" u="sng" strike="noStrike" kern="1200" cap="none" spc="0" normalizeH="0" baseline="0" noProof="0" dirty="0">
                   <a:ln>
@@ -23373,7 +23161,7 @@
                   <a:ea typeface="+mn-ea"/>
                   <a:cs typeface="+mn-cs"/>
                 </a:rPr>
-                <a:t>KILOGRAMOS RECEPCIONADOS</a:t>
+                <a:t>{{#F77}}</a:t>
               </a:r>
               <a:endParaRPr kumimoji="0" lang="es-PE" sz="1800" b="1" i="0" u="none" strike="noStrike" kern="1200" cap="none" spc="0" normalizeH="0" baseline="0" noProof="0" dirty="0">
                 <a:ln>
@@ -23536,7 +23324,7 @@
                   <a:ea typeface="+mn-ea"/>
                   <a:cs typeface="+mn-cs"/>
                 </a:rPr>
-                <a:t>{{#F48}}</a:t>
+                <a:t>{{#F78}}</a:t>
               </a:r>
               <a:endParaRPr kumimoji="0" lang="es-PE" sz="1600" b="0" i="0" u="sng" strike="noStrike" kern="1200" cap="none" spc="0" normalizeH="0" baseline="0" noProof="0" dirty="0">
                 <a:ln>
@@ -23607,7 +23395,7 @@
                   </a:solidFill>
                   <a:latin typeface="Century Gothic" panose="020B0502020202020204" pitchFamily="34" charset="0"/>
                 </a:rPr>
-                <a:t>{{#F37}}</a:t>
+                <a:t>{{#F62}}</a:t>
               </a:r>
             </a:p>
           </p:txBody>
@@ -23768,7 +23556,7 @@
                     <a:ea typeface="+mn-ea"/>
                     <a:cs typeface="+mn-cs"/>
                   </a:rPr>
-                  <a:t>AVANCE DE CAMPAÑA</a:t>
+                  <a:t>{{#F79}}</a:t>
                 </a:r>
                 <a:endParaRPr kumimoji="0" lang="es-PE" sz="1600" b="0" i="0" u="sng" strike="noStrike" kern="1200" cap="none" spc="0" normalizeH="0" baseline="0" noProof="0" dirty="0">
                   <a:ln>
@@ -23839,7 +23627,7 @@
                     </a:solidFill>
                     <a:latin typeface="Century Gothic" panose="020B0502020202020204" pitchFamily="34" charset="0"/>
                   </a:rPr>
-                  <a:t>{{#F38}}</a:t>
+                  <a:t>{{#F63}}</a:t>
                 </a:r>
               </a:p>
             </p:txBody>
@@ -23905,7 +23693,7 @@
                   <a:ea typeface="+mn-ea"/>
                   <a:cs typeface="+mn-cs"/>
                 </a:rPr>
-                <a:t>kilos</a:t>
+                <a:t>{{#F80}}</a:t>
               </a:r>
               <a:endParaRPr kumimoji="0" lang="es-PE" sz="1800" b="1" i="0" u="none" strike="noStrike" kern="1200" cap="none" spc="0" normalizeH="0" baseline="0" noProof="0" dirty="0">
                 <a:ln>
@@ -23959,7 +23747,7 @@
                   <a:schemeClr val="accent5"/>
                 </a:solidFill>
               </a:rPr>
-              <a:t>{{#F49}}</a:t>
+              <a:t>{{#F81}}</a:t>
             </a:r>
             <a:endParaRPr lang="es-PE" sz="1400" dirty="0">
               <a:solidFill>
@@ -24101,7 +23889,7 @@
                       <a:ea typeface="+mn-ea"/>
                       <a:cs typeface="+mn-cs"/>
                     </a:rPr>
-                    <a:t>{{#F39}}</a:t>
+                    <a:t>{{#F64}}</a:t>
                   </a:r>
                   <a:endParaRPr kumimoji="0" lang="es-PE" sz="3600" b="0" i="0" u="none" strike="noStrike" kern="1200" cap="none" spc="0" normalizeH="0" baseline="0" noProof="0" dirty="0">
                     <a:ln>
@@ -24180,7 +23968,7 @@
                       <a:ea typeface="+mn-ea"/>
                       <a:cs typeface="+mn-cs"/>
                     </a:rPr>
-                    <a:t>kilos</a:t>
+                    <a:t>{{#F82}}</a:t>
                   </a:r>
                 </a:p>
               </p:txBody>
@@ -24322,7 +24110,7 @@
                     <a:ea typeface="+mn-ea"/>
                     <a:cs typeface="+mn-cs"/>
                   </a:rPr>
-                  <a:t>PROYECTADOS</a:t>
+                  <a:t>{{#F83}}</a:t>
                 </a:r>
               </a:p>
             </p:txBody>
@@ -24420,7 +24208,7 @@
                       </a:solidFill>
                       <a:latin typeface="Century Gothic" panose="020B0502020202020204" pitchFamily="34" charset="0"/>
                     </a:rPr>
-                    <a:t>{{#F40}}</a:t>
+                    <a:t>{{#F65}}</a:t>
                   </a:r>
                   <a:endParaRPr kumimoji="0" lang="es-PE" sz="4000" b="0" i="0" u="none" strike="noStrike" kern="1200" cap="none" spc="0" normalizeH="0" baseline="0" noProof="0" dirty="0">
                     <a:ln>
@@ -24499,7 +24287,7 @@
                       <a:ea typeface="+mn-ea"/>
                       <a:cs typeface="+mn-cs"/>
                     </a:rPr>
-                    <a:t>kilos</a:t>
+                    <a:t>{{#F84}}</a:t>
                   </a:r>
                   <a:endParaRPr kumimoji="0" lang="es-PE" sz="1800" b="1" i="0" u="none" strike="noStrike" kern="1200" cap="none" spc="0" normalizeH="0" baseline="0" noProof="0" dirty="0">
                     <a:ln>
@@ -24660,7 +24448,7 @@
                   <a:ea typeface="+mn-ea"/>
                   <a:cs typeface="+mn-cs"/>
                 </a:rPr>
-                <a:t>KILOGRAMOS DRENADOS</a:t>
+                <a:t>{{#F85}}</a:t>
               </a:r>
               <a:endParaRPr kumimoji="0" lang="es-PE" sz="1800" b="1" i="0" u="none" strike="noStrike" kern="1200" cap="none" spc="0" normalizeH="0" baseline="0" noProof="0" dirty="0">
                 <a:ln>
@@ -24835,7 +24623,7 @@
                     <a:ea typeface="+mn-ea"/>
                     <a:cs typeface="+mn-cs"/>
                   </a:rPr>
-                  <a:t>AVANCE DE CAMPAÑA</a:t>
+                  <a:t>{{#F86}}</a:t>
                 </a:r>
                 <a:endParaRPr kumimoji="0" lang="es-PE" sz="1600" b="0" i="0" u="sng" strike="noStrike" kern="1200" cap="none" spc="0" normalizeH="0" baseline="0" noProof="0" dirty="0">
                   <a:ln>
@@ -24906,7 +24694,7 @@
                     </a:solidFill>
                     <a:latin typeface="Century Gothic" panose="020B0502020202020204" pitchFamily="34" charset="0"/>
                   </a:rPr>
-                  <a:t>{{#F41}}</a:t>
+                  <a:t>{{#F66}}</a:t>
                 </a:r>
               </a:p>
             </p:txBody>
@@ -25076,7 +24864,7 @@
                     <a:ea typeface="+mn-ea"/>
                     <a:cs typeface="+mn-cs"/>
                   </a:rPr>
-                  <a:t>{{#F50}}</a:t>
+                  <a:t>{{#F87}}</a:t>
                 </a:r>
                 <a:endParaRPr kumimoji="0" lang="es-PE" sz="1600" b="0" i="0" u="sng" strike="noStrike" kern="1200" cap="none" spc="0" normalizeH="0" baseline="0" noProof="0" dirty="0">
                   <a:ln>
@@ -25147,7 +24935,7 @@
                     </a:solidFill>
                     <a:latin typeface="Century Gothic" panose="020B0502020202020204" pitchFamily="34" charset="0"/>
                   </a:rPr>
-                  <a:t>{{#F42}}</a:t>
+                  <a:t>{{#F67}}</a:t>
                 </a:r>
               </a:p>
             </p:txBody>
@@ -25212,7 +25000,7 @@
                     <a:ea typeface="+mn-ea"/>
                     <a:cs typeface="+mn-cs"/>
                   </a:rPr>
-                  <a:t>kilos</a:t>
+                  <a:t>{{#F88}}</a:t>
                 </a:r>
                 <a:endParaRPr kumimoji="0" lang="es-PE" sz="1800" b="1" i="0" u="none" strike="noStrike" kern="1200" cap="none" spc="0" normalizeH="0" baseline="0" noProof="0" dirty="0">
                   <a:ln>
@@ -25293,7 +25081,7 @@
                 <a:ea typeface="+mn-ea"/>
                 <a:cs typeface="+mn-cs"/>
               </a:rPr>
-              <a:t>{{#F51}}</a:t>
+              <a:t>{{#F89}}</a:t>
             </a:r>
             <a:endParaRPr kumimoji="0" lang="es-PE" sz="1400" b="0" i="0" u="sng" strike="noStrike" kern="1200" cap="none" spc="0" normalizeH="0" baseline="0" noProof="0" dirty="0">
               <a:ln>
@@ -25487,7 +25275,7 @@
                         </a:solidFill>
                         <a:latin typeface="Abadi ExtraLight" panose="020B0204020104020204" pitchFamily="34" charset="0"/>
                       </a:rPr>
-                      <a:t>Objetivo: 3.50%</a:t>
+                      <a:t>{{#F90}}</a:t>
                     </a:r>
                   </a:p>
                 </p:txBody>
@@ -25558,7 +25346,7 @@
                             <a:srgbClr val="FF0000"/>
                           </a:solidFill>
                         </a:rPr>
-                        <a:t>{{#F43}}</a:t>
+                        <a:t>{{#F68}}</a:t>
                       </a:r>
                     </a:p>
                   </p:txBody>
@@ -25598,7 +25386,7 @@
                           </a:solidFill>
                           <a:latin typeface="Abadi ExtraLight" panose="020B0204020104020204" pitchFamily="34" charset="0"/>
                         </a:rPr>
-                        <a:t>{{#F44}}</a:t>
+                        <a:t>{{#F69}}</a:t>
                       </a:r>
                     </a:p>
                   </p:txBody>
@@ -25660,7 +25448,7 @@
                         </a:solidFill>
                         <a:latin typeface="Abadi ExtraLight" panose="020B0204020104020204" pitchFamily="34" charset="0"/>
                       </a:rPr>
-                      <a:t>Objetivo: 3.50%</a:t>
+                      <a:t>{{#F91}}</a:t>
                     </a:r>
                   </a:p>
                 </p:txBody>
@@ -25731,7 +25519,7 @@
                             <a:srgbClr val="00B050"/>
                           </a:solidFill>
                         </a:rPr>
-                        <a:t>{{#F45}}</a:t>
+                        <a:t>{{#F70}}</a:t>
                       </a:r>
                     </a:p>
                   </p:txBody>
@@ -25771,7 +25559,7 @@
                           </a:solidFill>
                           <a:latin typeface="Abadi ExtraLight" panose="020B0204020104020204" pitchFamily="34" charset="0"/>
                         </a:rPr>
-                        <a:t>{{#F46}}</a:t>
+                        <a:t>{{#F71}}</a:t>
                       </a:r>
                     </a:p>
                   </p:txBody>
@@ -25862,7 +25650,7 @@
                           <a:prstClr val="black"/>
                         </a:solidFill>
                       </a:rPr>
-                      <a:t>Producto terminado Observado</a:t>
+                      <a:t>{{#F92}}</a:t>
                     </a:r>
                     <a:endParaRPr lang="es-PE" b="1" dirty="0">
                       <a:solidFill>
@@ -25907,7 +25695,7 @@
                         </a:solidFill>
                         <a:latin typeface="Abadi ExtraLight" panose="020B0204020104020204" pitchFamily="34" charset="0"/>
                       </a:rPr>
-                      <a:t>{{#F52}}</a:t>
+                      <a:t>{{#F93}}</a:t>
                     </a:r>
                   </a:p>
                 </p:txBody>
@@ -25948,7 +25736,7 @@
                       </a:solidFill>
                       <a:latin typeface="Abadi ExtraLight" panose="020B0204020104020204" pitchFamily="34" charset="0"/>
                     </a:rPr>
-                    <a:t>AVANCE DE CAMPAÑA</a:t>
+                    <a:t>{{#F94}}</a:t>
                   </a:r>
                 </a:p>
               </p:txBody>
@@ -25990,7 +25778,7 @@
                   <a:schemeClr val="accent5"/>
                 </a:solidFill>
               </a:rPr>
-              <a:t>{{#F53}}</a:t>
+              <a:t>{{#F95}}</a:t>
             </a:r>
             <a:endParaRPr lang="es-PE" sz="1400" dirty="0">
               <a:solidFill>
@@ -26034,7 +25822,7 @@
                   <a:schemeClr val="accent5"/>
                 </a:solidFill>
               </a:rPr>
-              <a:t>*Rev. 11</a:t>
+              <a:t>{{#F96}}</a:t>
             </a:r>
             <a:endParaRPr lang="es-PE" sz="1400" dirty="0">
               <a:solidFill>
@@ -26078,7 +25866,7 @@
                   <a:schemeClr val="accent5"/>
                 </a:solidFill>
               </a:rPr>
-              <a:t>*Rev. 11</a:t>
+              <a:t>{{#F97}}</a:t>
             </a:r>
             <a:endParaRPr lang="es-PE" sz="1400" dirty="0">
               <a:solidFill>
@@ -26190,7 +25978,7 @@
                 <a:cs typeface="Candara"/>
                 <a:sym typeface="Candara"/>
               </a:rPr>
-              <a:t>{{#F58}}</a:t>
+              <a:t>{{#F102}}</a:t>
             </a:r>
             <a:endParaRPr kumimoji="0" lang="en-US" sz="1800" b="0" i="0" u="none" strike="noStrike" kern="0" cap="none" spc="0" normalizeH="0" baseline="0" noProof="0" dirty="0">
               <a:ln>
@@ -26414,7 +26202,7 @@
                         <a:srgbClr val="002060"/>
                       </a:solidFill>
                     </a:rPr>
-                    <a:t>{{#F54}}</a:t>
+                    <a:t>{{#F98}}</a:t>
                   </a:r>
                   <a:endParaRPr kumimoji="0" lang="es-PE" sz="3600" b="0" i="0" u="none" strike="noStrike" kern="1200" cap="none" spc="0" normalizeH="0" baseline="0" noProof="0" dirty="0">
                     <a:ln>
@@ -26493,7 +26281,7 @@
                       <a:ea typeface="+mn-ea"/>
                       <a:cs typeface="+mn-cs"/>
                     </a:rPr>
-                    <a:t>#FCL</a:t>
+                    <a:t>{{#F103}}</a:t>
                   </a:r>
                   <a:endParaRPr kumimoji="0" lang="es-PE" sz="1800" b="1" i="0" u="none" strike="noStrike" kern="1200" cap="none" spc="0" normalizeH="0" baseline="0" noProof="0" dirty="0">
                     <a:ln>
@@ -26649,7 +26437,7 @@
                     <a:ea typeface="+mn-ea"/>
                     <a:cs typeface="+mn-cs"/>
                   </a:rPr>
-                  <a:t>PROYECTADOS</a:t>
+                  <a:t>{{#F104}}</a:t>
                 </a:r>
               </a:p>
             </p:txBody>
@@ -26747,7 +26535,7 @@
                       </a:solidFill>
                       <a:latin typeface="Century Gothic" panose="020B0502020202020204" pitchFamily="34" charset="0"/>
                     </a:rPr>
-                    <a:t>{{#F55}}</a:t>
+                    <a:t>{{#F99}}</a:t>
                   </a:r>
                   <a:endParaRPr kumimoji="0" lang="es-PE" sz="3200" i="0" u="none" strike="noStrike" kern="1200" cap="none" spc="0" normalizeH="0" baseline="0" noProof="0" dirty="0">
                     <a:ln>
@@ -26826,16 +26614,7 @@
                       <a:ea typeface="+mn-ea"/>
                       <a:cs typeface="+mn-cs"/>
                     </a:rPr>
-                    <a:t># </a:t>
-                  </a:r>
-                  <a:r>
-                    <a:rPr lang="es-MX" b="1" dirty="0">
-                      <a:solidFill>
-                        <a:srgbClr val="000000"/>
-                      </a:solidFill>
-                      <a:latin typeface="Abadi ExtraLight" panose="020B0204020104020204" pitchFamily="34" charset="0"/>
-                    </a:rPr>
-                    <a:t>AWB</a:t>
+                    <a:t>{{#F105}}</a:t>
                   </a:r>
                   <a:endParaRPr kumimoji="0" lang="es-PE" sz="1800" b="1" i="0" u="none" strike="noStrike" kern="1200" cap="none" spc="0" normalizeH="0" baseline="0" noProof="0" dirty="0">
                     <a:ln>
@@ -26991,24 +26770,7 @@
                     <a:ea typeface="+mn-ea"/>
                     <a:cs typeface="+mn-cs"/>
                   </a:rPr>
-                  <a:t>EJECUTADOS </a:t>
-                </a:r>
-                <a:r>
-                  <a:rPr kumimoji="0" lang="es-MX" sz="1400" b="1" i="0" u="sng" strike="noStrike" kern="1200" cap="none" spc="0" normalizeH="0" baseline="0" noProof="0" dirty="0">
-                    <a:ln>
-                      <a:noFill/>
-                    </a:ln>
-                    <a:solidFill>
-                      <a:srgbClr val="000000"/>
-                    </a:solidFill>
-                    <a:effectLst/>
-                    <a:uLnTx/>
-                    <a:uFillTx/>
-                    <a:latin typeface="Abadi ExtraLight" panose="020B0204020104020204" pitchFamily="34" charset="0"/>
-                    <a:ea typeface="+mn-ea"/>
-                    <a:cs typeface="+mn-cs"/>
-                  </a:rPr>
-                  <a:t>AE</a:t>
+                  <a:t>{{#F106}}</a:t>
                 </a:r>
                 <a:endParaRPr kumimoji="0" lang="es-PE" sz="1400" b="1" i="0" u="sng" strike="noStrike" kern="1200" cap="none" spc="0" normalizeH="0" baseline="0" noProof="0" dirty="0">
                   <a:ln>
@@ -27092,7 +26854,7 @@
                   <a:ea typeface="+mn-ea"/>
                   <a:cs typeface="+mn-cs"/>
                 </a:rPr>
-                <a:t>DESPACHOS </a:t>
+                <a:t>{{#F107}}</a:t>
               </a:r>
               <a:endParaRPr kumimoji="0" lang="es-PE" sz="1800" b="1" i="0" u="none" strike="noStrike" kern="1200" cap="none" spc="0" normalizeH="0" baseline="0" noProof="0" dirty="0">
                 <a:ln>
@@ -27267,7 +27029,7 @@
                     <a:ea typeface="+mn-ea"/>
                     <a:cs typeface="+mn-cs"/>
                   </a:rPr>
-                  <a:t>AVANCE DE CAMPAÑA</a:t>
+                  <a:t>{{#F108}}</a:t>
                 </a:r>
                 <a:endParaRPr kumimoji="0" lang="es-PE" sz="1600" b="0" i="0" u="sng" strike="noStrike" kern="1200" cap="none" spc="0" normalizeH="0" baseline="0" noProof="0" dirty="0">
                   <a:ln>
@@ -27338,7 +27100,7 @@
                     </a:solidFill>
                     <a:latin typeface="Century Gothic" panose="020B0502020202020204" pitchFamily="34" charset="0"/>
                   </a:rPr>
-                  <a:t>{{#F56}}</a:t>
+                  <a:t>{{#F100}}</a:t>
                 </a:r>
               </a:p>
             </p:txBody>
@@ -27379,7 +27141,7 @@
                   <a:schemeClr val="accent5"/>
                 </a:solidFill>
               </a:rPr>
-              <a:t>*Proyectado Rev. 11</a:t>
+              <a:t>{{#F109}}</a:t>
             </a:r>
             <a:endParaRPr lang="es-PE" sz="1400" dirty="0">
               <a:solidFill>
@@ -27423,7 +27185,7 @@
                   <a:schemeClr val="accent5"/>
                 </a:solidFill>
               </a:rPr>
-              <a:t>{{#F59}}</a:t>
+              <a:t>{{#F110}}</a:t>
             </a:r>
             <a:endParaRPr lang="es-PE" sz="1400" dirty="0">
               <a:solidFill>
@@ -27493,7 +27255,7 @@
                 <a:ea typeface="+mn-ea"/>
                 <a:cs typeface="+mn-cs"/>
               </a:rPr>
-              <a:t>{{#F57}}</a:t>
+              <a:t>{{#F101}}</a:t>
             </a:r>
             <a:endParaRPr kumimoji="0" lang="es-PE" sz="3200" i="0" u="none" strike="noStrike" kern="1200" cap="none" spc="0" normalizeH="0" baseline="0" noProof="0" dirty="0">
               <a:ln>
@@ -27572,7 +27334,7 @@
                 <a:ea typeface="+mn-ea"/>
                 <a:cs typeface="+mn-cs"/>
               </a:rPr>
-              <a:t># FCL</a:t>
+              <a:t>{{#F111}}</a:t>
             </a:r>
             <a:endParaRPr kumimoji="0" lang="es-PE" sz="1800" b="1" i="0" u="none" strike="noStrike" kern="1200" cap="none" spc="0" normalizeH="0" baseline="0" noProof="0" dirty="0">
               <a:ln>
@@ -27727,16 +27489,7 @@
                 <a:ea typeface="+mn-ea"/>
                 <a:cs typeface="+mn-cs"/>
               </a:rPr>
-              <a:t>EJECUTADOS </a:t>
-            </a:r>
-            <a:r>
-              <a:rPr lang="es-MX" sz="1400" b="1" u="sng" dirty="0">
-                <a:solidFill>
-                  <a:srgbClr val="000000"/>
-                </a:solidFill>
-                <a:latin typeface="Abadi ExtraLight" panose="020B0204020104020204" pitchFamily="34" charset="0"/>
-              </a:rPr>
-              <a:t>MA</a:t>
+              <a:t>{{#F112}}</a:t>
             </a:r>
             <a:endParaRPr kumimoji="0" lang="es-PE" sz="1400" b="1" i="0" u="sng" strike="noStrike" kern="1200" cap="none" spc="0" normalizeH="0" baseline="0" noProof="0" dirty="0">
               <a:ln>
@@ -27857,37 +27610,7 @@
                 <a:cs typeface="Candara"/>
                 <a:sym typeface="Candara"/>
               </a:rPr>
-              <a:t>4</a:t>
-            </a:r>
-            <a:r>
-              <a:rPr kumimoji="0" lang="es-MX" sz="2000" b="1" i="1" u="none" strike="noStrike" kern="1200" cap="none" spc="0" normalizeH="0" baseline="0" noProof="0" dirty="0">
-                <a:ln>
-                  <a:noFill/>
-                </a:ln>
-                <a:solidFill>
-                  <a:srgbClr val="12781C"/>
-                </a:solidFill>
-                <a:effectLst/>
-                <a:uLnTx/>
-                <a:uFillTx/>
-                <a:latin typeface="Candara"/>
-                <a:ea typeface="Candara"/>
-                <a:cs typeface="Candara"/>
-                <a:sym typeface="Candara"/>
-              </a:rPr>
-              <a:t>.  </a:t>
-            </a:r>
-            <a:r>
-              <a:rPr lang="es-MX" sz="2000" b="1" i="1" dirty="0">
-                <a:solidFill>
-                  <a:srgbClr val="12781C"/>
-                </a:solidFill>
-                <a:latin typeface="Candara"/>
-                <a:ea typeface="Candara"/>
-                <a:cs typeface="Candara"/>
-                <a:sym typeface="Candara"/>
-              </a:rPr>
-              <a:t>Mano de Obra – Calidad / Ratio de Reclamos</a:t>
+              <a:t>{{#F122}}</a:t>
             </a:r>
             <a:endParaRPr kumimoji="0" lang="en-US" sz="1800" b="0" i="0" u="none" strike="noStrike" kern="0" cap="none" spc="0" normalizeH="0" baseline="0" noProof="0" dirty="0">
               <a:ln>
@@ -28101,24 +27824,7 @@
                     <a:ea typeface="+mn-ea"/>
                     <a:cs typeface="Aparajita" panose="020B0502040204020203" pitchFamily="18" charset="0"/>
                   </a:rPr>
-                  <a:t>P</a:t>
-                </a:r>
-                <a:r>
-                  <a:rPr kumimoji="0" lang="es-PE" sz="1400" b="1" i="0" u="sng" strike="noStrike" kern="1200" cap="none" spc="0" normalizeH="0" baseline="0" noProof="0" dirty="0">
-                    <a:ln>
-                      <a:noFill/>
-                    </a:ln>
-                    <a:solidFill>
-                      <a:srgbClr val="000000"/>
-                    </a:solidFill>
-                    <a:effectLst/>
-                    <a:uLnTx/>
-                    <a:uFillTx/>
-                    <a:latin typeface="Aptos Light" panose="020B0004020202020204" pitchFamily="34" charset="0"/>
-                    <a:ea typeface="+mn-ea"/>
-                    <a:cs typeface="Aparajita" panose="020B0502040204020203" pitchFamily="18" charset="0"/>
-                  </a:rPr>
-                  <a:t>ERSONAS PLANILLADAS</a:t>
+                  <a:t>{{#F123}}</a:t>
                 </a:r>
               </a:p>
             </p:txBody>
@@ -28320,7 +28026,7 @@
                       <a:ea typeface="+mn-ea"/>
                       <a:cs typeface="+mn-cs"/>
                     </a:rPr>
-                    <a:t>{{#F60}}</a:t>
+                    <a:t>{{#F113}}</a:t>
                   </a:r>
                 </a:p>
               </p:txBody>
@@ -28385,7 +28091,7 @@
                       <a:ea typeface="+mn-ea"/>
                       <a:cs typeface="+mn-cs"/>
                     </a:rPr>
-                    <a:t>Objetivo: 0.016</a:t>
+                    <a:t>{{#F124}}</a:t>
                   </a:r>
                 </a:p>
               </p:txBody>
@@ -28450,7 +28156,7 @@
                       <a:ea typeface="+mn-ea"/>
                       <a:cs typeface="+mn-cs"/>
                     </a:rPr>
-                    <a:t>{{#F61}}</a:t>
+                    <a:t>{{#F114}}</a:t>
                   </a:r>
                 </a:p>
               </p:txBody>
@@ -28592,7 +28298,7 @@
                     <a:ea typeface="+mn-ea"/>
                     <a:cs typeface="+mn-cs"/>
                   </a:rPr>
-                  <a:t>AVANCE DE CAMPAÑA</a:t>
+                  <a:t>{{#F125}}</a:t>
                 </a:r>
               </a:p>
             </p:txBody>
@@ -28698,7 +28404,7 @@
                       <a:ea typeface="+mn-ea"/>
                       <a:cs typeface="+mn-cs"/>
                     </a:rPr>
-                    <a:t>Objetivo: 0.016</a:t>
+                    <a:t>{{#F126}}</a:t>
                   </a:r>
                 </a:p>
               </p:txBody>
@@ -28763,7 +28469,7 @@
                       <a:ea typeface="+mn-ea"/>
                       <a:cs typeface="+mn-cs"/>
                     </a:rPr>
-                    <a:t>{{#F62}}</a:t>
+                    <a:t>{{#F115}}</a:t>
                   </a:r>
                 </a:p>
               </p:txBody>
@@ -28913,7 +28619,7 @@
                     <a:ea typeface="+mn-ea"/>
                     <a:cs typeface="+mn-cs"/>
                   </a:rPr>
-                  <a:t>{{#F69}}</a:t>
+                  <a:t>{{#F127}}</a:t>
                 </a:r>
                 <a:endParaRPr kumimoji="0" lang="es-PE" sz="1600" b="0" i="0" u="sng" strike="noStrike" kern="1200" cap="none" spc="0" normalizeH="0" baseline="0" noProof="0" dirty="0">
                   <a:ln>
@@ -28998,7 +28704,7 @@
                   <a:ea typeface="+mn-ea"/>
                   <a:cs typeface="+mn-cs"/>
                 </a:rPr>
-                <a:t>Mano de Obra/Personal – Calidad 2026</a:t>
+                <a:t>{{#F128}}</a:t>
               </a:r>
               <a:endParaRPr kumimoji="0" lang="es-PE" sz="1800" b="1" i="0" u="none" strike="noStrike" kern="1200" cap="none" spc="0" normalizeH="0" baseline="0" noProof="0" dirty="0">
                 <a:ln>
@@ -29089,7 +28795,7 @@
                   <a:ea typeface="+mn-ea"/>
                   <a:cs typeface="+mn-cs"/>
                 </a:rPr>
-                <a:t>{{#F63}}</a:t>
+                <a:t>{{#F116}}</a:t>
               </a:r>
             </a:p>
           </p:txBody>
@@ -29166,7 +28872,7 @@
                   <a:ea typeface="+mn-ea"/>
                   <a:cs typeface="+mn-cs"/>
                 </a:rPr>
-                <a:t>{{#F64}}</a:t>
+                <a:t>{{#F117}}</a:t>
               </a:r>
               <a:endParaRPr kumimoji="0" lang="es-PE" sz="3600" b="0" i="0" u="none" strike="noStrike" kern="1200" cap="none" spc="0" normalizeH="0" baseline="0" noProof="0" dirty="0">
                 <a:ln>
@@ -29245,7 +28951,7 @@
                   <a:ea typeface="+mn-ea"/>
                   <a:cs typeface="+mn-cs"/>
                 </a:rPr>
-                <a:t>{{#F70}}</a:t>
+                <a:t>{{#F129}}</a:t>
               </a:r>
               <a:endParaRPr kumimoji="0" lang="es-PE" sz="1600" b="0" i="0" u="sng" strike="noStrike" kern="1200" cap="none" spc="0" normalizeH="0" baseline="0" noProof="0" dirty="0">
                 <a:ln>
@@ -29324,7 +29030,7 @@
                   <a:ea typeface="+mn-ea"/>
                   <a:cs typeface="Aparajita" panose="020B0502040204020203" pitchFamily="18" charset="0"/>
                 </a:rPr>
-                <a:t>MANO DE OBRA</a:t>
+                <a:t>{{#F130}}</a:t>
               </a:r>
               <a:endParaRPr kumimoji="0" lang="es-PE" sz="1400" b="1" i="0" u="sng" strike="noStrike" kern="1200" cap="none" spc="0" normalizeH="0" baseline="0" noProof="0" dirty="0">
                 <a:ln>
@@ -29580,7 +29286,7 @@
                         <a:ea typeface="+mn-ea"/>
                         <a:cs typeface="+mn-cs"/>
                       </a:rPr>
-                      <a:t>{{#F65}}</a:t>
+                      <a:t>{{#F118}}</a:t>
                     </a:r>
                   </a:p>
                 </p:txBody>
@@ -29645,7 +29351,7 @@
                         <a:ea typeface="+mn-ea"/>
                         <a:cs typeface="+mn-cs"/>
                       </a:rPr>
-                      <a:t>Objetivo: 0.5%</a:t>
+                      <a:t>{{#F131}}</a:t>
                     </a:r>
                   </a:p>
                 </p:txBody>
@@ -29710,7 +29416,7 @@
                         <a:ea typeface="+mn-ea"/>
                         <a:cs typeface="+mn-cs"/>
                       </a:rPr>
-                      <a:t>{{#F66}}</a:t>
+                      <a:t>{{#F119}}</a:t>
                     </a:r>
                   </a:p>
                 </p:txBody>
@@ -29844,24 +29550,7 @@
                       </a:solidFill>
                       <a:latin typeface="Abadi ExtraLight" panose="020B0204020104020204" pitchFamily="34" charset="0"/>
                     </a:rPr>
-                    <a:t>AÑO</a:t>
-                  </a:r>
-                  <a:r>
-                    <a:rPr kumimoji="0" lang="es-PE" sz="1600" b="0" i="0" u="sng" strike="noStrike" kern="1200" cap="none" spc="0" normalizeH="0" baseline="0" noProof="0" dirty="0">
-                      <a:ln>
-                        <a:noFill/>
-                      </a:ln>
-                      <a:solidFill>
-                        <a:srgbClr val="000000"/>
-                      </a:solidFill>
-                      <a:effectLst/>
-                      <a:uLnTx/>
-                      <a:uFillTx/>
-                      <a:latin typeface="Abadi ExtraLight" panose="020B0204020104020204" pitchFamily="34" charset="0"/>
-                      <a:ea typeface="+mn-ea"/>
-                      <a:cs typeface="+mn-cs"/>
-                    </a:rPr>
-                    <a:t> 2026</a:t>
+                    <a:t>{{#F132}}</a:t>
                   </a:r>
                 </a:p>
               </p:txBody>
@@ -30031,7 +29720,7 @@
                       <a:ea typeface="+mn-ea"/>
                       <a:cs typeface="+mn-cs"/>
                     </a:rPr>
-                    <a:t>Monto Penalizado</a:t>
+                    <a:t>{{#F133}}</a:t>
                   </a:r>
                   <a:endParaRPr kumimoji="0" lang="es-PE" sz="1600" b="0" i="0" u="sng" strike="noStrike" kern="1200" cap="none" spc="0" normalizeH="0" baseline="0" noProof="0" dirty="0">
                     <a:ln>
@@ -30116,33 +29805,7 @@
                     <a:ea typeface="+mn-ea"/>
                     <a:cs typeface="+mn-cs"/>
                   </a:rPr>
-                  <a:t>Ratio de reclamos penalizados – </a:t>
-                </a:r>
-                <a:r>
-                  <a:rPr lang="es-MX" b="1" dirty="0">
-                    <a:solidFill>
-                      <a:prstClr val="black"/>
-                    </a:solidFill>
-                    <a:latin typeface="Calibri" panose="020F0502020204030204"/>
-                  </a:rPr>
-                  <a:t>A</a:t>
-                </a:r>
-                <a:r>
-                  <a:rPr kumimoji="0" lang="es-MX" sz="1800" b="1" i="0" u="none" strike="noStrike" kern="1200" cap="none" spc="0" normalizeH="0" baseline="0" noProof="0" dirty="0">
-                    <a:ln>
-                      <a:noFill/>
-                    </a:ln>
-                    <a:solidFill>
-                      <a:prstClr val="black"/>
-                    </a:solidFill>
-                    <a:effectLst/>
-                    <a:uLnTx/>
-                    <a:uFillTx/>
-                    <a:latin typeface="Calibri" panose="020F0502020204030204"/>
-                    <a:ea typeface="+mn-ea"/>
-                    <a:cs typeface="+mn-cs"/>
-                  </a:rPr>
-                  <a:t> 2026</a:t>
+                  <a:t>{{#F134}}</a:t>
                 </a:r>
                 <a:endParaRPr kumimoji="0" lang="es-PE" sz="1800" b="1" i="0" u="none" strike="noStrike" kern="1200" cap="none" spc="0" normalizeH="0" baseline="0" noProof="0" dirty="0">
                   <a:ln>
@@ -30224,7 +29887,7 @@
                       <a:srgbClr val="FF0000"/>
                     </a:solidFill>
                   </a:rPr>
-                  <a:t>{{#F67}}</a:t>
+                  <a:t>{{#F120}}</a:t>
                 </a:r>
               </a:p>
             </p:txBody>
@@ -30288,7 +29951,7 @@
                 </a:pPr>
                 <a:r>
                   <a:rPr lang="es-PE" sz="3200" dirty="0"/>
-                  <a:t>{{#F68}}</a:t>
+                  <a:t>{{#F121}}</a:t>
                 </a:r>
               </a:p>
             </p:txBody>
@@ -30353,7 +30016,7 @@
                     <a:ea typeface="+mn-ea"/>
                     <a:cs typeface="+mn-cs"/>
                   </a:rPr>
-                  <a:t>Venta $</a:t>
+                  <a:t>{{#F135}}</a:t>
                 </a:r>
               </a:p>
             </p:txBody>
@@ -30418,7 +30081,7 @@
                     <a:ea typeface="+mn-ea"/>
                     <a:cs typeface="+mn-cs"/>
                   </a:rPr>
-                  <a:t>Venta</a:t>
+                  <a:t>{{#F136}}</a:t>
                 </a:r>
                 <a:endParaRPr kumimoji="0" lang="es-PE" sz="1600" b="0" i="0" u="sng" strike="noStrike" kern="1200" cap="none" spc="0" normalizeH="0" baseline="0" noProof="0" dirty="0">
                   <a:ln>
@@ -30498,7 +30161,7 @@
                   <a:ea typeface="+mn-ea"/>
                   <a:cs typeface="+mn-cs"/>
                 </a:rPr>
-                <a:t>Penalizado $</a:t>
+                <a:t>{{#F137}}</a:t>
               </a:r>
             </a:p>
           </p:txBody>
@@ -30538,7 +30201,7 @@
                   <a:schemeClr val="accent5"/>
                 </a:solidFill>
               </a:rPr>
-              <a:t>*Indicadores extraídos de: 1.3 Informe Gerencial Reclamo de Clientes (JM). Información del mes de Julio - Agosto</a:t>
+              <a:t>{{#F138}}</a:t>
             </a:r>
             <a:endParaRPr lang="es-PE" sz="1400" dirty="0">
               <a:solidFill>
@@ -30582,7 +30245,7 @@
                   <a:schemeClr val="accent5"/>
                 </a:solidFill>
               </a:rPr>
-              <a:t>{{#F71}}</a:t>
+              <a:t>{{#F139}}</a:t>
             </a:r>
             <a:endParaRPr lang="es-PE" sz="1400" dirty="0">
               <a:solidFill>
@@ -31069,7 +30732,7 @@
                   <a:srgbClr val="080808"/>
                 </a:solidFill>
               </a:rPr>
-              <a:t>{{#F72}}</a:t>
+              <a:t>{{#F140}}</a:t>
             </a:r>
             <a:endParaRPr lang="es-PE" sz="3600" b="1" dirty="0">
               <a:solidFill>
@@ -31115,7 +30778,7 @@
                   <a:srgbClr val="080808"/>
                 </a:solidFill>
               </a:rPr>
-              <a:t>Aseguramiento de la Calidad Fresco</a:t>
+              <a:t>{{#F141}}</a:t>
             </a:r>
             <a:endParaRPr lang="es-PE" sz="2000" dirty="0">
               <a:solidFill>
@@ -31867,7 +31530,7 @@
                 <a:cs typeface="Candara"/>
                 <a:sym typeface="Candara"/>
               </a:rPr>
-              <a:t>5.  Recepción de Espárrago </a:t>
+              <a:t>{{#F146}}</a:t>
             </a:r>
             <a:endParaRPr lang="en-US" kern="0" dirty="0">
               <a:solidFill>
@@ -32051,7 +31714,7 @@
                 <a:ea typeface="ADLaM Display" panose="02010000000000000000" pitchFamily="2" charset="0"/>
                 <a:cs typeface="ADLaM Display" panose="02010000000000000000" pitchFamily="2" charset="0"/>
               </a:rPr>
-              <a:t>{{#F75}}</a:t>
+              <a:t>{{#F144}}</a:t>
             </a:r>
             <a:endParaRPr lang="es-PE" sz="2400" dirty="0">
               <a:solidFill>
@@ -32104,7 +31767,7 @@
                 <a:ea typeface="ADLaM Display" panose="02010000000000000000" pitchFamily="2" charset="0"/>
                 <a:cs typeface="ADLaM Display" panose="02010000000000000000" pitchFamily="2" charset="0"/>
               </a:rPr>
-              <a:t>{{#F76}}</a:t>
+              <a:t>{{#F145}}</a:t>
             </a:r>
             <a:endParaRPr lang="es-PE" sz="2400" dirty="0">
               <a:solidFill>
@@ -32261,7 +31924,7 @@
                   <a:latin typeface="Arial" panose="020B0604020202020204" pitchFamily="34" charset="0"/>
                   <a:cs typeface="Arial" panose="020B0604020202020204" pitchFamily="34" charset="0"/>
                 </a:rPr>
-                <a:t>{{#F73}}</a:t>
+                <a:t>{{#F142}}</a:t>
               </a:r>
               <a:endParaRPr lang="es-PE" sz="1600" b="1" dirty="0">
                 <a:solidFill>
@@ -32311,7 +31974,7 @@
                     </a:schemeClr>
                   </a:solidFill>
                 </a:rPr>
-                <a:t>KILOS RECEPCIONADOS</a:t>
+                <a:t>{{#F147}}</a:t>
               </a:r>
               <a:endParaRPr lang="es-PE" dirty="0">
                 <a:solidFill>
@@ -32468,7 +32131,7 @@
                   <a:latin typeface="Arial" panose="020B0604020202020204" pitchFamily="34" charset="0"/>
                   <a:cs typeface="Arial" panose="020B0604020202020204" pitchFamily="34" charset="0"/>
                 </a:rPr>
-                <a:t>{{#F74}}</a:t>
+                <a:t>{{#F143}}</a:t>
               </a:r>
               <a:endParaRPr lang="es-PE" sz="1600" b="1" dirty="0">
                 <a:solidFill>
@@ -32518,7 +32181,7 @@
                     </a:schemeClr>
                   </a:solidFill>
                 </a:rPr>
-                <a:t>KILOS EN STOCK</a:t>
+                <a:t>{{#F148}}</a:t>
               </a:r>
               <a:endParaRPr lang="es-PE" dirty="0">
                 <a:solidFill>
@@ -32696,7 +32359,7 @@
                             <a:srgbClr val="262626"/>
                           </a:solidFill>
                         </a:rPr>
-                        <a:t>{{#F77}}</a:t>
+                        <a:t>{{#F149}}</a:t>
                       </a:r>
                       <a:endParaRPr lang="es-PE" sz="1000"/>
                     </a:p>
@@ -32737,7 +32400,7 @@
                             <a:srgbClr val="262626"/>
                           </a:solidFill>
                         </a:rPr>
-                        <a:t>{{#F78}}</a:t>
+                        <a:t>{{#F150}}</a:t>
                       </a:r>
                       <a:endParaRPr lang="es-PE" sz="1000"/>
                     </a:p>
@@ -32778,7 +32441,7 @@
                             <a:srgbClr val="262626"/>
                           </a:solidFill>
                         </a:rPr>
-                        <a:t>{{#F79}}</a:t>
+                        <a:t>{{#F151}}</a:t>
                       </a:r>
                       <a:endParaRPr lang="es-PE" sz="1000"/>
                     </a:p>
@@ -32821,7 +32484,7 @@
                             <a:srgbClr val="262626"/>
                           </a:solidFill>
                         </a:rPr>
-                        <a:t>{{#F80}}</a:t>
+                        <a:t>{{#F152}}</a:t>
                       </a:r>
                       <a:endParaRPr lang="es-PE" sz="1000"/>
                     </a:p>
@@ -32862,7 +32525,7 @@
                             <a:srgbClr val="262626"/>
                           </a:solidFill>
                         </a:rPr>
-                        <a:t>{{#F81}}</a:t>
+                        <a:t>{{#F153}}</a:t>
                       </a:r>
                       <a:endParaRPr lang="es-PE" sz="1000"/>
                     </a:p>
@@ -32903,7 +32566,7 @@
                             <a:srgbClr val="262626"/>
                           </a:solidFill>
                         </a:rPr>
-                        <a:t>{{#F82}}</a:t>
+                        <a:t>{{#F154}}</a:t>
                       </a:r>
                       <a:endParaRPr lang="es-PE" sz="1000"/>
                     </a:p>
@@ -32946,7 +32609,7 @@
                             <a:srgbClr val="262626"/>
                           </a:solidFill>
                         </a:rPr>
-                        <a:t>{{#F83}}</a:t>
+                        <a:t>{{#F155}}</a:t>
                       </a:r>
                       <a:endParaRPr lang="es-PE" sz="1000"/>
                     </a:p>
@@ -32987,7 +32650,7 @@
                             <a:srgbClr val="262626"/>
                           </a:solidFill>
                         </a:rPr>
-                        <a:t>{{#F84}}</a:t>
+                        <a:t>{{#F156}}</a:t>
                       </a:r>
                       <a:endParaRPr lang="es-PE" sz="1000"/>
                     </a:p>
@@ -33028,7 +32691,7 @@
                             <a:srgbClr val="262626"/>
                           </a:solidFill>
                         </a:rPr>
-                        <a:t>{{#F85}}</a:t>
+                        <a:t>{{#F157}}</a:t>
                       </a:r>
                       <a:endParaRPr lang="es-PE" sz="1000"/>
                     </a:p>
@@ -33071,7 +32734,7 @@
                             <a:srgbClr val="262626"/>
                           </a:solidFill>
                         </a:rPr>
-                        <a:t>{{#F86}}</a:t>
+                        <a:t>{{#F158}}</a:t>
                       </a:r>
                       <a:endParaRPr lang="es-PE" sz="1000"/>
                     </a:p>
@@ -33112,7 +32775,7 @@
                             <a:srgbClr val="262626"/>
                           </a:solidFill>
                         </a:rPr>
-                        <a:t>{{#F87}}</a:t>
+                        <a:t>{{#F159}}</a:t>
                       </a:r>
                       <a:endParaRPr lang="es-PE" sz="1000"/>
                     </a:p>
@@ -33153,7 +32816,7 @@
                             <a:srgbClr val="262626"/>
                           </a:solidFill>
                         </a:rPr>
-                        <a:t>{{#F88}}</a:t>
+                        <a:t>{{#F160}}</a:t>
                       </a:r>
                       <a:endParaRPr lang="es-PE" sz="1000"/>
                     </a:p>
@@ -33295,19 +32958,7 @@
                 <a:cs typeface="Candara"/>
                 <a:sym typeface="Candara"/>
               </a:rPr>
-              <a:t>2. Indicadores de </a:t>
-            </a:r>
-            <a:r>
-              <a:rPr lang="es-MX" sz="2000" b="1" i="1" dirty="0">
-                <a:solidFill>
-                  <a:srgbClr val="12781C"/>
-                </a:solidFill>
-                <a:latin typeface="Candara"/>
-                <a:ea typeface="Candara"/>
-                <a:cs typeface="Candara"/>
-                <a:sym typeface="Candara"/>
-              </a:rPr>
-              <a:t>Calidad MMPP   - COMPOSITAN</a:t>
+              <a:t>{{#F175}}</a:t>
             </a:r>
             <a:endParaRPr kumimoji="0" lang="en-US" sz="1800" b="0" i="0" u="none" strike="noStrike" kern="0" cap="none" spc="0" normalizeH="0" baseline="0" noProof="0" dirty="0">
               <a:ln>
@@ -33576,16 +33227,7 @@
                     </a:solidFill>
                     <a:latin typeface="Abadi ExtraLight" panose="020B0204020104020204" pitchFamily="34" charset="0"/>
                   </a:rPr>
-                  <a:t>S</a:t>
-                </a:r>
-                <a:r>
-                  <a:rPr lang="es-PE" sz="1100" b="1" u="sng" dirty="0">
-                    <a:solidFill>
-                      <a:srgbClr val="000000"/>
-                    </a:solidFill>
-                    <a:latin typeface="Abadi ExtraLight" panose="020B0204020104020204" pitchFamily="34" charset="0"/>
-                  </a:rPr>
-                  <a:t>EMAFORIZACIÓN ELASMOSPALPUS</a:t>
+                  <a:t>{{#F176}}</a:t>
                 </a:r>
                 <a:endParaRPr kumimoji="0" lang="es-PE" sz="1100" b="1" i="0" u="sng" strike="noStrike" kern="1200" cap="none" spc="0" normalizeH="0" baseline="0" noProof="0" dirty="0">
                   <a:ln>
@@ -33661,7 +33303,7 @@
                   </a:solidFill>
                   <a:latin typeface="Calibri" panose="020F0502020204030204"/>
                 </a:rPr>
-                <a:t>FITOSANITARIOS</a:t>
+                <a:t>{{#F177}}</a:t>
               </a:r>
               <a:endParaRPr kumimoji="0" lang="es-PE" sz="1800" b="1" i="0" u="none" strike="noStrike" kern="1200" cap="none" spc="0" normalizeH="0" baseline="0" noProof="0" dirty="0">
                 <a:ln>
@@ -33741,7 +33383,7 @@
                 <a:ea typeface="+mn-ea"/>
                 <a:cs typeface="+mn-cs"/>
               </a:rPr>
-              <a:t>{{#F103}}</a:t>
+              <a:t>{{#F178}}</a:t>
             </a:r>
             <a:endParaRPr kumimoji="0" lang="es-PE" sz="1400" b="0" i="0" u="none" strike="noStrike" kern="1200" cap="none" spc="0" normalizeH="0" baseline="0" noProof="0" dirty="0">
               <a:ln>
@@ -33816,7 +33458,7 @@
                 </a:solidFill>
                 <a:latin typeface="Calibri" panose="020F0502020204030204"/>
               </a:rPr>
-              <a:t>CALIDADES Y CALIBRES</a:t>
+              <a:t>{{#F179}}</a:t>
             </a:r>
             <a:endParaRPr kumimoji="0" lang="es-PE" sz="1800" b="1" i="0" u="none" strike="noStrike" kern="1200" cap="none" spc="0" normalizeH="0" baseline="0" noProof="0" dirty="0">
               <a:ln>
@@ -33895,7 +33537,7 @@
                 <a:ea typeface="+mn-ea"/>
                 <a:cs typeface="+mn-cs"/>
               </a:rPr>
-              <a:t>{{#F104}}</a:t>
+              <a:t>{{#F180}}</a:t>
             </a:r>
             <a:endParaRPr kumimoji="0" lang="es-PE" sz="1400" b="0" i="0" u="none" strike="noStrike" kern="1200" cap="none" spc="0" normalizeH="0" baseline="0" noProof="0" dirty="0">
               <a:ln>
@@ -34050,7 +33692,7 @@
                 <a:ea typeface="+mn-ea"/>
                 <a:cs typeface="+mn-cs"/>
               </a:rPr>
-              <a:t>POSTURAS</a:t>
+              <a:t>{{#F181}}</a:t>
             </a:r>
             <a:endParaRPr kumimoji="0" lang="es-PE" sz="1100" b="1" i="0" u="sng" strike="noStrike" kern="1200" cap="none" spc="0" normalizeH="0" baseline="0" noProof="0" dirty="0">
               <a:ln>
@@ -34197,7 +33839,7 @@
                 </a:solidFill>
                 <a:latin typeface="Abadi ExtraLight" panose="020B0204020104020204" pitchFamily="34" charset="0"/>
               </a:rPr>
-              <a:t>LEPIDOPTERA</a:t>
+              <a:t>{{#F182}}</a:t>
             </a:r>
             <a:endParaRPr kumimoji="0" lang="es-PE" sz="1100" b="1" i="0" u="sng" strike="noStrike" kern="1200" cap="none" spc="0" normalizeH="0" baseline="0" noProof="0" dirty="0">
               <a:ln>
@@ -34352,7 +33994,7 @@
                 <a:ea typeface="+mn-ea"/>
                 <a:cs typeface="+mn-cs"/>
               </a:rPr>
-              <a:t>PRODIPLOSIS</a:t>
+              <a:t>{{#F183}}</a:t>
             </a:r>
             <a:endParaRPr kumimoji="0" lang="es-PE" sz="1100" b="1" i="0" u="sng" strike="noStrike" kern="1200" cap="none" spc="0" normalizeH="0" baseline="0" noProof="0" dirty="0">
               <a:ln>
@@ -34423,7 +34065,7 @@
                 </a:solidFill>
                 <a:latin typeface="Abadi ExtraLight" panose="020B0204020104020204" pitchFamily="34" charset="0"/>
               </a:rPr>
-              <a:t>{{#F89}}</a:t>
+              <a:t>{{#F161}}</a:t>
             </a:r>
             <a:endParaRPr kumimoji="0" lang="es-PE" sz="1800" b="1" i="0" u="none" strike="noStrike" kern="1200" cap="none" spc="0" normalizeH="0" baseline="0" noProof="0" dirty="0">
               <a:ln>
@@ -34494,7 +34136,7 @@
                 </a:solidFill>
                 <a:latin typeface="Abadi ExtraLight" panose="020B0204020104020204" pitchFamily="34" charset="0"/>
               </a:rPr>
-              <a:t>{{#F90}}</a:t>
+              <a:t>{{#F162}}</a:t>
             </a:r>
             <a:endParaRPr kumimoji="0" lang="es-PE" sz="1800" b="1" i="0" u="none" strike="noStrike" kern="1200" cap="none" spc="0" normalizeH="0" baseline="0" noProof="0" dirty="0">
               <a:ln>
@@ -34565,7 +34207,7 @@
                 </a:solidFill>
                 <a:latin typeface="Abadi ExtraLight" panose="020B0204020104020204" pitchFamily="34" charset="0"/>
               </a:rPr>
-              <a:t>{{#F91}}</a:t>
+              <a:t>{{#F163}}</a:t>
             </a:r>
             <a:endParaRPr kumimoji="0" lang="es-PE" sz="1800" b="1" i="0" u="none" strike="noStrike" kern="1200" cap="none" spc="0" normalizeH="0" baseline="0" noProof="0" dirty="0">
               <a:ln>
@@ -34636,7 +34278,7 @@
                 </a:solidFill>
                 <a:latin typeface="Abadi ExtraLight" panose="020B0204020104020204" pitchFamily="34" charset="0"/>
               </a:rPr>
-              <a:t>{{#F92}}</a:t>
+              <a:t>{{#F164}}</a:t>
             </a:r>
             <a:endParaRPr kumimoji="0" lang="es-PE" sz="1800" b="1" i="0" u="none" strike="noStrike" kern="1200" cap="none" spc="0" normalizeH="0" baseline="0" noProof="0" dirty="0">
               <a:ln>
@@ -34707,7 +34349,7 @@
                 </a:solidFill>
                 <a:latin typeface="Abadi ExtraLight" panose="020B0204020104020204" pitchFamily="34" charset="0"/>
               </a:rPr>
-              <a:t>{{#F93}}</a:t>
+              <a:t>{{#F165}}</a:t>
             </a:r>
             <a:endParaRPr kumimoji="0" lang="es-PE" sz="1800" b="1" i="0" u="none" strike="noStrike" kern="1200" cap="none" spc="0" normalizeH="0" baseline="0" noProof="0" dirty="0">
               <a:ln>
@@ -34778,7 +34420,7 @@
                 </a:solidFill>
                 <a:latin typeface="Abadi ExtraLight" panose="020B0204020104020204" pitchFamily="34" charset="0"/>
               </a:rPr>
-              <a:t>{{#F94}}</a:t>
+              <a:t>{{#F166}}</a:t>
             </a:r>
             <a:endParaRPr kumimoji="0" lang="es-PE" sz="1800" b="1" i="0" u="none" strike="noStrike" kern="1200" cap="none" spc="0" normalizeH="0" baseline="0" noProof="0" dirty="0">
               <a:ln>
@@ -34849,7 +34491,7 @@
                 </a:solidFill>
                 <a:latin typeface="Abadi ExtraLight" panose="020B0204020104020204" pitchFamily="34" charset="0"/>
               </a:rPr>
-              <a:t>{{#F95}}</a:t>
+              <a:t>{{#F167}}</a:t>
             </a:r>
             <a:endParaRPr kumimoji="0" lang="es-PE" sz="1800" b="1" i="0" u="none" strike="noStrike" kern="1200" cap="none" spc="0" normalizeH="0" baseline="0" noProof="0" dirty="0">
               <a:ln>
@@ -34920,7 +34562,7 @@
                 </a:solidFill>
                 <a:latin typeface="Abadi ExtraLight" panose="020B0204020104020204" pitchFamily="34" charset="0"/>
               </a:rPr>
-              <a:t>{{#F96}}</a:t>
+              <a:t>{{#F168}}</a:t>
             </a:r>
             <a:endParaRPr kumimoji="0" lang="es-PE" sz="1800" b="1" i="0" u="none" strike="noStrike" kern="1200" cap="none" spc="0" normalizeH="0" baseline="0" noProof="0" dirty="0">
               <a:ln>
@@ -35001,7 +34643,7 @@
                 <a:ea typeface="+mn-ea"/>
                 <a:cs typeface="+mn-cs"/>
               </a:rPr>
-              <a:t>{{#F97}}</a:t>
+              <a:t>{{#F169}}</a:t>
             </a:r>
           </a:p>
         </p:txBody>
@@ -35134,7 +34776,7 @@
                 </a:solidFill>
                 <a:latin typeface="Abadi ExtraLight" panose="020B0204020104020204" pitchFamily="34" charset="0"/>
               </a:rPr>
-              <a:t>SMALL</a:t>
+              <a:t>{{#F184}}</a:t>
             </a:r>
             <a:endParaRPr kumimoji="0" lang="es-PE" sz="1400" b="0" i="0" u="sng" strike="noStrike" kern="1200" cap="none" spc="0" normalizeH="0" baseline="0" noProof="0" dirty="0">
               <a:ln>
@@ -35289,25 +34931,7 @@
                 <a:ea typeface="+mn-ea"/>
                 <a:cs typeface="+mn-cs"/>
               </a:rPr>
-              <a:t>L</a:t>
-            </a:r>
-            <a:r>
-              <a:rPr lang="es-MX" sz="1400" u="sng" dirty="0" err="1">
-                <a:solidFill>
-                  <a:srgbClr val="000000"/>
-                </a:solidFill>
-                <a:latin typeface="Abadi ExtraLight" panose="020B0204020104020204" pitchFamily="34" charset="0"/>
-              </a:rPr>
-              <a:t>ong</a:t>
-            </a:r>
-            <a:r>
-              <a:rPr lang="es-MX" sz="1400" u="sng" dirty="0">
-                <a:solidFill>
-                  <a:srgbClr val="000000"/>
-                </a:solidFill>
-                <a:latin typeface="Abadi ExtraLight" panose="020B0204020104020204" pitchFamily="34" charset="0"/>
-              </a:rPr>
-              <a:t> &gt;30</a:t>
+              <a:t>{{#F185}}</a:t>
             </a:r>
             <a:endParaRPr kumimoji="0" lang="es-PE" sz="1400" b="0" i="0" u="sng" strike="noStrike" kern="1200" cap="none" spc="0" normalizeH="0" baseline="0" noProof="0" dirty="0">
               <a:ln>
@@ -35454,7 +35078,7 @@
                 </a:solidFill>
                 <a:latin typeface="Abadi ExtraLight" panose="020B0204020104020204" pitchFamily="34" charset="0"/>
               </a:rPr>
-              <a:t>C- Y Ramas</a:t>
+              <a:t>{{#F186}}</a:t>
             </a:r>
             <a:endParaRPr kumimoji="0" lang="es-PE" sz="1400" b="0" i="0" u="sng" strike="noStrike" kern="1200" cap="none" spc="0" normalizeH="0" baseline="0" noProof="0" dirty="0">
               <a:ln>
@@ -35528,7 +35152,7 @@
                 </a:solidFill>
                 <a:latin typeface="Century Gothic" panose="020B0502020202020204" pitchFamily="34" charset="0"/>
               </a:rPr>
-              <a:t>Acumulado:</a:t>
+              <a:t>{{#F187}}</a:t>
             </a:r>
             <a:endParaRPr kumimoji="0" lang="es-PE" sz="1200" b="1" i="0" u="none" strike="noStrike" kern="1200" cap="none" spc="0" normalizeH="0" baseline="0" noProof="0" dirty="0">
               <a:ln>
@@ -35612,7 +35236,7 @@
                 <a:ea typeface="+mn-ea"/>
                 <a:cs typeface="+mn-cs"/>
               </a:rPr>
-              <a:t>{{#F98}}</a:t>
+              <a:t>{{#F170}}</a:t>
             </a:r>
           </a:p>
         </p:txBody>
@@ -35672,7 +35296,7 @@
                 </a:solidFill>
                 <a:latin typeface="Century Gothic" panose="020B0502020202020204" pitchFamily="34" charset="0"/>
               </a:rPr>
-              <a:t>{{#F105}}</a:t>
+              <a:t>{{#F188}}</a:t>
             </a:r>
             <a:endParaRPr kumimoji="0" lang="es-PE" sz="1200" b="1" i="0" u="none" strike="noStrike" kern="1200" cap="none" spc="0" normalizeH="0" baseline="0" noProof="0" dirty="0">
               <a:ln>
@@ -35748,7 +35372,7 @@
                 </a:solidFill>
                 <a:latin typeface="Century Gothic" panose="020B0502020202020204" pitchFamily="34" charset="0"/>
               </a:rPr>
-              <a:t>{{#F99}}</a:t>
+              <a:t>{{#F171}}</a:t>
             </a:r>
           </a:p>
         </p:txBody>
@@ -35808,7 +35432,7 @@
                 </a:solidFill>
                 <a:latin typeface="Century Gothic" panose="020B0502020202020204" pitchFamily="34" charset="0"/>
               </a:rPr>
-              <a:t>Acumulado:</a:t>
+              <a:t>{{#F189}}</a:t>
             </a:r>
             <a:endParaRPr kumimoji="0" lang="es-PE" sz="1200" b="1" i="0" u="none" strike="noStrike" kern="1200" cap="none" spc="0" normalizeH="0" baseline="0" noProof="0" dirty="0">
               <a:ln>
@@ -35892,7 +35516,7 @@
                 <a:ea typeface="+mn-ea"/>
                 <a:cs typeface="+mn-cs"/>
               </a:rPr>
-              <a:t>{{#F100}}</a:t>
+              <a:t>{{#F172}}</a:t>
             </a:r>
           </a:p>
         </p:txBody>
@@ -35952,7 +35576,7 @@
                 </a:solidFill>
                 <a:latin typeface="Century Gothic" panose="020B0502020202020204" pitchFamily="34" charset="0"/>
               </a:rPr>
-              <a:t>{{#F106}}</a:t>
+              <a:t>{{#F190}}</a:t>
             </a:r>
             <a:endParaRPr kumimoji="0" lang="es-PE" sz="1200" b="1" i="0" u="none" strike="noStrike" kern="1200" cap="none" spc="0" normalizeH="0" baseline="0" noProof="0" dirty="0">
               <a:ln>
@@ -36036,7 +35660,7 @@
                 <a:ea typeface="+mn-ea"/>
                 <a:cs typeface="+mn-cs"/>
               </a:rPr>
-              <a:t>{{#F101}}</a:t>
+              <a:t>{{#F173}}</a:t>
             </a:r>
           </a:p>
         </p:txBody>
@@ -36096,7 +35720,7 @@
                 </a:solidFill>
                 <a:latin typeface="Century Gothic" panose="020B0502020202020204" pitchFamily="34" charset="0"/>
               </a:rPr>
-              <a:t>Acumulado:</a:t>
+              <a:t>{{#F191}}</a:t>
             </a:r>
             <a:endParaRPr kumimoji="0" lang="es-PE" sz="1200" b="1" i="0" u="none" strike="noStrike" kern="1200" cap="none" spc="0" normalizeH="0" baseline="0" noProof="0" dirty="0">
               <a:ln>
@@ -36180,7 +35804,7 @@
                 <a:ea typeface="+mn-ea"/>
                 <a:cs typeface="+mn-cs"/>
               </a:rPr>
-              <a:t>{{#F102}}</a:t>
+              <a:t>{{#F174}}</a:t>
             </a:r>
           </a:p>
         </p:txBody>
@@ -36240,7 +35864,7 @@
                 </a:solidFill>
                 <a:latin typeface="Century Gothic" panose="020B0502020202020204" pitchFamily="34" charset="0"/>
               </a:rPr>
-              <a:t>{{#F107}}</a:t>
+              <a:t>{{#F192}}</a:t>
             </a:r>
             <a:endParaRPr kumimoji="0" lang="es-PE" sz="1200" b="1" i="0" u="none" strike="noStrike" kern="1200" cap="none" spc="0" normalizeH="0" baseline="0" noProof="0" dirty="0">
               <a:ln>
@@ -36264,7 +35888,7 @@
       </p:sp>
       <p:sp>
         <p:nvSpPr>
-          <p:cNvPr id="1008" name="Lineas 1008">
+          <p:cNvPr id="1093" name="Lineas 1093">
             <a:extLst>
               <a:ext uri="{FF2B5EF4-FFF2-40B4-BE49-F238E27FC236}">
                 <a16:creationId xmlns:a16="http://schemas.microsoft.com/office/drawing/2014/main" id="{B63E2792-6AF6-56E3-0D5E-3C4DAA9FAED3}"/>
@@ -36312,7 +35936,7 @@
                 </a:solidFill>
                 <a:latin typeface="Abadi ExtraLight" panose="020B0204020104020204" pitchFamily="34" charset="0"/>
               </a:rPr>
-              <a:t>{{#F108}}</a:t>
+              <a:t>{{#F193}}</a:t>
             </a:r>
             <a:endParaRPr kumimoji="0" lang="es-PE" sz="1800" b="1" i="0" u="none" strike="noStrike" kern="1200" cap="none" spc="0" normalizeH="0" baseline="0" noProof="0" dirty="0">
               <a:ln>
@@ -36333,7 +35957,7 @@
       </p:sp>
       <p:sp>
         <p:nvSpPr>
-          <p:cNvPr id="1009" name="Lineas 1009">
+          <p:cNvPr id="1094" name="Lineas 1094">
             <a:extLst>
               <a:ext uri="{FF2B5EF4-FFF2-40B4-BE49-F238E27FC236}">
                 <a16:creationId xmlns:a16="http://schemas.microsoft.com/office/drawing/2014/main" id="{B63E2792-6AF6-56E3-0D5E-3C4DAA9FAED3}"/>
@@ -36381,7 +36005,7 @@
                 </a:solidFill>
                 <a:latin typeface="Abadi ExtraLight" panose="020B0204020104020204" pitchFamily="34" charset="0"/>
               </a:rPr>
-              <a:t>{{#F109}}</a:t>
+              <a:t>{{#F194}}</a:t>
             </a:r>
             <a:endParaRPr kumimoji="0" lang="es-PE" sz="1800" b="1" i="0" u="none" strike="noStrike" kern="1200" cap="none" spc="0" normalizeH="0" baseline="0" noProof="0" dirty="0">
               <a:ln>
@@ -36402,7 +36026,7 @@
       </p:sp>
       <p:sp>
         <p:nvSpPr>
-          <p:cNvPr id="1010" name="Lineas 1010">
+          <p:cNvPr id="1095" name="Lineas 1095">
             <a:extLst>
               <a:ext uri="{FF2B5EF4-FFF2-40B4-BE49-F238E27FC236}">
                 <a16:creationId xmlns:a16="http://schemas.microsoft.com/office/drawing/2014/main" id="{B63E2792-6AF6-56E3-0D5E-3C4DAA9FAED3}"/>
@@ -36450,7 +36074,7 @@
                 </a:solidFill>
                 <a:latin typeface="Abadi ExtraLight" panose="020B0204020104020204" pitchFamily="34" charset="0"/>
               </a:rPr>
-              <a:t>{{#F110}}</a:t>
+              <a:t>{{#F195}}</a:t>
             </a:r>
             <a:endParaRPr kumimoji="0" lang="es-PE" sz="1800" b="1" i="0" u="none" strike="noStrike" kern="1200" cap="none" spc="0" normalizeH="0" baseline="0" noProof="0" dirty="0">
               <a:ln>
@@ -36471,7 +36095,7 @@
       </p:sp>
       <p:sp>
         <p:nvSpPr>
-          <p:cNvPr id="1011" name="Lineas 1011">
+          <p:cNvPr id="1096" name="Lineas 1096">
             <a:extLst>
               <a:ext uri="{FF2B5EF4-FFF2-40B4-BE49-F238E27FC236}">
                 <a16:creationId xmlns:a16="http://schemas.microsoft.com/office/drawing/2014/main" id="{B63E2792-6AF6-56E3-0D5E-3C4DAA9FAED3}"/>
@@ -36519,7 +36143,7 @@
                 </a:solidFill>
                 <a:latin typeface="Abadi ExtraLight" panose="020B0204020104020204" pitchFamily="34" charset="0"/>
               </a:rPr>
-              <a:t>{{#F111}}</a:t>
+              <a:t>{{#F196}}</a:t>
             </a:r>
             <a:endParaRPr kumimoji="0" lang="es-PE" sz="1800" b="1" i="0" u="none" strike="noStrike" kern="1200" cap="none" spc="0" normalizeH="0" baseline="0" noProof="0" dirty="0">
               <a:ln>

</xml_diff>

<commit_message>
Vista PPT: notas en negro Arial 13, títulos de recepción centrados y sin diapositivas de zonas sin datos
</commit_message>
<xml_diff>
--- a/lib/plantilla_reporte.pptx
+++ b/lib/plantilla_reporte.pptx
@@ -9191,17 +9191,17 @@
               <a:defRPr/>
             </a:pPr>
             <a:r>
-              <a:rPr kumimoji="0" lang="es-MX" sz="1400" b="0" i="0" u="none" strike="noStrike" kern="1200" cap="none" spc="0" normalizeH="0" baseline="0" noProof="0" dirty="0">
+              <a:rPr kumimoji="0" lang="es-MX" sz="1300" b="0" i="0" strike="noStrike" kern="1200" cap="none" spc="0" normalizeH="0" baseline="0" noProof="0" dirty="0">
+                <a:solidFill>
+                  <a:srgbClr val="000000"/>
+                </a:solidFill>
                 <a:ln>
                   <a:noFill/>
                 </a:ln>
-                <a:solidFill>
-                  <a:srgbClr val="525252"/>
-                </a:solidFill>
                 <a:effectLst/>
                 <a:uLnTx/>
                 <a:uFillTx/>
-                <a:latin typeface="Calibri" panose="020F0502020204030204"/>
+                <a:latin typeface="Arial"/>
                 <a:ea typeface="+mn-ea"/>
                 <a:cs typeface="+mn-cs"/>
               </a:rPr>
@@ -9345,17 +9345,17 @@
               <a:defRPr/>
             </a:pPr>
             <a:r>
-              <a:rPr kumimoji="0" lang="es-MX" sz="1400" b="0" i="0" u="none" strike="noStrike" kern="1200" cap="none" spc="0" normalizeH="0" baseline="0" noProof="0" dirty="0">
+              <a:rPr kumimoji="0" lang="es-MX" sz="1300" b="0" i="0" strike="noStrike" kern="1200" cap="none" spc="0" normalizeH="0" baseline="0" noProof="0" dirty="0">
+                <a:solidFill>
+                  <a:srgbClr val="000000"/>
+                </a:solidFill>
                 <a:ln>
                   <a:noFill/>
                 </a:ln>
-                <a:solidFill>
-                  <a:srgbClr val="525252"/>
-                </a:solidFill>
                 <a:effectLst/>
                 <a:uLnTx/>
                 <a:uFillTx/>
-                <a:latin typeface="Calibri" panose="020F0502020204030204"/>
+                <a:latin typeface="Arial"/>
                 <a:ea typeface="+mn-ea"/>
                 <a:cs typeface="+mn-cs"/>
               </a:rPr>
@@ -12527,17 +12527,17 @@
               <a:defRPr/>
             </a:pPr>
             <a:r>
-              <a:rPr kumimoji="0" lang="es-MX" sz="1400" b="0" i="0" u="none" strike="noStrike" kern="1200" cap="none" spc="0" normalizeH="0" baseline="0" noProof="0" dirty="0">
+              <a:rPr kumimoji="0" lang="es-MX" sz="1300" b="0" i="0" strike="noStrike" kern="1200" cap="none" spc="0" normalizeH="0" baseline="0" noProof="0" dirty="0">
+                <a:solidFill>
+                  <a:srgbClr val="000000"/>
+                </a:solidFill>
                 <a:ln>
                   <a:noFill/>
                 </a:ln>
-                <a:solidFill>
-                  <a:srgbClr val="525252"/>
-                </a:solidFill>
                 <a:effectLst/>
                 <a:uLnTx/>
                 <a:uFillTx/>
-                <a:latin typeface="Calibri" panose="020F0502020204030204"/>
+                <a:latin typeface="Arial"/>
                 <a:ea typeface="+mn-ea"/>
                 <a:cs typeface="+mn-cs"/>
               </a:rPr>
@@ -12681,17 +12681,17 @@
               <a:defRPr/>
             </a:pPr>
             <a:r>
-              <a:rPr kumimoji="0" lang="es-MX" sz="1400" b="0" i="0" u="none" strike="noStrike" kern="1200" cap="none" spc="0" normalizeH="0" baseline="0" noProof="0" dirty="0">
+              <a:rPr kumimoji="0" lang="es-MX" sz="1300" b="0" i="0" strike="noStrike" kern="1200" cap="none" spc="0" normalizeH="0" baseline="0" noProof="0" dirty="0">
+                <a:solidFill>
+                  <a:srgbClr val="000000"/>
+                </a:solidFill>
                 <a:ln>
                   <a:noFill/>
                 </a:ln>
-                <a:solidFill>
-                  <a:srgbClr val="525252"/>
-                </a:solidFill>
                 <a:effectLst/>
                 <a:uLnTx/>
                 <a:uFillTx/>
-                <a:latin typeface="Calibri" panose="020F0502020204030204"/>
+                <a:latin typeface="Arial"/>
                 <a:ea typeface="+mn-ea"/>
                 <a:cs typeface="+mn-cs"/>
               </a:rPr>
@@ -20836,10 +20836,11 @@
           <a:lstStyle/>
           <a:p>
             <a:r>
-              <a:rPr lang="es-MX" sz="1400" dirty="0">
+              <a:rPr lang="es-MX" sz="1300" dirty="0" b="0" i="0">
                 <a:solidFill>
-                  <a:schemeClr val="accent5"/>
+                  <a:srgbClr val="000000"/>
                 </a:solidFill>
+                <a:latin typeface="Arial"/>
               </a:rPr>
               <a:t>{{#F48}}</a:t>
             </a:r>
@@ -20880,10 +20881,11 @@
           <a:lstStyle/>
           <a:p>
             <a:r>
-              <a:rPr lang="es-MX" sz="1400" dirty="0">
+              <a:rPr lang="es-MX" sz="1300" dirty="0" b="0" i="0">
                 <a:solidFill>
-                  <a:schemeClr val="accent5"/>
+                  <a:srgbClr val="000000"/>
                 </a:solidFill>
+                <a:latin typeface="Arial"/>
               </a:rPr>
               <a:t>{{#F49}}</a:t>
             </a:r>
@@ -20924,10 +20926,11 @@
           <a:lstStyle/>
           <a:p>
             <a:r>
-              <a:rPr lang="es-MX" sz="1400" dirty="0">
+              <a:rPr lang="es-MX" sz="1300" dirty="0" b="0" i="0">
                 <a:solidFill>
-                  <a:schemeClr val="accent5"/>
+                  <a:srgbClr val="000000"/>
                 </a:solidFill>
+                <a:latin typeface="Arial"/>
               </a:rPr>
               <a:t>{{#F50}}</a:t>
             </a:r>
@@ -20968,10 +20971,11 @@
           <a:lstStyle/>
           <a:p>
             <a:r>
-              <a:rPr lang="es-MX" sz="1400" dirty="0">
+              <a:rPr lang="es-MX" sz="1300" dirty="0" b="0" i="0">
                 <a:solidFill>
-                  <a:schemeClr val="accent5"/>
+                  <a:srgbClr val="000000"/>
                 </a:solidFill>
+                <a:latin typeface="Arial"/>
               </a:rPr>
               <a:t>{{#F51}}</a:t>
             </a:r>
@@ -21012,10 +21016,11 @@
           <a:lstStyle/>
           <a:p>
             <a:r>
-              <a:rPr lang="es-MX" sz="1400" dirty="0">
+              <a:rPr lang="es-MX" sz="1300" dirty="0" b="0" i="0">
                 <a:solidFill>
-                  <a:schemeClr val="accent5"/>
+                  <a:srgbClr val="000000"/>
                 </a:solidFill>
+                <a:latin typeface="Arial"/>
               </a:rPr>
               <a:t>{{#F52}}</a:t>
             </a:r>
@@ -23774,10 +23779,11 @@
           <a:lstStyle/>
           <a:p>
             <a:r>
-              <a:rPr lang="es-MX" sz="1400" dirty="0">
+              <a:rPr lang="es-MX" sz="1300" dirty="0" b="0" i="0">
                 <a:solidFill>
-                  <a:schemeClr val="accent5"/>
+                  <a:srgbClr val="000000"/>
                 </a:solidFill>
+                <a:latin typeface="Arial"/>
               </a:rPr>
               <a:t>{{#F81}}</a:t>
             </a:r>
@@ -25805,10 +25811,11 @@
           <a:lstStyle/>
           <a:p>
             <a:r>
-              <a:rPr lang="es-MX" sz="1400" dirty="0">
+              <a:rPr lang="es-MX" sz="1300" dirty="0" b="0" i="0">
                 <a:solidFill>
-                  <a:schemeClr val="accent5"/>
+                  <a:srgbClr val="000000"/>
                 </a:solidFill>
+                <a:latin typeface="Arial"/>
               </a:rPr>
               <a:t>{{#F95}}</a:t>
             </a:r>
@@ -25849,10 +25856,11 @@
           <a:lstStyle/>
           <a:p>
             <a:r>
-              <a:rPr lang="es-MX" sz="1400" dirty="0">
+              <a:rPr lang="es-MX" sz="1300" dirty="0" b="0" i="0">
                 <a:solidFill>
-                  <a:schemeClr val="accent5"/>
+                  <a:srgbClr val="000000"/>
                 </a:solidFill>
+                <a:latin typeface="Arial"/>
               </a:rPr>
               <a:t>{{#F96}}</a:t>
             </a:r>
@@ -25893,10 +25901,11 @@
           <a:lstStyle/>
           <a:p>
             <a:r>
-              <a:rPr lang="es-MX" sz="1400" dirty="0">
+              <a:rPr lang="es-MX" sz="1300" dirty="0" b="0" i="0">
                 <a:solidFill>
-                  <a:schemeClr val="accent5"/>
+                  <a:srgbClr val="000000"/>
                 </a:solidFill>
+                <a:latin typeface="Arial"/>
               </a:rPr>
               <a:t>{{#F97}}</a:t>
             </a:r>
@@ -27168,10 +27177,11 @@
           <a:lstStyle/>
           <a:p>
             <a:r>
-              <a:rPr lang="es-MX" sz="1400" dirty="0">
+              <a:rPr lang="es-MX" sz="1300" dirty="0" b="0" i="0">
                 <a:solidFill>
-                  <a:schemeClr val="accent5"/>
+                  <a:srgbClr val="000000"/>
                 </a:solidFill>
+                <a:latin typeface="Arial"/>
               </a:rPr>
               <a:t>{{#F109}}</a:t>
             </a:r>
@@ -27212,10 +27222,11 @@
           <a:lstStyle/>
           <a:p>
             <a:r>
-              <a:rPr lang="es-MX" sz="1400" dirty="0">
+              <a:rPr lang="es-MX" sz="1300" dirty="0" b="0" i="0">
                 <a:solidFill>
-                  <a:schemeClr val="accent5"/>
+                  <a:srgbClr val="000000"/>
                 </a:solidFill>
+                <a:latin typeface="Arial"/>
               </a:rPr>
               <a:t>{{#F110}}</a:t>
             </a:r>
@@ -30228,10 +30239,11 @@
           <a:lstStyle/>
           <a:p>
             <a:r>
-              <a:rPr lang="es-MX" sz="1400" dirty="0">
+              <a:rPr lang="es-MX" sz="1300" dirty="0" b="0" i="0">
                 <a:solidFill>
-                  <a:schemeClr val="accent5"/>
+                  <a:srgbClr val="000000"/>
                 </a:solidFill>
+                <a:latin typeface="Arial"/>
               </a:rPr>
               <a:t>{{#F138}}</a:t>
             </a:r>
@@ -30272,10 +30284,11 @@
           <a:lstStyle/>
           <a:p>
             <a:r>
-              <a:rPr lang="es-MX" sz="1400" dirty="0">
+              <a:rPr lang="es-MX" sz="1300" dirty="0" b="0" i="0">
                 <a:solidFill>
-                  <a:schemeClr val="accent5"/>
+                  <a:srgbClr val="000000"/>
                 </a:solidFill>
+                <a:latin typeface="Arial"/>
               </a:rPr>
               <a:t>{{#F139}}</a:t>
             </a:r>
@@ -31998,6 +32011,7 @@
             </a:bodyPr>
             <a:lstStyle/>
             <a:p>
+              <a:pPr algn="ctr"/>
               <a:r>
                 <a:rPr lang="es-ES" dirty="0">
                   <a:solidFill>
@@ -32205,6 +32219,7 @@
             </a:bodyPr>
             <a:lstStyle/>
             <a:p>
+              <a:pPr algn="ctr"/>
               <a:r>
                 <a:rPr lang="es-ES" dirty="0">
                   <a:solidFill>
@@ -33254,17 +33269,17 @@
               <a:defRPr/>
             </a:pPr>
             <a:r>
-              <a:rPr kumimoji="0" lang="es-MX" sz="1400" b="0" i="0" u="none" strike="noStrike" kern="1200" cap="none" spc="0" normalizeH="0" baseline="0" noProof="0" dirty="0">
+              <a:rPr kumimoji="0" lang="es-MX" sz="1300" b="0" i="0" strike="noStrike" kern="1200" cap="none" spc="0" normalizeH="0" baseline="0" noProof="0" dirty="0">
+                <a:solidFill>
+                  <a:srgbClr val="000000"/>
+                </a:solidFill>
                 <a:ln>
                   <a:noFill/>
                 </a:ln>
-                <a:solidFill>
-                  <a:srgbClr val="525252"/>
-                </a:solidFill>
                 <a:effectLst/>
                 <a:uLnTx/>
                 <a:uFillTx/>
-                <a:latin typeface="Calibri" panose="020F0502020204030204"/>
+                <a:latin typeface="Arial"/>
                 <a:ea typeface="+mn-ea"/>
                 <a:cs typeface="+mn-cs"/>
               </a:rPr>
@@ -33408,17 +33423,17 @@
               <a:defRPr/>
             </a:pPr>
             <a:r>
-              <a:rPr kumimoji="0" lang="es-MX" sz="1400" b="0" i="0" u="none" strike="noStrike" kern="1200" cap="none" spc="0" normalizeH="0" baseline="0" noProof="0" dirty="0">
+              <a:rPr kumimoji="0" lang="es-MX" sz="1300" b="0" i="0" strike="noStrike" kern="1200" cap="none" spc="0" normalizeH="0" baseline="0" noProof="0" dirty="0">
+                <a:solidFill>
+                  <a:srgbClr val="000000"/>
+                </a:solidFill>
                 <a:ln>
                   <a:noFill/>
                 </a:ln>
-                <a:solidFill>
-                  <a:srgbClr val="525252"/>
-                </a:solidFill>
                 <a:effectLst/>
                 <a:uLnTx/>
                 <a:uFillTx/>
-                <a:latin typeface="Calibri" panose="020F0502020204030204"/>
+                <a:latin typeface="Arial"/>
                 <a:ea typeface="+mn-ea"/>
                 <a:cs typeface="+mn-cs"/>
               </a:rPr>

</xml_diff>

<commit_message>
Vista PPT: objetivos de producción en 17 pt y botón para agregar textos
</commit_message>
<xml_diff>
--- a/lib/plantilla_reporte.pptx
+++ b/lib/plantilla_reporte.pptx
@@ -19392,7 +19392,7 @@
                     <a:defRPr/>
                   </a:pPr>
                   <a:r>
-                    <a:rPr kumimoji="0" lang="es-PE" sz="1800" b="1" i="0" u="none" strike="noStrike" kern="1200" cap="none" spc="0" normalizeH="0" baseline="0" noProof="0" dirty="0">
+                    <a:rPr kumimoji="0" lang="es-PE" sz="1700" b="1" i="0" u="none" strike="noStrike" kern="1200" cap="none" spc="0" normalizeH="0" baseline="0" noProof="0" dirty="0">
                       <a:ln>
                         <a:noFill/>
                       </a:ln>
@@ -19762,7 +19762,7 @@
                     <a:defRPr/>
                   </a:pPr>
                   <a:r>
-                    <a:rPr kumimoji="0" lang="es-PE" sz="1800" b="1" i="0" u="none" strike="noStrike" kern="1200" cap="none" spc="0" normalizeH="0" baseline="0" noProof="0" dirty="0">
+                    <a:rPr kumimoji="0" lang="es-PE" sz="1700" b="1" i="0" u="none" strike="noStrike" kern="1200" cap="none" spc="0" normalizeH="0" baseline="0" noProof="0" dirty="0">
                       <a:ln>
                         <a:noFill/>
                       </a:ln>
@@ -20266,7 +20266,7 @@
                   <a:defRPr/>
                 </a:pPr>
                 <a:r>
-                  <a:rPr kumimoji="0" lang="es-PE" sz="1800" b="1" i="0" u="none" strike="noStrike" kern="1200" cap="none" spc="0" normalizeH="0" baseline="0" noProof="0" dirty="0">
+                  <a:rPr kumimoji="0" lang="es-PE" sz="1700" b="1" i="0" u="none" strike="noStrike" kern="1200" cap="none" spc="0" normalizeH="0" baseline="0" noProof="0" dirty="0">
                     <a:ln>
                       <a:noFill/>
                     </a:ln>
@@ -20721,7 +20721,7 @@
                   <a:defRPr/>
                 </a:pPr>
                 <a:r>
-                  <a:rPr kumimoji="0" lang="es-PE" sz="1800" b="1" i="0" u="none" strike="noStrike" kern="1200" cap="none" spc="0" normalizeH="0" baseline="0" noProof="0" dirty="0">
+                  <a:rPr kumimoji="0" lang="es-PE" sz="1700" b="1" i="0" u="none" strike="noStrike" kern="1200" cap="none" spc="0" normalizeH="0" baseline="0" noProof="0" dirty="0">
                     <a:ln>
                       <a:noFill/>
                     </a:ln>
@@ -21892,7 +21892,7 @@
               <a:defRPr/>
             </a:pPr>
             <a:r>
-              <a:rPr kumimoji="0" lang="es-PE" sz="1800" b="1" i="0" u="none" strike="noStrike" kern="1200" cap="none" spc="0" normalizeH="0" baseline="0" noProof="0" dirty="0">
+              <a:rPr kumimoji="0" lang="es-PE" sz="1700" b="1" i="0" u="none" strike="noStrike" kern="1200" cap="none" spc="0" normalizeH="0" baseline="0" noProof="0" dirty="0">
                 <a:ln>
                   <a:noFill/>
                 </a:ln>
@@ -22086,7 +22086,7 @@
               <a:defRPr/>
             </a:pPr>
             <a:r>
-              <a:rPr kumimoji="0" lang="es-PE" sz="1800" b="1" i="0" u="none" strike="noStrike" kern="1200" cap="none" spc="0" normalizeH="0" baseline="0" noProof="0" dirty="0">
+              <a:rPr kumimoji="0" lang="es-PE" sz="1700" b="1" i="0" u="none" strike="noStrike" kern="1200" cap="none" spc="0" normalizeH="0" baseline="0" noProof="0" dirty="0">
                 <a:ln>
                   <a:noFill/>
                 </a:ln>

</xml_diff>

<commit_message>
Vista PPT: íconos de PDF y PowerPoint, nota al pie en dos líneas y recuadros Imagen 1-3
</commit_message>
<xml_diff>
--- a/lib/plantilla_reporte.pptx
+++ b/lib/plantilla_reporte.pptx
@@ -15983,6 +15983,49 @@
           </p:txBody>
         </p:sp>
       </p:grpSp>
+      <p:sp>
+        <p:nvSpPr>
+          <p:cNvPr id="712" name="Imagen 3"/>
+          <p:cNvSpPr/>
+          <p:nvPr/>
+        </p:nvSpPr>
+        <p:spPr>
+          <a:xfrm>
+            <a:off x="2063343" y="3644889"/>
+            <a:ext cx="7602047" cy="2152954"/>
+          </a:xfrm>
+          <a:prstGeom prst="roundRect">
+            <a:avLst>
+              <a:gd name="adj" fmla="val 5000"/>
+            </a:avLst>
+          </a:prstGeom>
+          <a:solidFill>
+            <a:srgbClr val="F4F4F4"/>
+          </a:solidFill>
+          <a:ln w="15875">
+            <a:solidFill>
+              <a:srgbClr val="A6A6A6"/>
+            </a:solidFill>
+            <a:prstDash val="dash"/>
+          </a:ln>
+        </p:spPr>
+        <p:txBody>
+          <a:bodyPr anchor="ctr"/>
+          <a:lstStyle/>
+          <a:p>
+            <a:pPr algn="ctr"/>
+            <a:r>
+              <a:rPr lang="es-PE" sz="1600">
+                <a:solidFill>
+                  <a:srgbClr val="A6A6A6"/>
+                </a:solidFill>
+                <a:latin typeface="Arial"/>
+              </a:rPr>
+              <a:t>Imagen 3</a:t>
+            </a:r>
+          </a:p>
+        </p:txBody>
+      </p:sp>
     </p:spTree>
     <p:extLst>
       <p:ext uri="{BB962C8B-B14F-4D97-AF65-F5344CB8AC3E}">
@@ -21046,8 +21089,8 @@
         </p:nvSpPr>
         <p:spPr>
           <a:xfrm>
-            <a:off x="316072" y="6245474"/>
-            <a:ext cx="11757193" cy="523220"/>
+            <a:off x="316072" y="5888736"/>
+            <a:ext cx="11757193" cy="475488"/>
           </a:xfrm>
           <a:prstGeom prst="rect">
             <a:avLst/>
@@ -21055,13 +21098,13 @@
           <a:noFill/>
         </p:spPr>
         <p:txBody>
-          <a:bodyPr wrap="none" rtlCol="0">
+          <a:bodyPr wrap="square" rtlCol="0">
             <a:spAutoFit/>
           </a:bodyPr>
           <a:lstStyle/>
           <a:p>
             <a:r>
-              <a:rPr lang="es-MX" sz="1400" dirty="0"/>
+              <a:rPr lang="es-MX" sz="1300" dirty="0"/>
               <a:t>{{#F53}}</a:t>
             </a:r>
           </a:p>
@@ -22231,6 +22274,49 @@
               </a:solidFill>
               <a:latin typeface="Aptos Light" panose="020B0004020202020204" pitchFamily="34" charset="0"/>
             </a:endParaRPr>
+          </a:p>
+        </p:txBody>
+      </p:sp>
+      <p:sp>
+        <p:nvSpPr>
+          <p:cNvPr id="703" name="Imagen 1"/>
+          <p:cNvSpPr/>
+          <p:nvPr/>
+        </p:nvSpPr>
+        <p:spPr>
+          <a:xfrm>
+            <a:off x="8689086" y="3482766"/>
+            <a:ext cx="3134197" cy="2219614"/>
+          </a:xfrm>
+          <a:prstGeom prst="roundRect">
+            <a:avLst>
+              <a:gd name="adj" fmla="val 5000"/>
+            </a:avLst>
+          </a:prstGeom>
+          <a:solidFill>
+            <a:srgbClr val="F4F4F4"/>
+          </a:solidFill>
+          <a:ln w="15875">
+            <a:solidFill>
+              <a:srgbClr val="A6A6A6"/>
+            </a:solidFill>
+            <a:prstDash val="dash"/>
+          </a:ln>
+        </p:spPr>
+        <p:txBody>
+          <a:bodyPr anchor="ctr"/>
+          <a:lstStyle/>
+          <a:p>
+            <a:pPr algn="ctr"/>
+            <a:r>
+              <a:rPr lang="es-PE" sz="1600">
+                <a:solidFill>
+                  <a:srgbClr val="A6A6A6"/>
+                </a:solidFill>
+                <a:latin typeface="Arial"/>
+              </a:rPr>
+              <a:t>Imagen 1</a:t>
+            </a:r>
           </a:p>
         </p:txBody>
       </p:sp>
@@ -30300,6 +30386,49 @@
           </a:p>
         </p:txBody>
       </p:sp>
+      <p:sp>
+        <p:nvSpPr>
+          <p:cNvPr id="706" name="Imagen 2"/>
+          <p:cNvSpPr/>
+          <p:nvPr/>
+        </p:nvSpPr>
+        <p:spPr>
+          <a:xfrm>
+            <a:off x="7238390" y="4193164"/>
+            <a:ext cx="4278843" cy="1890796"/>
+          </a:xfrm>
+          <a:prstGeom prst="roundRect">
+            <a:avLst>
+              <a:gd name="adj" fmla="val 5000"/>
+            </a:avLst>
+          </a:prstGeom>
+          <a:solidFill>
+            <a:srgbClr val="F4F4F4"/>
+          </a:solidFill>
+          <a:ln w="15875">
+            <a:solidFill>
+              <a:srgbClr val="A6A6A6"/>
+            </a:solidFill>
+            <a:prstDash val="dash"/>
+          </a:ln>
+        </p:spPr>
+        <p:txBody>
+          <a:bodyPr anchor="ctr"/>
+          <a:lstStyle/>
+          <a:p>
+            <a:pPr algn="ctr"/>
+            <a:r>
+              <a:rPr lang="es-PE" sz="1600">
+                <a:solidFill>
+                  <a:srgbClr val="A6A6A6"/>
+                </a:solidFill>
+                <a:latin typeface="Arial"/>
+              </a:rPr>
+              <a:t>Imagen 2</a:t>
+            </a:r>
+          </a:p>
+        </p:txBody>
+      </p:sp>
     </p:spTree>
     <p:extLst>
       <p:ext uri="{BB962C8B-B14F-4D97-AF65-F5344CB8AC3E}">

</xml_diff>

<commit_message>
Mano de obra – calidad: CMO desde Power BI (mano_obra_pbi.py), personas planilladas editables y diapositiva 6
</commit_message>
<xml_diff>
--- a/lib/plantilla_reporte.pptx
+++ b/lib/plantilla_reporte.pptx
@@ -27739,7 +27739,7 @@
                 <a:cs typeface="Candara"/>
                 <a:sym typeface="Candara"/>
               </a:rPr>
-              <a:t>{{#F122}}</a:t>
+              <a:t>{{#F124}}</a:t>
             </a:r>
             <a:endParaRPr kumimoji="0" lang="en-US" sz="1800" b="0" i="0" u="none" strike="noStrike" kern="0" cap="none" spc="0" normalizeH="0" baseline="0" noProof="0" dirty="0">
               <a:ln>
@@ -27953,7 +27953,7 @@
                     <a:ea typeface="+mn-ea"/>
                     <a:cs typeface="Aparajita" panose="020B0502040204020203" pitchFamily="18" charset="0"/>
                   </a:rPr>
-                  <a:t>{{#F123}}</a:t>
+                  <a:t>{{#F125}}</a:t>
                 </a:r>
               </a:p>
             </p:txBody>
@@ -28220,7 +28220,7 @@
                       <a:ea typeface="+mn-ea"/>
                       <a:cs typeface="+mn-cs"/>
                     </a:rPr>
-                    <a:t>{{#F124}}</a:t>
+                    <a:t>{{#F122}}</a:t>
                   </a:r>
                 </a:p>
               </p:txBody>
@@ -28427,7 +28427,7 @@
                     <a:ea typeface="+mn-ea"/>
                     <a:cs typeface="+mn-cs"/>
                   </a:rPr>
-                  <a:t>{{#F125}}</a:t>
+                  <a:t>{{#F126}}</a:t>
                 </a:r>
               </a:p>
             </p:txBody>
@@ -28533,7 +28533,7 @@
                       <a:ea typeface="+mn-ea"/>
                       <a:cs typeface="+mn-cs"/>
                     </a:rPr>
-                    <a:t>{{#F126}}</a:t>
+                    <a:t>{{#F123}}</a:t>
                   </a:r>
                 </a:p>
               </p:txBody>

</xml_diff>

<commit_message>
Ratio de reclamos: % penalidad, objetivo editable, penalizado, venta y gráfico desde Power BI (reclamos_pbi.py)
</commit_message>
<xml_diff>
--- a/lib/plantilla_reporte.pptx
+++ b/lib/plantilla_reporte.pptx
@@ -27739,7 +27739,7 @@
                 <a:cs typeface="Candara"/>
                 <a:sym typeface="Candara"/>
               </a:rPr>
-              <a:t>{{#F124}}</a:t>
+              <a:t>{{#F125}}</a:t>
             </a:r>
             <a:endParaRPr kumimoji="0" lang="en-US" sz="1800" b="0" i="0" u="none" strike="noStrike" kern="0" cap="none" spc="0" normalizeH="0" baseline="0" noProof="0" dirty="0">
               <a:ln>
@@ -27953,7 +27953,7 @@
                     <a:ea typeface="+mn-ea"/>
                     <a:cs typeface="Aparajita" panose="020B0502040204020203" pitchFamily="18" charset="0"/>
                   </a:rPr>
-                  <a:t>{{#F125}}</a:t>
+                  <a:t>{{#F126}}</a:t>
                 </a:r>
               </a:p>
             </p:txBody>
@@ -28427,7 +28427,7 @@
                     <a:ea typeface="+mn-ea"/>
                     <a:cs typeface="+mn-cs"/>
                   </a:rPr>
-                  <a:t>{{#F126}}</a:t>
+                  <a:t>{{#F127}}</a:t>
                 </a:r>
               </a:p>
             </p:txBody>
@@ -28748,7 +28748,7 @@
                     <a:ea typeface="+mn-ea"/>
                     <a:cs typeface="+mn-cs"/>
                   </a:rPr>
-                  <a:t>{{#F127}}</a:t>
+                  <a:t>{{#F128}}</a:t>
                 </a:r>
                 <a:endParaRPr kumimoji="0" lang="es-PE" sz="1600" b="0" i="0" u="sng" strike="noStrike" kern="1200" cap="none" spc="0" normalizeH="0" baseline="0" noProof="0" dirty="0">
                   <a:ln>
@@ -28833,7 +28833,7 @@
                   <a:ea typeface="+mn-ea"/>
                   <a:cs typeface="+mn-cs"/>
                 </a:rPr>
-                <a:t>{{#F128}}</a:t>
+                <a:t>{{#F129}}</a:t>
               </a:r>
               <a:endParaRPr kumimoji="0" lang="es-PE" sz="1800" b="1" i="0" u="none" strike="noStrike" kern="1200" cap="none" spc="0" normalizeH="0" baseline="0" noProof="0" dirty="0">
                 <a:ln>
@@ -29080,7 +29080,7 @@
                   <a:ea typeface="+mn-ea"/>
                   <a:cs typeface="+mn-cs"/>
                 </a:rPr>
-                <a:t>{{#F129}}</a:t>
+                <a:t>{{#F130}}</a:t>
               </a:r>
               <a:endParaRPr kumimoji="0" lang="es-PE" sz="1600" b="0" i="0" u="sng" strike="noStrike" kern="1200" cap="none" spc="0" normalizeH="0" baseline="0" noProof="0" dirty="0">
                 <a:ln>
@@ -29159,7 +29159,7 @@
                   <a:ea typeface="+mn-ea"/>
                   <a:cs typeface="Aparajita" panose="020B0502040204020203" pitchFamily="18" charset="0"/>
                 </a:rPr>
-                <a:t>{{#F130}}</a:t>
+                <a:t>{{#F131}}</a:t>
               </a:r>
               <a:endParaRPr kumimoji="0" lang="es-PE" sz="1400" b="1" i="0" u="sng" strike="noStrike" kern="1200" cap="none" spc="0" normalizeH="0" baseline="0" noProof="0" dirty="0">
                 <a:ln>
@@ -29480,7 +29480,7 @@
                         <a:ea typeface="+mn-ea"/>
                         <a:cs typeface="+mn-cs"/>
                       </a:rPr>
-                      <a:t>{{#F131}}</a:t>
+                      <a:t>{{#F124}}</a:t>
                     </a:r>
                   </a:p>
                 </p:txBody>

</xml_diff>

<commit_message>
Diapositiva 2: fila de arriba ordenada (valor Aptos Light 36, objetivo 16) y Mano de Obra con la semana elegida
</commit_message>
<xml_diff>
--- a/lib/plantilla_reporte.pptx
+++ b/lib/plantilla_reporte.pptx
@@ -17919,7 +17919,7 @@
                 <a:cs typeface="Candara"/>
                 <a:sym typeface="Candara"/>
               </a:rPr>
-              <a:t>{{#F28}}</a:t>
+              <a:t>{{#F30}}</a:t>
             </a:r>
             <a:endParaRPr kumimoji="0" lang="en-US" sz="1800" b="0" i="0" u="none" strike="noStrike" kern="0" cap="none" spc="0" normalizeH="0" baseline="0" noProof="0" dirty="0">
               <a:ln>
@@ -18105,7 +18105,7 @@
                   <a:ea typeface="+mn-ea"/>
                   <a:cs typeface="+mn-cs"/>
                 </a:rPr>
-                <a:t>{{#F29}}</a:t>
+                <a:t>{{#F31}}</a:t>
               </a:r>
               <a:endParaRPr kumimoji="0" lang="es-PE" sz="1800" b="1" i="0" u="none" strike="noStrike" kern="1200" cap="none" spc="0" normalizeH="0" baseline="0" noProof="0" dirty="0">
                 <a:ln>
@@ -18184,7 +18184,7 @@
                   <a:ea typeface="+mn-ea"/>
                   <a:cs typeface="+mn-cs"/>
                 </a:rPr>
-                <a:t>{{#F30}}</a:t>
+                <a:t>{{#F32}}</a:t>
               </a:r>
             </a:p>
           </p:txBody>
@@ -18249,7 +18249,7 @@
                   <a:ea typeface="+mn-ea"/>
                   <a:cs typeface="+mn-cs"/>
                 </a:rPr>
-                <a:t>{{#F31}}</a:t>
+                <a:t>{{#F33}}</a:t>
               </a:r>
               <a:endParaRPr kumimoji="0" lang="es-PE" sz="1800" b="0" i="0" u="sng" strike="noStrike" kern="1200" cap="none" spc="0" normalizeH="0" baseline="0" noProof="0" dirty="0">
                 <a:ln>
@@ -18514,7 +18514,7 @@
                   <a:ea typeface="+mn-ea"/>
                   <a:cs typeface="+mn-cs"/>
                 </a:rPr>
-                <a:t>{{#F32}}</a:t>
+                <a:t>{{#F34}}</a:t>
               </a:r>
               <a:endParaRPr kumimoji="0" lang="es-PE" sz="1800" b="1" i="0" u="none" strike="noStrike" kern="1200" cap="none" spc="0" normalizeH="0" baseline="0" noProof="0" dirty="0">
                 <a:ln>
@@ -18669,7 +18669,7 @@
                   <a:ea typeface="+mn-ea"/>
                   <a:cs typeface="+mn-cs"/>
                 </a:rPr>
-                <a:t>{{#F33}}</a:t>
+                <a:t>{{#F35}}</a:t>
               </a:r>
             </a:p>
           </p:txBody>
@@ -18818,7 +18818,7 @@
                   <a:ea typeface="+mn-ea"/>
                   <a:cs typeface="+mn-cs"/>
                 </a:rPr>
-                <a:t>{{#F34}}</a:t>
+                <a:t>{{#F36}}</a:t>
               </a:r>
               <a:endParaRPr kumimoji="0" lang="es-PE" sz="1800" b="0" i="0" u="sng" strike="noStrike" kern="1200" cap="none" spc="0" normalizeH="0" baseline="0" noProof="0" dirty="0">
                 <a:ln>
@@ -18923,7 +18923,7 @@
                   <a:ea typeface="+mn-ea"/>
                   <a:cs typeface="+mn-cs"/>
                 </a:rPr>
-                <a:t>{{#F35}}</a:t>
+                <a:t>{{#F37}}</a:t>
               </a:r>
               <a:endParaRPr kumimoji="0" lang="es-PE" sz="1800" b="1" i="0" u="none" strike="noStrike" kern="1200" cap="none" spc="0" normalizeH="0" baseline="0" noProof="0" dirty="0">
                 <a:ln>
@@ -19162,7 +19162,7 @@
                   <a:ea typeface="+mn-ea"/>
                   <a:cs typeface="+mn-cs"/>
                 </a:rPr>
-                <a:t>{{#F36}}</a:t>
+                <a:t>{{#F38}}</a:t>
               </a:r>
             </a:p>
           </p:txBody>
@@ -19227,7 +19227,7 @@
                   <a:ea typeface="+mn-ea"/>
                   <a:cs typeface="+mn-cs"/>
                 </a:rPr>
-                <a:t>{{#F37}}</a:t>
+                <a:t>{{#F39}}</a:t>
               </a:r>
               <a:endParaRPr kumimoji="0" lang="es-PE" sz="1800" b="0" i="0" u="sng" strike="noStrike" kern="1200" cap="none" spc="0" normalizeH="0" baseline="0" noProof="0" dirty="0">
                 <a:ln>
@@ -19321,8 +19321,8 @@
               </p:nvSpPr>
               <p:spPr>
                 <a:xfrm>
-                  <a:off x="7100199" y="4374036"/>
-                  <a:ext cx="1516198" cy="646331"/>
+                  <a:off x="6807770" y="4506905"/>
+                  <a:ext cx="2024738" cy="512090"/>
                 </a:xfrm>
                 <a:prstGeom prst="rect">
                   <a:avLst/>
@@ -19330,9 +19330,7 @@
                 <a:noFill/>
               </p:spPr>
               <p:txBody>
-                <a:bodyPr wrap="none" rtlCol="0">
-                  <a:spAutoFit/>
-                </a:bodyPr>
+                <a:bodyPr wrap="none" rtlCol="0" anchor="ctr" lIns="0" rIns="0" tIns="0" bIns="0"/>
                 <a:lstStyle>
                   <a:defPPr>
                     <a:defRPr lang="es-PE"/>
@@ -19347,7 +19345,7 @@
                   </a:lvl1pPr>
                 </a:lstStyle>
                 <a:p>
-                  <a:pPr marL="0" marR="0" lvl="0" indent="0" algn="l" defTabSz="914400" rtl="0" eaLnBrk="1" fontAlgn="auto" latinLnBrk="0" hangingPunct="1">
+                  <a:pPr marL="0" marR="0" lvl="0" indent="0" algn="ctr" defTabSz="914400" rtl="0" eaLnBrk="1" fontAlgn="auto" latinLnBrk="0" hangingPunct="1">
                     <a:lnSpc>
                       <a:spcPct val="100000"/>
                     </a:lnSpc>
@@ -19365,12 +19363,13 @@
                     <a:defRPr/>
                   </a:pPr>
                   <a:r>
-                    <a:rPr lang="es-ES" sz="3600" dirty="0">
+                    <a:rPr lang="es-ES" sz="3600" dirty="0" b="0">
                       <a:solidFill>
                         <a:srgbClr val="FF0000"/>
                       </a:solidFill>
+                      <a:latin typeface="Aptos Light"/>
                     </a:rPr>
-                    <a:t>{{#F8}}</a:t>
+                    <a:t>{{#F10}}</a:t>
                   </a:r>
                   <a:endParaRPr kumimoji="0" lang="es-PE" sz="3600" b="0" i="0" u="none" strike="noStrike" kern="1200" cap="none" spc="0" normalizeH="0" baseline="0" noProof="0" dirty="0">
                     <a:ln>
@@ -19403,8 +19402,8 @@
               </p:nvSpPr>
               <p:spPr>
                 <a:xfrm>
-                  <a:off x="6914301" y="4860433"/>
-                  <a:ext cx="1828007" cy="369332"/>
+                  <a:off x="6807745" y="5018992"/>
+                  <a:ext cx="2024756" cy="237747"/>
                 </a:xfrm>
                 <a:prstGeom prst="rect">
                   <a:avLst/>
@@ -19412,12 +19411,10 @@
                 <a:noFill/>
               </p:spPr>
               <p:txBody>
-                <a:bodyPr wrap="none" rtlCol="0">
-                  <a:spAutoFit/>
-                </a:bodyPr>
+                <a:bodyPr wrap="none" rtlCol="0" anchor="ctr" lIns="0" rIns="0" tIns="0" bIns="0"/>
                 <a:lstStyle/>
                 <a:p>
-                  <a:pPr marL="0" marR="0" lvl="0" indent="0" algn="l" defTabSz="914400" rtl="0" eaLnBrk="1" fontAlgn="auto" latinLnBrk="0" hangingPunct="1">
+                  <a:pPr marL="0" marR="0" lvl="0" indent="0" algn="ctr" defTabSz="914400" rtl="0" eaLnBrk="1" fontAlgn="auto" latinLnBrk="0" hangingPunct="1">
                     <a:lnSpc>
                       <a:spcPct val="100000"/>
                     </a:lnSpc>
@@ -19435,7 +19432,7 @@
                     <a:defRPr/>
                   </a:pPr>
                   <a:r>
-                    <a:rPr kumimoji="0" lang="es-PE" sz="1700" b="1" i="0" u="none" strike="noStrike" kern="1200" cap="none" spc="0" normalizeH="0" baseline="0" noProof="0" dirty="0">
+                    <a:rPr kumimoji="0" lang="es-PE" sz="1600" b="1" i="0" u="none" strike="noStrike" kern="1200" cap="none" spc="0" normalizeH="0" baseline="0" noProof="0" dirty="0">
                       <a:ln>
                         <a:noFill/>
                       </a:ln>
@@ -19449,7 +19446,7 @@
                       <a:ea typeface="+mn-ea"/>
                       <a:cs typeface="+mn-cs"/>
                     </a:rPr>
-                    <a:t>{{#F38}}</a:t>
+                    <a:t>{{#F40}}</a:t>
                   </a:r>
                 </a:p>
               </p:txBody>
@@ -19468,8 +19465,8 @@
               </p:nvSpPr>
               <p:spPr>
                 <a:xfrm>
-                  <a:off x="7353061" y="5123291"/>
-                  <a:ext cx="1100479" cy="369332"/>
+                  <a:off x="6807740" y="5238415"/>
+                  <a:ext cx="2024810" cy="219459"/>
                 </a:xfrm>
                 <a:prstGeom prst="rect">
                   <a:avLst/>
@@ -19477,12 +19474,10 @@
                 <a:noFill/>
               </p:spPr>
               <p:txBody>
-                <a:bodyPr wrap="none" rtlCol="0">
-                  <a:spAutoFit/>
-                </a:bodyPr>
+                <a:bodyPr wrap="none" rtlCol="0" anchor="ctr" lIns="0" rIns="0" tIns="0" bIns="0"/>
                 <a:lstStyle/>
                 <a:p>
-                  <a:pPr marL="0" marR="0" lvl="0" indent="0" algn="l" defTabSz="914400" rtl="0" eaLnBrk="1" fontAlgn="auto" latinLnBrk="0" hangingPunct="1">
+                  <a:pPr marL="0" marR="0" lvl="0" indent="0" algn="ctr" defTabSz="914400" rtl="0" eaLnBrk="1" fontAlgn="auto" latinLnBrk="0" hangingPunct="1">
                     <a:lnSpc>
                       <a:spcPct val="100000"/>
                     </a:lnSpc>
@@ -19500,7 +19495,7 @@
                     <a:defRPr/>
                   </a:pPr>
                   <a:r>
-                    <a:rPr kumimoji="0" lang="es-PE" sz="1800" b="1" i="0" u="none" strike="noStrike" kern="1200" cap="none" spc="0" normalizeH="0" baseline="0" noProof="0" dirty="0">
+                    <a:rPr kumimoji="0" lang="es-PE" sz="1600" b="1" i="0" u="none" strike="noStrike" kern="1200" cap="none" spc="0" normalizeH="0" baseline="0" noProof="0" dirty="0">
                       <a:ln>
                         <a:noFill/>
                       </a:ln>
@@ -19514,7 +19509,7 @@
                       <a:ea typeface="+mn-ea"/>
                       <a:cs typeface="+mn-cs"/>
                     </a:rPr>
-                    <a:t>{{#F9}}</a:t>
+                    <a:t>{{#F11}}</a:t>
                   </a:r>
                 </a:p>
               </p:txBody>
@@ -19656,7 +19651,7 @@
                     <a:ea typeface="+mn-ea"/>
                     <a:cs typeface="+mn-cs"/>
                   </a:rPr>
-                  <a:t>{{#F39}}</a:t>
+                  <a:t>{{#F41}}</a:t>
                 </a:r>
               </a:p>
             </p:txBody>
@@ -19716,8 +19711,8 @@
               </p:nvSpPr>
               <p:spPr>
                 <a:xfrm>
-                  <a:off x="6970470" y="4382907"/>
-                  <a:ext cx="1516198" cy="646331"/>
+                  <a:off x="6755290" y="4536259"/>
+                  <a:ext cx="2024738" cy="512090"/>
                 </a:xfrm>
                 <a:prstGeom prst="rect">
                   <a:avLst/>
@@ -19725,12 +19720,10 @@
                 <a:noFill/>
               </p:spPr>
               <p:txBody>
-                <a:bodyPr wrap="none" rtlCol="0">
-                  <a:spAutoFit/>
-                </a:bodyPr>
+                <a:bodyPr wrap="none" rtlCol="0" anchor="ctr" lIns="0" rIns="0" tIns="0" bIns="0"/>
                 <a:lstStyle/>
                 <a:p>
-                  <a:pPr marL="0" marR="0" lvl="0" indent="0" algn="l" defTabSz="914400" rtl="0" eaLnBrk="1" fontAlgn="auto" latinLnBrk="0" hangingPunct="1">
+                  <a:pPr marL="0" marR="0" lvl="0" indent="0" algn="ctr" defTabSz="914400" rtl="0" eaLnBrk="1" fontAlgn="auto" latinLnBrk="0" hangingPunct="1">
                     <a:lnSpc>
                       <a:spcPct val="100000"/>
                     </a:lnSpc>
@@ -19748,13 +19741,13 @@
                     <a:defRPr/>
                   </a:pPr>
                   <a:r>
-                    <a:rPr lang="es-PE" sz="3600" dirty="0">
+                    <a:rPr lang="es-PE" sz="3600" dirty="0" b="0">
                       <a:solidFill>
                         <a:srgbClr val="FF0000"/>
                       </a:solidFill>
-                      <a:latin typeface="Century Gothic" panose="020B0502020202020204" pitchFamily="34" charset="0"/>
+                      <a:latin typeface="Aptos Light"/>
                     </a:rPr>
-                    <a:t>{{#F10}}</a:t>
+                    <a:t>{{#F12}}</a:t>
                   </a:r>
                 </a:p>
               </p:txBody>
@@ -19773,8 +19766,8 @@
               </p:nvSpPr>
               <p:spPr>
                 <a:xfrm>
-                  <a:off x="6786092" y="4867051"/>
-                  <a:ext cx="1828007" cy="369332"/>
+                  <a:off x="6755233" y="5048379"/>
+                  <a:ext cx="2024756" cy="237747"/>
                 </a:xfrm>
                 <a:prstGeom prst="rect">
                   <a:avLst/>
@@ -19782,12 +19775,10 @@
                 <a:noFill/>
               </p:spPr>
               <p:txBody>
-                <a:bodyPr wrap="none" rtlCol="0">
-                  <a:spAutoFit/>
-                </a:bodyPr>
+                <a:bodyPr wrap="none" rtlCol="0" anchor="ctr" lIns="0" rIns="0" tIns="0" bIns="0"/>
                 <a:lstStyle/>
                 <a:p>
-                  <a:pPr marL="0" marR="0" lvl="0" indent="0" algn="l" defTabSz="914400" rtl="0" eaLnBrk="1" fontAlgn="auto" latinLnBrk="0" hangingPunct="1">
+                  <a:pPr marL="0" marR="0" lvl="0" indent="0" algn="ctr" defTabSz="914400" rtl="0" eaLnBrk="1" fontAlgn="auto" latinLnBrk="0" hangingPunct="1">
                     <a:lnSpc>
                       <a:spcPct val="100000"/>
                     </a:lnSpc>
@@ -19805,7 +19796,7 @@
                     <a:defRPr/>
                   </a:pPr>
                   <a:r>
-                    <a:rPr kumimoji="0" lang="es-PE" sz="1700" b="1" i="0" u="none" strike="noStrike" kern="1200" cap="none" spc="0" normalizeH="0" baseline="0" noProof="0" dirty="0">
+                    <a:rPr kumimoji="0" lang="es-PE" sz="1600" b="1" i="0" u="none" strike="noStrike" kern="1200" cap="none" spc="0" normalizeH="0" baseline="0" noProof="0" dirty="0">
                       <a:ln>
                         <a:noFill/>
                       </a:ln>
@@ -19819,7 +19810,7 @@
                       <a:ea typeface="+mn-ea"/>
                       <a:cs typeface="+mn-cs"/>
                     </a:rPr>
-                    <a:t>{{#F40}}</a:t>
+                    <a:t>{{#F42}}</a:t>
                   </a:r>
                 </a:p>
               </p:txBody>
@@ -19838,8 +19829,8 @@
               </p:nvSpPr>
               <p:spPr>
                 <a:xfrm>
-                  <a:off x="7132373" y="5119369"/>
-                  <a:ext cx="1247524" cy="369332"/>
+                  <a:off x="6755226" y="5267778"/>
+                  <a:ext cx="2024805" cy="219459"/>
                 </a:xfrm>
                 <a:prstGeom prst="rect">
                   <a:avLst/>
@@ -19847,12 +19838,10 @@
                 <a:noFill/>
               </p:spPr>
               <p:txBody>
-                <a:bodyPr wrap="none" rtlCol="0">
-                  <a:spAutoFit/>
-                </a:bodyPr>
+                <a:bodyPr wrap="none" rtlCol="0" anchor="ctr" lIns="0" rIns="0" tIns="0" bIns="0"/>
                 <a:lstStyle/>
                 <a:p>
-                  <a:pPr marL="0" marR="0" lvl="0" indent="0" algn="l" defTabSz="914400" rtl="0" eaLnBrk="1" fontAlgn="auto" latinLnBrk="0" hangingPunct="1">
+                  <a:pPr marL="0" marR="0" lvl="0" indent="0" algn="ctr" defTabSz="914400" rtl="0" eaLnBrk="1" fontAlgn="auto" latinLnBrk="0" hangingPunct="1">
                     <a:lnSpc>
                       <a:spcPct val="100000"/>
                     </a:lnSpc>
@@ -19870,7 +19859,7 @@
                     <a:defRPr/>
                   </a:pPr>
                   <a:r>
-                    <a:rPr kumimoji="0" lang="es-PE" sz="1800" b="1" i="0" u="none" strike="noStrike" kern="1200" cap="none" spc="0" normalizeH="0" baseline="0" noProof="0" dirty="0">
+                    <a:rPr kumimoji="0" lang="es-PE" sz="1600" b="1" i="0" u="none" strike="noStrike" kern="1200" cap="none" spc="0" normalizeH="0" baseline="0" noProof="0" dirty="0">
                       <a:ln>
                         <a:noFill/>
                       </a:ln>
@@ -19884,7 +19873,7 @@
                       <a:ea typeface="+mn-ea"/>
                       <a:cs typeface="+mn-cs"/>
                     </a:rPr>
-                    <a:t>{{#F11}}</a:t>
+                    <a:t>{{#F13}}</a:t>
                   </a:r>
                 </a:p>
               </p:txBody>
@@ -20034,7 +20023,7 @@
                     <a:ea typeface="+mn-ea"/>
                     <a:cs typeface="+mn-cs"/>
                   </a:rPr>
-                  <a:t>{{#F41}}</a:t>
+                  <a:t>{{#F8}}</a:t>
                 </a:r>
                 <a:endParaRPr kumimoji="0" lang="es-PE" sz="1600" b="0" i="0" u="sng" strike="noStrike" kern="1200" cap="none" spc="0" normalizeH="0" baseline="0" noProof="0" dirty="0">
                   <a:ln>
@@ -20119,7 +20108,7 @@
                   <a:ea typeface="+mn-ea"/>
                   <a:cs typeface="+mn-cs"/>
                 </a:rPr>
-                <a:t>{{#F42}}</a:t>
+                <a:t>{{#F43}}</a:t>
               </a:r>
               <a:endParaRPr kumimoji="0" lang="es-PE" sz="1800" b="1" i="0" u="none" strike="noStrike" kern="1200" cap="none" spc="0" normalizeH="0" baseline="0" noProof="0" dirty="0">
                 <a:ln>
@@ -20224,7 +20213,7 @@
                   <a:ea typeface="+mn-ea"/>
                   <a:cs typeface="+mn-cs"/>
                 </a:rPr>
-                <a:t>{{#F43}}</a:t>
+                <a:t>{{#F44}}</a:t>
               </a:r>
               <a:endParaRPr kumimoji="0" lang="es-PE" sz="1800" b="1" i="0" u="none" strike="noStrike" kern="1200" cap="none" spc="0" normalizeH="0" baseline="0" noProof="0" dirty="0">
                 <a:ln>
@@ -20277,8 +20266,8 @@
             </p:nvSpPr>
             <p:spPr>
               <a:xfrm>
-                <a:off x="1873003" y="6240221"/>
-                <a:ext cx="1817948" cy="369332"/>
+                <a:off x="1908848" y="6343824"/>
+                <a:ext cx="1757230" cy="237747"/>
               </a:xfrm>
               <a:prstGeom prst="rect">
                 <a:avLst/>
@@ -20286,12 +20275,10 @@
               <a:noFill/>
             </p:spPr>
             <p:txBody>
-              <a:bodyPr wrap="square" rtlCol="0">
-                <a:spAutoFit/>
-              </a:bodyPr>
+              <a:bodyPr wrap="none" rtlCol="0" anchor="ctr" lIns="0" rIns="0" tIns="0" bIns="0"/>
               <a:lstStyle/>
               <a:p>
-                <a:pPr marL="0" marR="0" lvl="0" indent="0" algn="l" defTabSz="914400" rtl="0" eaLnBrk="1" fontAlgn="auto" latinLnBrk="0" hangingPunct="1">
+                <a:pPr marL="0" marR="0" lvl="0" indent="0" algn="ctr" defTabSz="914400" rtl="0" eaLnBrk="1" fontAlgn="auto" latinLnBrk="0" hangingPunct="1">
                   <a:lnSpc>
                     <a:spcPct val="100000"/>
                   </a:lnSpc>
@@ -20309,7 +20296,7 @@
                   <a:defRPr/>
                 </a:pPr>
                 <a:r>
-                  <a:rPr kumimoji="0" lang="es-PE" sz="1700" b="1" i="0" u="none" strike="noStrike" kern="1200" cap="none" spc="0" normalizeH="0" baseline="0" noProof="0" dirty="0">
+                  <a:rPr kumimoji="0" lang="es-PE" sz="1600" b="1" i="0" u="none" strike="noStrike" kern="1200" cap="none" spc="0" normalizeH="0" baseline="0" noProof="0" dirty="0">
                     <a:ln>
                       <a:noFill/>
                     </a:ln>
@@ -20323,7 +20310,7 @@
                     <a:ea typeface="+mn-ea"/>
                     <a:cs typeface="+mn-cs"/>
                   </a:rPr>
-                  <a:t>{{#F44}}</a:t>
+                  <a:t>{{#F45}}</a:t>
                 </a:r>
               </a:p>
             </p:txBody>
@@ -20342,8 +20329,8 @@
             </p:nvSpPr>
             <p:spPr>
               <a:xfrm>
-                <a:off x="2304129" y="6462401"/>
-                <a:ext cx="938077" cy="369332"/>
+                <a:off x="1908927" y="6563260"/>
+                <a:ext cx="1757191" cy="219459"/>
               </a:xfrm>
               <a:prstGeom prst="rect">
                 <a:avLst/>
@@ -20351,12 +20338,10 @@
               <a:noFill/>
             </p:spPr>
             <p:txBody>
-              <a:bodyPr wrap="none" rtlCol="0">
-                <a:spAutoFit/>
-              </a:bodyPr>
+              <a:bodyPr wrap="none" rtlCol="0" anchor="ctr" lIns="0" rIns="0" tIns="0" bIns="0"/>
               <a:lstStyle/>
               <a:p>
-                <a:pPr marL="0" marR="0" lvl="0" indent="0" algn="l" defTabSz="914400" rtl="0" eaLnBrk="1" fontAlgn="auto" latinLnBrk="0" hangingPunct="1">
+                <a:pPr marL="0" marR="0" lvl="0" indent="0" algn="ctr" defTabSz="914400" rtl="0" eaLnBrk="1" fontAlgn="auto" latinLnBrk="0" hangingPunct="1">
                   <a:lnSpc>
                     <a:spcPct val="100000"/>
                   </a:lnSpc>
@@ -20374,7 +20359,7 @@
                   <a:defRPr/>
                 </a:pPr>
                 <a:r>
-                  <a:rPr kumimoji="0" lang="es-PE" sz="1800" b="1" i="0" u="none" strike="noStrike" kern="1200" cap="none" spc="0" normalizeH="0" baseline="0" noProof="0" dirty="0">
+                  <a:rPr kumimoji="0" lang="es-PE" sz="1600" b="1" i="0" u="none" strike="noStrike" kern="1200" cap="none" spc="0" normalizeH="0" baseline="0" noProof="0" dirty="0">
                     <a:ln>
                       <a:noFill/>
                     </a:ln>
@@ -20388,7 +20373,7 @@
                     <a:ea typeface="+mn-ea"/>
                     <a:cs typeface="+mn-cs"/>
                   </a:rPr>
-                  <a:t>{{#F12}}</a:t>
+                  <a:t>{{#F14}}</a:t>
                 </a:r>
               </a:p>
             </p:txBody>
@@ -20529,7 +20514,7 @@
                     <a:ea typeface="+mn-ea"/>
                     <a:cs typeface="+mn-cs"/>
                   </a:rPr>
-                  <a:t>{{#F45}}</a:t>
+                  <a:t>{{#F46}}</a:t>
                 </a:r>
               </a:p>
             </p:txBody>
@@ -20699,7 +20684,7 @@
                     <a:ea typeface="+mn-ea"/>
                     <a:cs typeface="+mn-cs"/>
                   </a:rPr>
-                  <a:t>{{#F46}}</a:t>
+                  <a:t>{{#F47}}</a:t>
                 </a:r>
                 <a:endParaRPr kumimoji="0" lang="es-PE" sz="1800" b="0" i="0" u="sng" strike="noStrike" kern="1200" cap="none" spc="0" normalizeH="0" baseline="0" noProof="0" dirty="0">
                   <a:ln>
@@ -20732,8 +20717,8 @@
             </p:nvSpPr>
             <p:spPr>
               <a:xfrm>
-                <a:off x="4299651" y="6221631"/>
-                <a:ext cx="1667059" cy="369332"/>
+                <a:off x="4323334" y="6322216"/>
+                <a:ext cx="1600307" cy="237747"/>
               </a:xfrm>
               <a:prstGeom prst="rect">
                 <a:avLst/>
@@ -20741,74 +20726,7 @@
               <a:noFill/>
             </p:spPr>
             <p:txBody>
-              <a:bodyPr wrap="none" rtlCol="0">
-                <a:spAutoFit/>
-              </a:bodyPr>
-              <a:lstStyle/>
-              <a:p>
-                <a:pPr marL="0" marR="0" lvl="0" indent="0" algn="l" defTabSz="914400" rtl="0" eaLnBrk="1" fontAlgn="auto" latinLnBrk="0" hangingPunct="1">
-                  <a:lnSpc>
-                    <a:spcPct val="100000"/>
-                  </a:lnSpc>
-                  <a:spcBef>
-                    <a:spcPts val="0"/>
-                  </a:spcBef>
-                  <a:spcAft>
-                    <a:spcPts val="0"/>
-                  </a:spcAft>
-                  <a:buClrTx/>
-                  <a:buSzTx/>
-                  <a:buFontTx/>
-                  <a:buNone/>
-                  <a:tabLst/>
-                  <a:defRPr/>
-                </a:pPr>
-                <a:r>
-                  <a:rPr kumimoji="0" lang="es-PE" sz="1700" b="1" i="0" u="none" strike="noStrike" kern="1200" cap="none" spc="0" normalizeH="0" baseline="0" noProof="0" dirty="0">
-                    <a:ln>
-                      <a:noFill/>
-                    </a:ln>
-                    <a:solidFill>
-                      <a:srgbClr val="000000"/>
-                    </a:solidFill>
-                    <a:effectLst/>
-                    <a:uLnTx/>
-                    <a:uFillTx/>
-                    <a:latin typeface="Abadi ExtraLight" panose="020B0204020104020204" pitchFamily="34" charset="0"/>
-                    <a:ea typeface="+mn-ea"/>
-                    <a:cs typeface="+mn-cs"/>
-                  </a:rPr>
-                  <a:t>{{#F47}}</a:t>
-                </a:r>
-              </a:p>
-            </p:txBody>
-          </p:sp>
-          <p:sp>
-            <p:nvSpPr>
-              <p:cNvPr id="39" name="CuadroTexto 38">
-                <a:extLst>
-                  <a:ext uri="{FF2B5EF4-FFF2-40B4-BE49-F238E27FC236}">
-                    <a16:creationId xmlns:a16="http://schemas.microsoft.com/office/drawing/2014/main" id="{821CC196-585E-D84C-FB6E-563F1B643773}"/>
-                  </a:ext>
-                </a:extLst>
-              </p:cNvPr>
-              <p:cNvSpPr txBox="1"/>
-              <p:nvPr/>
-            </p:nvSpPr>
-            <p:spPr>
-              <a:xfrm>
-                <a:off x="4299651" y="6479947"/>
-                <a:ext cx="1651119" cy="369332"/>
-              </a:xfrm>
-              <a:prstGeom prst="rect">
-                <a:avLst/>
-              </a:prstGeom>
-              <a:noFill/>
-            </p:spPr>
-            <p:txBody>
-              <a:bodyPr wrap="square" rtlCol="0">
-                <a:spAutoFit/>
-              </a:bodyPr>
+              <a:bodyPr wrap="none" rtlCol="0" anchor="ctr" lIns="0" rIns="0" tIns="0" bIns="0"/>
               <a:lstStyle/>
               <a:p>
                 <a:pPr marL="0" marR="0" lvl="0" indent="0" algn="ctr" defTabSz="914400" rtl="0" eaLnBrk="1" fontAlgn="auto" latinLnBrk="0" hangingPunct="1">
@@ -20829,7 +20747,7 @@
                   <a:defRPr/>
                 </a:pPr>
                 <a:r>
-                  <a:rPr kumimoji="0" lang="es-PE" sz="1800" b="1" i="0" u="none" strike="noStrike" kern="1200" cap="none" spc="0" normalizeH="0" baseline="0" noProof="0" dirty="0">
+                  <a:rPr kumimoji="0" lang="es-PE" sz="1600" b="1" i="0" u="none" strike="noStrike" kern="1200" cap="none" spc="0" normalizeH="0" baseline="0" noProof="0" dirty="0">
                     <a:ln>
                       <a:noFill/>
                     </a:ln>
@@ -20843,7 +20761,70 @@
                     <a:ea typeface="+mn-ea"/>
                     <a:cs typeface="+mn-cs"/>
                   </a:rPr>
-                  <a:t>{{#F13}}</a:t>
+                  <a:t>{{#F48}}</a:t>
+                </a:r>
+              </a:p>
+            </p:txBody>
+          </p:sp>
+          <p:sp>
+            <p:nvSpPr>
+              <p:cNvPr id="39" name="CuadroTexto 38">
+                <a:extLst>
+                  <a:ext uri="{FF2B5EF4-FFF2-40B4-BE49-F238E27FC236}">
+                    <a16:creationId xmlns:a16="http://schemas.microsoft.com/office/drawing/2014/main" id="{821CC196-585E-D84C-FB6E-563F1B643773}"/>
+                  </a:ext>
+                </a:extLst>
+              </p:cNvPr>
+              <p:cNvSpPr txBox="1"/>
+              <p:nvPr/>
+            </p:nvSpPr>
+            <p:spPr>
+              <a:xfrm>
+                <a:off x="4323333" y="6541669"/>
+                <a:ext cx="1600278" cy="219459"/>
+              </a:xfrm>
+              <a:prstGeom prst="rect">
+                <a:avLst/>
+              </a:prstGeom>
+              <a:noFill/>
+            </p:spPr>
+            <p:txBody>
+              <a:bodyPr wrap="none" rtlCol="0" anchor="ctr" lIns="0" rIns="0" tIns="0" bIns="0"/>
+              <a:lstStyle/>
+              <a:p>
+                <a:pPr marL="0" marR="0" lvl="0" indent="0" algn="ctr" defTabSz="914400" rtl="0" eaLnBrk="1" fontAlgn="auto" latinLnBrk="0" hangingPunct="1">
+                  <a:lnSpc>
+                    <a:spcPct val="100000"/>
+                  </a:lnSpc>
+                  <a:spcBef>
+                    <a:spcPts val="0"/>
+                  </a:spcBef>
+                  <a:spcAft>
+                    <a:spcPts val="0"/>
+                  </a:spcAft>
+                  <a:buClrTx/>
+                  <a:buSzTx/>
+                  <a:buFontTx/>
+                  <a:buNone/>
+                  <a:tabLst/>
+                  <a:defRPr/>
+                </a:pPr>
+                <a:r>
+                  <a:rPr kumimoji="0" lang="es-PE" sz="1600" b="1" i="0" u="none" strike="noStrike" kern="1200" cap="none" spc="0" normalizeH="0" baseline="0" noProof="0" dirty="0">
+                    <a:ln>
+                      <a:noFill/>
+                    </a:ln>
+                    <a:solidFill>
+                      <a:srgbClr val="000000"/>
+                    </a:solidFill>
+                    <a:effectLst/>
+                    <a:uLnTx/>
+                    <a:uFillTx/>
+                    <a:latin typeface="Abadi ExtraLight" panose="020B0204020104020204" pitchFamily="34" charset="0"/>
+                    <a:ea typeface="+mn-ea"/>
+                    <a:cs typeface="+mn-cs"/>
+                  </a:rPr>
+                  <a:t>{{#F15}}</a:t>
                 </a:r>
               </a:p>
             </p:txBody>
@@ -20885,7 +20866,7 @@
                 </a:solidFill>
                 <a:latin typeface="Arial"/>
               </a:rPr>
-              <a:t>{{#F48}}</a:t>
+              <a:t>{{#F49}}</a:t>
             </a:r>
             <a:endParaRPr lang="es-PE" sz="1400" dirty="0">
               <a:solidFill>
@@ -20930,7 +20911,7 @@
                 </a:solidFill>
                 <a:latin typeface="Arial"/>
               </a:rPr>
-              <a:t>{{#F49}}</a:t>
+              <a:t>{{#F50}}</a:t>
             </a:r>
             <a:endParaRPr lang="es-PE" sz="1400" dirty="0">
               <a:solidFill>
@@ -20975,7 +20956,7 @@
                 </a:solidFill>
                 <a:latin typeface="Arial"/>
               </a:rPr>
-              <a:t>{{#F50}}</a:t>
+              <a:t>{{#F9}}</a:t>
             </a:r>
             <a:endParaRPr lang="es-PE" sz="1400" dirty="0">
               <a:solidFill>
@@ -21166,7 +21147,7 @@
                 </a:solidFill>
                 <a:latin typeface="Aptos Light" panose="020B0004020202020204" pitchFamily="34" charset="0"/>
               </a:rPr>
-              <a:t>{{#F14}}</a:t>
+              <a:t>{{#F16}}</a:t>
             </a:r>
             <a:endParaRPr lang="es-PE" dirty="0">
               <a:solidFill>
@@ -21263,7 +21244,7 @@
                   </a:schemeClr>
                 </a:solidFill>
               </a:rPr>
-              <a:t>{{#F15}}</a:t>
+              <a:t>{{#F17}}</a:t>
             </a:r>
             <a:endParaRPr lang="es-PE" sz="1600" dirty="0">
               <a:solidFill>
@@ -21328,7 +21309,7 @@
                 </a:solidFill>
                 <a:latin typeface="Aptos Light" panose="020B0004020202020204" pitchFamily="34" charset="0"/>
               </a:rPr>
-              <a:t>{{#F16}}</a:t>
+              <a:t>{{#F18}}</a:t>
             </a:r>
             <a:endParaRPr lang="es-PE" dirty="0">
               <a:solidFill>
@@ -21425,7 +21406,7 @@
                   </a:schemeClr>
                 </a:solidFill>
               </a:rPr>
-              <a:t>{{#F17}}</a:t>
+              <a:t>{{#F19}}</a:t>
             </a:r>
             <a:endParaRPr lang="es-PE" sz="1600" dirty="0">
               <a:solidFill>
@@ -21490,7 +21471,7 @@
                 </a:solidFill>
                 <a:latin typeface="Aptos Light" panose="020B0004020202020204" pitchFamily="34" charset="0"/>
               </a:rPr>
-              <a:t>{{#F18}}</a:t>
+              <a:t>{{#F20}}</a:t>
             </a:r>
             <a:endParaRPr lang="es-PE" dirty="0">
               <a:solidFill>
@@ -21587,7 +21568,7 @@
                   </a:schemeClr>
                 </a:solidFill>
               </a:rPr>
-              <a:t>{{#F19}}</a:t>
+              <a:t>{{#F21}}</a:t>
             </a:r>
             <a:endParaRPr lang="es-PE" sz="1600" dirty="0">
               <a:solidFill>
@@ -21652,7 +21633,7 @@
                 </a:solidFill>
                 <a:latin typeface="Aptos Light" panose="020B0004020202020204" pitchFamily="34" charset="0"/>
               </a:rPr>
-              <a:t>{{#F20}}</a:t>
+              <a:t>{{#F22}}</a:t>
             </a:r>
             <a:endParaRPr lang="es-PE" dirty="0">
               <a:solidFill>
@@ -21749,7 +21730,7 @@
                   </a:schemeClr>
                 </a:solidFill>
               </a:rPr>
-              <a:t>{{#F21}}</a:t>
+              <a:t>{{#F23}}</a:t>
             </a:r>
             <a:endParaRPr lang="es-PE" sz="1600" dirty="0">
               <a:solidFill>
@@ -21775,8 +21756,8 @@
         </p:nvSpPr>
         <p:spPr>
           <a:xfrm>
-            <a:off x="393631" y="1902464"/>
-            <a:ext cx="1809621" cy="577298"/>
+            <a:off x="417405" y="1928617"/>
+            <a:ext cx="1757225" cy="512097"/>
           </a:xfrm>
           <a:prstGeom prst="rect">
             <a:avLst/>
@@ -21803,18 +21784,18 @@
           </a:fontRef>
         </p:style>
         <p:txBody>
-          <a:bodyPr rtlCol="0" anchor="ctr"/>
+          <a:bodyPr rtlCol="0" anchor="ctr" wrap="none" lIns="0" rIns="0" tIns="0" bIns="0"/>
           <a:lstStyle/>
           <a:p>
             <a:pPr algn="ctr"/>
             <a:r>
-              <a:rPr lang="es-ES" sz="3600" dirty="0">
+              <a:rPr lang="es-ES" sz="3600" dirty="0" b="0">
                 <a:solidFill>
                   <a:srgbClr val="FF0000"/>
                 </a:solidFill>
-                <a:latin typeface="Aptos Light" panose="020B0004020202020204" pitchFamily="34" charset="0"/>
+                <a:latin typeface="Aptos Light"/>
               </a:rPr>
-              <a:t>{{#F22}}</a:t>
+              <a:t>{{#F24}}</a:t>
             </a:r>
             <a:endParaRPr lang="es-PE" dirty="0">
               <a:solidFill>
@@ -21839,8 +21820,8 @@
         </p:nvSpPr>
         <p:spPr>
           <a:xfrm>
-            <a:off x="4167683" y="1821817"/>
-            <a:ext cx="1789145" cy="577298"/>
+            <a:off x="4194201" y="1864522"/>
+            <a:ext cx="1738212" cy="512097"/>
           </a:xfrm>
           <a:prstGeom prst="rect">
             <a:avLst/>
@@ -21867,18 +21848,18 @@
           </a:fontRef>
         </p:style>
         <p:txBody>
-          <a:bodyPr rtlCol="0" anchor="ctr"/>
+          <a:bodyPr rtlCol="0" anchor="ctr" wrap="none" lIns="0" rIns="0" tIns="0" bIns="0"/>
           <a:lstStyle/>
           <a:p>
             <a:pPr algn="ctr"/>
             <a:r>
-              <a:rPr lang="es-ES" sz="3600" dirty="0">
+              <a:rPr lang="es-ES" sz="3600" dirty="0" b="0">
                 <a:solidFill>
                   <a:srgbClr val="FF0000"/>
                 </a:solidFill>
-                <a:latin typeface="Aptos Light" panose="020B0004020202020204" pitchFamily="34" charset="0"/>
+                <a:latin typeface="Aptos Light"/>
               </a:rPr>
-              <a:t>{{#F23}}</a:t>
+              <a:t>{{#F25}}</a:t>
             </a:r>
             <a:endParaRPr lang="es-PE" dirty="0">
               <a:solidFill>
@@ -21903,8 +21884,8 @@
         </p:nvSpPr>
         <p:spPr>
           <a:xfrm>
-            <a:off x="4130621" y="2238501"/>
-            <a:ext cx="1838305" cy="369332"/>
+            <a:off x="4194171" y="2376577"/>
+            <a:ext cx="1738178" cy="237747"/>
           </a:xfrm>
           <a:prstGeom prst="rect">
             <a:avLst/>
@@ -21912,9 +21893,7 @@
           <a:noFill/>
         </p:spPr>
         <p:txBody>
-          <a:bodyPr wrap="square" rtlCol="0">
-            <a:spAutoFit/>
-          </a:bodyPr>
+          <a:bodyPr wrap="none" rtlCol="0" anchor="ctr" lIns="0" rIns="0" tIns="0" bIns="0"/>
           <a:lstStyle/>
           <a:p>
             <a:pPr marL="0" marR="0" lvl="0" indent="0" algn="ctr" defTabSz="914400" rtl="0" eaLnBrk="1" fontAlgn="auto" latinLnBrk="0" hangingPunct="1">
@@ -21935,7 +21914,7 @@
               <a:defRPr/>
             </a:pPr>
             <a:r>
-              <a:rPr kumimoji="0" lang="es-PE" sz="1700" b="1" i="0" u="none" strike="noStrike" kern="1200" cap="none" spc="0" normalizeH="0" baseline="0" noProof="0" dirty="0">
+              <a:rPr kumimoji="0" lang="es-PE" sz="1600" b="1" i="0" u="none" strike="noStrike" kern="1200" cap="none" spc="0" normalizeH="0" baseline="0" noProof="0" dirty="0">
                 <a:ln>
                   <a:noFill/>
                 </a:ln>
@@ -21968,8 +21947,8 @@
         </p:nvSpPr>
         <p:spPr>
           <a:xfrm>
-            <a:off x="4157569" y="2469023"/>
-            <a:ext cx="1811357" cy="369332"/>
+            <a:off x="4194145" y="2596035"/>
+            <a:ext cx="1738204" cy="219459"/>
           </a:xfrm>
           <a:prstGeom prst="rect">
             <a:avLst/>
@@ -21977,9 +21956,7 @@
           <a:noFill/>
         </p:spPr>
         <p:txBody>
-          <a:bodyPr wrap="square" rtlCol="0">
-            <a:spAutoFit/>
-          </a:bodyPr>
+          <a:bodyPr wrap="none" rtlCol="0" anchor="ctr" lIns="0" rIns="0" tIns="0" bIns="0"/>
           <a:lstStyle/>
           <a:p>
             <a:pPr marL="0" marR="0" lvl="0" indent="0" algn="ctr" defTabSz="914400" rtl="0" eaLnBrk="1" fontAlgn="auto" latinLnBrk="0" hangingPunct="1">
@@ -22000,7 +21977,7 @@
               <a:defRPr/>
             </a:pPr>
             <a:r>
-              <a:rPr kumimoji="0" lang="es-PE" sz="1800" b="1" i="0" u="none" strike="noStrike" kern="1200" cap="none" spc="0" normalizeH="0" baseline="0" noProof="0" dirty="0">
+              <a:rPr kumimoji="0" lang="es-PE" sz="1600" b="1" i="0" u="none" strike="noStrike" kern="1200" cap="none" spc="0" normalizeH="0" baseline="0" noProof="0" dirty="0">
                 <a:ln>
                   <a:noFill/>
                 </a:ln>
@@ -22014,7 +21991,7 @@
                 <a:ea typeface="+mn-ea"/>
                 <a:cs typeface="+mn-cs"/>
               </a:rPr>
-              <a:t>{{#F24}}</a:t>
+              <a:t>{{#F26}}</a:t>
             </a:r>
           </a:p>
         </p:txBody>
@@ -22033,8 +22010,8 @@
         </p:nvSpPr>
         <p:spPr>
           <a:xfrm>
-            <a:off x="6039812" y="1817497"/>
-            <a:ext cx="1649965" cy="577298"/>
+            <a:off x="6079771" y="1852886"/>
+            <a:ext cx="1578000" cy="512097"/>
           </a:xfrm>
           <a:prstGeom prst="rect">
             <a:avLst/>
@@ -22061,18 +22038,18 @@
           </a:fontRef>
         </p:style>
         <p:txBody>
-          <a:bodyPr rtlCol="0" anchor="ctr"/>
+          <a:bodyPr rtlCol="0" anchor="ctr" wrap="none" lIns="0" rIns="0" tIns="0" bIns="0"/>
           <a:lstStyle/>
           <a:p>
             <a:pPr algn="ctr"/>
             <a:r>
-              <a:rPr lang="es-ES" sz="3600" dirty="0">
+              <a:rPr lang="es-ES" sz="3600" dirty="0" b="0">
                 <a:solidFill>
                   <a:srgbClr val="FF0000"/>
                 </a:solidFill>
-                <a:latin typeface="Aptos Light" panose="020B0004020202020204" pitchFamily="34" charset="0"/>
+                <a:latin typeface="Aptos Light"/>
               </a:rPr>
-              <a:t>{{#F25}}</a:t>
+              <a:t>{{#F27}}</a:t>
             </a:r>
             <a:endParaRPr lang="es-PE" dirty="0">
               <a:solidFill>
@@ -22097,8 +22074,8 @@
         </p:nvSpPr>
         <p:spPr>
           <a:xfrm>
-            <a:off x="6002068" y="2188393"/>
-            <a:ext cx="1725452" cy="369332"/>
+            <a:off x="6079791" y="2364874"/>
+            <a:ext cx="1577961" cy="237747"/>
           </a:xfrm>
           <a:prstGeom prst="rect">
             <a:avLst/>
@@ -22106,9 +22083,7 @@
           <a:noFill/>
         </p:spPr>
         <p:txBody>
-          <a:bodyPr wrap="square" rtlCol="0">
-            <a:spAutoFit/>
-          </a:bodyPr>
+          <a:bodyPr wrap="none" rtlCol="0" anchor="ctr" lIns="0" rIns="0" tIns="0" bIns="0"/>
           <a:lstStyle/>
           <a:p>
             <a:pPr marL="0" marR="0" lvl="0" indent="0" algn="ctr" defTabSz="914400" rtl="0" eaLnBrk="1" fontAlgn="auto" latinLnBrk="0" hangingPunct="1">
@@ -22129,7 +22104,7 @@
               <a:defRPr/>
             </a:pPr>
             <a:r>
-              <a:rPr kumimoji="0" lang="es-PE" sz="1700" b="1" i="0" u="none" strike="noStrike" kern="1200" cap="none" spc="0" normalizeH="0" baseline="0" noProof="0" dirty="0">
+              <a:rPr kumimoji="0" lang="es-PE" sz="1600" b="1" i="0" u="none" strike="noStrike" kern="1200" cap="none" spc="0" normalizeH="0" baseline="0" noProof="0" dirty="0">
                 <a:ln>
                   <a:noFill/>
                 </a:ln>
@@ -22162,8 +22137,8 @@
         </p:nvSpPr>
         <p:spPr>
           <a:xfrm>
-            <a:off x="5998025" y="2453308"/>
-            <a:ext cx="1811357" cy="369332"/>
+            <a:off x="6079773" y="2584343"/>
+            <a:ext cx="1577999" cy="219459"/>
           </a:xfrm>
           <a:prstGeom prst="rect">
             <a:avLst/>
@@ -22171,9 +22146,7 @@
           <a:noFill/>
         </p:spPr>
         <p:txBody>
-          <a:bodyPr wrap="square" rtlCol="0">
-            <a:spAutoFit/>
-          </a:bodyPr>
+          <a:bodyPr wrap="none" rtlCol="0" anchor="ctr" lIns="0" rIns="0" tIns="0" bIns="0"/>
           <a:lstStyle/>
           <a:p>
             <a:pPr marL="0" marR="0" lvl="0" indent="0" algn="ctr" defTabSz="914400" rtl="0" eaLnBrk="1" fontAlgn="auto" latinLnBrk="0" hangingPunct="1">
@@ -22194,7 +22167,7 @@
               <a:defRPr/>
             </a:pPr>
             <a:r>
-              <a:rPr kumimoji="0" lang="es-PE" sz="1800" b="1" i="0" u="none" strike="noStrike" kern="1200" cap="none" spc="0" normalizeH="0" baseline="0" noProof="0" dirty="0">
+              <a:rPr kumimoji="0" lang="es-PE" sz="1600" b="1" i="0" u="none" strike="noStrike" kern="1200" cap="none" spc="0" normalizeH="0" baseline="0" noProof="0" dirty="0">
                 <a:ln>
                   <a:noFill/>
                 </a:ln>
@@ -22208,7 +22181,7 @@
                 <a:ea typeface="+mn-ea"/>
                 <a:cs typeface="+mn-cs"/>
               </a:rPr>
-              <a:t>{{#F26}}</a:t>
+              <a:t>{{#F28}}</a:t>
             </a:r>
           </a:p>
         </p:txBody>
@@ -22227,8 +22200,8 @@
         </p:nvSpPr>
         <p:spPr>
           <a:xfrm>
-            <a:off x="2273715" y="1897481"/>
-            <a:ext cx="1677260" cy="577298"/>
+            <a:off x="2301695" y="1912112"/>
+            <a:ext cx="1600268" cy="512097"/>
           </a:xfrm>
           <a:prstGeom prst="rect">
             <a:avLst/>
@@ -22255,18 +22228,18 @@
           </a:fontRef>
         </p:style>
         <p:txBody>
-          <a:bodyPr rtlCol="0" anchor="ctr"/>
+          <a:bodyPr rtlCol="0" anchor="ctr" wrap="none" lIns="0" rIns="0" tIns="0" bIns="0"/>
           <a:lstStyle/>
           <a:p>
             <a:pPr algn="ctr"/>
             <a:r>
-              <a:rPr lang="es-ES" sz="3600" dirty="0">
+              <a:rPr lang="es-ES" sz="3600" dirty="0" b="0">
                 <a:solidFill>
                   <a:srgbClr val="FF0000"/>
                 </a:solidFill>
-                <a:latin typeface="Aptos Light" panose="020B0004020202020204" pitchFamily="34" charset="0"/>
+                <a:latin typeface="Aptos Light"/>
               </a:rPr>
-              <a:t>{{#F27}}</a:t>
+              <a:t>{{#F29}}</a:t>
             </a:r>
             <a:endParaRPr lang="es-PE" dirty="0">
               <a:solidFill>

</xml_diff>

<commit_message>
Vista PPT: ediciones atadas a la versión de la plantilla; fila de arriba de la diapositiva 2 con más aire
</commit_message>
<xml_diff>
--- a/lib/plantilla_reporte.pptx
+++ b/lib/plantilla_reporte.pptx
@@ -19321,8 +19321,8 @@
               </p:nvSpPr>
               <p:spPr>
                 <a:xfrm>
-                  <a:off x="6807770" y="4506905"/>
-                  <a:ext cx="2024738" cy="512090"/>
+                  <a:off x="6807770" y="4479471"/>
+                  <a:ext cx="2024738" cy="493801"/>
                 </a:xfrm>
                 <a:prstGeom prst="rect">
                   <a:avLst/>
@@ -19402,8 +19402,8 @@
               </p:nvSpPr>
               <p:spPr>
                 <a:xfrm>
-                  <a:off x="6807745" y="5018992"/>
-                  <a:ext cx="2024756" cy="237747"/>
+                  <a:off x="6807745" y="4964127"/>
+                  <a:ext cx="2024756" cy="228603"/>
                 </a:xfrm>
                 <a:prstGeom prst="rect">
                   <a:avLst/>
@@ -19465,7 +19465,7 @@
               </p:nvSpPr>
               <p:spPr>
                 <a:xfrm>
-                  <a:off x="6807740" y="5238415"/>
+                  <a:off x="6807740" y="5165262"/>
                   <a:ext cx="2024810" cy="219459"/>
                 </a:xfrm>
                 <a:prstGeom prst="rect">
@@ -19711,8 +19711,8 @@
               </p:nvSpPr>
               <p:spPr>
                 <a:xfrm>
-                  <a:off x="6755290" y="4536259"/>
-                  <a:ext cx="2024738" cy="512090"/>
+                  <a:off x="6755290" y="4508826"/>
+                  <a:ext cx="2024738" cy="493801"/>
                 </a:xfrm>
                 <a:prstGeom prst="rect">
                   <a:avLst/>
@@ -19766,8 +19766,8 @@
               </p:nvSpPr>
               <p:spPr>
                 <a:xfrm>
-                  <a:off x="6755233" y="5048379"/>
-                  <a:ext cx="2024756" cy="237747"/>
+                  <a:off x="6755233" y="4993514"/>
+                  <a:ext cx="2024756" cy="228603"/>
                 </a:xfrm>
                 <a:prstGeom prst="rect">
                   <a:avLst/>
@@ -19829,7 +19829,7 @@
               </p:nvSpPr>
               <p:spPr>
                 <a:xfrm>
-                  <a:off x="6755226" y="5267778"/>
+                  <a:off x="6755226" y="5194625"/>
                   <a:ext cx="2024805" cy="219459"/>
                 </a:xfrm>
                 <a:prstGeom prst="rect">
@@ -20266,8 +20266,8 @@
             </p:nvSpPr>
             <p:spPr>
               <a:xfrm>
-                <a:off x="1908848" y="6343824"/>
-                <a:ext cx="1757230" cy="237747"/>
+                <a:off x="1908848" y="6288959"/>
+                <a:ext cx="1757230" cy="228603"/>
               </a:xfrm>
               <a:prstGeom prst="rect">
                 <a:avLst/>
@@ -20329,7 +20329,7 @@
             </p:nvSpPr>
             <p:spPr>
               <a:xfrm>
-                <a:off x="1908927" y="6563260"/>
+                <a:off x="1908927" y="6490107"/>
                 <a:ext cx="1757191" cy="219459"/>
               </a:xfrm>
               <a:prstGeom prst="rect">
@@ -20717,8 +20717,8 @@
             </p:nvSpPr>
             <p:spPr>
               <a:xfrm>
-                <a:off x="4323334" y="6322216"/>
-                <a:ext cx="1600307" cy="237747"/>
+                <a:off x="4323334" y="6267351"/>
+                <a:ext cx="1600307" cy="228603"/>
               </a:xfrm>
               <a:prstGeom prst="rect">
                 <a:avLst/>
@@ -20780,7 +20780,7 @@
             </p:nvSpPr>
             <p:spPr>
               <a:xfrm>
-                <a:off x="4323333" y="6541669"/>
+                <a:off x="4323333" y="6468516"/>
                 <a:ext cx="1600278" cy="219459"/>
               </a:xfrm>
               <a:prstGeom prst="rect">
@@ -21756,8 +21756,8 @@
         </p:nvSpPr>
         <p:spPr>
           <a:xfrm>
-            <a:off x="417405" y="1928617"/>
-            <a:ext cx="1757225" cy="512097"/>
+            <a:off x="417405" y="1901183"/>
+            <a:ext cx="1757225" cy="493807"/>
           </a:xfrm>
           <a:prstGeom prst="rect">
             <a:avLst/>
@@ -21820,8 +21820,8 @@
         </p:nvSpPr>
         <p:spPr>
           <a:xfrm>
-            <a:off x="4194201" y="1864522"/>
-            <a:ext cx="1738212" cy="512097"/>
+            <a:off x="4194201" y="1837088"/>
+            <a:ext cx="1738212" cy="493807"/>
           </a:xfrm>
           <a:prstGeom prst="rect">
             <a:avLst/>
@@ -21884,8 +21884,8 @@
         </p:nvSpPr>
         <p:spPr>
           <a:xfrm>
-            <a:off x="4194171" y="2376577"/>
-            <a:ext cx="1738178" cy="237747"/>
+            <a:off x="4194171" y="2321712"/>
+            <a:ext cx="1738178" cy="228603"/>
           </a:xfrm>
           <a:prstGeom prst="rect">
             <a:avLst/>
@@ -21947,7 +21947,7 @@
         </p:nvSpPr>
         <p:spPr>
           <a:xfrm>
-            <a:off x="4194145" y="2596035"/>
+            <a:off x="4194145" y="2522882"/>
             <a:ext cx="1738204" cy="219459"/>
           </a:xfrm>
           <a:prstGeom prst="rect">
@@ -22010,8 +22010,8 @@
         </p:nvSpPr>
         <p:spPr>
           <a:xfrm>
-            <a:off x="6079771" y="1852886"/>
-            <a:ext cx="1578000" cy="512097"/>
+            <a:off x="6079771" y="1825452"/>
+            <a:ext cx="1578000" cy="493807"/>
           </a:xfrm>
           <a:prstGeom prst="rect">
             <a:avLst/>
@@ -22074,8 +22074,8 @@
         </p:nvSpPr>
         <p:spPr>
           <a:xfrm>
-            <a:off x="6079791" y="2364874"/>
-            <a:ext cx="1577961" cy="237747"/>
+            <a:off x="6079791" y="2310010"/>
+            <a:ext cx="1577961" cy="228603"/>
           </a:xfrm>
           <a:prstGeom prst="rect">
             <a:avLst/>
@@ -22137,7 +22137,7 @@
         </p:nvSpPr>
         <p:spPr>
           <a:xfrm>
-            <a:off x="6079773" y="2584343"/>
+            <a:off x="6079773" y="2511190"/>
             <a:ext cx="1577999" cy="219459"/>
           </a:xfrm>
           <a:prstGeom prst="rect">
@@ -22200,8 +22200,8 @@
         </p:nvSpPr>
         <p:spPr>
           <a:xfrm>
-            <a:off x="2301695" y="1912112"/>
-            <a:ext cx="1600268" cy="512097"/>
+            <a:off x="2301695" y="1884678"/>
+            <a:ext cx="1600268" cy="493807"/>
           </a:xfrm>
           <a:prstGeom prst="rect">
             <a:avLst/>

</xml_diff>

<commit_message>
Diapositiva 2: los seis recuadros de arriba del mismo tamaño y a la misma altura
</commit_message>
<xml_diff>
--- a/lib/plantilla_reporte.pptx
+++ b/lib/plantilla_reporte.pptx
@@ -18138,8 +18138,8 @@
           </p:nvSpPr>
           <p:spPr>
             <a:xfrm>
-              <a:off x="728209" y="1584787"/>
-              <a:ext cx="1929439" cy="323165"/>
+              <a:off x="787918" y="1629137"/>
+              <a:ext cx="1700751" cy="292622"/>
             </a:xfrm>
             <a:prstGeom prst="rect">
               <a:avLst/>
@@ -18147,12 +18147,10 @@
             <a:noFill/>
           </p:spPr>
           <p:txBody>
-            <a:bodyPr wrap="none" rtlCol="0">
-              <a:spAutoFit/>
-            </a:bodyPr>
+            <a:bodyPr wrap="none" rtlCol="0" anchor="ctr" lIns="0" rIns="0" tIns="0" bIns="0"/>
             <a:lstStyle/>
             <a:p>
-              <a:pPr marL="0" marR="0" lvl="0" indent="0" algn="l" defTabSz="914400" rtl="0" eaLnBrk="1" fontAlgn="auto" latinLnBrk="0" hangingPunct="1">
+              <a:pPr marL="0" marR="0" lvl="0" indent="0" algn="ctr" defTabSz="914400" rtl="0" eaLnBrk="1" fontAlgn="auto" latinLnBrk="0" hangingPunct="1">
                 <a:lnSpc>
                   <a:spcPct val="100000"/>
                 </a:lnSpc>
@@ -18170,7 +18168,7 @@
                 <a:defRPr/>
               </a:pPr>
               <a:r>
-                <a:rPr kumimoji="0" lang="es-PE" sz="1500" b="0" i="0" u="sng" strike="noStrike" kern="1200" cap="none" spc="0" normalizeH="0" baseline="0" noProof="0" dirty="0">
+                <a:rPr kumimoji="0" lang="es-PE" sz="1400" b="0" i="0" u="sng" strike="noStrike" kern="1200" cap="none" spc="0" normalizeH="0" baseline="0" noProof="0" dirty="0">
                   <a:ln>
                     <a:noFill/>
                   </a:ln>
@@ -18203,8 +18201,8 @@
           </p:nvSpPr>
           <p:spPr>
             <a:xfrm>
-              <a:off x="2800426" y="1508254"/>
-              <a:ext cx="1316386" cy="369332"/>
+              <a:off x="2616720" y="1629139"/>
+              <a:ext cx="1700804" cy="292612"/>
             </a:xfrm>
             <a:prstGeom prst="rect">
               <a:avLst/>
@@ -18212,12 +18210,10 @@
             <a:noFill/>
           </p:spPr>
           <p:txBody>
-            <a:bodyPr wrap="none" rtlCol="0">
-              <a:spAutoFit/>
-            </a:bodyPr>
+            <a:bodyPr wrap="none" rtlCol="0" anchor="ctr" lIns="0" rIns="0" tIns="0" bIns="0"/>
             <a:lstStyle/>
             <a:p>
-              <a:pPr marL="0" marR="0" lvl="0" indent="0" algn="l" defTabSz="914400" rtl="0" eaLnBrk="1" fontAlgn="auto" latinLnBrk="0" hangingPunct="1">
+              <a:pPr marL="0" marR="0" lvl="0" indent="0" algn="ctr" defTabSz="914400" rtl="0" eaLnBrk="1" fontAlgn="auto" latinLnBrk="0" hangingPunct="1">
                 <a:lnSpc>
                   <a:spcPct val="100000"/>
                 </a:lnSpc>
@@ -18235,7 +18231,7 @@
                 <a:defRPr/>
               </a:pPr>
               <a:r>
-                <a:rPr kumimoji="0" lang="es-PE" sz="1800" b="0" i="0" u="sng" strike="noStrike" kern="1200" cap="none" spc="0" normalizeH="0" baseline="0" noProof="0" dirty="0">
+                <a:rPr kumimoji="0" lang="es-PE" sz="1400" b="0" i="0" u="sng" strike="noStrike" kern="1200" cap="none" spc="0" normalizeH="0" baseline="0" noProof="0" dirty="0">
                   <a:ln>
                     <a:noFill/>
                   </a:ln>
@@ -18282,8 +18278,8 @@
           </p:nvSpPr>
           <p:spPr>
             <a:xfrm>
-              <a:off x="784355" y="1546064"/>
-              <a:ext cx="1811357" cy="1285547"/>
+              <a:off x="787921" y="1592606"/>
+              <a:ext cx="1700804" cy="1298439"/>
             </a:xfrm>
             <a:prstGeom prst="roundRect">
               <a:avLst/>
@@ -18307,7 +18303,7 @@
             </a:fontRef>
           </p:style>
           <p:txBody>
-            <a:bodyPr rtlCol="0" anchor="ctr"/>
+            <a:bodyPr rtlCol="0" anchor="ctr" wrap="none" lIns="0" rIns="0" tIns="0" bIns="0"/>
             <a:lstStyle/>
             <a:p>
               <a:pPr marL="0" marR="0" lvl="0" indent="0" algn="ctr" defTabSz="914400" rtl="0" eaLnBrk="1" fontAlgn="auto" latinLnBrk="0" hangingPunct="1">
@@ -18358,8 +18354,8 @@
           </p:nvSpPr>
           <p:spPr>
             <a:xfrm>
-              <a:off x="2669946" y="1534360"/>
-              <a:ext cx="1651130" cy="1271354"/>
+              <a:off x="2616727" y="1592606"/>
+              <a:ext cx="1700781" cy="1298419"/>
             </a:xfrm>
             <a:prstGeom prst="roundRect">
               <a:avLst/>
@@ -18391,7 +18387,7 @@
             </a:fontRef>
           </p:style>
           <p:txBody>
-            <a:bodyPr rtlCol="0" anchor="ctr"/>
+            <a:bodyPr rtlCol="0" anchor="ctr" wrap="none" lIns="0" rIns="0" tIns="0" bIns="0"/>
             <a:lstStyle/>
             <a:p>
               <a:pPr marL="0" marR="0" lvl="0" indent="0" algn="ctr" defTabSz="914400" rtl="0" eaLnBrk="1" fontAlgn="auto" latinLnBrk="0" hangingPunct="1">
@@ -19321,8 +19317,8 @@
               </p:nvSpPr>
               <p:spPr>
                 <a:xfrm>
-                  <a:off x="6807770" y="4479471"/>
-                  <a:ext cx="2024738" cy="493801"/>
+                  <a:off x="7049148" y="4487153"/>
+                  <a:ext cx="1843212" cy="493801"/>
                 </a:xfrm>
                 <a:prstGeom prst="rect">
                   <a:avLst/>
@@ -19402,8 +19398,8 @@
               </p:nvSpPr>
               <p:spPr>
                 <a:xfrm>
-                  <a:off x="6807745" y="4964127"/>
-                  <a:ext cx="2024756" cy="228603"/>
+                  <a:off x="7049125" y="4971808"/>
+                  <a:ext cx="1843229" cy="228603"/>
                 </a:xfrm>
                 <a:prstGeom prst="rect">
                   <a:avLst/>
@@ -19465,8 +19461,8 @@
               </p:nvSpPr>
               <p:spPr>
                 <a:xfrm>
-                  <a:off x="6807740" y="5165262"/>
-                  <a:ext cx="2024810" cy="219459"/>
+                  <a:off x="7049127" y="5172943"/>
+                  <a:ext cx="1843279" cy="219459"/>
                 </a:xfrm>
                 <a:prstGeom prst="rect">
                   <a:avLst/>
@@ -19529,8 +19525,8 @@
             </p:nvSpPr>
             <p:spPr>
               <a:xfrm>
-                <a:off x="6983671" y="4194810"/>
-                <a:ext cx="2107617" cy="1318711"/>
+                <a:off x="7225105" y="4202490"/>
+                <a:ext cx="1926088" cy="1298411"/>
               </a:xfrm>
               <a:prstGeom prst="roundRect">
                 <a:avLst/>
@@ -19554,7 +19550,7 @@
               </a:fontRef>
             </p:style>
             <p:txBody>
-              <a:bodyPr rtlCol="0" anchor="ctr"/>
+              <a:bodyPr rtlCol="0" anchor="ctr" wrap="none" lIns="0" rIns="0" tIns="0" bIns="0"/>
               <a:lstStyle/>
               <a:p>
                 <a:pPr marL="0" marR="0" lvl="0" indent="0" algn="ctr" defTabSz="914400" rtl="0" eaLnBrk="1" fontAlgn="auto" latinLnBrk="0" hangingPunct="1">
@@ -19605,8 +19601,8 @@
             </p:nvSpPr>
             <p:spPr>
               <a:xfrm>
-                <a:off x="6987399" y="4225613"/>
-                <a:ext cx="2185055" cy="323165"/>
+                <a:off x="7225103" y="4239055"/>
+                <a:ext cx="1926070" cy="292622"/>
               </a:xfrm>
               <a:prstGeom prst="rect">
                 <a:avLst/>
@@ -19614,12 +19610,10 @@
               <a:noFill/>
             </p:spPr>
             <p:txBody>
-              <a:bodyPr wrap="none" rtlCol="0">
-                <a:spAutoFit/>
-              </a:bodyPr>
+              <a:bodyPr wrap="none" rtlCol="0" anchor="ctr" lIns="0" rIns="0" tIns="0" bIns="0"/>
               <a:lstStyle/>
               <a:p>
-                <a:pPr marL="0" marR="0" lvl="0" indent="0" algn="l" defTabSz="914400" rtl="0" eaLnBrk="1" fontAlgn="auto" latinLnBrk="0" hangingPunct="1">
+                <a:pPr marL="0" marR="0" lvl="0" indent="0" algn="ctr" defTabSz="914400" rtl="0" eaLnBrk="1" fontAlgn="auto" latinLnBrk="0" hangingPunct="1">
                   <a:lnSpc>
                     <a:spcPct val="100000"/>
                   </a:lnSpc>
@@ -19637,7 +19631,7 @@
                   <a:defRPr/>
                 </a:pPr>
                 <a:r>
-                  <a:rPr kumimoji="0" lang="es-PE" sz="1500" b="0" i="0" u="sng" strike="noStrike" kern="1200" cap="none" spc="0" normalizeH="0" baseline="0" noProof="0" dirty="0">
+                  <a:rPr kumimoji="0" lang="es-PE" sz="1400" b="0" i="0" u="sng" strike="noStrike" kern="1200" cap="none" spc="0" normalizeH="0" baseline="0" noProof="0" dirty="0">
                     <a:ln>
                       <a:noFill/>
                     </a:ln>
@@ -19711,8 +19705,8 @@
               </p:nvSpPr>
               <p:spPr>
                 <a:xfrm>
-                  <a:off x="6755290" y="4508826"/>
-                  <a:ext cx="2024738" cy="493801"/>
+                  <a:off x="6815764" y="4487153"/>
+                  <a:ext cx="1843212" cy="493801"/>
                 </a:xfrm>
                 <a:prstGeom prst="rect">
                   <a:avLst/>
@@ -19766,8 +19760,8 @@
               </p:nvSpPr>
               <p:spPr>
                 <a:xfrm>
-                  <a:off x="6755233" y="4993514"/>
-                  <a:ext cx="2024756" cy="228603"/>
+                  <a:off x="6815707" y="4971842"/>
+                  <a:ext cx="1843229" cy="228603"/>
                 </a:xfrm>
                 <a:prstGeom prst="rect">
                   <a:avLst/>
@@ -19829,8 +19823,8 @@
               </p:nvSpPr>
               <p:spPr>
                 <a:xfrm>
-                  <a:off x="6755226" y="5194625"/>
-                  <a:ext cx="2024805" cy="219459"/>
+                  <a:off x="6815702" y="5172953"/>
+                  <a:ext cx="1843274" cy="219459"/>
                 </a:xfrm>
                 <a:prstGeom prst="rect">
                   <a:avLst/>
@@ -19893,8 +19887,8 @@
             </p:nvSpPr>
             <p:spPr>
               <a:xfrm>
-                <a:off x="6931138" y="4224089"/>
-                <a:ext cx="2107617" cy="1318711"/>
+                <a:off x="6991664" y="4202418"/>
+                <a:ext cx="1926088" cy="1298411"/>
               </a:xfrm>
               <a:prstGeom prst="roundRect">
                 <a:avLst/>
@@ -19926,7 +19920,7 @@
               </a:fontRef>
             </p:style>
             <p:txBody>
-              <a:bodyPr rtlCol="0" anchor="ctr"/>
+              <a:bodyPr rtlCol="0" anchor="ctr" wrap="none" lIns="0" rIns="0" tIns="0" bIns="0"/>
               <a:lstStyle/>
               <a:p>
                 <a:pPr marL="0" marR="0" lvl="0" indent="0" algn="ctr" defTabSz="914400" rtl="0" eaLnBrk="1" fontAlgn="auto" latinLnBrk="0" hangingPunct="1">
@@ -19977,8 +19971,8 @@
             </p:nvSpPr>
             <p:spPr>
               <a:xfrm>
-                <a:off x="7269073" y="4197020"/>
-                <a:ext cx="1352815" cy="338554"/>
+                <a:off x="6991706" y="4239087"/>
+                <a:ext cx="1926083" cy="292645"/>
               </a:xfrm>
               <a:prstGeom prst="rect">
                 <a:avLst/>
@@ -19986,12 +19980,10 @@
               <a:noFill/>
             </p:spPr>
             <p:txBody>
-              <a:bodyPr wrap="none" rtlCol="0">
-                <a:spAutoFit/>
-              </a:bodyPr>
+              <a:bodyPr wrap="none" rtlCol="0" anchor="ctr" lIns="0" rIns="0" tIns="0" bIns="0"/>
               <a:lstStyle/>
               <a:p>
-                <a:pPr marL="0" marR="0" lvl="0" indent="0" algn="l" defTabSz="914400" rtl="0" eaLnBrk="1" fontAlgn="auto" latinLnBrk="0" hangingPunct="1">
+                <a:pPr marL="0" marR="0" lvl="0" indent="0" algn="ctr" defTabSz="914400" rtl="0" eaLnBrk="1" fontAlgn="auto" latinLnBrk="0" hangingPunct="1">
                   <a:lnSpc>
                     <a:spcPct val="100000"/>
                   </a:lnSpc>
@@ -20009,7 +20001,7 @@
                   <a:defRPr/>
                 </a:pPr>
                 <a:r>
-                  <a:rPr kumimoji="0" lang="es-MX" sz="1600" b="0" i="0" u="sng" strike="noStrike" kern="1200" cap="none" spc="0" normalizeH="0" baseline="0" noProof="0" dirty="0">
+                  <a:rPr kumimoji="0" lang="es-MX" sz="1400" b="0" i="0" u="sng" strike="noStrike" kern="1200" cap="none" spc="0" normalizeH="0" baseline="0" noProof="0" dirty="0">
                     <a:ln>
                       <a:noFill/>
                     </a:ln>
@@ -20266,8 +20258,8 @@
             </p:nvSpPr>
             <p:spPr>
               <a:xfrm>
-                <a:off x="1908848" y="6288959"/>
-                <a:ext cx="1757230" cy="228603"/>
+                <a:off x="1933537" y="6271402"/>
+                <a:ext cx="1627658" cy="228603"/>
               </a:xfrm>
               <a:prstGeom prst="rect">
                 <a:avLst/>
@@ -20329,8 +20321,8 @@
             </p:nvSpPr>
             <p:spPr>
               <a:xfrm>
-                <a:off x="1908927" y="6490107"/>
-                <a:ext cx="1757191" cy="219459"/>
+                <a:off x="1933616" y="6472551"/>
+                <a:ext cx="1627621" cy="219459"/>
               </a:xfrm>
               <a:prstGeom prst="rect">
                 <a:avLst/>
@@ -20392,8 +20384,8 @@
             </p:nvSpPr>
             <p:spPr>
               <a:xfrm>
-                <a:off x="1872323" y="5493361"/>
-                <a:ext cx="1830330" cy="1306297"/>
+                <a:off x="1897011" y="5475804"/>
+                <a:ext cx="1700761" cy="1298433"/>
               </a:xfrm>
               <a:prstGeom prst="roundRect">
                 <a:avLst/>
@@ -20417,7 +20409,7 @@
               </a:fontRef>
             </p:style>
             <p:txBody>
-              <a:bodyPr rtlCol="0" anchor="ctr"/>
+              <a:bodyPr rtlCol="0" anchor="ctr" wrap="none" lIns="0" rIns="0" tIns="0" bIns="0"/>
               <a:lstStyle/>
               <a:p>
                 <a:pPr marL="0" marR="0" lvl="0" indent="0" algn="ctr" defTabSz="914400" rtl="0" eaLnBrk="1" fontAlgn="auto" latinLnBrk="0" hangingPunct="1">
@@ -20468,8 +20460,8 @@
             </p:nvSpPr>
             <p:spPr>
               <a:xfrm>
-                <a:off x="1818318" y="5548268"/>
-                <a:ext cx="1929439" cy="323165"/>
+                <a:off x="1897046" y="5512421"/>
+                <a:ext cx="1700751" cy="292622"/>
               </a:xfrm>
               <a:prstGeom prst="rect">
                 <a:avLst/>
@@ -20477,12 +20469,10 @@
               <a:noFill/>
             </p:spPr>
             <p:txBody>
-              <a:bodyPr wrap="none" rtlCol="0">
-                <a:spAutoFit/>
-              </a:bodyPr>
+              <a:bodyPr wrap="none" rtlCol="0" anchor="ctr" lIns="0" rIns="0" tIns="0" bIns="0"/>
               <a:lstStyle/>
               <a:p>
-                <a:pPr marL="0" marR="0" lvl="0" indent="0" algn="l" defTabSz="914400" rtl="0" eaLnBrk="1" fontAlgn="auto" latinLnBrk="0" hangingPunct="1">
+                <a:pPr marL="0" marR="0" lvl="0" indent="0" algn="ctr" defTabSz="914400" rtl="0" eaLnBrk="1" fontAlgn="auto" latinLnBrk="0" hangingPunct="1">
                   <a:lnSpc>
                     <a:spcPct val="100000"/>
                   </a:lnSpc>
@@ -20500,7 +20490,7 @@
                   <a:defRPr/>
                 </a:pPr>
                 <a:r>
-                  <a:rPr kumimoji="0" lang="es-PE" sz="1500" b="0" i="0" u="sng" strike="noStrike" kern="1200" cap="none" spc="0" normalizeH="0" baseline="0" noProof="0" dirty="0">
+                  <a:rPr kumimoji="0" lang="es-PE" sz="1400" b="0" i="0" u="sng" strike="noStrike" kern="1200" cap="none" spc="0" normalizeH="0" baseline="0" noProof="0" dirty="0">
                     <a:ln>
                       <a:noFill/>
                     </a:ln>
@@ -20554,8 +20544,8 @@
             </p:nvSpPr>
             <p:spPr>
               <a:xfrm>
-                <a:off x="4286795" y="5471839"/>
-                <a:ext cx="1673487" cy="1339330"/>
+                <a:off x="4255978" y="5470833"/>
+                <a:ext cx="1700828" cy="1298456"/>
               </a:xfrm>
               <a:prstGeom prst="roundRect">
                 <a:avLst/>
@@ -20587,7 +20577,7 @@
               </a:fontRef>
             </p:style>
             <p:txBody>
-              <a:bodyPr rtlCol="0" anchor="ctr"/>
+              <a:bodyPr rtlCol="0" anchor="ctr" wrap="none" lIns="0" rIns="0" tIns="0" bIns="0"/>
               <a:lstStyle/>
               <a:p>
                 <a:pPr marL="0" marR="0" lvl="0" indent="0" algn="ctr" defTabSz="914400" rtl="0" eaLnBrk="1" fontAlgn="auto" latinLnBrk="0" hangingPunct="1">
@@ -20638,8 +20628,8 @@
             </p:nvSpPr>
             <p:spPr>
               <a:xfrm>
-                <a:off x="4487263" y="5479666"/>
-                <a:ext cx="1610626" cy="369332"/>
+                <a:off x="4255919" y="5507372"/>
+                <a:ext cx="1700785" cy="292612"/>
               </a:xfrm>
               <a:prstGeom prst="rect">
                 <a:avLst/>
@@ -20647,12 +20637,10 @@
               <a:noFill/>
             </p:spPr>
             <p:txBody>
-              <a:bodyPr wrap="square" rtlCol="0">
-                <a:spAutoFit/>
-              </a:bodyPr>
+              <a:bodyPr wrap="none" rtlCol="0" anchor="ctr" lIns="0" rIns="0" tIns="0" bIns="0"/>
               <a:lstStyle/>
               <a:p>
-                <a:pPr marL="0" marR="0" lvl="0" indent="0" algn="l" defTabSz="914400" rtl="0" eaLnBrk="1" fontAlgn="auto" latinLnBrk="0" hangingPunct="1">
+                <a:pPr marL="0" marR="0" lvl="0" indent="0" algn="ctr" defTabSz="914400" rtl="0" eaLnBrk="1" fontAlgn="auto" latinLnBrk="0" hangingPunct="1">
                   <a:lnSpc>
                     <a:spcPct val="100000"/>
                   </a:lnSpc>
@@ -20670,7 +20658,7 @@
                   <a:defRPr/>
                 </a:pPr>
                 <a:r>
-                  <a:rPr kumimoji="0" lang="es-PE" sz="1800" b="0" i="0" u="sng" strike="noStrike" kern="1200" cap="none" spc="0" normalizeH="0" baseline="0" noProof="0" dirty="0">
+                  <a:rPr kumimoji="0" lang="es-PE" sz="1400" b="0" i="0" u="sng" strike="noStrike" kern="1200" cap="none" spc="0" normalizeH="0" baseline="0" noProof="0" dirty="0">
                     <a:ln>
                       <a:noFill/>
                     </a:ln>
@@ -20717,8 +20705,8 @@
             </p:nvSpPr>
             <p:spPr>
               <a:xfrm>
-                <a:off x="4323334" y="6267351"/>
-                <a:ext cx="1600307" cy="228603"/>
+                <a:off x="4292518" y="6266345"/>
+                <a:ext cx="1627647" cy="228603"/>
               </a:xfrm>
               <a:prstGeom prst="rect">
                 <a:avLst/>
@@ -20780,8 +20768,8 @@
             </p:nvSpPr>
             <p:spPr>
               <a:xfrm>
-                <a:off x="4323333" y="6468516"/>
-                <a:ext cx="1600278" cy="219459"/>
+                <a:off x="4292518" y="6467510"/>
+                <a:ext cx="1627619" cy="219459"/>
               </a:xfrm>
               <a:prstGeom prst="rect">
                 <a:avLst/>
@@ -20845,8 +20833,8 @@
         </p:nvSpPr>
         <p:spPr>
           <a:xfrm>
-            <a:off x="497934" y="2911992"/>
-            <a:ext cx="1510029" cy="307777"/>
+            <a:off x="405580" y="2898642"/>
+            <a:ext cx="1700771" cy="274311"/>
           </a:xfrm>
           <a:prstGeom prst="rect">
             <a:avLst/>
@@ -20854,11 +20842,10 @@
           <a:noFill/>
         </p:spPr>
         <p:txBody>
-          <a:bodyPr wrap="none" rtlCol="0">
-            <a:spAutoFit/>
-          </a:bodyPr>
+          <a:bodyPr wrap="none" rtlCol="0" anchor="ctr" lIns="0" rIns="0" tIns="0" bIns="0"/>
           <a:lstStyle/>
           <a:p>
+            <a:pPr algn="ctr"/>
             <a:r>
               <a:rPr lang="es-MX" sz="1300" dirty="0" b="0" i="0">
                 <a:solidFill>
@@ -20890,8 +20877,8 @@
         </p:nvSpPr>
         <p:spPr>
           <a:xfrm>
-            <a:off x="4319038" y="2790856"/>
-            <a:ext cx="1510029" cy="307777"/>
+            <a:off x="4161122" y="2898660"/>
+            <a:ext cx="1700771" cy="274311"/>
           </a:xfrm>
           <a:prstGeom prst="rect">
             <a:avLst/>
@@ -20899,11 +20886,10 @@
           <a:noFill/>
         </p:spPr>
         <p:txBody>
-          <a:bodyPr wrap="none" rtlCol="0">
-            <a:spAutoFit/>
-          </a:bodyPr>
+          <a:bodyPr wrap="none" rtlCol="0" anchor="ctr" lIns="0" rIns="0" tIns="0" bIns="0"/>
           <a:lstStyle/>
           <a:p>
+            <a:pPr algn="ctr"/>
             <a:r>
               <a:rPr lang="es-MX" sz="1300" dirty="0" b="0" i="0">
                 <a:solidFill>
@@ -20935,8 +20921,8 @@
         </p:nvSpPr>
         <p:spPr>
           <a:xfrm>
-            <a:off x="8140142" y="2868314"/>
-            <a:ext cx="1510029" cy="307777"/>
+            <a:off x="8161950" y="2898671"/>
+            <a:ext cx="1700771" cy="274311"/>
           </a:xfrm>
           <a:prstGeom prst="rect">
             <a:avLst/>
@@ -20944,11 +20930,10 @@
           <a:noFill/>
         </p:spPr>
         <p:txBody>
-          <a:bodyPr wrap="none" rtlCol="0">
-            <a:spAutoFit/>
-          </a:bodyPr>
+          <a:bodyPr wrap="none" rtlCol="0" anchor="ctr" lIns="0" rIns="0" tIns="0" bIns="0"/>
           <a:lstStyle/>
           <a:p>
+            <a:pPr algn="ctr"/>
             <a:r>
               <a:rPr lang="es-MX" sz="1300" dirty="0" b="0" i="0">
                 <a:solidFill>
@@ -21756,8 +21741,8 @@
         </p:nvSpPr>
         <p:spPr>
           <a:xfrm>
-            <a:off x="417405" y="1901183"/>
-            <a:ext cx="1757225" cy="493807"/>
+            <a:off x="442094" y="1883626"/>
+            <a:ext cx="1627653" cy="493807"/>
           </a:xfrm>
           <a:prstGeom prst="rect">
             <a:avLst/>
@@ -21820,8 +21805,8 @@
         </p:nvSpPr>
         <p:spPr>
           <a:xfrm>
-            <a:off x="4194201" y="1837088"/>
-            <a:ext cx="1738212" cy="493807"/>
+            <a:off x="4197767" y="1883634"/>
+            <a:ext cx="1627659" cy="493807"/>
           </a:xfrm>
           <a:prstGeom prst="rect">
             <a:avLst/>
@@ -21884,8 +21869,8 @@
         </p:nvSpPr>
         <p:spPr>
           <a:xfrm>
-            <a:off x="4194171" y="2321712"/>
-            <a:ext cx="1738178" cy="228603"/>
+            <a:off x="4197737" y="2368256"/>
+            <a:ext cx="1627627" cy="228603"/>
           </a:xfrm>
           <a:prstGeom prst="rect">
             <a:avLst/>
@@ -21947,8 +21932,8 @@
         </p:nvSpPr>
         <p:spPr>
           <a:xfrm>
-            <a:off x="4194145" y="2522882"/>
-            <a:ext cx="1738204" cy="219459"/>
+            <a:off x="4197711" y="2569425"/>
+            <a:ext cx="1627651" cy="219459"/>
           </a:xfrm>
           <a:prstGeom prst="rect">
             <a:avLst/>
@@ -22010,8 +21995,8 @@
         </p:nvSpPr>
         <p:spPr>
           <a:xfrm>
-            <a:off x="6079771" y="1825452"/>
-            <a:ext cx="1578000" cy="493807"/>
+            <a:off x="6026553" y="1883703"/>
+            <a:ext cx="1627653" cy="493807"/>
           </a:xfrm>
           <a:prstGeom prst="rect">
             <a:avLst/>
@@ -22074,8 +22059,8 @@
         </p:nvSpPr>
         <p:spPr>
           <a:xfrm>
-            <a:off x="6079791" y="2310010"/>
-            <a:ext cx="1577961" cy="228603"/>
+            <a:off x="6026573" y="2368258"/>
+            <a:ext cx="1627612" cy="228603"/>
           </a:xfrm>
           <a:prstGeom prst="rect">
             <a:avLst/>
@@ -22137,8 +22122,8 @@
         </p:nvSpPr>
         <p:spPr>
           <a:xfrm>
-            <a:off x="6079773" y="2511190"/>
-            <a:ext cx="1577999" cy="219459"/>
+            <a:off x="6026554" y="2569438"/>
+            <a:ext cx="1627651" cy="219459"/>
           </a:xfrm>
           <a:prstGeom prst="rect">
             <a:avLst/>
@@ -22200,8 +22185,8 @@
         </p:nvSpPr>
         <p:spPr>
           <a:xfrm>
-            <a:off x="2301695" y="1884678"/>
-            <a:ext cx="1600268" cy="493807"/>
+            <a:off x="2270880" y="1883672"/>
+            <a:ext cx="1627608" cy="493807"/>
           </a:xfrm>
           <a:prstGeom prst="rect">
             <a:avLst/>

</xml_diff>

<commit_message>
Diapositiva 2: recuadros de arriba solo igualados en altura (posición, ancho y rótulos como el PPT)
</commit_message>
<xml_diff>
--- a/lib/plantilla_reporte.pptx
+++ b/lib/plantilla_reporte.pptx
@@ -18138,8 +18138,8 @@
           </p:nvSpPr>
           <p:spPr>
             <a:xfrm>
-              <a:off x="787918" y="1629137"/>
-              <a:ext cx="1700751" cy="292622"/>
+              <a:off x="728209" y="1584787"/>
+              <a:ext cx="1929439" cy="323165"/>
             </a:xfrm>
             <a:prstGeom prst="rect">
               <a:avLst/>
@@ -18147,10 +18147,12 @@
             <a:noFill/>
           </p:spPr>
           <p:txBody>
-            <a:bodyPr wrap="none" rtlCol="0" anchor="ctr" lIns="0" rIns="0" tIns="0" bIns="0"/>
+            <a:bodyPr wrap="none" rtlCol="0">
+              <a:spAutoFit/>
+            </a:bodyPr>
             <a:lstStyle/>
             <a:p>
-              <a:pPr marL="0" marR="0" lvl="0" indent="0" algn="ctr" defTabSz="914400" rtl="0" eaLnBrk="1" fontAlgn="auto" latinLnBrk="0" hangingPunct="1">
+              <a:pPr marL="0" marR="0" lvl="0" indent="0" algn="l" defTabSz="914400" rtl="0" eaLnBrk="1" fontAlgn="auto" latinLnBrk="0" hangingPunct="1">
                 <a:lnSpc>
                   <a:spcPct val="100000"/>
                 </a:lnSpc>
@@ -18168,7 +18170,7 @@
                 <a:defRPr/>
               </a:pPr>
               <a:r>
-                <a:rPr kumimoji="0" lang="es-PE" sz="1400" b="0" i="0" u="sng" strike="noStrike" kern="1200" cap="none" spc="0" normalizeH="0" baseline="0" noProof="0" dirty="0">
+                <a:rPr kumimoji="0" lang="es-PE" sz="1500" b="0" i="0" u="sng" strike="noStrike" kern="1200" cap="none" spc="0" normalizeH="0" baseline="0" noProof="0" dirty="0">
                   <a:ln>
                     <a:noFill/>
                   </a:ln>
@@ -18201,8 +18203,8 @@
           </p:nvSpPr>
           <p:spPr>
             <a:xfrm>
-              <a:off x="2616720" y="1629139"/>
-              <a:ext cx="1700804" cy="292612"/>
+              <a:off x="2800426" y="1508254"/>
+              <a:ext cx="1316386" cy="369332"/>
             </a:xfrm>
             <a:prstGeom prst="rect">
               <a:avLst/>
@@ -18210,10 +18212,12 @@
             <a:noFill/>
           </p:spPr>
           <p:txBody>
-            <a:bodyPr wrap="none" rtlCol="0" anchor="ctr" lIns="0" rIns="0" tIns="0" bIns="0"/>
+            <a:bodyPr wrap="none" rtlCol="0">
+              <a:spAutoFit/>
+            </a:bodyPr>
             <a:lstStyle/>
             <a:p>
-              <a:pPr marL="0" marR="0" lvl="0" indent="0" algn="ctr" defTabSz="914400" rtl="0" eaLnBrk="1" fontAlgn="auto" latinLnBrk="0" hangingPunct="1">
+              <a:pPr marL="0" marR="0" lvl="0" indent="0" algn="l" defTabSz="914400" rtl="0" eaLnBrk="1" fontAlgn="auto" latinLnBrk="0" hangingPunct="1">
                 <a:lnSpc>
                   <a:spcPct val="100000"/>
                 </a:lnSpc>
@@ -18231,7 +18235,7 @@
                 <a:defRPr/>
               </a:pPr>
               <a:r>
-                <a:rPr kumimoji="0" lang="es-PE" sz="1400" b="0" i="0" u="sng" strike="noStrike" kern="1200" cap="none" spc="0" normalizeH="0" baseline="0" noProof="0" dirty="0">
+                <a:rPr kumimoji="0" lang="es-PE" sz="1800" b="0" i="0" u="sng" strike="noStrike" kern="1200" cap="none" spc="0" normalizeH="0" baseline="0" noProof="0" dirty="0">
                   <a:ln>
                     <a:noFill/>
                   </a:ln>
@@ -18278,8 +18282,8 @@
           </p:nvSpPr>
           <p:spPr>
             <a:xfrm>
-              <a:off x="787921" y="1592606"/>
-              <a:ext cx="1700804" cy="1298439"/>
+              <a:off x="784355" y="1537743"/>
+              <a:ext cx="1811357" cy="1389879"/>
             </a:xfrm>
             <a:prstGeom prst="roundRect">
               <a:avLst/>
@@ -18354,8 +18358,8 @@
           </p:nvSpPr>
           <p:spPr>
             <a:xfrm>
-              <a:off x="2616727" y="1592606"/>
-              <a:ext cx="1700781" cy="1298419"/>
+              <a:off x="2669946" y="1537743"/>
+              <a:ext cx="1651130" cy="1389857"/>
             </a:xfrm>
             <a:prstGeom prst="roundRect">
               <a:avLst/>
@@ -19317,8 +19321,8 @@
               </p:nvSpPr>
               <p:spPr>
                 <a:xfrm>
-                  <a:off x="7049148" y="4487153"/>
-                  <a:ext cx="1843212" cy="493801"/>
+                  <a:off x="6807770" y="4487153"/>
+                  <a:ext cx="2024738" cy="493801"/>
                 </a:xfrm>
                 <a:prstGeom prst="rect">
                   <a:avLst/>
@@ -19398,8 +19402,8 @@
               </p:nvSpPr>
               <p:spPr>
                 <a:xfrm>
-                  <a:off x="7049125" y="4971808"/>
-                  <a:ext cx="1843229" cy="228603"/>
+                  <a:off x="6807745" y="4990096"/>
+                  <a:ext cx="2024756" cy="228603"/>
                 </a:xfrm>
                 <a:prstGeom prst="rect">
                   <a:avLst/>
@@ -19461,8 +19465,8 @@
               </p:nvSpPr>
               <p:spPr>
                 <a:xfrm>
-                  <a:off x="7049127" y="5172943"/>
-                  <a:ext cx="1843279" cy="219459"/>
+                  <a:off x="6807740" y="5209520"/>
+                  <a:ext cx="2024810" cy="228603"/>
                 </a:xfrm>
                 <a:prstGeom prst="rect">
                   <a:avLst/>
@@ -19525,8 +19529,8 @@
             </p:nvSpPr>
             <p:spPr>
               <a:xfrm>
-                <a:off x="7225105" y="4202490"/>
-                <a:ext cx="1926088" cy="1298411"/>
+                <a:off x="6983671" y="4147628"/>
+                <a:ext cx="2107617" cy="1389849"/>
               </a:xfrm>
               <a:prstGeom prst="roundRect">
                 <a:avLst/>
@@ -19601,8 +19605,8 @@
             </p:nvSpPr>
             <p:spPr>
               <a:xfrm>
-                <a:off x="7225103" y="4239055"/>
-                <a:ext cx="1926070" cy="292622"/>
+                <a:off x="6987399" y="4225613"/>
+                <a:ext cx="2185055" cy="323165"/>
               </a:xfrm>
               <a:prstGeom prst="rect">
                 <a:avLst/>
@@ -19610,10 +19614,12 @@
               <a:noFill/>
             </p:spPr>
             <p:txBody>
-              <a:bodyPr wrap="none" rtlCol="0" anchor="ctr" lIns="0" rIns="0" tIns="0" bIns="0"/>
+              <a:bodyPr wrap="none" rtlCol="0">
+                <a:spAutoFit/>
+              </a:bodyPr>
               <a:lstStyle/>
               <a:p>
-                <a:pPr marL="0" marR="0" lvl="0" indent="0" algn="ctr" defTabSz="914400" rtl="0" eaLnBrk="1" fontAlgn="auto" latinLnBrk="0" hangingPunct="1">
+                <a:pPr marL="0" marR="0" lvl="0" indent="0" algn="l" defTabSz="914400" rtl="0" eaLnBrk="1" fontAlgn="auto" latinLnBrk="0" hangingPunct="1">
                   <a:lnSpc>
                     <a:spcPct val="100000"/>
                   </a:lnSpc>
@@ -19631,7 +19637,7 @@
                   <a:defRPr/>
                 </a:pPr>
                 <a:r>
-                  <a:rPr kumimoji="0" lang="es-PE" sz="1400" b="0" i="0" u="sng" strike="noStrike" kern="1200" cap="none" spc="0" normalizeH="0" baseline="0" noProof="0" dirty="0">
+                  <a:rPr kumimoji="0" lang="es-PE" sz="1500" b="0" i="0" u="sng" strike="noStrike" kern="1200" cap="none" spc="0" normalizeH="0" baseline="0" noProof="0" dirty="0">
                     <a:ln>
                       <a:noFill/>
                     </a:ln>
@@ -19705,8 +19711,8 @@
               </p:nvSpPr>
               <p:spPr>
                 <a:xfrm>
-                  <a:off x="6815764" y="4487153"/>
-                  <a:ext cx="1843212" cy="493801"/>
+                  <a:off x="6755290" y="4487153"/>
+                  <a:ext cx="2024738" cy="493801"/>
                 </a:xfrm>
                 <a:prstGeom prst="rect">
                   <a:avLst/>
@@ -19760,8 +19766,8 @@
               </p:nvSpPr>
               <p:spPr>
                 <a:xfrm>
-                  <a:off x="6815707" y="4971842"/>
-                  <a:ext cx="1843229" cy="228603"/>
+                  <a:off x="6755233" y="4990131"/>
+                  <a:ext cx="2024756" cy="228603"/>
                 </a:xfrm>
                 <a:prstGeom prst="rect">
                   <a:avLst/>
@@ -19823,8 +19829,8 @@
               </p:nvSpPr>
               <p:spPr>
                 <a:xfrm>
-                  <a:off x="6815702" y="5172953"/>
-                  <a:ext cx="1843274" cy="219459"/>
+                  <a:off x="6755226" y="5209530"/>
+                  <a:ext cx="2024805" cy="228603"/>
                 </a:xfrm>
                 <a:prstGeom prst="rect">
                   <a:avLst/>
@@ -19887,8 +19893,8 @@
             </p:nvSpPr>
             <p:spPr>
               <a:xfrm>
-                <a:off x="6991664" y="4202418"/>
-                <a:ext cx="1926088" cy="1298411"/>
+                <a:off x="6931138" y="4147555"/>
+                <a:ext cx="2107617" cy="1389849"/>
               </a:xfrm>
               <a:prstGeom prst="roundRect">
                 <a:avLst/>
@@ -19971,8 +19977,8 @@
             </p:nvSpPr>
             <p:spPr>
               <a:xfrm>
-                <a:off x="6991706" y="4239087"/>
-                <a:ext cx="1926083" cy="292645"/>
+                <a:off x="7269073" y="4197020"/>
+                <a:ext cx="1352815" cy="338554"/>
               </a:xfrm>
               <a:prstGeom prst="rect">
                 <a:avLst/>
@@ -19980,10 +19986,12 @@
               <a:noFill/>
             </p:spPr>
             <p:txBody>
-              <a:bodyPr wrap="none" rtlCol="0" anchor="ctr" lIns="0" rIns="0" tIns="0" bIns="0"/>
+              <a:bodyPr wrap="none" rtlCol="0">
+                <a:spAutoFit/>
+              </a:bodyPr>
               <a:lstStyle/>
               <a:p>
-                <a:pPr marL="0" marR="0" lvl="0" indent="0" algn="ctr" defTabSz="914400" rtl="0" eaLnBrk="1" fontAlgn="auto" latinLnBrk="0" hangingPunct="1">
+                <a:pPr marL="0" marR="0" lvl="0" indent="0" algn="l" defTabSz="914400" rtl="0" eaLnBrk="1" fontAlgn="auto" latinLnBrk="0" hangingPunct="1">
                   <a:lnSpc>
                     <a:spcPct val="100000"/>
                   </a:lnSpc>
@@ -20001,7 +20009,7 @@
                   <a:defRPr/>
                 </a:pPr>
                 <a:r>
-                  <a:rPr kumimoji="0" lang="es-MX" sz="1400" b="0" i="0" u="sng" strike="noStrike" kern="1200" cap="none" spc="0" normalizeH="0" baseline="0" noProof="0" dirty="0">
+                  <a:rPr kumimoji="0" lang="es-MX" sz="1600" b="0" i="0" u="sng" strike="noStrike" kern="1200" cap="none" spc="0" normalizeH="0" baseline="0" noProof="0" dirty="0">
                     <a:ln>
                       <a:noFill/>
                     </a:ln>
@@ -20258,8 +20266,8 @@
             </p:nvSpPr>
             <p:spPr>
               <a:xfrm>
-                <a:off x="1933537" y="6271402"/>
-                <a:ext cx="1627658" cy="228603"/>
+                <a:off x="1908848" y="6289690"/>
+                <a:ext cx="1757230" cy="228603"/>
               </a:xfrm>
               <a:prstGeom prst="rect">
                 <a:avLst/>
@@ -20321,8 +20329,8 @@
             </p:nvSpPr>
             <p:spPr>
               <a:xfrm>
-                <a:off x="1933616" y="6472551"/>
-                <a:ext cx="1627621" cy="219459"/>
+                <a:off x="1908927" y="6509127"/>
+                <a:ext cx="1757191" cy="228603"/>
               </a:xfrm>
               <a:prstGeom prst="rect">
                 <a:avLst/>
@@ -20384,8 +20392,8 @@
             </p:nvSpPr>
             <p:spPr>
               <a:xfrm>
-                <a:off x="1897011" y="5475804"/>
-                <a:ext cx="1700761" cy="1298433"/>
+                <a:off x="1872323" y="5420941"/>
+                <a:ext cx="1830330" cy="1389872"/>
               </a:xfrm>
               <a:prstGeom prst="roundRect">
                 <a:avLst/>
@@ -20460,8 +20468,8 @@
             </p:nvSpPr>
             <p:spPr>
               <a:xfrm>
-                <a:off x="1897046" y="5512421"/>
-                <a:ext cx="1700751" cy="292622"/>
+                <a:off x="1818318" y="5548268"/>
+                <a:ext cx="1929439" cy="323165"/>
               </a:xfrm>
               <a:prstGeom prst="rect">
                 <a:avLst/>
@@ -20469,10 +20477,12 @@
               <a:noFill/>
             </p:spPr>
             <p:txBody>
-              <a:bodyPr wrap="none" rtlCol="0" anchor="ctr" lIns="0" rIns="0" tIns="0" bIns="0"/>
+              <a:bodyPr wrap="none" rtlCol="0">
+                <a:spAutoFit/>
+              </a:bodyPr>
               <a:lstStyle/>
               <a:p>
-                <a:pPr marL="0" marR="0" lvl="0" indent="0" algn="ctr" defTabSz="914400" rtl="0" eaLnBrk="1" fontAlgn="auto" latinLnBrk="0" hangingPunct="1">
+                <a:pPr marL="0" marR="0" lvl="0" indent="0" algn="l" defTabSz="914400" rtl="0" eaLnBrk="1" fontAlgn="auto" latinLnBrk="0" hangingPunct="1">
                   <a:lnSpc>
                     <a:spcPct val="100000"/>
                   </a:lnSpc>
@@ -20490,7 +20500,7 @@
                   <a:defRPr/>
                 </a:pPr>
                 <a:r>
-                  <a:rPr kumimoji="0" lang="es-PE" sz="1400" b="0" i="0" u="sng" strike="noStrike" kern="1200" cap="none" spc="0" normalizeH="0" baseline="0" noProof="0" dirty="0">
+                  <a:rPr kumimoji="0" lang="es-PE" sz="1500" b="0" i="0" u="sng" strike="noStrike" kern="1200" cap="none" spc="0" normalizeH="0" baseline="0" noProof="0" dirty="0">
                     <a:ln>
                       <a:noFill/>
                     </a:ln>
@@ -20544,8 +20554,8 @@
             </p:nvSpPr>
             <p:spPr>
               <a:xfrm>
-                <a:off x="4255978" y="5470833"/>
-                <a:ext cx="1700828" cy="1298456"/>
+                <a:off x="4286795" y="5415968"/>
+                <a:ext cx="1673487" cy="1389896"/>
               </a:xfrm>
               <a:prstGeom prst="roundRect">
                 <a:avLst/>
@@ -20628,8 +20638,8 @@
             </p:nvSpPr>
             <p:spPr>
               <a:xfrm>
-                <a:off x="4255919" y="5507372"/>
-                <a:ext cx="1700785" cy="292612"/>
+                <a:off x="4487263" y="5479666"/>
+                <a:ext cx="1610626" cy="369332"/>
               </a:xfrm>
               <a:prstGeom prst="rect">
                 <a:avLst/>
@@ -20637,10 +20647,12 @@
               <a:noFill/>
             </p:spPr>
             <p:txBody>
-              <a:bodyPr wrap="none" rtlCol="0" anchor="ctr" lIns="0" rIns="0" tIns="0" bIns="0"/>
+              <a:bodyPr wrap="square" rtlCol="0">
+                <a:spAutoFit/>
+              </a:bodyPr>
               <a:lstStyle/>
               <a:p>
-                <a:pPr marL="0" marR="0" lvl="0" indent="0" algn="ctr" defTabSz="914400" rtl="0" eaLnBrk="1" fontAlgn="auto" latinLnBrk="0" hangingPunct="1">
+                <a:pPr marL="0" marR="0" lvl="0" indent="0" algn="l" defTabSz="914400" rtl="0" eaLnBrk="1" fontAlgn="auto" latinLnBrk="0" hangingPunct="1">
                   <a:lnSpc>
                     <a:spcPct val="100000"/>
                   </a:lnSpc>
@@ -20658,7 +20670,7 @@
                   <a:defRPr/>
                 </a:pPr>
                 <a:r>
-                  <a:rPr kumimoji="0" lang="es-PE" sz="1400" b="0" i="0" u="sng" strike="noStrike" kern="1200" cap="none" spc="0" normalizeH="0" baseline="0" noProof="0" dirty="0">
+                  <a:rPr kumimoji="0" lang="es-PE" sz="1800" b="0" i="0" u="sng" strike="noStrike" kern="1200" cap="none" spc="0" normalizeH="0" baseline="0" noProof="0" dirty="0">
                     <a:ln>
                       <a:noFill/>
                     </a:ln>
@@ -20705,8 +20717,8 @@
             </p:nvSpPr>
             <p:spPr>
               <a:xfrm>
-                <a:off x="4292518" y="6266345"/>
-                <a:ext cx="1627647" cy="228603"/>
+                <a:off x="4323334" y="6284634"/>
+                <a:ext cx="1600307" cy="228603"/>
               </a:xfrm>
               <a:prstGeom prst="rect">
                 <a:avLst/>
@@ -20768,8 +20780,8 @@
             </p:nvSpPr>
             <p:spPr>
               <a:xfrm>
-                <a:off x="4292518" y="6467510"/>
-                <a:ext cx="1627619" cy="219459"/>
+                <a:off x="4323333" y="6504087"/>
+                <a:ext cx="1600278" cy="228603"/>
               </a:xfrm>
               <a:prstGeom prst="rect">
                 <a:avLst/>
@@ -20833,8 +20845,8 @@
         </p:nvSpPr>
         <p:spPr>
           <a:xfrm>
-            <a:off x="405580" y="2898642"/>
-            <a:ext cx="1700771" cy="274311"/>
+            <a:off x="497934" y="2926073"/>
+            <a:ext cx="1510029" cy="307777"/>
           </a:xfrm>
           <a:prstGeom prst="rect">
             <a:avLst/>
@@ -20845,7 +20857,6 @@
           <a:bodyPr wrap="none" rtlCol="0" anchor="ctr" lIns="0" rIns="0" tIns="0" bIns="0"/>
           <a:lstStyle/>
           <a:p>
-            <a:pPr algn="ctr"/>
             <a:r>
               <a:rPr lang="es-MX" sz="1300" dirty="0" b="0" i="0">
                 <a:solidFill>
@@ -20877,8 +20888,8 @@
         </p:nvSpPr>
         <p:spPr>
           <a:xfrm>
-            <a:off x="4161122" y="2898660"/>
-            <a:ext cx="1700771" cy="274311"/>
+            <a:off x="4319038" y="2926091"/>
+            <a:ext cx="1510029" cy="307777"/>
           </a:xfrm>
           <a:prstGeom prst="rect">
             <a:avLst/>
@@ -20889,7 +20900,6 @@
           <a:bodyPr wrap="none" rtlCol="0" anchor="ctr" lIns="0" rIns="0" tIns="0" bIns="0"/>
           <a:lstStyle/>
           <a:p>
-            <a:pPr algn="ctr"/>
             <a:r>
               <a:rPr lang="es-MX" sz="1300" dirty="0" b="0" i="0">
                 <a:solidFill>
@@ -20921,8 +20931,8 @@
         </p:nvSpPr>
         <p:spPr>
           <a:xfrm>
-            <a:off x="8161950" y="2898671"/>
-            <a:ext cx="1700771" cy="274311"/>
+            <a:off x="8140142" y="2926102"/>
+            <a:ext cx="1510029" cy="307777"/>
           </a:xfrm>
           <a:prstGeom prst="rect">
             <a:avLst/>
@@ -20933,7 +20943,6 @@
           <a:bodyPr wrap="none" rtlCol="0" anchor="ctr" lIns="0" rIns="0" tIns="0" bIns="0"/>
           <a:lstStyle/>
           <a:p>
-            <a:pPr algn="ctr"/>
             <a:r>
               <a:rPr lang="es-MX" sz="1300" dirty="0" b="0" i="0">
                 <a:solidFill>
@@ -21741,8 +21750,8 @@
         </p:nvSpPr>
         <p:spPr>
           <a:xfrm>
-            <a:off x="442094" y="1883626"/>
-            <a:ext cx="1627653" cy="493807"/>
+            <a:off x="417405" y="1883626"/>
+            <a:ext cx="1757225" cy="493807"/>
           </a:xfrm>
           <a:prstGeom prst="rect">
             <a:avLst/>
@@ -21805,8 +21814,8 @@
         </p:nvSpPr>
         <p:spPr>
           <a:xfrm>
-            <a:off x="4197767" y="1883634"/>
-            <a:ext cx="1627659" cy="493807"/>
+            <a:off x="4194201" y="1883634"/>
+            <a:ext cx="1738212" cy="493807"/>
           </a:xfrm>
           <a:prstGeom prst="rect">
             <a:avLst/>
@@ -21869,8 +21878,8 @@
         </p:nvSpPr>
         <p:spPr>
           <a:xfrm>
-            <a:off x="4197737" y="2368256"/>
-            <a:ext cx="1627627" cy="228603"/>
+            <a:off x="4194171" y="2386544"/>
+            <a:ext cx="1738178" cy="228603"/>
           </a:xfrm>
           <a:prstGeom prst="rect">
             <a:avLst/>
@@ -21932,8 +21941,8 @@
         </p:nvSpPr>
         <p:spPr>
           <a:xfrm>
-            <a:off x="4197711" y="2569425"/>
-            <a:ext cx="1627651" cy="219459"/>
+            <a:off x="4194145" y="2606002"/>
+            <a:ext cx="1738204" cy="228603"/>
           </a:xfrm>
           <a:prstGeom prst="rect">
             <a:avLst/>
@@ -21995,8 +22004,8 @@
         </p:nvSpPr>
         <p:spPr>
           <a:xfrm>
-            <a:off x="6026553" y="1883703"/>
-            <a:ext cx="1627653" cy="493807"/>
+            <a:off x="6079771" y="1883703"/>
+            <a:ext cx="1578000" cy="493807"/>
           </a:xfrm>
           <a:prstGeom prst="rect">
             <a:avLst/>
@@ -22059,8 +22068,8 @@
         </p:nvSpPr>
         <p:spPr>
           <a:xfrm>
-            <a:off x="6026573" y="2368258"/>
-            <a:ext cx="1627612" cy="228603"/>
+            <a:off x="6079791" y="2386546"/>
+            <a:ext cx="1577961" cy="228603"/>
           </a:xfrm>
           <a:prstGeom prst="rect">
             <a:avLst/>
@@ -22122,8 +22131,8 @@
         </p:nvSpPr>
         <p:spPr>
           <a:xfrm>
-            <a:off x="6026554" y="2569438"/>
-            <a:ext cx="1627651" cy="219459"/>
+            <a:off x="6079773" y="2606015"/>
+            <a:ext cx="1577999" cy="228603"/>
           </a:xfrm>
           <a:prstGeom prst="rect">
             <a:avLst/>
@@ -22185,8 +22194,8 @@
         </p:nvSpPr>
         <p:spPr>
           <a:xfrm>
-            <a:off x="2270880" y="1883672"/>
-            <a:ext cx="1627608" cy="493807"/>
+            <a:off x="2301695" y="1883672"/>
+            <a:ext cx="1600268" cy="493807"/>
           </a:xfrm>
           <a:prstGeom prst="rect">
             <a:avLst/>

</xml_diff>

<commit_message>
Despachos: 8 recuadros (AE y MA en # PV y # AWB/FCL, avance y solo semana) y «Proyección de mercado»
</commit_message>
<xml_diff>
--- a/lib/plantilla_reporte.pptx
+++ b/lib/plantilla_reporte.pptx
@@ -8927,7 +8927,7 @@
                 <a:cs typeface="Candara"/>
                 <a:sym typeface="Candara"/>
               </a:rPr>
-              <a:t>{{#F211}}</a:t>
+              <a:t>{{#F229}}</a:t>
             </a:r>
             <a:endParaRPr kumimoji="0" lang="en-US" sz="1800" b="0" i="0" u="none" strike="noStrike" kern="0" cap="none" spc="0" normalizeH="0" baseline="0" noProof="0" dirty="0">
               <a:ln>
@@ -9125,7 +9125,7 @@
                   </a:solidFill>
                   <a:latin typeface="Calibri" panose="020F0502020204030204"/>
                 </a:rPr>
-                <a:t>{{#F212}}</a:t>
+                <a:t>{{#F230}}</a:t>
               </a:r>
               <a:endParaRPr kumimoji="0" lang="es-PE" sz="1800" b="1" i="0" u="none" strike="noStrike" kern="1200" cap="none" spc="0" normalizeH="0" baseline="0" noProof="0" dirty="0">
                 <a:ln>
@@ -9205,7 +9205,7 @@
                 <a:ea typeface="+mn-ea"/>
                 <a:cs typeface="+mn-cs"/>
               </a:rPr>
-              <a:t>{{#F213}}</a:t>
+              <a:t>{{#F231}}</a:t>
             </a:r>
             <a:endParaRPr kumimoji="0" lang="es-PE" sz="1400" b="0" i="0" u="none" strike="noStrike" kern="1200" cap="none" spc="0" normalizeH="0" baseline="0" noProof="0" dirty="0">
               <a:ln>
@@ -9280,7 +9280,7 @@
                 </a:solidFill>
                 <a:latin typeface="Calibri" panose="020F0502020204030204"/>
               </a:rPr>
-              <a:t>{{#F214}}</a:t>
+              <a:t>{{#F232}}</a:t>
             </a:r>
             <a:endParaRPr kumimoji="0" lang="es-PE" sz="1800" b="1" i="0" u="none" strike="noStrike" kern="1200" cap="none" spc="0" normalizeH="0" baseline="0" noProof="0" dirty="0">
               <a:ln>
@@ -9359,7 +9359,7 @@
                 <a:ea typeface="+mn-ea"/>
                 <a:cs typeface="+mn-cs"/>
               </a:rPr>
-              <a:t>{{#F215}}</a:t>
+              <a:t>{{#F233}}</a:t>
             </a:r>
             <a:endParaRPr kumimoji="0" lang="es-PE" sz="1400" b="0" i="0" u="none" strike="noStrike" kern="1200" cap="none" spc="0" normalizeH="0" baseline="0" noProof="0" dirty="0">
               <a:ln>
@@ -9430,7 +9430,7 @@
                 </a:solidFill>
                 <a:latin typeface="Abadi ExtraLight" panose="020B0204020104020204" pitchFamily="34" charset="0"/>
               </a:rPr>
-              <a:t>{{#F197}}</a:t>
+              <a:t>{{#F215}}</a:t>
             </a:r>
             <a:endParaRPr kumimoji="0" lang="es-PE" sz="1800" b="1" i="0" u="none" strike="noStrike" kern="1200" cap="none" spc="0" normalizeH="0" baseline="0" noProof="0" dirty="0">
               <a:ln>
@@ -9501,7 +9501,7 @@
                 </a:solidFill>
                 <a:latin typeface="Abadi ExtraLight" panose="020B0204020104020204" pitchFamily="34" charset="0"/>
               </a:rPr>
-              <a:t>{{#F198}}</a:t>
+              <a:t>{{#F216}}</a:t>
             </a:r>
             <a:endParaRPr kumimoji="0" lang="es-PE" sz="1800" b="1" i="0" u="none" strike="noStrike" kern="1200" cap="none" spc="0" normalizeH="0" baseline="0" noProof="0" dirty="0">
               <a:ln>
@@ -9572,7 +9572,7 @@
                 </a:solidFill>
                 <a:latin typeface="Abadi ExtraLight" panose="020B0204020104020204" pitchFamily="34" charset="0"/>
               </a:rPr>
-              <a:t>{{#F199}}</a:t>
+              <a:t>{{#F217}}</a:t>
             </a:r>
             <a:endParaRPr kumimoji="0" lang="es-PE" sz="1800" b="1" i="0" u="none" strike="noStrike" kern="1200" cap="none" spc="0" normalizeH="0" baseline="0" noProof="0" dirty="0">
               <a:ln>
@@ -9643,7 +9643,7 @@
                 </a:solidFill>
                 <a:latin typeface="Abadi ExtraLight" panose="020B0204020104020204" pitchFamily="34" charset="0"/>
               </a:rPr>
-              <a:t>{{#F200}}</a:t>
+              <a:t>{{#F218}}</a:t>
             </a:r>
             <a:endParaRPr kumimoji="0" lang="es-PE" sz="1800" b="1" i="0" u="none" strike="noStrike" kern="1200" cap="none" spc="0" normalizeH="0" baseline="0" noProof="0" dirty="0">
               <a:ln>
@@ -9714,7 +9714,7 @@
                 </a:solidFill>
                 <a:latin typeface="Abadi ExtraLight" panose="020B0204020104020204" pitchFamily="34" charset="0"/>
               </a:rPr>
-              <a:t>{{#F201}}</a:t>
+              <a:t>{{#F219}}</a:t>
             </a:r>
             <a:endParaRPr kumimoji="0" lang="es-PE" sz="1800" b="1" i="0" u="none" strike="noStrike" kern="1200" cap="none" spc="0" normalizeH="0" baseline="0" noProof="0" dirty="0">
               <a:ln>
@@ -9785,7 +9785,7 @@
                 </a:solidFill>
                 <a:latin typeface="Abadi ExtraLight" panose="020B0204020104020204" pitchFamily="34" charset="0"/>
               </a:rPr>
-              <a:t>{{#F202}}</a:t>
+              <a:t>{{#F220}}</a:t>
             </a:r>
             <a:endParaRPr kumimoji="0" lang="es-PE" sz="1800" b="1" i="0" u="none" strike="noStrike" kern="1200" cap="none" spc="0" normalizeH="0" baseline="0" noProof="0" dirty="0">
               <a:ln>
@@ -9856,7 +9856,7 @@
                 </a:solidFill>
                 <a:latin typeface="Abadi ExtraLight" panose="020B0204020104020204" pitchFamily="34" charset="0"/>
               </a:rPr>
-              <a:t>{{#F203}}</a:t>
+              <a:t>{{#F221}}</a:t>
             </a:r>
             <a:endParaRPr kumimoji="0" lang="es-PE" sz="1800" b="1" i="0" u="none" strike="noStrike" kern="1200" cap="none" spc="0" normalizeH="0" baseline="0" noProof="0" dirty="0">
               <a:ln>
@@ -9927,7 +9927,7 @@
                 </a:solidFill>
                 <a:latin typeface="Abadi ExtraLight" panose="020B0204020104020204" pitchFamily="34" charset="0"/>
               </a:rPr>
-              <a:t>{{#F204}}</a:t>
+              <a:t>{{#F222}}</a:t>
             </a:r>
             <a:endParaRPr kumimoji="0" lang="es-PE" sz="1800" b="1" i="0" u="none" strike="noStrike" kern="1200" cap="none" spc="0" normalizeH="0" baseline="0" noProof="0" dirty="0">
               <a:ln>
@@ -10008,7 +10008,7 @@
                 <a:ea typeface="+mn-ea"/>
                 <a:cs typeface="+mn-cs"/>
               </a:rPr>
-              <a:t>{{#F205}}</a:t>
+              <a:t>{{#F223}}</a:t>
             </a:r>
           </a:p>
         </p:txBody>
@@ -10141,7 +10141,7 @@
                 </a:solidFill>
                 <a:latin typeface="Abadi ExtraLight" panose="020B0204020104020204" pitchFamily="34" charset="0"/>
               </a:rPr>
-              <a:t>{{#F216}}</a:t>
+              <a:t>{{#F234}}</a:t>
             </a:r>
             <a:endParaRPr kumimoji="0" lang="es-PE" sz="1400" b="0" i="0" u="sng" strike="noStrike" kern="1200" cap="none" spc="0" normalizeH="0" baseline="0" noProof="0" dirty="0">
               <a:ln>
@@ -10296,7 +10296,7 @@
                 <a:ea typeface="+mn-ea"/>
                 <a:cs typeface="+mn-cs"/>
               </a:rPr>
-              <a:t>{{#F217}}</a:t>
+              <a:t>{{#F235}}</a:t>
             </a:r>
             <a:endParaRPr kumimoji="0" lang="es-PE" sz="1400" b="0" i="0" u="sng" strike="noStrike" kern="1200" cap="none" spc="0" normalizeH="0" baseline="0" noProof="0" dirty="0">
               <a:ln>
@@ -10443,7 +10443,7 @@
                 </a:solidFill>
                 <a:latin typeface="Abadi ExtraLight" panose="020B0204020104020204" pitchFamily="34" charset="0"/>
               </a:rPr>
-              <a:t>{{#F218}}</a:t>
+              <a:t>{{#F236}}</a:t>
             </a:r>
             <a:endParaRPr kumimoji="0" lang="es-PE" sz="1400" b="0" i="0" u="sng" strike="noStrike" kern="1200" cap="none" spc="0" normalizeH="0" baseline="0" noProof="0" dirty="0">
               <a:ln>
@@ -10517,7 +10517,7 @@
                 </a:solidFill>
                 <a:latin typeface="Century Gothic" panose="020B0502020202020204" pitchFamily="34" charset="0"/>
               </a:rPr>
-              <a:t>{{#F219}}</a:t>
+              <a:t>{{#F237}}</a:t>
             </a:r>
             <a:endParaRPr kumimoji="0" lang="es-PE" sz="1200" b="1" i="0" u="none" strike="noStrike" kern="1200" cap="none" spc="0" normalizeH="0" baseline="0" noProof="0" dirty="0">
               <a:ln>
@@ -10601,7 +10601,7 @@
                 <a:ea typeface="+mn-ea"/>
                 <a:cs typeface="+mn-cs"/>
               </a:rPr>
-              <a:t>{{#F206}}</a:t>
+              <a:t>{{#F224}}</a:t>
             </a:r>
           </a:p>
         </p:txBody>
@@ -10661,7 +10661,7 @@
                 </a:solidFill>
                 <a:latin typeface="Century Gothic" panose="020B0502020202020204" pitchFamily="34" charset="0"/>
               </a:rPr>
-              <a:t>{{#F220}}</a:t>
+              <a:t>{{#F238}}</a:t>
             </a:r>
             <a:endParaRPr kumimoji="0" lang="es-PE" sz="1200" b="1" i="0" u="none" strike="noStrike" kern="1200" cap="none" spc="0" normalizeH="0" baseline="0" noProof="0" dirty="0">
               <a:ln>
@@ -10745,7 +10745,7 @@
                 <a:ea typeface="+mn-ea"/>
                 <a:cs typeface="+mn-cs"/>
               </a:rPr>
-              <a:t>{{#F207}}</a:t>
+              <a:t>{{#F225}}</a:t>
             </a:r>
           </a:p>
         </p:txBody>
@@ -10805,7 +10805,7 @@
                 </a:solidFill>
                 <a:latin typeface="Century Gothic" panose="020B0502020202020204" pitchFamily="34" charset="0"/>
               </a:rPr>
-              <a:t>{{#F221}}</a:t>
+              <a:t>{{#F239}}</a:t>
             </a:r>
             <a:endParaRPr kumimoji="0" lang="es-PE" sz="1200" b="1" i="0" u="none" strike="noStrike" kern="1200" cap="none" spc="0" normalizeH="0" baseline="0" noProof="0" dirty="0">
               <a:ln>
@@ -10889,7 +10889,7 @@
                 <a:ea typeface="+mn-ea"/>
                 <a:cs typeface="+mn-cs"/>
               </a:rPr>
-              <a:t>{{#F208}}</a:t>
+              <a:t>{{#F226}}</a:t>
             </a:r>
           </a:p>
         </p:txBody>
@@ -10949,7 +10949,7 @@
                 </a:solidFill>
                 <a:latin typeface="Century Gothic" panose="020B0502020202020204" pitchFamily="34" charset="0"/>
               </a:rPr>
-              <a:t>{{#F222}}</a:t>
+              <a:t>{{#F240}}</a:t>
             </a:r>
             <a:endParaRPr kumimoji="0" lang="es-PE" sz="1200" b="1" i="0" u="none" strike="noStrike" kern="1200" cap="none" spc="0" normalizeH="0" baseline="0" noProof="0" dirty="0">
               <a:ln>
@@ -11033,7 +11033,7 @@
                 <a:ea typeface="+mn-ea"/>
                 <a:cs typeface="+mn-cs"/>
               </a:rPr>
-              <a:t>{{#F209}}</a:t>
+              <a:t>{{#F227}}</a:t>
             </a:r>
           </a:p>
         </p:txBody>
@@ -11093,7 +11093,7 @@
                 </a:solidFill>
                 <a:latin typeface="Century Gothic" panose="020B0502020202020204" pitchFamily="34" charset="0"/>
               </a:rPr>
-              <a:t>{{#F223}}</a:t>
+              <a:t>{{#F241}}</a:t>
             </a:r>
             <a:endParaRPr kumimoji="0" lang="es-PE" sz="1200" b="1" i="0" u="none" strike="noStrike" kern="1200" cap="none" spc="0" normalizeH="0" baseline="0" noProof="0" dirty="0">
               <a:ln>
@@ -11177,7 +11177,7 @@
                 <a:ea typeface="+mn-ea"/>
                 <a:cs typeface="+mn-cs"/>
               </a:rPr>
-              <a:t>{{#F210}}</a:t>
+              <a:t>{{#F228}}</a:t>
             </a:r>
           </a:p>
         </p:txBody>
@@ -11237,7 +11237,7 @@
                 </a:solidFill>
                 <a:latin typeface="Century Gothic" panose="020B0502020202020204" pitchFamily="34" charset="0"/>
               </a:rPr>
-              <a:t>{{#F224}}</a:t>
+              <a:t>{{#F242}}</a:t>
             </a:r>
             <a:endParaRPr kumimoji="0" lang="es-PE" sz="1200" b="1" i="0" u="none" strike="noStrike" kern="1200" cap="none" spc="0" normalizeH="0" baseline="0" noProof="0" dirty="0">
               <a:ln>
@@ -11395,7 +11395,7 @@
                 <a:ea typeface="+mn-ea"/>
                 <a:cs typeface="+mn-cs"/>
               </a:rPr>
-              <a:t>{{#F225}}</a:t>
+              <a:t>{{#F243}}</a:t>
             </a:r>
             <a:endParaRPr kumimoji="0" lang="es-PE" sz="1100" b="1" i="0" u="sng" strike="noStrike" kern="1200" cap="none" spc="0" normalizeH="0" baseline="0" noProof="0" dirty="0">
               <a:ln>
@@ -11550,7 +11550,7 @@
                 <a:ea typeface="+mn-ea"/>
                 <a:cs typeface="+mn-cs"/>
               </a:rPr>
-              <a:t>{{#F226}}</a:t>
+              <a:t>{{#F244}}</a:t>
             </a:r>
             <a:endParaRPr kumimoji="0" lang="es-PE" sz="1100" b="1" i="0" u="sng" strike="noStrike" kern="1200" cap="none" spc="0" normalizeH="0" baseline="0" noProof="0" dirty="0">
               <a:ln>
@@ -11705,7 +11705,7 @@
                 <a:ea typeface="+mn-ea"/>
                 <a:cs typeface="+mn-cs"/>
               </a:rPr>
-              <a:t>{{#F227}}</a:t>
+              <a:t>{{#F245}}</a:t>
             </a:r>
             <a:endParaRPr kumimoji="0" lang="es-PE" sz="1100" b="1" i="0" u="sng" strike="noStrike" kern="1200" cap="none" spc="0" normalizeH="0" baseline="0" noProof="0" dirty="0">
               <a:ln>
@@ -11860,7 +11860,7 @@
                 <a:ea typeface="+mn-ea"/>
                 <a:cs typeface="+mn-cs"/>
               </a:rPr>
-              <a:t>{{#F228}}</a:t>
+              <a:t>{{#F246}}</a:t>
             </a:r>
             <a:endParaRPr kumimoji="0" lang="es-PE" sz="1100" b="1" i="0" u="sng" strike="noStrike" kern="1200" cap="none" spc="0" normalizeH="0" baseline="0" noProof="0" dirty="0">
               <a:ln>
@@ -11881,7 +11881,7 @@
       </p:sp>
       <p:sp>
         <p:nvSpPr>
-          <p:cNvPr id="1129" name="Lineas 1129">
+          <p:cNvPr id="1147" name="Lineas 1147">
             <a:extLst>
               <a:ext uri="{FF2B5EF4-FFF2-40B4-BE49-F238E27FC236}">
                 <a16:creationId xmlns:a16="http://schemas.microsoft.com/office/drawing/2014/main" id="{1411DB53-B1E6-1270-3C2B-02D7177B8A2F}"/>
@@ -11929,7 +11929,7 @@
                 </a:solidFill>
                 <a:latin typeface="Abadi ExtraLight" panose="020B0204020104020204" pitchFamily="34" charset="0"/>
               </a:rPr>
-              <a:t>{{#F229}}</a:t>
+              <a:t>{{#F247}}</a:t>
             </a:r>
             <a:endParaRPr kumimoji="0" lang="es-PE" sz="1800" b="1" i="0" u="none" strike="noStrike" kern="1200" cap="none" spc="0" normalizeH="0" baseline="0" noProof="0" dirty="0">
               <a:ln>
@@ -11950,7 +11950,7 @@
       </p:sp>
       <p:sp>
         <p:nvSpPr>
-          <p:cNvPr id="1130" name="Lineas 1130">
+          <p:cNvPr id="1148" name="Lineas 1148">
             <a:extLst>
               <a:ext uri="{FF2B5EF4-FFF2-40B4-BE49-F238E27FC236}">
                 <a16:creationId xmlns:a16="http://schemas.microsoft.com/office/drawing/2014/main" id="{1411DB53-B1E6-1270-3C2B-02D7177B8A2F}"/>
@@ -11998,7 +11998,7 @@
                 </a:solidFill>
                 <a:latin typeface="Abadi ExtraLight" panose="020B0204020104020204" pitchFamily="34" charset="0"/>
               </a:rPr>
-              <a:t>{{#F230}}</a:t>
+              <a:t>{{#F248}}</a:t>
             </a:r>
             <a:endParaRPr kumimoji="0" lang="es-PE" sz="1800" b="1" i="0" u="none" strike="noStrike" kern="1200" cap="none" spc="0" normalizeH="0" baseline="0" noProof="0" dirty="0">
               <a:ln>
@@ -12019,7 +12019,7 @@
       </p:sp>
       <p:sp>
         <p:nvSpPr>
-          <p:cNvPr id="1131" name="Lineas 1131">
+          <p:cNvPr id="1149" name="Lineas 1149">
             <a:extLst>
               <a:ext uri="{FF2B5EF4-FFF2-40B4-BE49-F238E27FC236}">
                 <a16:creationId xmlns:a16="http://schemas.microsoft.com/office/drawing/2014/main" id="{1411DB53-B1E6-1270-3C2B-02D7177B8A2F}"/>
@@ -12067,7 +12067,7 @@
                 </a:solidFill>
                 <a:latin typeface="Abadi ExtraLight" panose="020B0204020104020204" pitchFamily="34" charset="0"/>
               </a:rPr>
-              <a:t>{{#F231}}</a:t>
+              <a:t>{{#F249}}</a:t>
             </a:r>
             <a:endParaRPr kumimoji="0" lang="es-PE" sz="1800" b="1" i="0" u="none" strike="noStrike" kern="1200" cap="none" spc="0" normalizeH="0" baseline="0" noProof="0" dirty="0">
               <a:ln>
@@ -12088,7 +12088,7 @@
       </p:sp>
       <p:sp>
         <p:nvSpPr>
-          <p:cNvPr id="1132" name="Lineas 1132">
+          <p:cNvPr id="1150" name="Lineas 1150">
             <a:extLst>
               <a:ext uri="{FF2B5EF4-FFF2-40B4-BE49-F238E27FC236}">
                 <a16:creationId xmlns:a16="http://schemas.microsoft.com/office/drawing/2014/main" id="{1411DB53-B1E6-1270-3C2B-02D7177B8A2F}"/>
@@ -12136,7 +12136,7 @@
                 </a:solidFill>
                 <a:latin typeface="Abadi ExtraLight" panose="020B0204020104020204" pitchFamily="34" charset="0"/>
               </a:rPr>
-              <a:t>{{#F232}}</a:t>
+              <a:t>{{#F250}}</a:t>
             </a:r>
             <a:endParaRPr kumimoji="0" lang="es-PE" sz="1800" b="1" i="0" u="none" strike="noStrike" kern="1200" cap="none" spc="0" normalizeH="0" baseline="0" noProof="0" dirty="0">
               <a:ln>
@@ -12263,7 +12263,7 @@
                 <a:cs typeface="Candara"/>
                 <a:sym typeface="Candara"/>
               </a:rPr>
-              <a:t>{{#F247}}</a:t>
+              <a:t>{{#F265}}</a:t>
             </a:r>
             <a:endParaRPr kumimoji="0" lang="en-US" sz="1800" b="0" i="0" u="none" strike="noStrike" kern="0" cap="none" spc="0" normalizeH="0" baseline="0" noProof="0" dirty="0">
               <a:ln>
@@ -12461,7 +12461,7 @@
                   </a:solidFill>
                   <a:latin typeface="Calibri" panose="020F0502020204030204"/>
                 </a:rPr>
-                <a:t>{{#F248}}</a:t>
+                <a:t>{{#F266}}</a:t>
               </a:r>
               <a:endParaRPr kumimoji="0" lang="es-PE" sz="1800" b="1" i="0" u="none" strike="noStrike" kern="1200" cap="none" spc="0" normalizeH="0" baseline="0" noProof="0" dirty="0">
                 <a:ln>
@@ -12541,7 +12541,7 @@
                 <a:ea typeface="+mn-ea"/>
                 <a:cs typeface="+mn-cs"/>
               </a:rPr>
-              <a:t>{{#F249}}</a:t>
+              <a:t>{{#F267}}</a:t>
             </a:r>
             <a:endParaRPr kumimoji="0" lang="es-PE" sz="1400" b="0" i="0" u="none" strike="noStrike" kern="1200" cap="none" spc="0" normalizeH="0" baseline="0" noProof="0" dirty="0">
               <a:ln>
@@ -12616,7 +12616,7 @@
                 </a:solidFill>
                 <a:latin typeface="Calibri" panose="020F0502020204030204"/>
               </a:rPr>
-              <a:t>{{#F250}}</a:t>
+              <a:t>{{#F268}}</a:t>
             </a:r>
             <a:endParaRPr kumimoji="0" lang="es-PE" sz="1800" b="1" i="0" u="none" strike="noStrike" kern="1200" cap="none" spc="0" normalizeH="0" baseline="0" noProof="0" dirty="0">
               <a:ln>
@@ -12695,7 +12695,7 @@
                 <a:ea typeface="+mn-ea"/>
                 <a:cs typeface="+mn-cs"/>
               </a:rPr>
-              <a:t>{{#F251}}</a:t>
+              <a:t>{{#F269}}</a:t>
             </a:r>
             <a:endParaRPr kumimoji="0" lang="es-PE" sz="1400" b="0" i="0" u="none" strike="noStrike" kern="1200" cap="none" spc="0" normalizeH="0" baseline="0" noProof="0" dirty="0">
               <a:ln>
@@ -12766,7 +12766,7 @@
                 </a:solidFill>
                 <a:latin typeface="Abadi ExtraLight" panose="020B0204020104020204" pitchFamily="34" charset="0"/>
               </a:rPr>
-              <a:t>{{#F233}}</a:t>
+              <a:t>{{#F251}}</a:t>
             </a:r>
             <a:endParaRPr kumimoji="0" lang="es-PE" sz="1800" b="1" i="0" u="none" strike="noStrike" kern="1200" cap="none" spc="0" normalizeH="0" baseline="0" noProof="0" dirty="0">
               <a:ln>
@@ -12837,7 +12837,7 @@
                 </a:solidFill>
                 <a:latin typeface="Abadi ExtraLight" panose="020B0204020104020204" pitchFamily="34" charset="0"/>
               </a:rPr>
-              <a:t>{{#F234}}</a:t>
+              <a:t>{{#F252}}</a:t>
             </a:r>
             <a:endParaRPr kumimoji="0" lang="es-PE" sz="1800" b="1" i="0" u="none" strike="noStrike" kern="1200" cap="none" spc="0" normalizeH="0" baseline="0" noProof="0" dirty="0">
               <a:ln>
@@ -12908,7 +12908,7 @@
                 </a:solidFill>
                 <a:latin typeface="Abadi ExtraLight" panose="020B0204020104020204" pitchFamily="34" charset="0"/>
               </a:rPr>
-              <a:t>{{#F235}}</a:t>
+              <a:t>{{#F253}}</a:t>
             </a:r>
             <a:endParaRPr kumimoji="0" lang="es-PE" sz="1800" b="1" i="0" u="none" strike="noStrike" kern="1200" cap="none" spc="0" normalizeH="0" baseline="0" noProof="0" dirty="0">
               <a:ln>
@@ -12979,7 +12979,7 @@
                 </a:solidFill>
                 <a:latin typeface="Abadi ExtraLight" panose="020B0204020104020204" pitchFamily="34" charset="0"/>
               </a:rPr>
-              <a:t>{{#F236}}</a:t>
+              <a:t>{{#F254}}</a:t>
             </a:r>
             <a:endParaRPr kumimoji="0" lang="es-PE" sz="1800" b="1" i="0" u="none" strike="noStrike" kern="1200" cap="none" spc="0" normalizeH="0" baseline="0" noProof="0" dirty="0">
               <a:ln>
@@ -13050,7 +13050,7 @@
                 </a:solidFill>
                 <a:latin typeface="Abadi ExtraLight" panose="020B0204020104020204" pitchFamily="34" charset="0"/>
               </a:rPr>
-              <a:t>{{#F237}}</a:t>
+              <a:t>{{#F255}}</a:t>
             </a:r>
             <a:endParaRPr kumimoji="0" lang="es-PE" sz="1800" b="1" i="0" u="none" strike="noStrike" kern="1200" cap="none" spc="0" normalizeH="0" baseline="0" noProof="0" dirty="0">
               <a:ln>
@@ -13121,7 +13121,7 @@
                 </a:solidFill>
                 <a:latin typeface="Abadi ExtraLight" panose="020B0204020104020204" pitchFamily="34" charset="0"/>
               </a:rPr>
-              <a:t>{{#F238}}</a:t>
+              <a:t>{{#F256}}</a:t>
             </a:r>
             <a:endParaRPr kumimoji="0" lang="es-PE" sz="1800" b="1" i="0" u="none" strike="noStrike" kern="1200" cap="none" spc="0" normalizeH="0" baseline="0" noProof="0" dirty="0">
               <a:ln>
@@ -13192,7 +13192,7 @@
                 </a:solidFill>
                 <a:latin typeface="Abadi ExtraLight" panose="020B0204020104020204" pitchFamily="34" charset="0"/>
               </a:rPr>
-              <a:t>{{#F239}}</a:t>
+              <a:t>{{#F257}}</a:t>
             </a:r>
             <a:endParaRPr kumimoji="0" lang="es-PE" sz="1800" b="1" i="0" u="none" strike="noStrike" kern="1200" cap="none" spc="0" normalizeH="0" baseline="0" noProof="0" dirty="0">
               <a:ln>
@@ -13263,7 +13263,7 @@
                 </a:solidFill>
                 <a:latin typeface="Abadi ExtraLight" panose="020B0204020104020204" pitchFamily="34" charset="0"/>
               </a:rPr>
-              <a:t>{{#F240}}</a:t>
+              <a:t>{{#F258}}</a:t>
             </a:r>
             <a:endParaRPr kumimoji="0" lang="es-PE" sz="1800" b="1" i="0" u="none" strike="noStrike" kern="1200" cap="none" spc="0" normalizeH="0" baseline="0" noProof="0" dirty="0">
               <a:ln>
@@ -13344,7 +13344,7 @@
                 <a:ea typeface="+mn-ea"/>
                 <a:cs typeface="+mn-cs"/>
               </a:rPr>
-              <a:t>{{#F241}}</a:t>
+              <a:t>{{#F259}}</a:t>
             </a:r>
           </a:p>
         </p:txBody>
@@ -13477,7 +13477,7 @@
                 </a:solidFill>
                 <a:latin typeface="Abadi ExtraLight" panose="020B0204020104020204" pitchFamily="34" charset="0"/>
               </a:rPr>
-              <a:t>{{#F252}}</a:t>
+              <a:t>{{#F270}}</a:t>
             </a:r>
             <a:endParaRPr kumimoji="0" lang="es-PE" sz="1400" b="0" i="0" u="sng" strike="noStrike" kern="1200" cap="none" spc="0" normalizeH="0" baseline="0" noProof="0" dirty="0">
               <a:ln>
@@ -13632,7 +13632,7 @@
                 <a:ea typeface="+mn-ea"/>
                 <a:cs typeface="+mn-cs"/>
               </a:rPr>
-              <a:t>{{#F253}}</a:t>
+              <a:t>{{#F271}}</a:t>
             </a:r>
             <a:endParaRPr kumimoji="0" lang="es-PE" sz="1400" b="0" i="0" u="sng" strike="noStrike" kern="1200" cap="none" spc="0" normalizeH="0" baseline="0" noProof="0" dirty="0">
               <a:ln>
@@ -13779,7 +13779,7 @@
                 </a:solidFill>
                 <a:latin typeface="Abadi ExtraLight" panose="020B0204020104020204" pitchFamily="34" charset="0"/>
               </a:rPr>
-              <a:t>{{#F254}}</a:t>
+              <a:t>{{#F272}}</a:t>
             </a:r>
             <a:endParaRPr kumimoji="0" lang="es-PE" sz="1400" b="0" i="0" u="sng" strike="noStrike" kern="1200" cap="none" spc="0" normalizeH="0" baseline="0" noProof="0" dirty="0">
               <a:ln>
@@ -13853,7 +13853,7 @@
                 </a:solidFill>
                 <a:latin typeface="Century Gothic" panose="020B0502020202020204" pitchFamily="34" charset="0"/>
               </a:rPr>
-              <a:t>{{#F255}}</a:t>
+              <a:t>{{#F273}}</a:t>
             </a:r>
             <a:endParaRPr kumimoji="0" lang="es-PE" sz="1200" b="1" i="0" u="none" strike="noStrike" kern="1200" cap="none" spc="0" normalizeH="0" baseline="0" noProof="0" dirty="0">
               <a:ln>
@@ -13937,7 +13937,7 @@
                 <a:ea typeface="+mn-ea"/>
                 <a:cs typeface="+mn-cs"/>
               </a:rPr>
-              <a:t>{{#F242}}</a:t>
+              <a:t>{{#F260}}</a:t>
             </a:r>
           </a:p>
         </p:txBody>
@@ -13997,7 +13997,7 @@
                 </a:solidFill>
                 <a:latin typeface="Century Gothic" panose="020B0502020202020204" pitchFamily="34" charset="0"/>
               </a:rPr>
-              <a:t>{{#F256}}</a:t>
+              <a:t>{{#F274}}</a:t>
             </a:r>
             <a:endParaRPr kumimoji="0" lang="es-PE" sz="1200" b="1" i="0" u="none" strike="noStrike" kern="1200" cap="none" spc="0" normalizeH="0" baseline="0" noProof="0" dirty="0">
               <a:ln>
@@ -14081,7 +14081,7 @@
                 <a:ea typeface="+mn-ea"/>
                 <a:cs typeface="+mn-cs"/>
               </a:rPr>
-              <a:t>{{#F243}}</a:t>
+              <a:t>{{#F261}}</a:t>
             </a:r>
           </a:p>
         </p:txBody>
@@ -14141,7 +14141,7 @@
                 </a:solidFill>
                 <a:latin typeface="Century Gothic" panose="020B0502020202020204" pitchFamily="34" charset="0"/>
               </a:rPr>
-              <a:t>{{#F257}}</a:t>
+              <a:t>{{#F275}}</a:t>
             </a:r>
             <a:endParaRPr kumimoji="0" lang="es-PE" sz="1200" b="1" i="0" u="none" strike="noStrike" kern="1200" cap="none" spc="0" normalizeH="0" baseline="0" noProof="0" dirty="0">
               <a:ln>
@@ -14225,7 +14225,7 @@
                 <a:ea typeface="+mn-ea"/>
                 <a:cs typeface="+mn-cs"/>
               </a:rPr>
-              <a:t>{{#F244}}</a:t>
+              <a:t>{{#F262}}</a:t>
             </a:r>
           </a:p>
         </p:txBody>
@@ -14285,7 +14285,7 @@
                 </a:solidFill>
                 <a:latin typeface="Century Gothic" panose="020B0502020202020204" pitchFamily="34" charset="0"/>
               </a:rPr>
-              <a:t>{{#F258}}</a:t>
+              <a:t>{{#F276}}</a:t>
             </a:r>
             <a:endParaRPr kumimoji="0" lang="es-PE" sz="1200" b="1" i="0" u="none" strike="noStrike" kern="1200" cap="none" spc="0" normalizeH="0" baseline="0" noProof="0" dirty="0">
               <a:ln>
@@ -14369,7 +14369,7 @@
                 <a:ea typeface="+mn-ea"/>
                 <a:cs typeface="+mn-cs"/>
               </a:rPr>
-              <a:t>{{#F245}}</a:t>
+              <a:t>{{#F263}}</a:t>
             </a:r>
           </a:p>
         </p:txBody>
@@ -14429,7 +14429,7 @@
                 </a:solidFill>
                 <a:latin typeface="Century Gothic" panose="020B0502020202020204" pitchFamily="34" charset="0"/>
               </a:rPr>
-              <a:t>{{#F259}}</a:t>
+              <a:t>{{#F277}}</a:t>
             </a:r>
             <a:endParaRPr kumimoji="0" lang="es-PE" sz="1200" b="1" i="0" u="none" strike="noStrike" kern="1200" cap="none" spc="0" normalizeH="0" baseline="0" noProof="0" dirty="0">
               <a:ln>
@@ -14513,7 +14513,7 @@
                 <a:ea typeface="+mn-ea"/>
                 <a:cs typeface="+mn-cs"/>
               </a:rPr>
-              <a:t>{{#F246}}</a:t>
+              <a:t>{{#F264}}</a:t>
             </a:r>
           </a:p>
         </p:txBody>
@@ -14573,7 +14573,7 @@
                 </a:solidFill>
                 <a:latin typeface="Century Gothic" panose="020B0502020202020204" pitchFamily="34" charset="0"/>
               </a:rPr>
-              <a:t>{{#F260}}</a:t>
+              <a:t>{{#F278}}</a:t>
             </a:r>
             <a:endParaRPr kumimoji="0" lang="es-PE" sz="1200" b="1" i="0" u="none" strike="noStrike" kern="1200" cap="none" spc="0" normalizeH="0" baseline="0" noProof="0" dirty="0">
               <a:ln>
@@ -14731,7 +14731,7 @@
                 <a:ea typeface="+mn-ea"/>
                 <a:cs typeface="+mn-cs"/>
               </a:rPr>
-              <a:t>{{#F261}}</a:t>
+              <a:t>{{#F279}}</a:t>
             </a:r>
             <a:endParaRPr kumimoji="0" lang="es-PE" sz="1100" b="1" i="0" u="sng" strike="noStrike" kern="1200" cap="none" spc="0" normalizeH="0" baseline="0" noProof="0" dirty="0">
               <a:ln>
@@ -14886,7 +14886,7 @@
                 <a:ea typeface="+mn-ea"/>
                 <a:cs typeface="+mn-cs"/>
               </a:rPr>
-              <a:t>{{#F262}}</a:t>
+              <a:t>{{#F280}}</a:t>
             </a:r>
             <a:endParaRPr kumimoji="0" lang="es-PE" sz="1100" b="1" i="0" u="sng" strike="noStrike" kern="1200" cap="none" spc="0" normalizeH="0" baseline="0" noProof="0" dirty="0">
               <a:ln>
@@ -15041,7 +15041,7 @@
                 <a:ea typeface="+mn-ea"/>
                 <a:cs typeface="+mn-cs"/>
               </a:rPr>
-              <a:t>{{#F263}}</a:t>
+              <a:t>{{#F281}}</a:t>
             </a:r>
             <a:endParaRPr kumimoji="0" lang="es-PE" sz="1100" b="1" i="0" u="sng" strike="noStrike" kern="1200" cap="none" spc="0" normalizeH="0" baseline="0" noProof="0" dirty="0">
               <a:ln>
@@ -15196,7 +15196,7 @@
                 <a:ea typeface="+mn-ea"/>
                 <a:cs typeface="+mn-cs"/>
               </a:rPr>
-              <a:t>{{#F264}}</a:t>
+              <a:t>{{#F282}}</a:t>
             </a:r>
             <a:endParaRPr kumimoji="0" lang="es-PE" sz="1100" b="1" i="0" u="sng" strike="noStrike" kern="1200" cap="none" spc="0" normalizeH="0" baseline="0" noProof="0" dirty="0">
               <a:ln>
@@ -15217,7 +15217,7 @@
       </p:sp>
       <p:sp>
         <p:nvSpPr>
-          <p:cNvPr id="1165" name="Lineas 1165">
+          <p:cNvPr id="1183" name="Lineas 1183">
             <a:extLst>
               <a:ext uri="{FF2B5EF4-FFF2-40B4-BE49-F238E27FC236}">
                 <a16:creationId xmlns:a16="http://schemas.microsoft.com/office/drawing/2014/main" id="{473DA5A5-E11C-DB40-DF4F-8F3A69757349}"/>
@@ -15265,7 +15265,7 @@
                 </a:solidFill>
                 <a:latin typeface="Abadi ExtraLight" panose="020B0204020104020204" pitchFamily="34" charset="0"/>
               </a:rPr>
-              <a:t>{{#F265}}</a:t>
+              <a:t>{{#F283}}</a:t>
             </a:r>
             <a:endParaRPr kumimoji="0" lang="es-PE" sz="1800" b="1" i="0" u="none" strike="noStrike" kern="1200" cap="none" spc="0" normalizeH="0" baseline="0" noProof="0" dirty="0">
               <a:ln>
@@ -15286,7 +15286,7 @@
       </p:sp>
       <p:sp>
         <p:nvSpPr>
-          <p:cNvPr id="1166" name="Lineas 1166">
+          <p:cNvPr id="1184" name="Lineas 1184">
             <a:extLst>
               <a:ext uri="{FF2B5EF4-FFF2-40B4-BE49-F238E27FC236}">
                 <a16:creationId xmlns:a16="http://schemas.microsoft.com/office/drawing/2014/main" id="{473DA5A5-E11C-DB40-DF4F-8F3A69757349}"/>
@@ -15334,7 +15334,7 @@
                 </a:solidFill>
                 <a:latin typeface="Abadi ExtraLight" panose="020B0204020104020204" pitchFamily="34" charset="0"/>
               </a:rPr>
-              <a:t>{{#F266}}</a:t>
+              <a:t>{{#F284}}</a:t>
             </a:r>
             <a:endParaRPr kumimoji="0" lang="es-PE" sz="1800" b="1" i="0" u="none" strike="noStrike" kern="1200" cap="none" spc="0" normalizeH="0" baseline="0" noProof="0" dirty="0">
               <a:ln>
@@ -15355,7 +15355,7 @@
       </p:sp>
       <p:sp>
         <p:nvSpPr>
-          <p:cNvPr id="1167" name="Lineas 1167">
+          <p:cNvPr id="1185" name="Lineas 1185">
             <a:extLst>
               <a:ext uri="{FF2B5EF4-FFF2-40B4-BE49-F238E27FC236}">
                 <a16:creationId xmlns:a16="http://schemas.microsoft.com/office/drawing/2014/main" id="{473DA5A5-E11C-DB40-DF4F-8F3A69757349}"/>
@@ -15403,7 +15403,7 @@
                 </a:solidFill>
                 <a:latin typeface="Abadi ExtraLight" panose="020B0204020104020204" pitchFamily="34" charset="0"/>
               </a:rPr>
-              <a:t>{{#F267}}</a:t>
+              <a:t>{{#F285}}</a:t>
             </a:r>
             <a:endParaRPr kumimoji="0" lang="es-PE" sz="1800" b="1" i="0" u="none" strike="noStrike" kern="1200" cap="none" spc="0" normalizeH="0" baseline="0" noProof="0" dirty="0">
               <a:ln>
@@ -15424,7 +15424,7 @@
       </p:sp>
       <p:sp>
         <p:nvSpPr>
-          <p:cNvPr id="1168" name="Lineas 1168">
+          <p:cNvPr id="1186" name="Lineas 1186">
             <a:extLst>
               <a:ext uri="{FF2B5EF4-FFF2-40B4-BE49-F238E27FC236}">
                 <a16:creationId xmlns:a16="http://schemas.microsoft.com/office/drawing/2014/main" id="{473DA5A5-E11C-DB40-DF4F-8F3A69757349}"/>
@@ -15472,7 +15472,7 @@
                 </a:solidFill>
                 <a:latin typeface="Abadi ExtraLight" panose="020B0204020104020204" pitchFamily="34" charset="0"/>
               </a:rPr>
-              <a:t>{{#F268}}</a:t>
+              <a:t>{{#F286}}</a:t>
             </a:r>
             <a:endParaRPr kumimoji="0" lang="es-PE" sz="1800" b="1" i="0" u="none" strike="noStrike" kern="1200" cap="none" spc="0" normalizeH="0" baseline="0" noProof="0" dirty="0">
               <a:ln>
@@ -15579,7 +15579,7 @@
                 <a:cs typeface="Candara"/>
                 <a:sym typeface="Candara"/>
               </a:rPr>
-              <a:t>{{#F271}}</a:t>
+              <a:t>{{#F289}}</a:t>
             </a:r>
             <a:endParaRPr lang="en-US" kern="0" dirty="0">
               <a:solidFill>
@@ -15763,7 +15763,7 @@
                 <a:ea typeface="ADLaM Display" panose="02010000000000000000" pitchFamily="2" charset="0"/>
                 <a:cs typeface="ADLaM Display" panose="02010000000000000000" pitchFamily="2" charset="0"/>
               </a:rPr>
-              <a:t>{{#F270}}</a:t>
+              <a:t>{{#F288}}</a:t>
             </a:r>
             <a:endParaRPr lang="es-PE" sz="2000" dirty="0">
               <a:solidFill>
@@ -15920,7 +15920,7 @@
                   <a:latin typeface="Arial" panose="020B0604020202020204" pitchFamily="34" charset="0"/>
                   <a:cs typeface="Arial" panose="020B0604020202020204" pitchFamily="34" charset="0"/>
                 </a:rPr>
-                <a:t>{{#F269}}</a:t>
+                <a:t>{{#F287}}</a:t>
               </a:r>
               <a:endParaRPr lang="es-PE" sz="1600" b="1" dirty="0">
                 <a:solidFill>
@@ -15970,7 +15970,7 @@
                     </a:schemeClr>
                   </a:solidFill>
                 </a:rPr>
-                <a:t>{{#F272}}</a:t>
+                <a:t>{{#F290}}</a:t>
               </a:r>
               <a:endParaRPr lang="es-PE" b="1" dirty="0">
                 <a:solidFill>
@@ -16330,7 +16330,7 @@
                   </a:srgbClr>
                 </a:solidFill>
               </a:rPr>
-              <a:t>{{#F273}}</a:t>
+              <a:t>{{#F291}}</a:t>
             </a:r>
             <a:endParaRPr lang="es-PE" sz="1400" b="0" dirty="0">
               <a:solidFill>
@@ -16392,7 +16392,7 @@
                   </a:srgbClr>
                 </a:solidFill>
               </a:rPr>
-              <a:t>{{#F274}}</a:t>
+              <a:t>{{#F292}}</a:t>
             </a:r>
             <a:endParaRPr lang="es-PE" sz="1400" b="0" dirty="0">
               <a:solidFill>
@@ -26072,7 +26072,7 @@
                 <a:cs typeface="Candara"/>
                 <a:sym typeface="Candara"/>
               </a:rPr>
-              <a:t>{{#F102}}</a:t>
+              <a:t>{{#F100}}</a:t>
             </a:r>
             <a:endParaRPr kumimoji="0" lang="en-US" sz="1800" b="0" i="0" u="none" strike="noStrike" kern="0" cap="none" spc="0" normalizeH="0" baseline="0" noProof="0" dirty="0">
               <a:ln>
@@ -26207,7 +26207,7 @@
           </p:nvGrpSpPr>
           <p:grpSpPr>
             <a:xfrm>
-              <a:off x="2432753" y="1486018"/>
+              <a:off x="1278625" y="1319298"/>
               <a:ext cx="1501121" cy="1117899"/>
               <a:chOff x="8285925" y="3955078"/>
               <a:chExt cx="1501121" cy="1508760"/>
@@ -26256,9 +26256,7 @@
                 <a:noFill/>
               </p:spPr>
               <p:txBody>
-                <a:bodyPr wrap="none" rtlCol="0">
-                  <a:spAutoFit/>
-                </a:bodyPr>
+                <a:bodyPr wrap="none" rtlCol="0" anchor="ctr" lIns="0" rIns="0" tIns="0" bIns="0"/>
                 <a:lstStyle>
                   <a:defPPr>
                     <a:defRPr lang="es-PE"/>
@@ -26375,7 +26373,7 @@
                       <a:ea typeface="+mn-ea"/>
                       <a:cs typeface="+mn-cs"/>
                     </a:rPr>
-                    <a:t>{{#F103}}</a:t>
+                    <a:t>{{#F101}}</a:t>
                   </a:r>
                   <a:endParaRPr kumimoji="0" lang="es-PE" sz="1800" b="1" i="0" u="none" strike="noStrike" kern="1200" cap="none" spc="0" normalizeH="0" baseline="0" noProof="0" dirty="0">
                     <a:ln>
@@ -26531,355 +26529,8 @@
                     <a:ea typeface="+mn-ea"/>
                     <a:cs typeface="+mn-cs"/>
                   </a:rPr>
-                  <a:t>{{#F104}}</a:t>
+                  <a:t>{{#F102}}</a:t>
                 </a:r>
-              </a:p>
-            </p:txBody>
-          </p:sp>
-        </p:grpSp>
-        <p:grpSp>
-          <p:nvGrpSpPr>
-            <p:cNvPr id="10" name="Grupo 9">
-              <a:extLst>
-                <a:ext uri="{FF2B5EF4-FFF2-40B4-BE49-F238E27FC236}">
-                  <a16:creationId xmlns:a16="http://schemas.microsoft.com/office/drawing/2014/main" id="{A405260E-06FB-E520-33D4-8A7805DE4BF3}"/>
-                </a:ext>
-              </a:extLst>
-            </p:cNvPr>
-            <p:cNvGrpSpPr/>
-            <p:nvPr/>
-          </p:nvGrpSpPr>
-          <p:grpSpPr>
-            <a:xfrm>
-              <a:off x="4599711" y="1002405"/>
-              <a:ext cx="1458473" cy="849383"/>
-              <a:chOff x="8148359" y="3317397"/>
-              <a:chExt cx="1458473" cy="1129473"/>
-            </a:xfrm>
-          </p:grpSpPr>
-          <p:grpSp>
-            <p:nvGrpSpPr>
-              <p:cNvPr id="33" name="Grupo 32">
-                <a:extLst>
-                  <a:ext uri="{FF2B5EF4-FFF2-40B4-BE49-F238E27FC236}">
-                    <a16:creationId xmlns:a16="http://schemas.microsoft.com/office/drawing/2014/main" id="{54532A16-BDF3-42B7-0C06-2C6BE2C6059E}"/>
-                  </a:ext>
-                </a:extLst>
-              </p:cNvPr>
-              <p:cNvGrpSpPr/>
-              <p:nvPr/>
-            </p:nvGrpSpPr>
-            <p:grpSpPr>
-              <a:xfrm>
-                <a:off x="8480674" y="3603075"/>
-                <a:ext cx="845605" cy="816562"/>
-                <a:chOff x="8263340" y="3576896"/>
-                <a:chExt cx="845605" cy="816562"/>
-              </a:xfrm>
-            </p:grpSpPr>
-            <p:sp>
-              <p:nvSpPr>
-                <p:cNvPr id="39" name="CuadroTexto 38">
-                  <a:extLst>
-                    <a:ext uri="{FF2B5EF4-FFF2-40B4-BE49-F238E27FC236}">
-                      <a16:creationId xmlns:a16="http://schemas.microsoft.com/office/drawing/2014/main" id="{80D58F99-4594-0797-3844-6E9001ECE2CE}"/>
-                    </a:ext>
-                  </a:extLst>
-                </p:cNvPr>
-                <p:cNvSpPr txBox="1"/>
-                <p:nvPr/>
-              </p:nvSpPr>
-              <p:spPr>
-                <a:xfrm>
-                  <a:off x="8271658" y="3576896"/>
-                  <a:ext cx="837287" cy="551672"/>
-                </a:xfrm>
-                <a:prstGeom prst="rect">
-                  <a:avLst/>
-                </a:prstGeom>
-                <a:noFill/>
-              </p:spPr>
-              <p:txBody>
-                <a:bodyPr wrap="square" rtlCol="0">
-                  <a:spAutoFit/>
-                </a:bodyPr>
-                <a:lstStyle/>
-                <a:p>
-                  <a:pPr marL="0" marR="0" lvl="0" indent="0" algn="ctr" defTabSz="914400" rtl="0" eaLnBrk="1" fontAlgn="auto" latinLnBrk="0" hangingPunct="1">
-                    <a:lnSpc>
-                      <a:spcPct val="100000"/>
-                    </a:lnSpc>
-                    <a:spcBef>
-                      <a:spcPts val="0"/>
-                    </a:spcBef>
-                    <a:spcAft>
-                      <a:spcPts val="0"/>
-                    </a:spcAft>
-                    <a:buClrTx/>
-                    <a:buSzTx/>
-                    <a:buFontTx/>
-                    <a:buNone/>
-                    <a:tabLst/>
-                    <a:defRPr/>
-                  </a:pPr>
-                  <a:r>
-                    <a:rPr lang="es-MX" sz="2400" dirty="0">
-                      <a:solidFill>
-                        <a:srgbClr val="48BC65"/>
-                      </a:solidFill>
-                      <a:latin typeface="Century Gothic" panose="020B0502020202020204" pitchFamily="34" charset="0"/>
-                    </a:rPr>
-                    <a:t>{{#F99}}</a:t>
-                  </a:r>
-                  <a:endParaRPr kumimoji="0" lang="es-PE" sz="3200" i="0" u="none" strike="noStrike" kern="1200" cap="none" spc="0" normalizeH="0" baseline="0" noProof="0" dirty="0">
-                    <a:ln>
-                      <a:noFill/>
-                    </a:ln>
-                    <a:solidFill>
-                      <a:srgbClr val="48BC65"/>
-                    </a:solidFill>
-                    <a:effectLst/>
-                    <a:uLnTx/>
-                    <a:uFillTx/>
-                    <a:latin typeface="Century Gothic" panose="020B0502020202020204" pitchFamily="34" charset="0"/>
-                    <a:ea typeface="+mn-ea"/>
-                    <a:cs typeface="+mn-cs"/>
-                  </a:endParaRPr>
-                </a:p>
-              </p:txBody>
-            </p:sp>
-            <p:sp>
-              <p:nvSpPr>
-                <p:cNvPr id="41" name="CuadroTexto 40">
-                  <a:extLst>
-                    <a:ext uri="{FF2B5EF4-FFF2-40B4-BE49-F238E27FC236}">
-                      <a16:creationId xmlns:a16="http://schemas.microsoft.com/office/drawing/2014/main" id="{161EC9D4-1CC8-E356-0CC9-ECA014823FD8}"/>
-                    </a:ext>
-                  </a:extLst>
-                </p:cNvPr>
-                <p:cNvSpPr txBox="1"/>
-                <p:nvPr/>
-              </p:nvSpPr>
-              <p:spPr>
-                <a:xfrm>
-                  <a:off x="8263340" y="3952121"/>
-                  <a:ext cx="780431" cy="441337"/>
-                </a:xfrm>
-                <a:prstGeom prst="rect">
-                  <a:avLst/>
-                </a:prstGeom>
-                <a:noFill/>
-              </p:spPr>
-              <p:txBody>
-                <a:bodyPr wrap="none" rtlCol="0">
-                  <a:spAutoFit/>
-                </a:bodyPr>
-                <a:lstStyle/>
-                <a:p>
-                  <a:pPr marL="0" marR="0" lvl="0" indent="0" algn="l" defTabSz="914400" rtl="0" eaLnBrk="1" fontAlgn="auto" latinLnBrk="0" hangingPunct="1">
-                    <a:lnSpc>
-                      <a:spcPct val="100000"/>
-                    </a:lnSpc>
-                    <a:spcBef>
-                      <a:spcPts val="0"/>
-                    </a:spcBef>
-                    <a:spcAft>
-                      <a:spcPts val="0"/>
-                    </a:spcAft>
-                    <a:buClrTx/>
-                    <a:buSzTx/>
-                    <a:buFontTx/>
-                    <a:buNone/>
-                    <a:tabLst/>
-                    <a:defRPr/>
-                  </a:pPr>
-                  <a:r>
-                    <a:rPr kumimoji="0" lang="es-MX" sz="1800" b="1" i="0" u="none" strike="noStrike" kern="1200" cap="none" spc="0" normalizeH="0" baseline="0" noProof="0" dirty="0">
-                      <a:ln>
-                        <a:noFill/>
-                      </a:ln>
-                      <a:solidFill>
-                        <a:srgbClr val="000000"/>
-                      </a:solidFill>
-                      <a:effectLst/>
-                      <a:uLnTx/>
-                      <a:uFillTx/>
-                      <a:latin typeface="Abadi ExtraLight" panose="020B0204020104020204" pitchFamily="34" charset="0"/>
-                      <a:ea typeface="+mn-ea"/>
-                      <a:cs typeface="+mn-cs"/>
-                    </a:rPr>
-                    <a:t>{{#F105}}</a:t>
-                  </a:r>
-                  <a:endParaRPr kumimoji="0" lang="es-PE" sz="1800" b="1" i="0" u="none" strike="noStrike" kern="1200" cap="none" spc="0" normalizeH="0" baseline="0" noProof="0" dirty="0">
-                    <a:ln>
-                      <a:noFill/>
-                    </a:ln>
-                    <a:solidFill>
-                      <a:srgbClr val="000000"/>
-                    </a:solidFill>
-                    <a:effectLst/>
-                    <a:uLnTx/>
-                    <a:uFillTx/>
-                    <a:latin typeface="Abadi ExtraLight" panose="020B0204020104020204" pitchFamily="34" charset="0"/>
-                    <a:ea typeface="+mn-ea"/>
-                    <a:cs typeface="+mn-cs"/>
-                  </a:endParaRPr>
-                </a:p>
-              </p:txBody>
-            </p:sp>
-          </p:grpSp>
-          <p:sp>
-            <p:nvSpPr>
-              <p:cNvPr id="35" name="Rectángulo: esquinas redondeadas 34">
-                <a:extLst>
-                  <a:ext uri="{FF2B5EF4-FFF2-40B4-BE49-F238E27FC236}">
-                    <a16:creationId xmlns:a16="http://schemas.microsoft.com/office/drawing/2014/main" id="{2B70C59F-98ED-EC6B-75AD-D2C192A0D68A}"/>
-                  </a:ext>
-                </a:extLst>
-              </p:cNvPr>
-              <p:cNvSpPr/>
-              <p:nvPr/>
-            </p:nvSpPr>
-            <p:spPr>
-              <a:xfrm>
-                <a:off x="8148359" y="3317397"/>
-                <a:ext cx="1458473" cy="1129473"/>
-              </a:xfrm>
-              <a:prstGeom prst="roundRect">
-                <a:avLst/>
-              </a:prstGeom>
-              <a:noFill/>
-            </p:spPr>
-            <p:style>
-              <a:lnRef idx="2">
-                <a:schemeClr val="accent1">
-                  <a:shade val="15000"/>
-                </a:schemeClr>
-              </a:lnRef>
-              <a:fillRef idx="1">
-                <a:schemeClr val="accent1"/>
-              </a:fillRef>
-              <a:effectRef idx="0">
-                <a:schemeClr val="accent1"/>
-              </a:effectRef>
-              <a:fontRef idx="minor">
-                <a:schemeClr val="lt1"/>
-              </a:fontRef>
-            </p:style>
-            <p:txBody>
-              <a:bodyPr rtlCol="0" anchor="ctr"/>
-              <a:lstStyle/>
-              <a:p>
-                <a:pPr marL="0" marR="0" lvl="0" indent="0" algn="ctr" defTabSz="914400" rtl="0" eaLnBrk="1" fontAlgn="auto" latinLnBrk="0" hangingPunct="1">
-                  <a:lnSpc>
-                    <a:spcPct val="100000"/>
-                  </a:lnSpc>
-                  <a:spcBef>
-                    <a:spcPts val="0"/>
-                  </a:spcBef>
-                  <a:spcAft>
-                    <a:spcPts val="0"/>
-                  </a:spcAft>
-                  <a:buClrTx/>
-                  <a:buSzTx/>
-                  <a:buFontTx/>
-                  <a:buNone/>
-                  <a:tabLst/>
-                  <a:defRPr/>
-                </a:pPr>
-                <a:endParaRPr kumimoji="0" lang="es-PE" sz="1800" b="0" i="0" u="none" strike="noStrike" kern="1200" cap="none" spc="0" normalizeH="0" baseline="0" noProof="0" dirty="0">
-                  <a:ln>
-                    <a:noFill/>
-                  </a:ln>
-                  <a:solidFill>
-                    <a:prstClr val="white"/>
-                  </a:solidFill>
-                  <a:effectLst/>
-                  <a:uLnTx/>
-                  <a:uFillTx/>
-                  <a:latin typeface="Calibri" panose="020F0502020204030204"/>
-                  <a:ea typeface="+mn-ea"/>
-                  <a:cs typeface="+mn-cs"/>
-                </a:endParaRPr>
-              </a:p>
-            </p:txBody>
-          </p:sp>
-          <p:sp>
-            <p:nvSpPr>
-              <p:cNvPr id="37" name="CuadroTexto 36">
-                <a:extLst>
-                  <a:ext uri="{FF2B5EF4-FFF2-40B4-BE49-F238E27FC236}">
-                    <a16:creationId xmlns:a16="http://schemas.microsoft.com/office/drawing/2014/main" id="{20531A44-8D1B-BB9D-E3D9-412D741D758E}"/>
-                  </a:ext>
-                </a:extLst>
-              </p:cNvPr>
-              <p:cNvSpPr txBox="1"/>
-              <p:nvPr/>
-            </p:nvSpPr>
-            <p:spPr>
-              <a:xfrm>
-                <a:off x="8220465" y="3338443"/>
-                <a:ext cx="1287887" cy="367782"/>
-              </a:xfrm>
-              <a:prstGeom prst="rect">
-                <a:avLst/>
-              </a:prstGeom>
-              <a:noFill/>
-            </p:spPr>
-            <p:txBody>
-              <a:bodyPr wrap="none" rtlCol="0">
-                <a:spAutoFit/>
-              </a:bodyPr>
-              <a:lstStyle/>
-              <a:p>
-                <a:pPr marL="0" marR="0" lvl="0" indent="0" algn="l" defTabSz="914400" rtl="0" eaLnBrk="1" fontAlgn="auto" latinLnBrk="0" hangingPunct="1">
-                  <a:lnSpc>
-                    <a:spcPct val="100000"/>
-                  </a:lnSpc>
-                  <a:spcBef>
-                    <a:spcPts val="0"/>
-                  </a:spcBef>
-                  <a:spcAft>
-                    <a:spcPts val="0"/>
-                  </a:spcAft>
-                  <a:buClrTx/>
-                  <a:buSzTx/>
-                  <a:buFontTx/>
-                  <a:buNone/>
-                  <a:tabLst/>
-                  <a:defRPr/>
-                </a:pPr>
-                <a:r>
-                  <a:rPr kumimoji="0" lang="es-MX" sz="1400" b="0" i="0" u="sng" strike="noStrike" kern="1200" cap="none" spc="0" normalizeH="0" baseline="0" noProof="0" dirty="0">
-                    <a:ln>
-                      <a:noFill/>
-                    </a:ln>
-                    <a:solidFill>
-                      <a:srgbClr val="000000"/>
-                    </a:solidFill>
-                    <a:effectLst/>
-                    <a:uLnTx/>
-                    <a:uFillTx/>
-                    <a:latin typeface="Abadi ExtraLight" panose="020B0204020104020204" pitchFamily="34" charset="0"/>
-                    <a:ea typeface="+mn-ea"/>
-                    <a:cs typeface="+mn-cs"/>
-                  </a:rPr>
-                  <a:t>{{#F106}}</a:t>
-                </a:r>
-                <a:endParaRPr kumimoji="0" lang="es-PE" sz="1400" b="1" i="0" u="sng" strike="noStrike" kern="1200" cap="none" spc="0" normalizeH="0" baseline="0" noProof="0" dirty="0">
-                  <a:ln>
-                    <a:noFill/>
-                  </a:ln>
-                  <a:solidFill>
-                    <a:srgbClr val="000000"/>
-                  </a:solidFill>
-                  <a:effectLst/>
-                  <a:uLnTx/>
-                  <a:uFillTx/>
-                  <a:latin typeface="Abadi ExtraLight" panose="020B0204020104020204" pitchFamily="34" charset="0"/>
-                  <a:ea typeface="+mn-ea"/>
-                  <a:cs typeface="+mn-cs"/>
-                </a:endParaRPr>
               </a:p>
             </p:txBody>
           </p:sp>
@@ -26898,8 +26549,8 @@
           </p:nvSpPr>
           <p:spPr>
             <a:xfrm>
-              <a:off x="2432753" y="579734"/>
-              <a:ext cx="6635108" cy="369332"/>
+              <a:off x="1278619" y="579734"/>
+              <a:ext cx="10294038" cy="369742"/>
             </a:xfrm>
             <a:prstGeom prst="rect">
               <a:avLst/>
@@ -26911,9 +26562,7 @@
             </a:solidFill>
           </p:spPr>
           <p:txBody>
-            <a:bodyPr wrap="square" rtlCol="0">
-              <a:spAutoFit/>
-            </a:bodyPr>
+            <a:bodyPr wrap="none" rtlCol="0" anchor="ctr" lIns="0" rIns="0" tIns="0" bIns="0"/>
             <a:lstStyle/>
             <a:p>
               <a:pPr marL="0" marR="0" lvl="0" indent="0" algn="ctr" defTabSz="914400" rtl="0" eaLnBrk="1" fontAlgn="auto" latinLnBrk="0" hangingPunct="1">
@@ -26948,7 +26597,7 @@
                   <a:ea typeface="+mn-ea"/>
                   <a:cs typeface="+mn-cs"/>
                 </a:rPr>
-                <a:t>{{#F107}}</a:t>
+                <a:t>{{#F103}}</a:t>
               </a:r>
               <a:endParaRPr kumimoji="0" lang="es-PE" sz="1800" b="1" i="0" u="none" strike="noStrike" kern="1200" cap="none" spc="0" normalizeH="0" baseline="0" noProof="0" dirty="0">
                 <a:ln>
@@ -26981,7 +26630,7 @@
           </p:nvGrpSpPr>
           <p:grpSpPr>
             <a:xfrm>
-              <a:off x="6539995" y="1299631"/>
+              <a:off x="9659597" y="1302835"/>
               <a:ext cx="2042419" cy="1134614"/>
               <a:chOff x="6576866" y="1251186"/>
               <a:chExt cx="2042419" cy="1508760"/>
@@ -27026,7 +26675,7 @@
               </a:fontRef>
             </p:style>
             <p:txBody>
-              <a:bodyPr rtlCol="0" anchor="ctr"/>
+              <a:bodyPr rtlCol="0" anchor="ctr" wrap="none" lIns="0" rIns="0" tIns="0" bIns="0"/>
               <a:lstStyle/>
               <a:p>
                 <a:pPr marL="0" marR="0" lvl="0" indent="0" algn="ctr" defTabSz="914400" rtl="0" eaLnBrk="1" fontAlgn="auto" latinLnBrk="0" hangingPunct="1">
@@ -27123,7 +26772,7 @@
                     <a:ea typeface="+mn-ea"/>
                     <a:cs typeface="+mn-cs"/>
                   </a:rPr>
-                  <a:t>{{#F108}}</a:t>
+                  <a:t>{{#F104}}</a:t>
                 </a:r>
                 <a:endParaRPr kumimoji="0" lang="es-PE" sz="1600" b="0" i="0" u="sng" strike="noStrike" kern="1200" cap="none" spc="0" normalizeH="0" baseline="0" noProof="0" dirty="0">
                   <a:ln>
@@ -27194,7 +26843,7 @@
                     </a:solidFill>
                     <a:latin typeface="Century Gothic" panose="020B0502020202020204" pitchFamily="34" charset="0"/>
                   </a:rPr>
-                  <a:t>{{#F100}}</a:t>
+                  <a:t>{{#F99}}</a:t>
                 </a:r>
               </a:p>
             </p:txBody>
@@ -27215,8 +26864,8 @@
         </p:nvSpPr>
         <p:spPr>
           <a:xfrm>
-            <a:off x="2659994" y="3290690"/>
-            <a:ext cx="1658083" cy="307777"/>
+            <a:off x="822962" y="3291878"/>
+            <a:ext cx="1655065" cy="310885"/>
           </a:xfrm>
           <a:prstGeom prst="rect">
             <a:avLst/>
@@ -27224,9 +26873,7 @@
           <a:noFill/>
         </p:spPr>
         <p:txBody>
-          <a:bodyPr wrap="none" rtlCol="0">
-            <a:spAutoFit/>
-          </a:bodyPr>
+          <a:bodyPr wrap="none" rtlCol="0" anchor="ctr" lIns="0" rIns="0" tIns="0" bIns="0"/>
           <a:lstStyle/>
           <a:p>
             <a:r>
@@ -27236,7 +26883,7 @@
                 </a:solidFill>
                 <a:latin typeface="Arial"/>
               </a:rPr>
-              <a:t>{{#F109}}</a:t>
+              <a:t>{{#F105}}</a:t>
             </a:r>
             <a:endParaRPr lang="es-PE" sz="1400" dirty="0">
               <a:solidFill>
@@ -27260,8 +26907,8 @@
         </p:nvSpPr>
         <p:spPr>
           <a:xfrm>
-            <a:off x="4495425" y="3330498"/>
-            <a:ext cx="3458447" cy="307777"/>
+            <a:off x="2697438" y="3291820"/>
+            <a:ext cx="3456435" cy="310885"/>
           </a:xfrm>
           <a:prstGeom prst="rect">
             <a:avLst/>
@@ -27269,9 +26916,7 @@
           <a:noFill/>
         </p:spPr>
         <p:txBody>
-          <a:bodyPr wrap="none" rtlCol="0">
-            <a:spAutoFit/>
-          </a:bodyPr>
+          <a:bodyPr wrap="none" rtlCol="0" anchor="ctr" lIns="0" rIns="0" tIns="0" bIns="0"/>
           <a:lstStyle/>
           <a:p>
             <a:r>
@@ -27281,7 +26926,7 @@
                 </a:solidFill>
                 <a:latin typeface="Arial"/>
               </a:rPr>
-              <a:t>{{#F110}}</a:t>
+              <a:t>{{#F106}}</a:t>
             </a:r>
             <a:endParaRPr lang="es-PE" sz="1400" dirty="0">
               <a:solidFill>
@@ -27293,10 +26938,86 @@
       </p:sp>
       <p:sp>
         <p:nvSpPr>
-          <p:cNvPr id="9" name="CuadroTexto 8">
+          <p:cNvPr id="850" name="Rectángulo: esquinas redondeadas 34">
             <a:extLst>
               <a:ext uri="{FF2B5EF4-FFF2-40B4-BE49-F238E27FC236}">
-                <a16:creationId xmlns:a16="http://schemas.microsoft.com/office/drawing/2014/main" id="{BE2E8076-D83D-F5E6-2F84-AE9517EF44F6}"/>
+                <a16:creationId xmlns:a16="http://schemas.microsoft.com/office/drawing/2014/main" id="{2B70C59F-98ED-EC6B-75AD-D2C192A0D68A}"/>
+              </a:ext>
+            </a:extLst>
+          </p:cNvPr>
+          <p:cNvSpPr/>
+          <p:nvPr/>
+        </p:nvSpPr>
+        <p:spPr>
+          <a:xfrm>
+            <a:off x="2697480" y="1243584"/>
+            <a:ext cx="1600200" cy="941832"/>
+          </a:xfrm>
+          <a:prstGeom prst="roundRect">
+            <a:avLst/>
+          </a:prstGeom>
+          <a:noFill/>
+        </p:spPr>
+        <p:style>
+          <a:lnRef idx="2">
+            <a:schemeClr val="accent1">
+              <a:shade val="15000"/>
+            </a:schemeClr>
+          </a:lnRef>
+          <a:fillRef idx="1">
+            <a:schemeClr val="accent1"/>
+          </a:fillRef>
+          <a:effectRef idx="0">
+            <a:schemeClr val="accent1"/>
+          </a:effectRef>
+          <a:fontRef idx="minor">
+            <a:schemeClr val="lt1"/>
+          </a:fontRef>
+        </p:style>
+        <p:txBody>
+          <a:bodyPr rtlCol="0" anchor="ctr"/>
+          <a:lstStyle/>
+          <a:p>
+            <a:pPr marL="0" marR="0" lvl="0" indent="0" algn="ctr" defTabSz="914400" rtl="0" eaLnBrk="1" fontAlgn="auto" latinLnBrk="0" hangingPunct="1">
+              <a:lnSpc>
+                <a:spcPct val="100000"/>
+              </a:lnSpc>
+              <a:spcBef>
+                <a:spcPts val="0"/>
+              </a:spcBef>
+              <a:spcAft>
+                <a:spcPts val="0"/>
+              </a:spcAft>
+              <a:buClrTx/>
+              <a:buSzTx/>
+              <a:buFontTx/>
+              <a:buNone/>
+              <a:tabLst/>
+              <a:defRPr/>
+            </a:pPr>
+            <a:endParaRPr kumimoji="0" lang="es-PE" sz="1800" b="0" i="0" u="none" strike="noStrike" kern="1200" cap="none" spc="0" normalizeH="0" baseline="0" noProof="0" dirty="0">
+              <a:ln>
+                <a:noFill/>
+              </a:ln>
+              <a:solidFill>
+                <a:prstClr val="white"/>
+              </a:solidFill>
+              <a:effectLst/>
+              <a:uLnTx/>
+              <a:uFillTx/>
+              <a:latin typeface="Calibri" panose="020F0502020204030204"/>
+              <a:ea typeface="+mn-ea"/>
+              <a:cs typeface="+mn-cs"/>
+            </a:endParaRPr>
+          </a:p>
+        </p:txBody>
+      </p:sp>
+      <p:sp>
+        <p:nvSpPr>
+          <p:cNvPr id="851" name="CuadroTexto 36">
+            <a:extLst>
+              <a:ext uri="{FF2B5EF4-FFF2-40B4-BE49-F238E27FC236}">
+                <a16:creationId xmlns:a16="http://schemas.microsoft.com/office/drawing/2014/main" id="{20531A44-8D1B-BB9D-E3D9-412D741D758E}"/>
               </a:ext>
             </a:extLst>
           </p:cNvPr>
@@ -27305,8 +27026,8 @@
         </p:nvSpPr>
         <p:spPr>
           <a:xfrm>
-            <a:off x="4657811" y="2550165"/>
-            <a:ext cx="892499" cy="461665"/>
+            <a:off x="2734056" y="1271016"/>
+            <a:ext cx="1527048" cy="274320"/>
           </a:xfrm>
           <a:prstGeom prst="rect">
             <a:avLst/>
@@ -27314,7 +27035,7 @@
           <a:noFill/>
         </p:spPr>
         <p:txBody>
-          <a:bodyPr wrap="square" rtlCol="0">
+          <a:bodyPr wrap="none" rtlCol="0" anchor="ctr" lIns="0" rIns="0" tIns="0" bIns="0">
             <a:spAutoFit/>
           </a:bodyPr>
           <a:lstStyle/>
@@ -27337,21 +27058,92 @@
               <a:defRPr/>
             </a:pPr>
             <a:r>
-              <a:rPr kumimoji="0" lang="es-MX" sz="2400" i="0" u="none" strike="noStrike" kern="1200" cap="none" spc="0" normalizeH="0" baseline="0" noProof="0" dirty="0">
+              <a:rPr kumimoji="0" lang="es-MX" sz="1200" b="0" i="0" u="sng" strike="noStrike" kern="1200" cap="none" spc="0" normalizeH="0" baseline="0" noProof="0" dirty="0">
                 <a:ln>
                   <a:noFill/>
                 </a:ln>
                 <a:solidFill>
-                  <a:srgbClr val="48BC65"/>
+                  <a:srgbClr val="000000"/>
                 </a:solidFill>
                 <a:effectLst/>
                 <a:uLnTx/>
                 <a:uFillTx/>
-                <a:latin typeface="Century Gothic" panose="020B0502020202020204" pitchFamily="34" charset="0"/>
+                <a:latin typeface="Abadi ExtraLight" panose="020B0204020104020204" pitchFamily="34" charset="0"/>
                 <a:ea typeface="+mn-ea"/>
                 <a:cs typeface="+mn-cs"/>
               </a:rPr>
-              <a:t>{{#F101}}</a:t>
+              <a:t>{{#F107}}</a:t>
+            </a:r>
+            <a:endParaRPr kumimoji="0" lang="es-PE" sz="1400" b="1" i="0" u="sng" strike="noStrike" kern="1200" cap="none" spc="0" normalizeH="0" baseline="0" noProof="0" dirty="0">
+              <a:ln>
+                <a:noFill/>
+              </a:ln>
+              <a:solidFill>
+                <a:srgbClr val="000000"/>
+              </a:solidFill>
+              <a:effectLst/>
+              <a:uLnTx/>
+              <a:uFillTx/>
+              <a:latin typeface="Abadi ExtraLight" panose="020B0204020104020204" pitchFamily="34" charset="0"/>
+              <a:ea typeface="+mn-ea"/>
+              <a:cs typeface="+mn-cs"/>
+            </a:endParaRPr>
+          </a:p>
+        </p:txBody>
+      </p:sp>
+      <p:sp>
+        <p:nvSpPr>
+          <p:cNvPr id="852" name="CuadroTexto 38">
+            <a:extLst>
+              <a:ext uri="{FF2B5EF4-FFF2-40B4-BE49-F238E27FC236}">
+                <a16:creationId xmlns:a16="http://schemas.microsoft.com/office/drawing/2014/main" id="{80D58F99-4594-0797-3844-6E9001ECE2CE}"/>
+              </a:ext>
+            </a:extLst>
+          </p:cNvPr>
+          <p:cNvSpPr txBox="1"/>
+          <p:nvPr/>
+        </p:nvSpPr>
+        <p:spPr>
+          <a:xfrm>
+            <a:off x="2734056" y="1545336"/>
+            <a:ext cx="1527048" cy="347472"/>
+          </a:xfrm>
+          <a:prstGeom prst="rect">
+            <a:avLst/>
+          </a:prstGeom>
+          <a:noFill/>
+        </p:spPr>
+        <p:txBody>
+          <a:bodyPr wrap="none" rtlCol="0" anchor="ctr" lIns="0" rIns="0" tIns="0" bIns="0">
+            <a:spAutoFit/>
+          </a:bodyPr>
+          <a:lstStyle/>
+          <a:p>
+            <a:pPr marL="0" marR="0" lvl="0" indent="0" algn="ctr" defTabSz="914400" rtl="0" eaLnBrk="1" fontAlgn="auto" latinLnBrk="0" hangingPunct="1">
+              <a:lnSpc>
+                <a:spcPct val="100000"/>
+              </a:lnSpc>
+              <a:spcBef>
+                <a:spcPts val="0"/>
+              </a:spcBef>
+              <a:spcAft>
+                <a:spcPts val="0"/>
+              </a:spcAft>
+              <a:buClrTx/>
+              <a:buSzTx/>
+              <a:buFontTx/>
+              <a:buNone/>
+              <a:tabLst/>
+              <a:defRPr/>
+            </a:pPr>
+            <a:r>
+              <a:rPr lang="es-MX" sz="2400" dirty="0">
+                <a:solidFill>
+                  <a:srgbClr val="48BC65"/>
+                </a:solidFill>
+                <a:latin typeface="Century Gothic" panose="020B0502020202020204" pitchFamily="34" charset="0"/>
+              </a:rPr>
+              <a:t>{{#F108}}</a:t>
             </a:r>
             <a:endParaRPr kumimoji="0" lang="es-PE" sz="3200" i="0" u="none" strike="noStrike" kern="1200" cap="none" spc="0" normalizeH="0" baseline="0" noProof="0" dirty="0">
               <a:ln>
@@ -27372,10 +27164,10 @@
       </p:sp>
       <p:sp>
         <p:nvSpPr>
-          <p:cNvPr id="23" name="CuadroTexto 22">
+          <p:cNvPr id="853" name="CuadroTexto 40">
             <a:extLst>
               <a:ext uri="{FF2B5EF4-FFF2-40B4-BE49-F238E27FC236}">
-                <a16:creationId xmlns:a16="http://schemas.microsoft.com/office/drawing/2014/main" id="{09D1780C-79C8-62D1-D075-C30A3EDB70DC}"/>
+                <a16:creationId xmlns:a16="http://schemas.microsoft.com/office/drawing/2014/main" id="{161EC9D4-1CC8-E356-0CC9-ECA014823FD8}"/>
               </a:ext>
             </a:extLst>
           </p:cNvPr>
@@ -27384,8 +27176,8 @@
         </p:nvSpPr>
         <p:spPr>
           <a:xfrm>
-            <a:off x="4691166" y="2902537"/>
-            <a:ext cx="763351" cy="369332"/>
+            <a:off x="2734056" y="1865376"/>
+            <a:ext cx="1527048" cy="292608"/>
           </a:xfrm>
           <a:prstGeom prst="rect">
             <a:avLst/>
@@ -27393,12 +27185,12 @@
           <a:noFill/>
         </p:spPr>
         <p:txBody>
-          <a:bodyPr wrap="none" rtlCol="0">
+          <a:bodyPr wrap="none" rtlCol="0" anchor="ctr" lIns="0" rIns="0" tIns="0" bIns="0">
             <a:spAutoFit/>
           </a:bodyPr>
           <a:lstStyle/>
           <a:p>
-            <a:pPr marL="0" marR="0" lvl="0" indent="0" algn="l" defTabSz="914400" rtl="0" eaLnBrk="1" fontAlgn="auto" latinLnBrk="0" hangingPunct="1">
+            <a:pPr marL="0" marR="0" lvl="0" indent="0" algn="ctr" defTabSz="914400" rtl="0" eaLnBrk="1" fontAlgn="auto" latinLnBrk="0" hangingPunct="1">
               <a:lnSpc>
                 <a:spcPct val="100000"/>
               </a:lnSpc>
@@ -27430,7 +27222,7 @@
                 <a:ea typeface="+mn-ea"/>
                 <a:cs typeface="+mn-cs"/>
               </a:rPr>
-              <a:t>{{#F111}}</a:t>
+              <a:t>{{#F109}}</a:t>
             </a:r>
             <a:endParaRPr kumimoji="0" lang="es-PE" sz="1800" b="1" i="0" u="none" strike="noStrike" kern="1200" cap="none" spc="0" normalizeH="0" baseline="0" noProof="0" dirty="0">
               <a:ln>
@@ -27451,10 +27243,10 @@
       </p:sp>
       <p:sp>
         <p:nvSpPr>
-          <p:cNvPr id="26" name="Rectángulo: esquinas redondeadas 25">
+          <p:cNvPr id="854" name="Rectángulo: esquinas redondeadas 34">
             <a:extLst>
               <a:ext uri="{FF2B5EF4-FFF2-40B4-BE49-F238E27FC236}">
-                <a16:creationId xmlns:a16="http://schemas.microsoft.com/office/drawing/2014/main" id="{25FADA95-7C61-F84F-87AA-53CB83E6036E}"/>
+                <a16:creationId xmlns:a16="http://schemas.microsoft.com/office/drawing/2014/main" id="{2B70C59F-98ED-EC6B-75AD-D2C192A0D68A}"/>
               </a:ext>
             </a:extLst>
           </p:cNvPr>
@@ -27463,8 +27255,8 @@
         </p:nvSpPr>
         <p:spPr>
           <a:xfrm>
-            <a:off x="4363072" y="2274028"/>
-            <a:ext cx="1554647" cy="945196"/>
+            <a:off x="4416552" y="1243584"/>
+            <a:ext cx="1600200" cy="941832"/>
           </a:xfrm>
           <a:prstGeom prst="roundRect">
             <a:avLst/>
@@ -27527,10 +27319,10 @@
       </p:sp>
       <p:sp>
         <p:nvSpPr>
-          <p:cNvPr id="29" name="CuadroTexto 28">
+          <p:cNvPr id="855" name="CuadroTexto 36">
             <a:extLst>
               <a:ext uri="{FF2B5EF4-FFF2-40B4-BE49-F238E27FC236}">
-                <a16:creationId xmlns:a16="http://schemas.microsoft.com/office/drawing/2014/main" id="{5D6AA6F5-FD04-2D06-82CE-58B0BF2DAA61}"/>
+                <a16:creationId xmlns:a16="http://schemas.microsoft.com/office/drawing/2014/main" id="{20531A44-8D1B-BB9D-E3D9-412D741D758E}"/>
               </a:ext>
             </a:extLst>
           </p:cNvPr>
@@ -27539,8 +27331,8 @@
         </p:nvSpPr>
         <p:spPr>
           <a:xfrm>
-            <a:off x="4470326" y="2283359"/>
-            <a:ext cx="1412887" cy="307777"/>
+            <a:off x="4453128" y="1271016"/>
+            <a:ext cx="1527048" cy="274320"/>
           </a:xfrm>
           <a:prstGeom prst="rect">
             <a:avLst/>
@@ -27548,12 +27340,12 @@
           <a:noFill/>
         </p:spPr>
         <p:txBody>
-          <a:bodyPr wrap="none" rtlCol="0">
+          <a:bodyPr wrap="none" rtlCol="0" anchor="ctr" lIns="0" rIns="0" tIns="0" bIns="0">
             <a:spAutoFit/>
           </a:bodyPr>
           <a:lstStyle/>
           <a:p>
-            <a:pPr marL="0" marR="0" lvl="0" indent="0" algn="l" defTabSz="914400" rtl="0" eaLnBrk="1" fontAlgn="auto" latinLnBrk="0" hangingPunct="1">
+            <a:pPr marL="0" marR="0" lvl="0" indent="0" algn="ctr" defTabSz="914400" rtl="0" eaLnBrk="1" fontAlgn="auto" latinLnBrk="0" hangingPunct="1">
               <a:lnSpc>
                 <a:spcPct val="100000"/>
               </a:lnSpc>
@@ -27571,7 +27363,157 @@
               <a:defRPr/>
             </a:pPr>
             <a:r>
-              <a:rPr kumimoji="0" lang="es-MX" sz="1400" b="0" i="0" u="sng" strike="noStrike" kern="1200" cap="none" spc="0" normalizeH="0" baseline="0" noProof="0" dirty="0">
+              <a:rPr kumimoji="0" lang="es-MX" sz="1200" b="0" i="0" u="sng" strike="noStrike" kern="1200" cap="none" spc="0" normalizeH="0" baseline="0" noProof="0" dirty="0">
+                <a:ln>
+                  <a:noFill/>
+                </a:ln>
+                <a:solidFill>
+                  <a:srgbClr val="000000"/>
+                </a:solidFill>
+                <a:effectLst/>
+                <a:uLnTx/>
+                <a:uFillTx/>
+                <a:latin typeface="Abadi ExtraLight" panose="020B0204020104020204" pitchFamily="34" charset="0"/>
+                <a:ea typeface="+mn-ea"/>
+                <a:cs typeface="+mn-cs"/>
+              </a:rPr>
+              <a:t>{{#F110}}</a:t>
+            </a:r>
+            <a:endParaRPr kumimoji="0" lang="es-PE" sz="1400" b="1" i="0" u="sng" strike="noStrike" kern="1200" cap="none" spc="0" normalizeH="0" baseline="0" noProof="0" dirty="0">
+              <a:ln>
+                <a:noFill/>
+              </a:ln>
+              <a:solidFill>
+                <a:srgbClr val="000000"/>
+              </a:solidFill>
+              <a:effectLst/>
+              <a:uLnTx/>
+              <a:uFillTx/>
+              <a:latin typeface="Abadi ExtraLight" panose="020B0204020104020204" pitchFamily="34" charset="0"/>
+              <a:ea typeface="+mn-ea"/>
+              <a:cs typeface="+mn-cs"/>
+            </a:endParaRPr>
+          </a:p>
+        </p:txBody>
+      </p:sp>
+      <p:sp>
+        <p:nvSpPr>
+          <p:cNvPr id="856" name="CuadroTexto 38">
+            <a:extLst>
+              <a:ext uri="{FF2B5EF4-FFF2-40B4-BE49-F238E27FC236}">
+                <a16:creationId xmlns:a16="http://schemas.microsoft.com/office/drawing/2014/main" id="{80D58F99-4594-0797-3844-6E9001ECE2CE}"/>
+              </a:ext>
+            </a:extLst>
+          </p:cNvPr>
+          <p:cNvSpPr txBox="1"/>
+          <p:nvPr/>
+        </p:nvSpPr>
+        <p:spPr>
+          <a:xfrm>
+            <a:off x="4453128" y="1545336"/>
+            <a:ext cx="1527048" cy="347472"/>
+          </a:xfrm>
+          <a:prstGeom prst="rect">
+            <a:avLst/>
+          </a:prstGeom>
+          <a:noFill/>
+        </p:spPr>
+        <p:txBody>
+          <a:bodyPr wrap="none" rtlCol="0" anchor="ctr" lIns="0" rIns="0" tIns="0" bIns="0">
+            <a:spAutoFit/>
+          </a:bodyPr>
+          <a:lstStyle/>
+          <a:p>
+            <a:pPr marL="0" marR="0" lvl="0" indent="0" algn="ctr" defTabSz="914400" rtl="0" eaLnBrk="1" fontAlgn="auto" latinLnBrk="0" hangingPunct="1">
+              <a:lnSpc>
+                <a:spcPct val="100000"/>
+              </a:lnSpc>
+              <a:spcBef>
+                <a:spcPts val="0"/>
+              </a:spcBef>
+              <a:spcAft>
+                <a:spcPts val="0"/>
+              </a:spcAft>
+              <a:buClrTx/>
+              <a:buSzTx/>
+              <a:buFontTx/>
+              <a:buNone/>
+              <a:tabLst/>
+              <a:defRPr/>
+            </a:pPr>
+            <a:r>
+              <a:rPr lang="es-MX" sz="2400" dirty="0">
+                <a:solidFill>
+                  <a:srgbClr val="48BC65"/>
+                </a:solidFill>
+                <a:latin typeface="Century Gothic" panose="020B0502020202020204" pitchFamily="34" charset="0"/>
+              </a:rPr>
+              <a:t>{{#F111}}</a:t>
+            </a:r>
+            <a:endParaRPr kumimoji="0" lang="es-PE" sz="3200" i="0" u="none" strike="noStrike" kern="1200" cap="none" spc="0" normalizeH="0" baseline="0" noProof="0" dirty="0">
+              <a:ln>
+                <a:noFill/>
+              </a:ln>
+              <a:solidFill>
+                <a:srgbClr val="48BC65"/>
+              </a:solidFill>
+              <a:effectLst/>
+              <a:uLnTx/>
+              <a:uFillTx/>
+              <a:latin typeface="Century Gothic" panose="020B0502020202020204" pitchFamily="34" charset="0"/>
+              <a:ea typeface="+mn-ea"/>
+              <a:cs typeface="+mn-cs"/>
+            </a:endParaRPr>
+          </a:p>
+        </p:txBody>
+      </p:sp>
+      <p:sp>
+        <p:nvSpPr>
+          <p:cNvPr id="857" name="CuadroTexto 40">
+            <a:extLst>
+              <a:ext uri="{FF2B5EF4-FFF2-40B4-BE49-F238E27FC236}">
+                <a16:creationId xmlns:a16="http://schemas.microsoft.com/office/drawing/2014/main" id="{161EC9D4-1CC8-E356-0CC9-ECA014823FD8}"/>
+              </a:ext>
+            </a:extLst>
+          </p:cNvPr>
+          <p:cNvSpPr txBox="1"/>
+          <p:nvPr/>
+        </p:nvSpPr>
+        <p:spPr>
+          <a:xfrm>
+            <a:off x="4453128" y="1865376"/>
+            <a:ext cx="1527048" cy="292608"/>
+          </a:xfrm>
+          <a:prstGeom prst="rect">
+            <a:avLst/>
+          </a:prstGeom>
+          <a:noFill/>
+        </p:spPr>
+        <p:txBody>
+          <a:bodyPr wrap="none" rtlCol="0" anchor="ctr" lIns="0" rIns="0" tIns="0" bIns="0">
+            <a:spAutoFit/>
+          </a:bodyPr>
+          <a:lstStyle/>
+          <a:p>
+            <a:pPr marL="0" marR="0" lvl="0" indent="0" algn="ctr" defTabSz="914400" rtl="0" eaLnBrk="1" fontAlgn="auto" latinLnBrk="0" hangingPunct="1">
+              <a:lnSpc>
+                <a:spcPct val="100000"/>
+              </a:lnSpc>
+              <a:spcBef>
+                <a:spcPts val="0"/>
+              </a:spcBef>
+              <a:spcAft>
+                <a:spcPts val="0"/>
+              </a:spcAft>
+              <a:buClrTx/>
+              <a:buSzTx/>
+              <a:buFontTx/>
+              <a:buNone/>
+              <a:tabLst/>
+              <a:defRPr/>
+            </a:pPr>
+            <a:r>
+              <a:rPr kumimoji="0" lang="es-MX" sz="1800" b="1" i="0" u="none" strike="noStrike" kern="1200" cap="none" spc="0" normalizeH="0" baseline="0" noProof="0" dirty="0">
                 <a:ln>
                   <a:noFill/>
                 </a:ln>
@@ -27587,7 +27529,1837 @@
               </a:rPr>
               <a:t>{{#F112}}</a:t>
             </a:r>
+            <a:endParaRPr kumimoji="0" lang="es-PE" sz="1800" b="1" i="0" u="none" strike="noStrike" kern="1200" cap="none" spc="0" normalizeH="0" baseline="0" noProof="0" dirty="0">
+              <a:ln>
+                <a:noFill/>
+              </a:ln>
+              <a:solidFill>
+                <a:srgbClr val="000000"/>
+              </a:solidFill>
+              <a:effectLst/>
+              <a:uLnTx/>
+              <a:uFillTx/>
+              <a:latin typeface="Abadi ExtraLight" panose="020B0204020104020204" pitchFamily="34" charset="0"/>
+              <a:ea typeface="+mn-ea"/>
+              <a:cs typeface="+mn-cs"/>
+            </a:endParaRPr>
+          </a:p>
+        </p:txBody>
+      </p:sp>
+      <p:sp>
+        <p:nvSpPr>
+          <p:cNvPr id="858" name="Rectángulo: esquinas redondeadas 34">
+            <a:extLst>
+              <a:ext uri="{FF2B5EF4-FFF2-40B4-BE49-F238E27FC236}">
+                <a16:creationId xmlns:a16="http://schemas.microsoft.com/office/drawing/2014/main" id="{2B70C59F-98ED-EC6B-75AD-D2C192A0D68A}"/>
+              </a:ext>
+            </a:extLst>
+          </p:cNvPr>
+          <p:cNvSpPr/>
+          <p:nvPr/>
+        </p:nvSpPr>
+        <p:spPr>
+          <a:xfrm>
+            <a:off x="6135624" y="1243584"/>
+            <a:ext cx="1600200" cy="941832"/>
+          </a:xfrm>
+          <a:prstGeom prst="roundRect">
+            <a:avLst/>
+          </a:prstGeom>
+          <a:noFill/>
+        </p:spPr>
+        <p:style>
+          <a:lnRef idx="2">
+            <a:schemeClr val="accent1">
+              <a:shade val="15000"/>
+            </a:schemeClr>
+          </a:lnRef>
+          <a:fillRef idx="1">
+            <a:schemeClr val="accent1"/>
+          </a:fillRef>
+          <a:effectRef idx="0">
+            <a:schemeClr val="accent1"/>
+          </a:effectRef>
+          <a:fontRef idx="minor">
+            <a:schemeClr val="lt1"/>
+          </a:fontRef>
+        </p:style>
+        <p:txBody>
+          <a:bodyPr rtlCol="0" anchor="ctr"/>
+          <a:lstStyle/>
+          <a:p>
+            <a:pPr marL="0" marR="0" lvl="0" indent="0" algn="ctr" defTabSz="914400" rtl="0" eaLnBrk="1" fontAlgn="auto" latinLnBrk="0" hangingPunct="1">
+              <a:lnSpc>
+                <a:spcPct val="100000"/>
+              </a:lnSpc>
+              <a:spcBef>
+                <a:spcPts val="0"/>
+              </a:spcBef>
+              <a:spcAft>
+                <a:spcPts val="0"/>
+              </a:spcAft>
+              <a:buClrTx/>
+              <a:buSzTx/>
+              <a:buFontTx/>
+              <a:buNone/>
+              <a:tabLst/>
+              <a:defRPr/>
+            </a:pPr>
+            <a:endParaRPr kumimoji="0" lang="es-PE" sz="1800" b="0" i="0" u="none" strike="noStrike" kern="1200" cap="none" spc="0" normalizeH="0" baseline="0" noProof="0" dirty="0">
+              <a:ln>
+                <a:noFill/>
+              </a:ln>
+              <a:solidFill>
+                <a:prstClr val="white"/>
+              </a:solidFill>
+              <a:effectLst/>
+              <a:uLnTx/>
+              <a:uFillTx/>
+              <a:latin typeface="Calibri" panose="020F0502020204030204"/>
+              <a:ea typeface="+mn-ea"/>
+              <a:cs typeface="+mn-cs"/>
+            </a:endParaRPr>
+          </a:p>
+        </p:txBody>
+      </p:sp>
+      <p:sp>
+        <p:nvSpPr>
+          <p:cNvPr id="859" name="CuadroTexto 36">
+            <a:extLst>
+              <a:ext uri="{FF2B5EF4-FFF2-40B4-BE49-F238E27FC236}">
+                <a16:creationId xmlns:a16="http://schemas.microsoft.com/office/drawing/2014/main" id="{20531A44-8D1B-BB9D-E3D9-412D741D758E}"/>
+              </a:ext>
+            </a:extLst>
+          </p:cNvPr>
+          <p:cNvSpPr txBox="1"/>
+          <p:nvPr/>
+        </p:nvSpPr>
+        <p:spPr>
+          <a:xfrm>
+            <a:off x="6172200" y="1271016"/>
+            <a:ext cx="1527048" cy="274320"/>
+          </a:xfrm>
+          <a:prstGeom prst="rect">
+            <a:avLst/>
+          </a:prstGeom>
+          <a:noFill/>
+        </p:spPr>
+        <p:txBody>
+          <a:bodyPr wrap="none" rtlCol="0" anchor="ctr" lIns="0" rIns="0" tIns="0" bIns="0">
+            <a:spAutoFit/>
+          </a:bodyPr>
+          <a:lstStyle/>
+          <a:p>
+            <a:pPr marL="0" marR="0" lvl="0" indent="0" algn="ctr" defTabSz="914400" rtl="0" eaLnBrk="1" fontAlgn="auto" latinLnBrk="0" hangingPunct="1">
+              <a:lnSpc>
+                <a:spcPct val="100000"/>
+              </a:lnSpc>
+              <a:spcBef>
+                <a:spcPts val="0"/>
+              </a:spcBef>
+              <a:spcAft>
+                <a:spcPts val="0"/>
+              </a:spcAft>
+              <a:buClrTx/>
+              <a:buSzTx/>
+              <a:buFontTx/>
+              <a:buNone/>
+              <a:tabLst/>
+              <a:defRPr/>
+            </a:pPr>
+            <a:r>
+              <a:rPr kumimoji="0" lang="es-MX" sz="1200" b="0" i="0" u="sng" strike="noStrike" kern="1200" cap="none" spc="0" normalizeH="0" baseline="0" noProof="0" dirty="0">
+                <a:ln>
+                  <a:noFill/>
+                </a:ln>
+                <a:solidFill>
+                  <a:srgbClr val="000000"/>
+                </a:solidFill>
+                <a:effectLst/>
+                <a:uLnTx/>
+                <a:uFillTx/>
+                <a:latin typeface="Abadi ExtraLight" panose="020B0204020104020204" pitchFamily="34" charset="0"/>
+                <a:ea typeface="+mn-ea"/>
+                <a:cs typeface="+mn-cs"/>
+              </a:rPr>
+              <a:t>{{#F113}}</a:t>
+            </a:r>
             <a:endParaRPr kumimoji="0" lang="es-PE" sz="1400" b="1" i="0" u="sng" strike="noStrike" kern="1200" cap="none" spc="0" normalizeH="0" baseline="0" noProof="0" dirty="0">
+              <a:ln>
+                <a:noFill/>
+              </a:ln>
+              <a:solidFill>
+                <a:srgbClr val="000000"/>
+              </a:solidFill>
+              <a:effectLst/>
+              <a:uLnTx/>
+              <a:uFillTx/>
+              <a:latin typeface="Abadi ExtraLight" panose="020B0204020104020204" pitchFamily="34" charset="0"/>
+              <a:ea typeface="+mn-ea"/>
+              <a:cs typeface="+mn-cs"/>
+            </a:endParaRPr>
+          </a:p>
+        </p:txBody>
+      </p:sp>
+      <p:sp>
+        <p:nvSpPr>
+          <p:cNvPr id="860" name="CuadroTexto 38">
+            <a:extLst>
+              <a:ext uri="{FF2B5EF4-FFF2-40B4-BE49-F238E27FC236}">
+                <a16:creationId xmlns:a16="http://schemas.microsoft.com/office/drawing/2014/main" id="{80D58F99-4594-0797-3844-6E9001ECE2CE}"/>
+              </a:ext>
+            </a:extLst>
+          </p:cNvPr>
+          <p:cNvSpPr txBox="1"/>
+          <p:nvPr/>
+        </p:nvSpPr>
+        <p:spPr>
+          <a:xfrm>
+            <a:off x="6172200" y="1545336"/>
+            <a:ext cx="1527048" cy="347472"/>
+          </a:xfrm>
+          <a:prstGeom prst="rect">
+            <a:avLst/>
+          </a:prstGeom>
+          <a:noFill/>
+        </p:spPr>
+        <p:txBody>
+          <a:bodyPr wrap="none" rtlCol="0" anchor="ctr" lIns="0" rIns="0" tIns="0" bIns="0">
+            <a:spAutoFit/>
+          </a:bodyPr>
+          <a:lstStyle/>
+          <a:p>
+            <a:pPr marL="0" marR="0" lvl="0" indent="0" algn="ctr" defTabSz="914400" rtl="0" eaLnBrk="1" fontAlgn="auto" latinLnBrk="0" hangingPunct="1">
+              <a:lnSpc>
+                <a:spcPct val="100000"/>
+              </a:lnSpc>
+              <a:spcBef>
+                <a:spcPts val="0"/>
+              </a:spcBef>
+              <a:spcAft>
+                <a:spcPts val="0"/>
+              </a:spcAft>
+              <a:buClrTx/>
+              <a:buSzTx/>
+              <a:buFontTx/>
+              <a:buNone/>
+              <a:tabLst/>
+              <a:defRPr/>
+            </a:pPr>
+            <a:r>
+              <a:rPr lang="es-MX" sz="2400" dirty="0">
+                <a:solidFill>
+                  <a:srgbClr val="48BC65"/>
+                </a:solidFill>
+                <a:latin typeface="Century Gothic" panose="020B0502020202020204" pitchFamily="34" charset="0"/>
+              </a:rPr>
+              <a:t>{{#F114}}</a:t>
+            </a:r>
+            <a:endParaRPr kumimoji="0" lang="es-PE" sz="3200" i="0" u="none" strike="noStrike" kern="1200" cap="none" spc="0" normalizeH="0" baseline="0" noProof="0" dirty="0">
+              <a:ln>
+                <a:noFill/>
+              </a:ln>
+              <a:solidFill>
+                <a:srgbClr val="48BC65"/>
+              </a:solidFill>
+              <a:effectLst/>
+              <a:uLnTx/>
+              <a:uFillTx/>
+              <a:latin typeface="Century Gothic" panose="020B0502020202020204" pitchFamily="34" charset="0"/>
+              <a:ea typeface="+mn-ea"/>
+              <a:cs typeface="+mn-cs"/>
+            </a:endParaRPr>
+          </a:p>
+        </p:txBody>
+      </p:sp>
+      <p:sp>
+        <p:nvSpPr>
+          <p:cNvPr id="861" name="CuadroTexto 40">
+            <a:extLst>
+              <a:ext uri="{FF2B5EF4-FFF2-40B4-BE49-F238E27FC236}">
+                <a16:creationId xmlns:a16="http://schemas.microsoft.com/office/drawing/2014/main" id="{161EC9D4-1CC8-E356-0CC9-ECA014823FD8}"/>
+              </a:ext>
+            </a:extLst>
+          </p:cNvPr>
+          <p:cNvSpPr txBox="1"/>
+          <p:nvPr/>
+        </p:nvSpPr>
+        <p:spPr>
+          <a:xfrm>
+            <a:off x="6172200" y="1865376"/>
+            <a:ext cx="1527048" cy="292608"/>
+          </a:xfrm>
+          <a:prstGeom prst="rect">
+            <a:avLst/>
+          </a:prstGeom>
+          <a:noFill/>
+        </p:spPr>
+        <p:txBody>
+          <a:bodyPr wrap="none" rtlCol="0" anchor="ctr" lIns="0" rIns="0" tIns="0" bIns="0">
+            <a:spAutoFit/>
+          </a:bodyPr>
+          <a:lstStyle/>
+          <a:p>
+            <a:pPr marL="0" marR="0" lvl="0" indent="0" algn="ctr" defTabSz="914400" rtl="0" eaLnBrk="1" fontAlgn="auto" latinLnBrk="0" hangingPunct="1">
+              <a:lnSpc>
+                <a:spcPct val="100000"/>
+              </a:lnSpc>
+              <a:spcBef>
+                <a:spcPts val="0"/>
+              </a:spcBef>
+              <a:spcAft>
+                <a:spcPts val="0"/>
+              </a:spcAft>
+              <a:buClrTx/>
+              <a:buSzTx/>
+              <a:buFontTx/>
+              <a:buNone/>
+              <a:tabLst/>
+              <a:defRPr/>
+            </a:pPr>
+            <a:r>
+              <a:rPr kumimoji="0" lang="es-MX" sz="1800" b="1" i="0" u="none" strike="noStrike" kern="1200" cap="none" spc="0" normalizeH="0" baseline="0" noProof="0" dirty="0">
+                <a:ln>
+                  <a:noFill/>
+                </a:ln>
+                <a:solidFill>
+                  <a:srgbClr val="000000"/>
+                </a:solidFill>
+                <a:effectLst/>
+                <a:uLnTx/>
+                <a:uFillTx/>
+                <a:latin typeface="Abadi ExtraLight" panose="020B0204020104020204" pitchFamily="34" charset="0"/>
+                <a:ea typeface="+mn-ea"/>
+                <a:cs typeface="+mn-cs"/>
+              </a:rPr>
+              <a:t>{{#F115}}</a:t>
+            </a:r>
+            <a:endParaRPr kumimoji="0" lang="es-PE" sz="1800" b="1" i="0" u="none" strike="noStrike" kern="1200" cap="none" spc="0" normalizeH="0" baseline="0" noProof="0" dirty="0">
+              <a:ln>
+                <a:noFill/>
+              </a:ln>
+              <a:solidFill>
+                <a:srgbClr val="000000"/>
+              </a:solidFill>
+              <a:effectLst/>
+              <a:uLnTx/>
+              <a:uFillTx/>
+              <a:latin typeface="Abadi ExtraLight" panose="020B0204020104020204" pitchFamily="34" charset="0"/>
+              <a:ea typeface="+mn-ea"/>
+              <a:cs typeface="+mn-cs"/>
+            </a:endParaRPr>
+          </a:p>
+        </p:txBody>
+      </p:sp>
+      <p:sp>
+        <p:nvSpPr>
+          <p:cNvPr id="862" name="Rectángulo: esquinas redondeadas 34">
+            <a:extLst>
+              <a:ext uri="{FF2B5EF4-FFF2-40B4-BE49-F238E27FC236}">
+                <a16:creationId xmlns:a16="http://schemas.microsoft.com/office/drawing/2014/main" id="{2B70C59F-98ED-EC6B-75AD-D2C192A0D68A}"/>
+              </a:ext>
+            </a:extLst>
+          </p:cNvPr>
+          <p:cNvSpPr/>
+          <p:nvPr/>
+        </p:nvSpPr>
+        <p:spPr>
+          <a:xfrm>
+            <a:off x="7854696" y="1243584"/>
+            <a:ext cx="1600200" cy="941832"/>
+          </a:xfrm>
+          <a:prstGeom prst="roundRect">
+            <a:avLst/>
+          </a:prstGeom>
+          <a:noFill/>
+        </p:spPr>
+        <p:style>
+          <a:lnRef idx="2">
+            <a:schemeClr val="accent1">
+              <a:shade val="15000"/>
+            </a:schemeClr>
+          </a:lnRef>
+          <a:fillRef idx="1">
+            <a:schemeClr val="accent1"/>
+          </a:fillRef>
+          <a:effectRef idx="0">
+            <a:schemeClr val="accent1"/>
+          </a:effectRef>
+          <a:fontRef idx="minor">
+            <a:schemeClr val="lt1"/>
+          </a:fontRef>
+        </p:style>
+        <p:txBody>
+          <a:bodyPr rtlCol="0" anchor="ctr"/>
+          <a:lstStyle/>
+          <a:p>
+            <a:pPr marL="0" marR="0" lvl="0" indent="0" algn="ctr" defTabSz="914400" rtl="0" eaLnBrk="1" fontAlgn="auto" latinLnBrk="0" hangingPunct="1">
+              <a:lnSpc>
+                <a:spcPct val="100000"/>
+              </a:lnSpc>
+              <a:spcBef>
+                <a:spcPts val="0"/>
+              </a:spcBef>
+              <a:spcAft>
+                <a:spcPts val="0"/>
+              </a:spcAft>
+              <a:buClrTx/>
+              <a:buSzTx/>
+              <a:buFontTx/>
+              <a:buNone/>
+              <a:tabLst/>
+              <a:defRPr/>
+            </a:pPr>
+            <a:endParaRPr kumimoji="0" lang="es-PE" sz="1800" b="0" i="0" u="none" strike="noStrike" kern="1200" cap="none" spc="0" normalizeH="0" baseline="0" noProof="0" dirty="0">
+              <a:ln>
+                <a:noFill/>
+              </a:ln>
+              <a:solidFill>
+                <a:prstClr val="white"/>
+              </a:solidFill>
+              <a:effectLst/>
+              <a:uLnTx/>
+              <a:uFillTx/>
+              <a:latin typeface="Calibri" panose="020F0502020204030204"/>
+              <a:ea typeface="+mn-ea"/>
+              <a:cs typeface="+mn-cs"/>
+            </a:endParaRPr>
+          </a:p>
+        </p:txBody>
+      </p:sp>
+      <p:sp>
+        <p:nvSpPr>
+          <p:cNvPr id="863" name="CuadroTexto 36">
+            <a:extLst>
+              <a:ext uri="{FF2B5EF4-FFF2-40B4-BE49-F238E27FC236}">
+                <a16:creationId xmlns:a16="http://schemas.microsoft.com/office/drawing/2014/main" id="{20531A44-8D1B-BB9D-E3D9-412D741D758E}"/>
+              </a:ext>
+            </a:extLst>
+          </p:cNvPr>
+          <p:cNvSpPr txBox="1"/>
+          <p:nvPr/>
+        </p:nvSpPr>
+        <p:spPr>
+          <a:xfrm>
+            <a:off x="7891271" y="1271016"/>
+            <a:ext cx="1527048" cy="274320"/>
+          </a:xfrm>
+          <a:prstGeom prst="rect">
+            <a:avLst/>
+          </a:prstGeom>
+          <a:noFill/>
+        </p:spPr>
+        <p:txBody>
+          <a:bodyPr wrap="none" rtlCol="0" anchor="ctr" lIns="0" rIns="0" tIns="0" bIns="0">
+            <a:spAutoFit/>
+          </a:bodyPr>
+          <a:lstStyle/>
+          <a:p>
+            <a:pPr marL="0" marR="0" lvl="0" indent="0" algn="ctr" defTabSz="914400" rtl="0" eaLnBrk="1" fontAlgn="auto" latinLnBrk="0" hangingPunct="1">
+              <a:lnSpc>
+                <a:spcPct val="100000"/>
+              </a:lnSpc>
+              <a:spcBef>
+                <a:spcPts val="0"/>
+              </a:spcBef>
+              <a:spcAft>
+                <a:spcPts val="0"/>
+              </a:spcAft>
+              <a:buClrTx/>
+              <a:buSzTx/>
+              <a:buFontTx/>
+              <a:buNone/>
+              <a:tabLst/>
+              <a:defRPr/>
+            </a:pPr>
+            <a:r>
+              <a:rPr kumimoji="0" lang="es-MX" sz="1200" b="0" i="0" u="sng" strike="noStrike" kern="1200" cap="none" spc="0" normalizeH="0" baseline="0" noProof="0" dirty="0">
+                <a:ln>
+                  <a:noFill/>
+                </a:ln>
+                <a:solidFill>
+                  <a:srgbClr val="000000"/>
+                </a:solidFill>
+                <a:effectLst/>
+                <a:uLnTx/>
+                <a:uFillTx/>
+                <a:latin typeface="Abadi ExtraLight" panose="020B0204020104020204" pitchFamily="34" charset="0"/>
+                <a:ea typeface="+mn-ea"/>
+                <a:cs typeface="+mn-cs"/>
+              </a:rPr>
+              <a:t>{{#F116}}</a:t>
+            </a:r>
+            <a:endParaRPr kumimoji="0" lang="es-PE" sz="1400" b="1" i="0" u="sng" strike="noStrike" kern="1200" cap="none" spc="0" normalizeH="0" baseline="0" noProof="0" dirty="0">
+              <a:ln>
+                <a:noFill/>
+              </a:ln>
+              <a:solidFill>
+                <a:srgbClr val="000000"/>
+              </a:solidFill>
+              <a:effectLst/>
+              <a:uLnTx/>
+              <a:uFillTx/>
+              <a:latin typeface="Abadi ExtraLight" panose="020B0204020104020204" pitchFamily="34" charset="0"/>
+              <a:ea typeface="+mn-ea"/>
+              <a:cs typeface="+mn-cs"/>
+            </a:endParaRPr>
+          </a:p>
+        </p:txBody>
+      </p:sp>
+      <p:sp>
+        <p:nvSpPr>
+          <p:cNvPr id="864" name="CuadroTexto 38">
+            <a:extLst>
+              <a:ext uri="{FF2B5EF4-FFF2-40B4-BE49-F238E27FC236}">
+                <a16:creationId xmlns:a16="http://schemas.microsoft.com/office/drawing/2014/main" id="{80D58F99-4594-0797-3844-6E9001ECE2CE}"/>
+              </a:ext>
+            </a:extLst>
+          </p:cNvPr>
+          <p:cNvSpPr txBox="1"/>
+          <p:nvPr/>
+        </p:nvSpPr>
+        <p:spPr>
+          <a:xfrm>
+            <a:off x="7891271" y="1545336"/>
+            <a:ext cx="1527048" cy="347472"/>
+          </a:xfrm>
+          <a:prstGeom prst="rect">
+            <a:avLst/>
+          </a:prstGeom>
+          <a:noFill/>
+        </p:spPr>
+        <p:txBody>
+          <a:bodyPr wrap="none" rtlCol="0" anchor="ctr" lIns="0" rIns="0" tIns="0" bIns="0">
+            <a:spAutoFit/>
+          </a:bodyPr>
+          <a:lstStyle/>
+          <a:p>
+            <a:pPr marL="0" marR="0" lvl="0" indent="0" algn="ctr" defTabSz="914400" rtl="0" eaLnBrk="1" fontAlgn="auto" latinLnBrk="0" hangingPunct="1">
+              <a:lnSpc>
+                <a:spcPct val="100000"/>
+              </a:lnSpc>
+              <a:spcBef>
+                <a:spcPts val="0"/>
+              </a:spcBef>
+              <a:spcAft>
+                <a:spcPts val="0"/>
+              </a:spcAft>
+              <a:buClrTx/>
+              <a:buSzTx/>
+              <a:buFontTx/>
+              <a:buNone/>
+              <a:tabLst/>
+              <a:defRPr/>
+            </a:pPr>
+            <a:r>
+              <a:rPr lang="es-MX" sz="2400" dirty="0">
+                <a:solidFill>
+                  <a:srgbClr val="48BC65"/>
+                </a:solidFill>
+                <a:latin typeface="Century Gothic" panose="020B0502020202020204" pitchFamily="34" charset="0"/>
+              </a:rPr>
+              <a:t>{{#F117}}</a:t>
+            </a:r>
+            <a:endParaRPr kumimoji="0" lang="es-PE" sz="3200" i="0" u="none" strike="noStrike" kern="1200" cap="none" spc="0" normalizeH="0" baseline="0" noProof="0" dirty="0">
+              <a:ln>
+                <a:noFill/>
+              </a:ln>
+              <a:solidFill>
+                <a:srgbClr val="48BC65"/>
+              </a:solidFill>
+              <a:effectLst/>
+              <a:uLnTx/>
+              <a:uFillTx/>
+              <a:latin typeface="Century Gothic" panose="020B0502020202020204" pitchFamily="34" charset="0"/>
+              <a:ea typeface="+mn-ea"/>
+              <a:cs typeface="+mn-cs"/>
+            </a:endParaRPr>
+          </a:p>
+        </p:txBody>
+      </p:sp>
+      <p:sp>
+        <p:nvSpPr>
+          <p:cNvPr id="865" name="CuadroTexto 40">
+            <a:extLst>
+              <a:ext uri="{FF2B5EF4-FFF2-40B4-BE49-F238E27FC236}">
+                <a16:creationId xmlns:a16="http://schemas.microsoft.com/office/drawing/2014/main" id="{161EC9D4-1CC8-E356-0CC9-ECA014823FD8}"/>
+              </a:ext>
+            </a:extLst>
+          </p:cNvPr>
+          <p:cNvSpPr txBox="1"/>
+          <p:nvPr/>
+        </p:nvSpPr>
+        <p:spPr>
+          <a:xfrm>
+            <a:off x="7891271" y="1865376"/>
+            <a:ext cx="1527048" cy="292608"/>
+          </a:xfrm>
+          <a:prstGeom prst="rect">
+            <a:avLst/>
+          </a:prstGeom>
+          <a:noFill/>
+        </p:spPr>
+        <p:txBody>
+          <a:bodyPr wrap="none" rtlCol="0" anchor="ctr" lIns="0" rIns="0" tIns="0" bIns="0">
+            <a:spAutoFit/>
+          </a:bodyPr>
+          <a:lstStyle/>
+          <a:p>
+            <a:pPr marL="0" marR="0" lvl="0" indent="0" algn="ctr" defTabSz="914400" rtl="0" eaLnBrk="1" fontAlgn="auto" latinLnBrk="0" hangingPunct="1">
+              <a:lnSpc>
+                <a:spcPct val="100000"/>
+              </a:lnSpc>
+              <a:spcBef>
+                <a:spcPts val="0"/>
+              </a:spcBef>
+              <a:spcAft>
+                <a:spcPts val="0"/>
+              </a:spcAft>
+              <a:buClrTx/>
+              <a:buSzTx/>
+              <a:buFontTx/>
+              <a:buNone/>
+              <a:tabLst/>
+              <a:defRPr/>
+            </a:pPr>
+            <a:r>
+              <a:rPr kumimoji="0" lang="es-MX" sz="1800" b="1" i="0" u="none" strike="noStrike" kern="1200" cap="none" spc="0" normalizeH="0" baseline="0" noProof="0" dirty="0">
+                <a:ln>
+                  <a:noFill/>
+                </a:ln>
+                <a:solidFill>
+                  <a:srgbClr val="000000"/>
+                </a:solidFill>
+                <a:effectLst/>
+                <a:uLnTx/>
+                <a:uFillTx/>
+                <a:latin typeface="Abadi ExtraLight" panose="020B0204020104020204" pitchFamily="34" charset="0"/>
+                <a:ea typeface="+mn-ea"/>
+                <a:cs typeface="+mn-cs"/>
+              </a:rPr>
+              <a:t>{{#F118}}</a:t>
+            </a:r>
+            <a:endParaRPr kumimoji="0" lang="es-PE" sz="1800" b="1" i="0" u="none" strike="noStrike" kern="1200" cap="none" spc="0" normalizeH="0" baseline="0" noProof="0" dirty="0">
+              <a:ln>
+                <a:noFill/>
+              </a:ln>
+              <a:solidFill>
+                <a:srgbClr val="000000"/>
+              </a:solidFill>
+              <a:effectLst/>
+              <a:uLnTx/>
+              <a:uFillTx/>
+              <a:latin typeface="Abadi ExtraLight" panose="020B0204020104020204" pitchFamily="34" charset="0"/>
+              <a:ea typeface="+mn-ea"/>
+              <a:cs typeface="+mn-cs"/>
+            </a:endParaRPr>
+          </a:p>
+        </p:txBody>
+      </p:sp>
+      <p:sp>
+        <p:nvSpPr>
+          <p:cNvPr id="866" name="Rectángulo: esquinas redondeadas 34">
+            <a:extLst>
+              <a:ext uri="{FF2B5EF4-FFF2-40B4-BE49-F238E27FC236}">
+                <a16:creationId xmlns:a16="http://schemas.microsoft.com/office/drawing/2014/main" id="{2B70C59F-98ED-EC6B-75AD-D2C192A0D68A}"/>
+              </a:ext>
+            </a:extLst>
+          </p:cNvPr>
+          <p:cNvSpPr/>
+          <p:nvPr/>
+        </p:nvSpPr>
+        <p:spPr>
+          <a:xfrm>
+            <a:off x="2697480" y="2276856"/>
+            <a:ext cx="1600200" cy="941832"/>
+          </a:xfrm>
+          <a:prstGeom prst="roundRect">
+            <a:avLst/>
+          </a:prstGeom>
+          <a:noFill/>
+        </p:spPr>
+        <p:style>
+          <a:lnRef idx="2">
+            <a:schemeClr val="accent1">
+              <a:shade val="15000"/>
+            </a:schemeClr>
+          </a:lnRef>
+          <a:fillRef idx="1">
+            <a:schemeClr val="accent1"/>
+          </a:fillRef>
+          <a:effectRef idx="0">
+            <a:schemeClr val="accent1"/>
+          </a:effectRef>
+          <a:fontRef idx="minor">
+            <a:schemeClr val="lt1"/>
+          </a:fontRef>
+        </p:style>
+        <p:txBody>
+          <a:bodyPr rtlCol="0" anchor="ctr"/>
+          <a:lstStyle/>
+          <a:p>
+            <a:pPr marL="0" marR="0" lvl="0" indent="0" algn="ctr" defTabSz="914400" rtl="0" eaLnBrk="1" fontAlgn="auto" latinLnBrk="0" hangingPunct="1">
+              <a:lnSpc>
+                <a:spcPct val="100000"/>
+              </a:lnSpc>
+              <a:spcBef>
+                <a:spcPts val="0"/>
+              </a:spcBef>
+              <a:spcAft>
+                <a:spcPts val="0"/>
+              </a:spcAft>
+              <a:buClrTx/>
+              <a:buSzTx/>
+              <a:buFontTx/>
+              <a:buNone/>
+              <a:tabLst/>
+              <a:defRPr/>
+            </a:pPr>
+            <a:endParaRPr kumimoji="0" lang="es-PE" sz="1800" b="0" i="0" u="none" strike="noStrike" kern="1200" cap="none" spc="0" normalizeH="0" baseline="0" noProof="0" dirty="0">
+              <a:ln>
+                <a:noFill/>
+              </a:ln>
+              <a:solidFill>
+                <a:prstClr val="white"/>
+              </a:solidFill>
+              <a:effectLst/>
+              <a:uLnTx/>
+              <a:uFillTx/>
+              <a:latin typeface="Calibri" panose="020F0502020204030204"/>
+              <a:ea typeface="+mn-ea"/>
+              <a:cs typeface="+mn-cs"/>
+            </a:endParaRPr>
+          </a:p>
+        </p:txBody>
+      </p:sp>
+      <p:sp>
+        <p:nvSpPr>
+          <p:cNvPr id="867" name="CuadroTexto 36">
+            <a:extLst>
+              <a:ext uri="{FF2B5EF4-FFF2-40B4-BE49-F238E27FC236}">
+                <a16:creationId xmlns:a16="http://schemas.microsoft.com/office/drawing/2014/main" id="{20531A44-8D1B-BB9D-E3D9-412D741D758E}"/>
+              </a:ext>
+            </a:extLst>
+          </p:cNvPr>
+          <p:cNvSpPr txBox="1"/>
+          <p:nvPr/>
+        </p:nvSpPr>
+        <p:spPr>
+          <a:xfrm>
+            <a:off x="2734056" y="2304288"/>
+            <a:ext cx="1527048" cy="274320"/>
+          </a:xfrm>
+          <a:prstGeom prst="rect">
+            <a:avLst/>
+          </a:prstGeom>
+          <a:noFill/>
+        </p:spPr>
+        <p:txBody>
+          <a:bodyPr wrap="none" rtlCol="0" anchor="ctr" lIns="0" rIns="0" tIns="0" bIns="0">
+            <a:spAutoFit/>
+          </a:bodyPr>
+          <a:lstStyle/>
+          <a:p>
+            <a:pPr marL="0" marR="0" lvl="0" indent="0" algn="ctr" defTabSz="914400" rtl="0" eaLnBrk="1" fontAlgn="auto" latinLnBrk="0" hangingPunct="1">
+              <a:lnSpc>
+                <a:spcPct val="100000"/>
+              </a:lnSpc>
+              <a:spcBef>
+                <a:spcPts val="0"/>
+              </a:spcBef>
+              <a:spcAft>
+                <a:spcPts val="0"/>
+              </a:spcAft>
+              <a:buClrTx/>
+              <a:buSzTx/>
+              <a:buFontTx/>
+              <a:buNone/>
+              <a:tabLst/>
+              <a:defRPr/>
+            </a:pPr>
+            <a:r>
+              <a:rPr kumimoji="0" lang="es-MX" sz="1200" b="0" i="0" u="sng" strike="noStrike" kern="1200" cap="none" spc="0" normalizeH="0" baseline="0" noProof="0" dirty="0">
+                <a:ln>
+                  <a:noFill/>
+                </a:ln>
+                <a:solidFill>
+                  <a:srgbClr val="000000"/>
+                </a:solidFill>
+                <a:effectLst/>
+                <a:uLnTx/>
+                <a:uFillTx/>
+                <a:latin typeface="Abadi ExtraLight" panose="020B0204020104020204" pitchFamily="34" charset="0"/>
+                <a:ea typeface="+mn-ea"/>
+                <a:cs typeface="+mn-cs"/>
+              </a:rPr>
+              <a:t>{{#F119}}</a:t>
+            </a:r>
+            <a:endParaRPr kumimoji="0" lang="es-PE" sz="1400" b="1" i="0" u="sng" strike="noStrike" kern="1200" cap="none" spc="0" normalizeH="0" baseline="0" noProof="0" dirty="0">
+              <a:ln>
+                <a:noFill/>
+              </a:ln>
+              <a:solidFill>
+                <a:srgbClr val="000000"/>
+              </a:solidFill>
+              <a:effectLst/>
+              <a:uLnTx/>
+              <a:uFillTx/>
+              <a:latin typeface="Abadi ExtraLight" panose="020B0204020104020204" pitchFamily="34" charset="0"/>
+              <a:ea typeface="+mn-ea"/>
+              <a:cs typeface="+mn-cs"/>
+            </a:endParaRPr>
+          </a:p>
+        </p:txBody>
+      </p:sp>
+      <p:sp>
+        <p:nvSpPr>
+          <p:cNvPr id="868" name="CuadroTexto 38">
+            <a:extLst>
+              <a:ext uri="{FF2B5EF4-FFF2-40B4-BE49-F238E27FC236}">
+                <a16:creationId xmlns:a16="http://schemas.microsoft.com/office/drawing/2014/main" id="{80D58F99-4594-0797-3844-6E9001ECE2CE}"/>
+              </a:ext>
+            </a:extLst>
+          </p:cNvPr>
+          <p:cNvSpPr txBox="1"/>
+          <p:nvPr/>
+        </p:nvSpPr>
+        <p:spPr>
+          <a:xfrm>
+            <a:off x="2734056" y="2578608"/>
+            <a:ext cx="1527048" cy="347472"/>
+          </a:xfrm>
+          <a:prstGeom prst="rect">
+            <a:avLst/>
+          </a:prstGeom>
+          <a:noFill/>
+        </p:spPr>
+        <p:txBody>
+          <a:bodyPr wrap="none" rtlCol="0" anchor="ctr" lIns="0" rIns="0" tIns="0" bIns="0">
+            <a:spAutoFit/>
+          </a:bodyPr>
+          <a:lstStyle/>
+          <a:p>
+            <a:pPr marL="0" marR="0" lvl="0" indent="0" algn="ctr" defTabSz="914400" rtl="0" eaLnBrk="1" fontAlgn="auto" latinLnBrk="0" hangingPunct="1">
+              <a:lnSpc>
+                <a:spcPct val="100000"/>
+              </a:lnSpc>
+              <a:spcBef>
+                <a:spcPts val="0"/>
+              </a:spcBef>
+              <a:spcAft>
+                <a:spcPts val="0"/>
+              </a:spcAft>
+              <a:buClrTx/>
+              <a:buSzTx/>
+              <a:buFontTx/>
+              <a:buNone/>
+              <a:tabLst/>
+              <a:defRPr/>
+            </a:pPr>
+            <a:r>
+              <a:rPr lang="es-MX" sz="2400" dirty="0">
+                <a:solidFill>
+                  <a:srgbClr val="48BC65"/>
+                </a:solidFill>
+                <a:latin typeface="Century Gothic" panose="020B0502020202020204" pitchFamily="34" charset="0"/>
+              </a:rPr>
+              <a:t>{{#F120}}</a:t>
+            </a:r>
+            <a:endParaRPr kumimoji="0" lang="es-PE" sz="3200" i="0" u="none" strike="noStrike" kern="1200" cap="none" spc="0" normalizeH="0" baseline="0" noProof="0" dirty="0">
+              <a:ln>
+                <a:noFill/>
+              </a:ln>
+              <a:solidFill>
+                <a:srgbClr val="48BC65"/>
+              </a:solidFill>
+              <a:effectLst/>
+              <a:uLnTx/>
+              <a:uFillTx/>
+              <a:latin typeface="Century Gothic" panose="020B0502020202020204" pitchFamily="34" charset="0"/>
+              <a:ea typeface="+mn-ea"/>
+              <a:cs typeface="+mn-cs"/>
+            </a:endParaRPr>
+          </a:p>
+        </p:txBody>
+      </p:sp>
+      <p:sp>
+        <p:nvSpPr>
+          <p:cNvPr id="869" name="CuadroTexto 40">
+            <a:extLst>
+              <a:ext uri="{FF2B5EF4-FFF2-40B4-BE49-F238E27FC236}">
+                <a16:creationId xmlns:a16="http://schemas.microsoft.com/office/drawing/2014/main" id="{161EC9D4-1CC8-E356-0CC9-ECA014823FD8}"/>
+              </a:ext>
+            </a:extLst>
+          </p:cNvPr>
+          <p:cNvSpPr txBox="1"/>
+          <p:nvPr/>
+        </p:nvSpPr>
+        <p:spPr>
+          <a:xfrm>
+            <a:off x="2734056" y="2898648"/>
+            <a:ext cx="1527048" cy="292608"/>
+          </a:xfrm>
+          <a:prstGeom prst="rect">
+            <a:avLst/>
+          </a:prstGeom>
+          <a:noFill/>
+        </p:spPr>
+        <p:txBody>
+          <a:bodyPr wrap="none" rtlCol="0" anchor="ctr" lIns="0" rIns="0" tIns="0" bIns="0">
+            <a:spAutoFit/>
+          </a:bodyPr>
+          <a:lstStyle/>
+          <a:p>
+            <a:pPr marL="0" marR="0" lvl="0" indent="0" algn="ctr" defTabSz="914400" rtl="0" eaLnBrk="1" fontAlgn="auto" latinLnBrk="0" hangingPunct="1">
+              <a:lnSpc>
+                <a:spcPct val="100000"/>
+              </a:lnSpc>
+              <a:spcBef>
+                <a:spcPts val="0"/>
+              </a:spcBef>
+              <a:spcAft>
+                <a:spcPts val="0"/>
+              </a:spcAft>
+              <a:buClrTx/>
+              <a:buSzTx/>
+              <a:buFontTx/>
+              <a:buNone/>
+              <a:tabLst/>
+              <a:defRPr/>
+            </a:pPr>
+            <a:r>
+              <a:rPr kumimoji="0" lang="es-MX" sz="1800" b="1" i="0" u="none" strike="noStrike" kern="1200" cap="none" spc="0" normalizeH="0" baseline="0" noProof="0" dirty="0">
+                <a:ln>
+                  <a:noFill/>
+                </a:ln>
+                <a:solidFill>
+                  <a:srgbClr val="000000"/>
+                </a:solidFill>
+                <a:effectLst/>
+                <a:uLnTx/>
+                <a:uFillTx/>
+                <a:latin typeface="Abadi ExtraLight" panose="020B0204020104020204" pitchFamily="34" charset="0"/>
+                <a:ea typeface="+mn-ea"/>
+                <a:cs typeface="+mn-cs"/>
+              </a:rPr>
+              <a:t>{{#F121}}</a:t>
+            </a:r>
+            <a:endParaRPr kumimoji="0" lang="es-PE" sz="1800" b="1" i="0" u="none" strike="noStrike" kern="1200" cap="none" spc="0" normalizeH="0" baseline="0" noProof="0" dirty="0">
+              <a:ln>
+                <a:noFill/>
+              </a:ln>
+              <a:solidFill>
+                <a:srgbClr val="000000"/>
+              </a:solidFill>
+              <a:effectLst/>
+              <a:uLnTx/>
+              <a:uFillTx/>
+              <a:latin typeface="Abadi ExtraLight" panose="020B0204020104020204" pitchFamily="34" charset="0"/>
+              <a:ea typeface="+mn-ea"/>
+              <a:cs typeface="+mn-cs"/>
+            </a:endParaRPr>
+          </a:p>
+        </p:txBody>
+      </p:sp>
+      <p:sp>
+        <p:nvSpPr>
+          <p:cNvPr id="870" name="Rectángulo: esquinas redondeadas 34">
+            <a:extLst>
+              <a:ext uri="{FF2B5EF4-FFF2-40B4-BE49-F238E27FC236}">
+                <a16:creationId xmlns:a16="http://schemas.microsoft.com/office/drawing/2014/main" id="{2B70C59F-98ED-EC6B-75AD-D2C192A0D68A}"/>
+              </a:ext>
+            </a:extLst>
+          </p:cNvPr>
+          <p:cNvSpPr/>
+          <p:nvPr/>
+        </p:nvSpPr>
+        <p:spPr>
+          <a:xfrm>
+            <a:off x="4416552" y="2276856"/>
+            <a:ext cx="1600200" cy="941832"/>
+          </a:xfrm>
+          <a:prstGeom prst="roundRect">
+            <a:avLst/>
+          </a:prstGeom>
+          <a:noFill/>
+        </p:spPr>
+        <p:style>
+          <a:lnRef idx="2">
+            <a:schemeClr val="accent1">
+              <a:shade val="15000"/>
+            </a:schemeClr>
+          </a:lnRef>
+          <a:fillRef idx="1">
+            <a:schemeClr val="accent1"/>
+          </a:fillRef>
+          <a:effectRef idx="0">
+            <a:schemeClr val="accent1"/>
+          </a:effectRef>
+          <a:fontRef idx="minor">
+            <a:schemeClr val="lt1"/>
+          </a:fontRef>
+        </p:style>
+        <p:txBody>
+          <a:bodyPr rtlCol="0" anchor="ctr"/>
+          <a:lstStyle/>
+          <a:p>
+            <a:pPr marL="0" marR="0" lvl="0" indent="0" algn="ctr" defTabSz="914400" rtl="0" eaLnBrk="1" fontAlgn="auto" latinLnBrk="0" hangingPunct="1">
+              <a:lnSpc>
+                <a:spcPct val="100000"/>
+              </a:lnSpc>
+              <a:spcBef>
+                <a:spcPts val="0"/>
+              </a:spcBef>
+              <a:spcAft>
+                <a:spcPts val="0"/>
+              </a:spcAft>
+              <a:buClrTx/>
+              <a:buSzTx/>
+              <a:buFontTx/>
+              <a:buNone/>
+              <a:tabLst/>
+              <a:defRPr/>
+            </a:pPr>
+            <a:endParaRPr kumimoji="0" lang="es-PE" sz="1800" b="0" i="0" u="none" strike="noStrike" kern="1200" cap="none" spc="0" normalizeH="0" baseline="0" noProof="0" dirty="0">
+              <a:ln>
+                <a:noFill/>
+              </a:ln>
+              <a:solidFill>
+                <a:prstClr val="white"/>
+              </a:solidFill>
+              <a:effectLst/>
+              <a:uLnTx/>
+              <a:uFillTx/>
+              <a:latin typeface="Calibri" panose="020F0502020204030204"/>
+              <a:ea typeface="+mn-ea"/>
+              <a:cs typeface="+mn-cs"/>
+            </a:endParaRPr>
+          </a:p>
+        </p:txBody>
+      </p:sp>
+      <p:sp>
+        <p:nvSpPr>
+          <p:cNvPr id="871" name="CuadroTexto 36">
+            <a:extLst>
+              <a:ext uri="{FF2B5EF4-FFF2-40B4-BE49-F238E27FC236}">
+                <a16:creationId xmlns:a16="http://schemas.microsoft.com/office/drawing/2014/main" id="{20531A44-8D1B-BB9D-E3D9-412D741D758E}"/>
+              </a:ext>
+            </a:extLst>
+          </p:cNvPr>
+          <p:cNvSpPr txBox="1"/>
+          <p:nvPr/>
+        </p:nvSpPr>
+        <p:spPr>
+          <a:xfrm>
+            <a:off x="4453128" y="2304288"/>
+            <a:ext cx="1527048" cy="274320"/>
+          </a:xfrm>
+          <a:prstGeom prst="rect">
+            <a:avLst/>
+          </a:prstGeom>
+          <a:noFill/>
+        </p:spPr>
+        <p:txBody>
+          <a:bodyPr wrap="none" rtlCol="0" anchor="ctr" lIns="0" rIns="0" tIns="0" bIns="0">
+            <a:spAutoFit/>
+          </a:bodyPr>
+          <a:lstStyle/>
+          <a:p>
+            <a:pPr marL="0" marR="0" lvl="0" indent="0" algn="ctr" defTabSz="914400" rtl="0" eaLnBrk="1" fontAlgn="auto" latinLnBrk="0" hangingPunct="1">
+              <a:lnSpc>
+                <a:spcPct val="100000"/>
+              </a:lnSpc>
+              <a:spcBef>
+                <a:spcPts val="0"/>
+              </a:spcBef>
+              <a:spcAft>
+                <a:spcPts val="0"/>
+              </a:spcAft>
+              <a:buClrTx/>
+              <a:buSzTx/>
+              <a:buFontTx/>
+              <a:buNone/>
+              <a:tabLst/>
+              <a:defRPr/>
+            </a:pPr>
+            <a:r>
+              <a:rPr kumimoji="0" lang="es-MX" sz="1200" b="0" i="0" u="sng" strike="noStrike" kern="1200" cap="none" spc="0" normalizeH="0" baseline="0" noProof="0" dirty="0">
+                <a:ln>
+                  <a:noFill/>
+                </a:ln>
+                <a:solidFill>
+                  <a:srgbClr val="000000"/>
+                </a:solidFill>
+                <a:effectLst/>
+                <a:uLnTx/>
+                <a:uFillTx/>
+                <a:latin typeface="Abadi ExtraLight" panose="020B0204020104020204" pitchFamily="34" charset="0"/>
+                <a:ea typeface="+mn-ea"/>
+                <a:cs typeface="+mn-cs"/>
+              </a:rPr>
+              <a:t>{{#F122}}</a:t>
+            </a:r>
+            <a:endParaRPr kumimoji="0" lang="es-PE" sz="1400" b="1" i="0" u="sng" strike="noStrike" kern="1200" cap="none" spc="0" normalizeH="0" baseline="0" noProof="0" dirty="0">
+              <a:ln>
+                <a:noFill/>
+              </a:ln>
+              <a:solidFill>
+                <a:srgbClr val="000000"/>
+              </a:solidFill>
+              <a:effectLst/>
+              <a:uLnTx/>
+              <a:uFillTx/>
+              <a:latin typeface="Abadi ExtraLight" panose="020B0204020104020204" pitchFamily="34" charset="0"/>
+              <a:ea typeface="+mn-ea"/>
+              <a:cs typeface="+mn-cs"/>
+            </a:endParaRPr>
+          </a:p>
+        </p:txBody>
+      </p:sp>
+      <p:sp>
+        <p:nvSpPr>
+          <p:cNvPr id="872" name="CuadroTexto 38">
+            <a:extLst>
+              <a:ext uri="{FF2B5EF4-FFF2-40B4-BE49-F238E27FC236}">
+                <a16:creationId xmlns:a16="http://schemas.microsoft.com/office/drawing/2014/main" id="{80D58F99-4594-0797-3844-6E9001ECE2CE}"/>
+              </a:ext>
+            </a:extLst>
+          </p:cNvPr>
+          <p:cNvSpPr txBox="1"/>
+          <p:nvPr/>
+        </p:nvSpPr>
+        <p:spPr>
+          <a:xfrm>
+            <a:off x="4453128" y="2578608"/>
+            <a:ext cx="1527048" cy="347472"/>
+          </a:xfrm>
+          <a:prstGeom prst="rect">
+            <a:avLst/>
+          </a:prstGeom>
+          <a:noFill/>
+        </p:spPr>
+        <p:txBody>
+          <a:bodyPr wrap="none" rtlCol="0" anchor="ctr" lIns="0" rIns="0" tIns="0" bIns="0">
+            <a:spAutoFit/>
+          </a:bodyPr>
+          <a:lstStyle/>
+          <a:p>
+            <a:pPr marL="0" marR="0" lvl="0" indent="0" algn="ctr" defTabSz="914400" rtl="0" eaLnBrk="1" fontAlgn="auto" latinLnBrk="0" hangingPunct="1">
+              <a:lnSpc>
+                <a:spcPct val="100000"/>
+              </a:lnSpc>
+              <a:spcBef>
+                <a:spcPts val="0"/>
+              </a:spcBef>
+              <a:spcAft>
+                <a:spcPts val="0"/>
+              </a:spcAft>
+              <a:buClrTx/>
+              <a:buSzTx/>
+              <a:buFontTx/>
+              <a:buNone/>
+              <a:tabLst/>
+              <a:defRPr/>
+            </a:pPr>
+            <a:r>
+              <a:rPr lang="es-MX" sz="2400" dirty="0">
+                <a:solidFill>
+                  <a:srgbClr val="48BC65"/>
+                </a:solidFill>
+                <a:latin typeface="Century Gothic" panose="020B0502020202020204" pitchFamily="34" charset="0"/>
+              </a:rPr>
+              <a:t>{{#F123}}</a:t>
+            </a:r>
+            <a:endParaRPr kumimoji="0" lang="es-PE" sz="3200" i="0" u="none" strike="noStrike" kern="1200" cap="none" spc="0" normalizeH="0" baseline="0" noProof="0" dirty="0">
+              <a:ln>
+                <a:noFill/>
+              </a:ln>
+              <a:solidFill>
+                <a:srgbClr val="48BC65"/>
+              </a:solidFill>
+              <a:effectLst/>
+              <a:uLnTx/>
+              <a:uFillTx/>
+              <a:latin typeface="Century Gothic" panose="020B0502020202020204" pitchFamily="34" charset="0"/>
+              <a:ea typeface="+mn-ea"/>
+              <a:cs typeface="+mn-cs"/>
+            </a:endParaRPr>
+          </a:p>
+        </p:txBody>
+      </p:sp>
+      <p:sp>
+        <p:nvSpPr>
+          <p:cNvPr id="873" name="CuadroTexto 40">
+            <a:extLst>
+              <a:ext uri="{FF2B5EF4-FFF2-40B4-BE49-F238E27FC236}">
+                <a16:creationId xmlns:a16="http://schemas.microsoft.com/office/drawing/2014/main" id="{161EC9D4-1CC8-E356-0CC9-ECA014823FD8}"/>
+              </a:ext>
+            </a:extLst>
+          </p:cNvPr>
+          <p:cNvSpPr txBox="1"/>
+          <p:nvPr/>
+        </p:nvSpPr>
+        <p:spPr>
+          <a:xfrm>
+            <a:off x="4453128" y="2898648"/>
+            <a:ext cx="1527048" cy="292608"/>
+          </a:xfrm>
+          <a:prstGeom prst="rect">
+            <a:avLst/>
+          </a:prstGeom>
+          <a:noFill/>
+        </p:spPr>
+        <p:txBody>
+          <a:bodyPr wrap="none" rtlCol="0" anchor="ctr" lIns="0" rIns="0" tIns="0" bIns="0">
+            <a:spAutoFit/>
+          </a:bodyPr>
+          <a:lstStyle/>
+          <a:p>
+            <a:pPr marL="0" marR="0" lvl="0" indent="0" algn="ctr" defTabSz="914400" rtl="0" eaLnBrk="1" fontAlgn="auto" latinLnBrk="0" hangingPunct="1">
+              <a:lnSpc>
+                <a:spcPct val="100000"/>
+              </a:lnSpc>
+              <a:spcBef>
+                <a:spcPts val="0"/>
+              </a:spcBef>
+              <a:spcAft>
+                <a:spcPts val="0"/>
+              </a:spcAft>
+              <a:buClrTx/>
+              <a:buSzTx/>
+              <a:buFontTx/>
+              <a:buNone/>
+              <a:tabLst/>
+              <a:defRPr/>
+            </a:pPr>
+            <a:r>
+              <a:rPr kumimoji="0" lang="es-MX" sz="1800" b="1" i="0" u="none" strike="noStrike" kern="1200" cap="none" spc="0" normalizeH="0" baseline="0" noProof="0" dirty="0">
+                <a:ln>
+                  <a:noFill/>
+                </a:ln>
+                <a:solidFill>
+                  <a:srgbClr val="000000"/>
+                </a:solidFill>
+                <a:effectLst/>
+                <a:uLnTx/>
+                <a:uFillTx/>
+                <a:latin typeface="Abadi ExtraLight" panose="020B0204020104020204" pitchFamily="34" charset="0"/>
+                <a:ea typeface="+mn-ea"/>
+                <a:cs typeface="+mn-cs"/>
+              </a:rPr>
+              <a:t>{{#F124}}</a:t>
+            </a:r>
+            <a:endParaRPr kumimoji="0" lang="es-PE" sz="1800" b="1" i="0" u="none" strike="noStrike" kern="1200" cap="none" spc="0" normalizeH="0" baseline="0" noProof="0" dirty="0">
+              <a:ln>
+                <a:noFill/>
+              </a:ln>
+              <a:solidFill>
+                <a:srgbClr val="000000"/>
+              </a:solidFill>
+              <a:effectLst/>
+              <a:uLnTx/>
+              <a:uFillTx/>
+              <a:latin typeface="Abadi ExtraLight" panose="020B0204020104020204" pitchFamily="34" charset="0"/>
+              <a:ea typeface="+mn-ea"/>
+              <a:cs typeface="+mn-cs"/>
+            </a:endParaRPr>
+          </a:p>
+        </p:txBody>
+      </p:sp>
+      <p:sp>
+        <p:nvSpPr>
+          <p:cNvPr id="874" name="Rectángulo: esquinas redondeadas 34">
+            <a:extLst>
+              <a:ext uri="{FF2B5EF4-FFF2-40B4-BE49-F238E27FC236}">
+                <a16:creationId xmlns:a16="http://schemas.microsoft.com/office/drawing/2014/main" id="{2B70C59F-98ED-EC6B-75AD-D2C192A0D68A}"/>
+              </a:ext>
+            </a:extLst>
+          </p:cNvPr>
+          <p:cNvSpPr/>
+          <p:nvPr/>
+        </p:nvSpPr>
+        <p:spPr>
+          <a:xfrm>
+            <a:off x="6135624" y="2276856"/>
+            <a:ext cx="1600200" cy="941832"/>
+          </a:xfrm>
+          <a:prstGeom prst="roundRect">
+            <a:avLst/>
+          </a:prstGeom>
+          <a:noFill/>
+        </p:spPr>
+        <p:style>
+          <a:lnRef idx="2">
+            <a:schemeClr val="accent1">
+              <a:shade val="15000"/>
+            </a:schemeClr>
+          </a:lnRef>
+          <a:fillRef idx="1">
+            <a:schemeClr val="accent1"/>
+          </a:fillRef>
+          <a:effectRef idx="0">
+            <a:schemeClr val="accent1"/>
+          </a:effectRef>
+          <a:fontRef idx="minor">
+            <a:schemeClr val="lt1"/>
+          </a:fontRef>
+        </p:style>
+        <p:txBody>
+          <a:bodyPr rtlCol="0" anchor="ctr"/>
+          <a:lstStyle/>
+          <a:p>
+            <a:pPr marL="0" marR="0" lvl="0" indent="0" algn="ctr" defTabSz="914400" rtl="0" eaLnBrk="1" fontAlgn="auto" latinLnBrk="0" hangingPunct="1">
+              <a:lnSpc>
+                <a:spcPct val="100000"/>
+              </a:lnSpc>
+              <a:spcBef>
+                <a:spcPts val="0"/>
+              </a:spcBef>
+              <a:spcAft>
+                <a:spcPts val="0"/>
+              </a:spcAft>
+              <a:buClrTx/>
+              <a:buSzTx/>
+              <a:buFontTx/>
+              <a:buNone/>
+              <a:tabLst/>
+              <a:defRPr/>
+            </a:pPr>
+            <a:endParaRPr kumimoji="0" lang="es-PE" sz="1800" b="0" i="0" u="none" strike="noStrike" kern="1200" cap="none" spc="0" normalizeH="0" baseline="0" noProof="0" dirty="0">
+              <a:ln>
+                <a:noFill/>
+              </a:ln>
+              <a:solidFill>
+                <a:prstClr val="white"/>
+              </a:solidFill>
+              <a:effectLst/>
+              <a:uLnTx/>
+              <a:uFillTx/>
+              <a:latin typeface="Calibri" panose="020F0502020204030204"/>
+              <a:ea typeface="+mn-ea"/>
+              <a:cs typeface="+mn-cs"/>
+            </a:endParaRPr>
+          </a:p>
+        </p:txBody>
+      </p:sp>
+      <p:sp>
+        <p:nvSpPr>
+          <p:cNvPr id="875" name="CuadroTexto 36">
+            <a:extLst>
+              <a:ext uri="{FF2B5EF4-FFF2-40B4-BE49-F238E27FC236}">
+                <a16:creationId xmlns:a16="http://schemas.microsoft.com/office/drawing/2014/main" id="{20531A44-8D1B-BB9D-E3D9-412D741D758E}"/>
+              </a:ext>
+            </a:extLst>
+          </p:cNvPr>
+          <p:cNvSpPr txBox="1"/>
+          <p:nvPr/>
+        </p:nvSpPr>
+        <p:spPr>
+          <a:xfrm>
+            <a:off x="6172200" y="2304288"/>
+            <a:ext cx="1527048" cy="274320"/>
+          </a:xfrm>
+          <a:prstGeom prst="rect">
+            <a:avLst/>
+          </a:prstGeom>
+          <a:noFill/>
+        </p:spPr>
+        <p:txBody>
+          <a:bodyPr wrap="none" rtlCol="0" anchor="ctr" lIns="0" rIns="0" tIns="0" bIns="0">
+            <a:spAutoFit/>
+          </a:bodyPr>
+          <a:lstStyle/>
+          <a:p>
+            <a:pPr marL="0" marR="0" lvl="0" indent="0" algn="ctr" defTabSz="914400" rtl="0" eaLnBrk="1" fontAlgn="auto" latinLnBrk="0" hangingPunct="1">
+              <a:lnSpc>
+                <a:spcPct val="100000"/>
+              </a:lnSpc>
+              <a:spcBef>
+                <a:spcPts val="0"/>
+              </a:spcBef>
+              <a:spcAft>
+                <a:spcPts val="0"/>
+              </a:spcAft>
+              <a:buClrTx/>
+              <a:buSzTx/>
+              <a:buFontTx/>
+              <a:buNone/>
+              <a:tabLst/>
+              <a:defRPr/>
+            </a:pPr>
+            <a:r>
+              <a:rPr kumimoji="0" lang="es-MX" sz="1200" b="0" i="0" u="sng" strike="noStrike" kern="1200" cap="none" spc="0" normalizeH="0" baseline="0" noProof="0" dirty="0">
+                <a:ln>
+                  <a:noFill/>
+                </a:ln>
+                <a:solidFill>
+                  <a:srgbClr val="000000"/>
+                </a:solidFill>
+                <a:effectLst/>
+                <a:uLnTx/>
+                <a:uFillTx/>
+                <a:latin typeface="Abadi ExtraLight" panose="020B0204020104020204" pitchFamily="34" charset="0"/>
+                <a:ea typeface="+mn-ea"/>
+                <a:cs typeface="+mn-cs"/>
+              </a:rPr>
+              <a:t>{{#F125}}</a:t>
+            </a:r>
+            <a:endParaRPr kumimoji="0" lang="es-PE" sz="1400" b="1" i="0" u="sng" strike="noStrike" kern="1200" cap="none" spc="0" normalizeH="0" baseline="0" noProof="0" dirty="0">
+              <a:ln>
+                <a:noFill/>
+              </a:ln>
+              <a:solidFill>
+                <a:srgbClr val="000000"/>
+              </a:solidFill>
+              <a:effectLst/>
+              <a:uLnTx/>
+              <a:uFillTx/>
+              <a:latin typeface="Abadi ExtraLight" panose="020B0204020104020204" pitchFamily="34" charset="0"/>
+              <a:ea typeface="+mn-ea"/>
+              <a:cs typeface="+mn-cs"/>
+            </a:endParaRPr>
+          </a:p>
+        </p:txBody>
+      </p:sp>
+      <p:sp>
+        <p:nvSpPr>
+          <p:cNvPr id="876" name="CuadroTexto 38">
+            <a:extLst>
+              <a:ext uri="{FF2B5EF4-FFF2-40B4-BE49-F238E27FC236}">
+                <a16:creationId xmlns:a16="http://schemas.microsoft.com/office/drawing/2014/main" id="{80D58F99-4594-0797-3844-6E9001ECE2CE}"/>
+              </a:ext>
+            </a:extLst>
+          </p:cNvPr>
+          <p:cNvSpPr txBox="1"/>
+          <p:nvPr/>
+        </p:nvSpPr>
+        <p:spPr>
+          <a:xfrm>
+            <a:off x="6172200" y="2578608"/>
+            <a:ext cx="1527048" cy="347472"/>
+          </a:xfrm>
+          <a:prstGeom prst="rect">
+            <a:avLst/>
+          </a:prstGeom>
+          <a:noFill/>
+        </p:spPr>
+        <p:txBody>
+          <a:bodyPr wrap="none" rtlCol="0" anchor="ctr" lIns="0" rIns="0" tIns="0" bIns="0">
+            <a:spAutoFit/>
+          </a:bodyPr>
+          <a:lstStyle/>
+          <a:p>
+            <a:pPr marL="0" marR="0" lvl="0" indent="0" algn="ctr" defTabSz="914400" rtl="0" eaLnBrk="1" fontAlgn="auto" latinLnBrk="0" hangingPunct="1">
+              <a:lnSpc>
+                <a:spcPct val="100000"/>
+              </a:lnSpc>
+              <a:spcBef>
+                <a:spcPts val="0"/>
+              </a:spcBef>
+              <a:spcAft>
+                <a:spcPts val="0"/>
+              </a:spcAft>
+              <a:buClrTx/>
+              <a:buSzTx/>
+              <a:buFontTx/>
+              <a:buNone/>
+              <a:tabLst/>
+              <a:defRPr/>
+            </a:pPr>
+            <a:r>
+              <a:rPr lang="es-MX" sz="2400" dirty="0">
+                <a:solidFill>
+                  <a:srgbClr val="48BC65"/>
+                </a:solidFill>
+                <a:latin typeface="Century Gothic" panose="020B0502020202020204" pitchFamily="34" charset="0"/>
+              </a:rPr>
+              <a:t>{{#F126}}</a:t>
+            </a:r>
+            <a:endParaRPr kumimoji="0" lang="es-PE" sz="3200" i="0" u="none" strike="noStrike" kern="1200" cap="none" spc="0" normalizeH="0" baseline="0" noProof="0" dirty="0">
+              <a:ln>
+                <a:noFill/>
+              </a:ln>
+              <a:solidFill>
+                <a:srgbClr val="48BC65"/>
+              </a:solidFill>
+              <a:effectLst/>
+              <a:uLnTx/>
+              <a:uFillTx/>
+              <a:latin typeface="Century Gothic" panose="020B0502020202020204" pitchFamily="34" charset="0"/>
+              <a:ea typeface="+mn-ea"/>
+              <a:cs typeface="+mn-cs"/>
+            </a:endParaRPr>
+          </a:p>
+        </p:txBody>
+      </p:sp>
+      <p:sp>
+        <p:nvSpPr>
+          <p:cNvPr id="877" name="CuadroTexto 40">
+            <a:extLst>
+              <a:ext uri="{FF2B5EF4-FFF2-40B4-BE49-F238E27FC236}">
+                <a16:creationId xmlns:a16="http://schemas.microsoft.com/office/drawing/2014/main" id="{161EC9D4-1CC8-E356-0CC9-ECA014823FD8}"/>
+              </a:ext>
+            </a:extLst>
+          </p:cNvPr>
+          <p:cNvSpPr txBox="1"/>
+          <p:nvPr/>
+        </p:nvSpPr>
+        <p:spPr>
+          <a:xfrm>
+            <a:off x="6172200" y="2898648"/>
+            <a:ext cx="1527048" cy="292608"/>
+          </a:xfrm>
+          <a:prstGeom prst="rect">
+            <a:avLst/>
+          </a:prstGeom>
+          <a:noFill/>
+        </p:spPr>
+        <p:txBody>
+          <a:bodyPr wrap="none" rtlCol="0" anchor="ctr" lIns="0" rIns="0" tIns="0" bIns="0">
+            <a:spAutoFit/>
+          </a:bodyPr>
+          <a:lstStyle/>
+          <a:p>
+            <a:pPr marL="0" marR="0" lvl="0" indent="0" algn="ctr" defTabSz="914400" rtl="0" eaLnBrk="1" fontAlgn="auto" latinLnBrk="0" hangingPunct="1">
+              <a:lnSpc>
+                <a:spcPct val="100000"/>
+              </a:lnSpc>
+              <a:spcBef>
+                <a:spcPts val="0"/>
+              </a:spcBef>
+              <a:spcAft>
+                <a:spcPts val="0"/>
+              </a:spcAft>
+              <a:buClrTx/>
+              <a:buSzTx/>
+              <a:buFontTx/>
+              <a:buNone/>
+              <a:tabLst/>
+              <a:defRPr/>
+            </a:pPr>
+            <a:r>
+              <a:rPr kumimoji="0" lang="es-MX" sz="1800" b="1" i="0" u="none" strike="noStrike" kern="1200" cap="none" spc="0" normalizeH="0" baseline="0" noProof="0" dirty="0">
+                <a:ln>
+                  <a:noFill/>
+                </a:ln>
+                <a:solidFill>
+                  <a:srgbClr val="000000"/>
+                </a:solidFill>
+                <a:effectLst/>
+                <a:uLnTx/>
+                <a:uFillTx/>
+                <a:latin typeface="Abadi ExtraLight" panose="020B0204020104020204" pitchFamily="34" charset="0"/>
+                <a:ea typeface="+mn-ea"/>
+                <a:cs typeface="+mn-cs"/>
+              </a:rPr>
+              <a:t>{{#F127}}</a:t>
+            </a:r>
+            <a:endParaRPr kumimoji="0" lang="es-PE" sz="1800" b="1" i="0" u="none" strike="noStrike" kern="1200" cap="none" spc="0" normalizeH="0" baseline="0" noProof="0" dirty="0">
+              <a:ln>
+                <a:noFill/>
+              </a:ln>
+              <a:solidFill>
+                <a:srgbClr val="000000"/>
+              </a:solidFill>
+              <a:effectLst/>
+              <a:uLnTx/>
+              <a:uFillTx/>
+              <a:latin typeface="Abadi ExtraLight" panose="020B0204020104020204" pitchFamily="34" charset="0"/>
+              <a:ea typeface="+mn-ea"/>
+              <a:cs typeface="+mn-cs"/>
+            </a:endParaRPr>
+          </a:p>
+        </p:txBody>
+      </p:sp>
+      <p:sp>
+        <p:nvSpPr>
+          <p:cNvPr id="878" name="Rectángulo: esquinas redondeadas 34">
+            <a:extLst>
+              <a:ext uri="{FF2B5EF4-FFF2-40B4-BE49-F238E27FC236}">
+                <a16:creationId xmlns:a16="http://schemas.microsoft.com/office/drawing/2014/main" id="{2B70C59F-98ED-EC6B-75AD-D2C192A0D68A}"/>
+              </a:ext>
+            </a:extLst>
+          </p:cNvPr>
+          <p:cNvSpPr/>
+          <p:nvPr/>
+        </p:nvSpPr>
+        <p:spPr>
+          <a:xfrm>
+            <a:off x="7854696" y="2276856"/>
+            <a:ext cx="1600200" cy="941832"/>
+          </a:xfrm>
+          <a:prstGeom prst="roundRect">
+            <a:avLst/>
+          </a:prstGeom>
+          <a:noFill/>
+        </p:spPr>
+        <p:style>
+          <a:lnRef idx="2">
+            <a:schemeClr val="accent1">
+              <a:shade val="15000"/>
+            </a:schemeClr>
+          </a:lnRef>
+          <a:fillRef idx="1">
+            <a:schemeClr val="accent1"/>
+          </a:fillRef>
+          <a:effectRef idx="0">
+            <a:schemeClr val="accent1"/>
+          </a:effectRef>
+          <a:fontRef idx="minor">
+            <a:schemeClr val="lt1"/>
+          </a:fontRef>
+        </p:style>
+        <p:txBody>
+          <a:bodyPr rtlCol="0" anchor="ctr"/>
+          <a:lstStyle/>
+          <a:p>
+            <a:pPr marL="0" marR="0" lvl="0" indent="0" algn="ctr" defTabSz="914400" rtl="0" eaLnBrk="1" fontAlgn="auto" latinLnBrk="0" hangingPunct="1">
+              <a:lnSpc>
+                <a:spcPct val="100000"/>
+              </a:lnSpc>
+              <a:spcBef>
+                <a:spcPts val="0"/>
+              </a:spcBef>
+              <a:spcAft>
+                <a:spcPts val="0"/>
+              </a:spcAft>
+              <a:buClrTx/>
+              <a:buSzTx/>
+              <a:buFontTx/>
+              <a:buNone/>
+              <a:tabLst/>
+              <a:defRPr/>
+            </a:pPr>
+            <a:endParaRPr kumimoji="0" lang="es-PE" sz="1800" b="0" i="0" u="none" strike="noStrike" kern="1200" cap="none" spc="0" normalizeH="0" baseline="0" noProof="0" dirty="0">
+              <a:ln>
+                <a:noFill/>
+              </a:ln>
+              <a:solidFill>
+                <a:prstClr val="white"/>
+              </a:solidFill>
+              <a:effectLst/>
+              <a:uLnTx/>
+              <a:uFillTx/>
+              <a:latin typeface="Calibri" panose="020F0502020204030204"/>
+              <a:ea typeface="+mn-ea"/>
+              <a:cs typeface="+mn-cs"/>
+            </a:endParaRPr>
+          </a:p>
+        </p:txBody>
+      </p:sp>
+      <p:sp>
+        <p:nvSpPr>
+          <p:cNvPr id="879" name="CuadroTexto 36">
+            <a:extLst>
+              <a:ext uri="{FF2B5EF4-FFF2-40B4-BE49-F238E27FC236}">
+                <a16:creationId xmlns:a16="http://schemas.microsoft.com/office/drawing/2014/main" id="{20531A44-8D1B-BB9D-E3D9-412D741D758E}"/>
+              </a:ext>
+            </a:extLst>
+          </p:cNvPr>
+          <p:cNvSpPr txBox="1"/>
+          <p:nvPr/>
+        </p:nvSpPr>
+        <p:spPr>
+          <a:xfrm>
+            <a:off x="7891271" y="2304288"/>
+            <a:ext cx="1527048" cy="274320"/>
+          </a:xfrm>
+          <a:prstGeom prst="rect">
+            <a:avLst/>
+          </a:prstGeom>
+          <a:noFill/>
+        </p:spPr>
+        <p:txBody>
+          <a:bodyPr wrap="none" rtlCol="0" anchor="ctr" lIns="0" rIns="0" tIns="0" bIns="0">
+            <a:spAutoFit/>
+          </a:bodyPr>
+          <a:lstStyle/>
+          <a:p>
+            <a:pPr marL="0" marR="0" lvl="0" indent="0" algn="ctr" defTabSz="914400" rtl="0" eaLnBrk="1" fontAlgn="auto" latinLnBrk="0" hangingPunct="1">
+              <a:lnSpc>
+                <a:spcPct val="100000"/>
+              </a:lnSpc>
+              <a:spcBef>
+                <a:spcPts val="0"/>
+              </a:spcBef>
+              <a:spcAft>
+                <a:spcPts val="0"/>
+              </a:spcAft>
+              <a:buClrTx/>
+              <a:buSzTx/>
+              <a:buFontTx/>
+              <a:buNone/>
+              <a:tabLst/>
+              <a:defRPr/>
+            </a:pPr>
+            <a:r>
+              <a:rPr kumimoji="0" lang="es-MX" sz="1200" b="0" i="0" u="sng" strike="noStrike" kern="1200" cap="none" spc="0" normalizeH="0" baseline="0" noProof="0" dirty="0">
+                <a:ln>
+                  <a:noFill/>
+                </a:ln>
+                <a:solidFill>
+                  <a:srgbClr val="000000"/>
+                </a:solidFill>
+                <a:effectLst/>
+                <a:uLnTx/>
+                <a:uFillTx/>
+                <a:latin typeface="Abadi ExtraLight" panose="020B0204020104020204" pitchFamily="34" charset="0"/>
+                <a:ea typeface="+mn-ea"/>
+                <a:cs typeface="+mn-cs"/>
+              </a:rPr>
+              <a:t>{{#F128}}</a:t>
+            </a:r>
+            <a:endParaRPr kumimoji="0" lang="es-PE" sz="1400" b="1" i="0" u="sng" strike="noStrike" kern="1200" cap="none" spc="0" normalizeH="0" baseline="0" noProof="0" dirty="0">
+              <a:ln>
+                <a:noFill/>
+              </a:ln>
+              <a:solidFill>
+                <a:srgbClr val="000000"/>
+              </a:solidFill>
+              <a:effectLst/>
+              <a:uLnTx/>
+              <a:uFillTx/>
+              <a:latin typeface="Abadi ExtraLight" panose="020B0204020104020204" pitchFamily="34" charset="0"/>
+              <a:ea typeface="+mn-ea"/>
+              <a:cs typeface="+mn-cs"/>
+            </a:endParaRPr>
+          </a:p>
+        </p:txBody>
+      </p:sp>
+      <p:sp>
+        <p:nvSpPr>
+          <p:cNvPr id="880" name="CuadroTexto 38">
+            <a:extLst>
+              <a:ext uri="{FF2B5EF4-FFF2-40B4-BE49-F238E27FC236}">
+                <a16:creationId xmlns:a16="http://schemas.microsoft.com/office/drawing/2014/main" id="{80D58F99-4594-0797-3844-6E9001ECE2CE}"/>
+              </a:ext>
+            </a:extLst>
+          </p:cNvPr>
+          <p:cNvSpPr txBox="1"/>
+          <p:nvPr/>
+        </p:nvSpPr>
+        <p:spPr>
+          <a:xfrm>
+            <a:off x="7891271" y="2578608"/>
+            <a:ext cx="1527048" cy="347472"/>
+          </a:xfrm>
+          <a:prstGeom prst="rect">
+            <a:avLst/>
+          </a:prstGeom>
+          <a:noFill/>
+        </p:spPr>
+        <p:txBody>
+          <a:bodyPr wrap="none" rtlCol="0" anchor="ctr" lIns="0" rIns="0" tIns="0" bIns="0">
+            <a:spAutoFit/>
+          </a:bodyPr>
+          <a:lstStyle/>
+          <a:p>
+            <a:pPr marL="0" marR="0" lvl="0" indent="0" algn="ctr" defTabSz="914400" rtl="0" eaLnBrk="1" fontAlgn="auto" latinLnBrk="0" hangingPunct="1">
+              <a:lnSpc>
+                <a:spcPct val="100000"/>
+              </a:lnSpc>
+              <a:spcBef>
+                <a:spcPts val="0"/>
+              </a:spcBef>
+              <a:spcAft>
+                <a:spcPts val="0"/>
+              </a:spcAft>
+              <a:buClrTx/>
+              <a:buSzTx/>
+              <a:buFontTx/>
+              <a:buNone/>
+              <a:tabLst/>
+              <a:defRPr/>
+            </a:pPr>
+            <a:r>
+              <a:rPr lang="es-MX" sz="2400" dirty="0">
+                <a:solidFill>
+                  <a:srgbClr val="48BC65"/>
+                </a:solidFill>
+                <a:latin typeface="Century Gothic" panose="020B0502020202020204" pitchFamily="34" charset="0"/>
+              </a:rPr>
+              <a:t>{{#F129}}</a:t>
+            </a:r>
+            <a:endParaRPr kumimoji="0" lang="es-PE" sz="3200" i="0" u="none" strike="noStrike" kern="1200" cap="none" spc="0" normalizeH="0" baseline="0" noProof="0" dirty="0">
+              <a:ln>
+                <a:noFill/>
+              </a:ln>
+              <a:solidFill>
+                <a:srgbClr val="48BC65"/>
+              </a:solidFill>
+              <a:effectLst/>
+              <a:uLnTx/>
+              <a:uFillTx/>
+              <a:latin typeface="Century Gothic" panose="020B0502020202020204" pitchFamily="34" charset="0"/>
+              <a:ea typeface="+mn-ea"/>
+              <a:cs typeface="+mn-cs"/>
+            </a:endParaRPr>
+          </a:p>
+        </p:txBody>
+      </p:sp>
+      <p:sp>
+        <p:nvSpPr>
+          <p:cNvPr id="881" name="CuadroTexto 40">
+            <a:extLst>
+              <a:ext uri="{FF2B5EF4-FFF2-40B4-BE49-F238E27FC236}">
+                <a16:creationId xmlns:a16="http://schemas.microsoft.com/office/drawing/2014/main" id="{161EC9D4-1CC8-E356-0CC9-ECA014823FD8}"/>
+              </a:ext>
+            </a:extLst>
+          </p:cNvPr>
+          <p:cNvSpPr txBox="1"/>
+          <p:nvPr/>
+        </p:nvSpPr>
+        <p:spPr>
+          <a:xfrm>
+            <a:off x="7891271" y="2898648"/>
+            <a:ext cx="1527048" cy="292608"/>
+          </a:xfrm>
+          <a:prstGeom prst="rect">
+            <a:avLst/>
+          </a:prstGeom>
+          <a:noFill/>
+        </p:spPr>
+        <p:txBody>
+          <a:bodyPr wrap="none" rtlCol="0" anchor="ctr" lIns="0" rIns="0" tIns="0" bIns="0">
+            <a:spAutoFit/>
+          </a:bodyPr>
+          <a:lstStyle/>
+          <a:p>
+            <a:pPr marL="0" marR="0" lvl="0" indent="0" algn="ctr" defTabSz="914400" rtl="0" eaLnBrk="1" fontAlgn="auto" latinLnBrk="0" hangingPunct="1">
+              <a:lnSpc>
+                <a:spcPct val="100000"/>
+              </a:lnSpc>
+              <a:spcBef>
+                <a:spcPts val="0"/>
+              </a:spcBef>
+              <a:spcAft>
+                <a:spcPts val="0"/>
+              </a:spcAft>
+              <a:buClrTx/>
+              <a:buSzTx/>
+              <a:buFontTx/>
+              <a:buNone/>
+              <a:tabLst/>
+              <a:defRPr/>
+            </a:pPr>
+            <a:r>
+              <a:rPr kumimoji="0" lang="es-MX" sz="1800" b="1" i="0" u="none" strike="noStrike" kern="1200" cap="none" spc="0" normalizeH="0" baseline="0" noProof="0" dirty="0">
+                <a:ln>
+                  <a:noFill/>
+                </a:ln>
+                <a:solidFill>
+                  <a:srgbClr val="000000"/>
+                </a:solidFill>
+                <a:effectLst/>
+                <a:uLnTx/>
+                <a:uFillTx/>
+                <a:latin typeface="Abadi ExtraLight" panose="020B0204020104020204" pitchFamily="34" charset="0"/>
+                <a:ea typeface="+mn-ea"/>
+                <a:cs typeface="+mn-cs"/>
+              </a:rPr>
+              <a:t>{{#F130}}</a:t>
+            </a:r>
+            <a:endParaRPr kumimoji="0" lang="es-PE" sz="1800" b="1" i="0" u="none" strike="noStrike" kern="1200" cap="none" spc="0" normalizeH="0" baseline="0" noProof="0" dirty="0">
               <a:ln>
                 <a:noFill/>
               </a:ln>
@@ -27706,7 +29478,7 @@
                 <a:cs typeface="Candara"/>
                 <a:sym typeface="Candara"/>
               </a:rPr>
-              <a:t>{{#F125}}</a:t>
+              <a:t>{{#F143}}</a:t>
             </a:r>
             <a:endParaRPr kumimoji="0" lang="en-US" sz="1800" b="0" i="0" u="none" strike="noStrike" kern="0" cap="none" spc="0" normalizeH="0" baseline="0" noProof="0" dirty="0">
               <a:ln>
@@ -27920,7 +29692,7 @@
                     <a:ea typeface="+mn-ea"/>
                     <a:cs typeface="Aparajita" panose="020B0502040204020203" pitchFamily="18" charset="0"/>
                   </a:rPr>
-                  <a:t>{{#F126}}</a:t>
+                  <a:t>{{#F144}}</a:t>
                 </a:r>
               </a:p>
             </p:txBody>
@@ -28122,7 +29894,7 @@
                       <a:ea typeface="+mn-ea"/>
                       <a:cs typeface="+mn-cs"/>
                     </a:rPr>
-                    <a:t>{{#F113}}</a:t>
+                    <a:t>{{#F131}}</a:t>
                   </a:r>
                 </a:p>
               </p:txBody>
@@ -28187,7 +29959,7 @@
                       <a:ea typeface="+mn-ea"/>
                       <a:cs typeface="+mn-cs"/>
                     </a:rPr>
-                    <a:t>{{#F122}}</a:t>
+                    <a:t>{{#F140}}</a:t>
                   </a:r>
                 </a:p>
               </p:txBody>
@@ -28252,7 +30024,7 @@
                       <a:ea typeface="+mn-ea"/>
                       <a:cs typeface="+mn-cs"/>
                     </a:rPr>
-                    <a:t>{{#F114}}</a:t>
+                    <a:t>{{#F132}}</a:t>
                   </a:r>
                 </a:p>
               </p:txBody>
@@ -28394,7 +30166,7 @@
                     <a:ea typeface="+mn-ea"/>
                     <a:cs typeface="+mn-cs"/>
                   </a:rPr>
-                  <a:t>{{#F127}}</a:t>
+                  <a:t>{{#F145}}</a:t>
                 </a:r>
               </a:p>
             </p:txBody>
@@ -28500,7 +30272,7 @@
                       <a:ea typeface="+mn-ea"/>
                       <a:cs typeface="+mn-cs"/>
                     </a:rPr>
-                    <a:t>{{#F123}}</a:t>
+                    <a:t>{{#F141}}</a:t>
                   </a:r>
                 </a:p>
               </p:txBody>
@@ -28565,7 +30337,7 @@
                       <a:ea typeface="+mn-ea"/>
                       <a:cs typeface="+mn-cs"/>
                     </a:rPr>
-                    <a:t>{{#F115}}</a:t>
+                    <a:t>{{#F133}}</a:t>
                   </a:r>
                 </a:p>
               </p:txBody>
@@ -28715,7 +30487,7 @@
                     <a:ea typeface="+mn-ea"/>
                     <a:cs typeface="+mn-cs"/>
                   </a:rPr>
-                  <a:t>{{#F128}}</a:t>
+                  <a:t>{{#F146}}</a:t>
                 </a:r>
                 <a:endParaRPr kumimoji="0" lang="es-PE" sz="1600" b="0" i="0" u="sng" strike="noStrike" kern="1200" cap="none" spc="0" normalizeH="0" baseline="0" noProof="0" dirty="0">
                   <a:ln>
@@ -28800,7 +30572,7 @@
                   <a:ea typeface="+mn-ea"/>
                   <a:cs typeface="+mn-cs"/>
                 </a:rPr>
-                <a:t>{{#F129}}</a:t>
+                <a:t>{{#F147}}</a:t>
               </a:r>
               <a:endParaRPr kumimoji="0" lang="es-PE" sz="1800" b="1" i="0" u="none" strike="noStrike" kern="1200" cap="none" spc="0" normalizeH="0" baseline="0" noProof="0" dirty="0">
                 <a:ln>
@@ -28891,7 +30663,7 @@
                   <a:ea typeface="+mn-ea"/>
                   <a:cs typeface="+mn-cs"/>
                 </a:rPr>
-                <a:t>{{#F116}}</a:t>
+                <a:t>{{#F134}}</a:t>
               </a:r>
             </a:p>
           </p:txBody>
@@ -28968,7 +30740,7 @@
                   <a:ea typeface="+mn-ea"/>
                   <a:cs typeface="+mn-cs"/>
                 </a:rPr>
-                <a:t>{{#F117}}</a:t>
+                <a:t>{{#F135}}</a:t>
               </a:r>
               <a:endParaRPr kumimoji="0" lang="es-PE" sz="3600" b="0" i="0" u="none" strike="noStrike" kern="1200" cap="none" spc="0" normalizeH="0" baseline="0" noProof="0" dirty="0">
                 <a:ln>
@@ -29047,7 +30819,7 @@
                   <a:ea typeface="+mn-ea"/>
                   <a:cs typeface="+mn-cs"/>
                 </a:rPr>
-                <a:t>{{#F130}}</a:t>
+                <a:t>{{#F148}}</a:t>
               </a:r>
               <a:endParaRPr kumimoji="0" lang="es-PE" sz="1600" b="0" i="0" u="sng" strike="noStrike" kern="1200" cap="none" spc="0" normalizeH="0" baseline="0" noProof="0" dirty="0">
                 <a:ln>
@@ -29126,7 +30898,7 @@
                   <a:ea typeface="+mn-ea"/>
                   <a:cs typeface="Aparajita" panose="020B0502040204020203" pitchFamily="18" charset="0"/>
                 </a:rPr>
-                <a:t>{{#F131}}</a:t>
+                <a:t>{{#F149}}</a:t>
               </a:r>
               <a:endParaRPr kumimoji="0" lang="es-PE" sz="1400" b="1" i="0" u="sng" strike="noStrike" kern="1200" cap="none" spc="0" normalizeH="0" baseline="0" noProof="0" dirty="0">
                 <a:ln>
@@ -29382,7 +31154,7 @@
                         <a:ea typeface="+mn-ea"/>
                         <a:cs typeface="+mn-cs"/>
                       </a:rPr>
-                      <a:t>{{#F118}}</a:t>
+                      <a:t>{{#F136}}</a:t>
                     </a:r>
                   </a:p>
                 </p:txBody>
@@ -29447,7 +31219,7 @@
                         <a:ea typeface="+mn-ea"/>
                         <a:cs typeface="+mn-cs"/>
                       </a:rPr>
-                      <a:t>{{#F124}}</a:t>
+                      <a:t>{{#F142}}</a:t>
                     </a:r>
                   </a:p>
                 </p:txBody>
@@ -29512,7 +31284,7 @@
                         <a:ea typeface="+mn-ea"/>
                         <a:cs typeface="+mn-cs"/>
                       </a:rPr>
-                      <a:t>{{#F119}}</a:t>
+                      <a:t>{{#F137}}</a:t>
                     </a:r>
                   </a:p>
                 </p:txBody>
@@ -29646,7 +31418,7 @@
                       </a:solidFill>
                       <a:latin typeface="Abadi ExtraLight" panose="020B0204020104020204" pitchFamily="34" charset="0"/>
                     </a:rPr>
-                    <a:t>{{#F132}}</a:t>
+                    <a:t>{{#F150}}</a:t>
                   </a:r>
                 </a:p>
               </p:txBody>
@@ -29816,7 +31588,7 @@
                       <a:ea typeface="+mn-ea"/>
                       <a:cs typeface="+mn-cs"/>
                     </a:rPr>
-                    <a:t>{{#F133}}</a:t>
+                    <a:t>{{#F151}}</a:t>
                   </a:r>
                   <a:endParaRPr kumimoji="0" lang="es-PE" sz="1600" b="0" i="0" u="sng" strike="noStrike" kern="1200" cap="none" spc="0" normalizeH="0" baseline="0" noProof="0" dirty="0">
                     <a:ln>
@@ -29901,7 +31673,7 @@
                     <a:ea typeface="+mn-ea"/>
                     <a:cs typeface="+mn-cs"/>
                   </a:rPr>
-                  <a:t>{{#F134}}</a:t>
+                  <a:t>{{#F152}}</a:t>
                 </a:r>
                 <a:endParaRPr kumimoji="0" lang="es-PE" sz="1800" b="1" i="0" u="none" strike="noStrike" kern="1200" cap="none" spc="0" normalizeH="0" baseline="0" noProof="0" dirty="0">
                   <a:ln>
@@ -29983,7 +31755,7 @@
                       <a:srgbClr val="FF0000"/>
                     </a:solidFill>
                   </a:rPr>
-                  <a:t>{{#F120}}</a:t>
+                  <a:t>{{#F138}}</a:t>
                 </a:r>
               </a:p>
             </p:txBody>
@@ -30047,7 +31819,7 @@
                 </a:pPr>
                 <a:r>
                   <a:rPr lang="es-PE" sz="3200" dirty="0"/>
-                  <a:t>{{#F121}}</a:t>
+                  <a:t>{{#F139}}</a:t>
                 </a:r>
               </a:p>
             </p:txBody>
@@ -30112,7 +31884,7 @@
                     <a:ea typeface="+mn-ea"/>
                     <a:cs typeface="+mn-cs"/>
                   </a:rPr>
-                  <a:t>{{#F135}}</a:t>
+                  <a:t>{{#F153}}</a:t>
                 </a:r>
               </a:p>
             </p:txBody>
@@ -30177,7 +31949,7 @@
                     <a:ea typeface="+mn-ea"/>
                     <a:cs typeface="+mn-cs"/>
                   </a:rPr>
-                  <a:t>{{#F136}}</a:t>
+                  <a:t>{{#F154}}</a:t>
                 </a:r>
                 <a:endParaRPr kumimoji="0" lang="es-PE" sz="1600" b="0" i="0" u="sng" strike="noStrike" kern="1200" cap="none" spc="0" normalizeH="0" baseline="0" noProof="0" dirty="0">
                   <a:ln>
@@ -30257,7 +32029,7 @@
                   <a:ea typeface="+mn-ea"/>
                   <a:cs typeface="+mn-cs"/>
                 </a:rPr>
-                <a:t>{{#F137}}</a:t>
+                <a:t>{{#F155}}</a:t>
               </a:r>
             </a:p>
           </p:txBody>
@@ -30298,7 +32070,7 @@
                 </a:solidFill>
                 <a:latin typeface="Arial"/>
               </a:rPr>
-              <a:t>{{#F138}}</a:t>
+              <a:t>{{#F156}}</a:t>
             </a:r>
             <a:endParaRPr lang="es-PE" sz="1400" dirty="0">
               <a:solidFill>
@@ -30343,7 +32115,7 @@
                 </a:solidFill>
                 <a:latin typeface="Arial"/>
               </a:rPr>
-              <a:t>{{#F139}}</a:t>
+              <a:t>{{#F157}}</a:t>
             </a:r>
             <a:endParaRPr lang="es-PE" sz="1400" dirty="0">
               <a:solidFill>
@@ -30873,7 +32645,7 @@
                   <a:srgbClr val="080808"/>
                 </a:solidFill>
               </a:rPr>
-              <a:t>{{#F140}}</a:t>
+              <a:t>{{#F158}}</a:t>
             </a:r>
             <a:endParaRPr lang="es-PE" sz="3600" b="1" dirty="0">
               <a:solidFill>
@@ -30919,7 +32691,7 @@
                   <a:srgbClr val="080808"/>
                 </a:solidFill>
               </a:rPr>
-              <a:t>{{#F141}}</a:t>
+              <a:t>{{#F159}}</a:t>
             </a:r>
             <a:endParaRPr lang="es-PE" sz="2000" dirty="0">
               <a:solidFill>
@@ -31671,7 +33443,7 @@
                 <a:cs typeface="Candara"/>
                 <a:sym typeface="Candara"/>
               </a:rPr>
-              <a:t>{{#F146}}</a:t>
+              <a:t>{{#F164}}</a:t>
             </a:r>
             <a:endParaRPr lang="en-US" kern="0" dirty="0">
               <a:solidFill>
@@ -31855,7 +33627,7 @@
                 <a:ea typeface="ADLaM Display" panose="02010000000000000000" pitchFamily="2" charset="0"/>
                 <a:cs typeface="ADLaM Display" panose="02010000000000000000" pitchFamily="2" charset="0"/>
               </a:rPr>
-              <a:t>{{#F144}}</a:t>
+              <a:t>{{#F162}}</a:t>
             </a:r>
             <a:endParaRPr lang="es-PE" sz="2400" dirty="0">
               <a:solidFill>
@@ -31908,7 +33680,7 @@
                 <a:ea typeface="ADLaM Display" panose="02010000000000000000" pitchFamily="2" charset="0"/>
                 <a:cs typeface="ADLaM Display" panose="02010000000000000000" pitchFamily="2" charset="0"/>
               </a:rPr>
-              <a:t>{{#F145}}</a:t>
+              <a:t>{{#F163}}</a:t>
             </a:r>
             <a:endParaRPr lang="es-PE" sz="2400" dirty="0">
               <a:solidFill>
@@ -32065,7 +33837,7 @@
                   <a:latin typeface="Arial" panose="020B0604020202020204" pitchFamily="34" charset="0"/>
                   <a:cs typeface="Arial" panose="020B0604020202020204" pitchFamily="34" charset="0"/>
                 </a:rPr>
-                <a:t>{{#F142}}</a:t>
+                <a:t>{{#F160}}</a:t>
               </a:r>
               <a:endParaRPr lang="es-PE" sz="1600" b="1" dirty="0">
                 <a:solidFill>
@@ -32116,7 +33888,7 @@
                     </a:schemeClr>
                   </a:solidFill>
                 </a:rPr>
-                <a:t>{{#F147}}</a:t>
+                <a:t>{{#F165}}</a:t>
               </a:r>
               <a:endParaRPr lang="es-PE" dirty="0">
                 <a:solidFill>
@@ -32273,7 +34045,7 @@
                   <a:latin typeface="Arial" panose="020B0604020202020204" pitchFamily="34" charset="0"/>
                   <a:cs typeface="Arial" panose="020B0604020202020204" pitchFamily="34" charset="0"/>
                 </a:rPr>
-                <a:t>{{#F143}}</a:t>
+                <a:t>{{#F161}}</a:t>
               </a:r>
               <a:endParaRPr lang="es-PE" sz="1600" b="1" dirty="0">
                 <a:solidFill>
@@ -32324,7 +34096,7 @@
                     </a:schemeClr>
                   </a:solidFill>
                 </a:rPr>
-                <a:t>{{#F148}}</a:t>
+                <a:t>{{#F166}}</a:t>
               </a:r>
               <a:endParaRPr lang="es-PE" dirty="0">
                 <a:solidFill>
@@ -32502,7 +34274,7 @@
                             <a:srgbClr val="262626"/>
                           </a:solidFill>
                         </a:rPr>
-                        <a:t>{{#F149}}</a:t>
+                        <a:t>{{#F167}}</a:t>
                       </a:r>
                       <a:endParaRPr lang="es-PE" sz="1000"/>
                     </a:p>
@@ -32543,7 +34315,7 @@
                             <a:srgbClr val="262626"/>
                           </a:solidFill>
                         </a:rPr>
-                        <a:t>{{#F150}}</a:t>
+                        <a:t>{{#F168}}</a:t>
                       </a:r>
                       <a:endParaRPr lang="es-PE" sz="1000"/>
                     </a:p>
@@ -32584,7 +34356,7 @@
                             <a:srgbClr val="262626"/>
                           </a:solidFill>
                         </a:rPr>
-                        <a:t>{{#F151}}</a:t>
+                        <a:t>{{#F169}}</a:t>
                       </a:r>
                       <a:endParaRPr lang="es-PE" sz="1000"/>
                     </a:p>
@@ -32627,7 +34399,7 @@
                             <a:srgbClr val="262626"/>
                           </a:solidFill>
                         </a:rPr>
-                        <a:t>{{#F152}}</a:t>
+                        <a:t>{{#F170}}</a:t>
                       </a:r>
                       <a:endParaRPr lang="es-PE" sz="1000"/>
                     </a:p>
@@ -32668,7 +34440,7 @@
                             <a:srgbClr val="262626"/>
                           </a:solidFill>
                         </a:rPr>
-                        <a:t>{{#F153}}</a:t>
+                        <a:t>{{#F171}}</a:t>
                       </a:r>
                       <a:endParaRPr lang="es-PE" sz="1000"/>
                     </a:p>
@@ -32709,7 +34481,7 @@
                             <a:srgbClr val="262626"/>
                           </a:solidFill>
                         </a:rPr>
-                        <a:t>{{#F154}}</a:t>
+                        <a:t>{{#F172}}</a:t>
                       </a:r>
                       <a:endParaRPr lang="es-PE" sz="1000"/>
                     </a:p>
@@ -32752,7 +34524,7 @@
                             <a:srgbClr val="262626"/>
                           </a:solidFill>
                         </a:rPr>
-                        <a:t>{{#F155}}</a:t>
+                        <a:t>{{#F173}}</a:t>
                       </a:r>
                       <a:endParaRPr lang="es-PE" sz="1000"/>
                     </a:p>
@@ -32793,7 +34565,7 @@
                             <a:srgbClr val="262626"/>
                           </a:solidFill>
                         </a:rPr>
-                        <a:t>{{#F156}}</a:t>
+                        <a:t>{{#F174}}</a:t>
                       </a:r>
                       <a:endParaRPr lang="es-PE" sz="1000"/>
                     </a:p>
@@ -32834,7 +34606,7 @@
                             <a:srgbClr val="262626"/>
                           </a:solidFill>
                         </a:rPr>
-                        <a:t>{{#F157}}</a:t>
+                        <a:t>{{#F175}}</a:t>
                       </a:r>
                       <a:endParaRPr lang="es-PE" sz="1000"/>
                     </a:p>
@@ -32877,7 +34649,7 @@
                             <a:srgbClr val="262626"/>
                           </a:solidFill>
                         </a:rPr>
-                        <a:t>{{#F158}}</a:t>
+                        <a:t>{{#F176}}</a:t>
                       </a:r>
                       <a:endParaRPr lang="es-PE" sz="1000"/>
                     </a:p>
@@ -32918,7 +34690,7 @@
                             <a:srgbClr val="262626"/>
                           </a:solidFill>
                         </a:rPr>
-                        <a:t>{{#F159}}</a:t>
+                        <a:t>{{#F177}}</a:t>
                       </a:r>
                       <a:endParaRPr lang="es-PE" sz="1000"/>
                     </a:p>
@@ -32959,7 +34731,7 @@
                             <a:srgbClr val="262626"/>
                           </a:solidFill>
                         </a:rPr>
-                        <a:t>{{#F160}}</a:t>
+                        <a:t>{{#F178}}</a:t>
                       </a:r>
                       <a:endParaRPr lang="es-PE" sz="1000"/>
                     </a:p>
@@ -33101,7 +34873,7 @@
                 <a:cs typeface="Candara"/>
                 <a:sym typeface="Candara"/>
               </a:rPr>
-              <a:t>{{#F175}}</a:t>
+              <a:t>{{#F193}}</a:t>
             </a:r>
             <a:endParaRPr kumimoji="0" lang="en-US" sz="1800" b="0" i="0" u="none" strike="noStrike" kern="0" cap="none" spc="0" normalizeH="0" baseline="0" noProof="0" dirty="0">
               <a:ln>
@@ -33299,7 +35071,7 @@
                   </a:solidFill>
                   <a:latin typeface="Calibri" panose="020F0502020204030204"/>
                 </a:rPr>
-                <a:t>{{#F176}}</a:t>
+                <a:t>{{#F194}}</a:t>
               </a:r>
               <a:endParaRPr kumimoji="0" lang="es-PE" sz="1800" b="1" i="0" u="none" strike="noStrike" kern="1200" cap="none" spc="0" normalizeH="0" baseline="0" noProof="0" dirty="0">
                 <a:ln>
@@ -33379,7 +35151,7 @@
                 <a:ea typeface="+mn-ea"/>
                 <a:cs typeface="+mn-cs"/>
               </a:rPr>
-              <a:t>{{#F177}}</a:t>
+              <a:t>{{#F195}}</a:t>
             </a:r>
             <a:endParaRPr kumimoji="0" lang="es-PE" sz="1400" b="0" i="0" u="none" strike="noStrike" kern="1200" cap="none" spc="0" normalizeH="0" baseline="0" noProof="0" dirty="0">
               <a:ln>
@@ -33454,7 +35226,7 @@
                 </a:solidFill>
                 <a:latin typeface="Calibri" panose="020F0502020204030204"/>
               </a:rPr>
-              <a:t>{{#F178}}</a:t>
+              <a:t>{{#F196}}</a:t>
             </a:r>
             <a:endParaRPr kumimoji="0" lang="es-PE" sz="1800" b="1" i="0" u="none" strike="noStrike" kern="1200" cap="none" spc="0" normalizeH="0" baseline="0" noProof="0" dirty="0">
               <a:ln>
@@ -33533,7 +35305,7 @@
                 <a:ea typeface="+mn-ea"/>
                 <a:cs typeface="+mn-cs"/>
               </a:rPr>
-              <a:t>{{#F179}}</a:t>
+              <a:t>{{#F197}}</a:t>
             </a:r>
             <a:endParaRPr kumimoji="0" lang="es-PE" sz="1400" b="0" i="0" u="none" strike="noStrike" kern="1200" cap="none" spc="0" normalizeH="0" baseline="0" noProof="0" dirty="0">
               <a:ln>
@@ -33604,7 +35376,7 @@
                 </a:solidFill>
                 <a:latin typeface="Abadi ExtraLight" panose="020B0204020104020204" pitchFamily="34" charset="0"/>
               </a:rPr>
-              <a:t>{{#F161}}</a:t>
+              <a:t>{{#F179}}</a:t>
             </a:r>
             <a:endParaRPr kumimoji="0" lang="es-PE" sz="1800" b="1" i="0" u="none" strike="noStrike" kern="1200" cap="none" spc="0" normalizeH="0" baseline="0" noProof="0" dirty="0">
               <a:ln>
@@ -33675,7 +35447,7 @@
                 </a:solidFill>
                 <a:latin typeface="Abadi ExtraLight" panose="020B0204020104020204" pitchFamily="34" charset="0"/>
               </a:rPr>
-              <a:t>{{#F162}}</a:t>
+              <a:t>{{#F180}}</a:t>
             </a:r>
             <a:endParaRPr kumimoji="0" lang="es-PE" sz="1800" b="1" i="0" u="none" strike="noStrike" kern="1200" cap="none" spc="0" normalizeH="0" baseline="0" noProof="0" dirty="0">
               <a:ln>
@@ -33746,7 +35518,7 @@
                 </a:solidFill>
                 <a:latin typeface="Abadi ExtraLight" panose="020B0204020104020204" pitchFamily="34" charset="0"/>
               </a:rPr>
-              <a:t>{{#F163}}</a:t>
+              <a:t>{{#F181}}</a:t>
             </a:r>
             <a:endParaRPr kumimoji="0" lang="es-PE" sz="1800" b="1" i="0" u="none" strike="noStrike" kern="1200" cap="none" spc="0" normalizeH="0" baseline="0" noProof="0" dirty="0">
               <a:ln>
@@ -33817,7 +35589,7 @@
                 </a:solidFill>
                 <a:latin typeface="Abadi ExtraLight" panose="020B0204020104020204" pitchFamily="34" charset="0"/>
               </a:rPr>
-              <a:t>{{#F164}}</a:t>
+              <a:t>{{#F182}}</a:t>
             </a:r>
             <a:endParaRPr kumimoji="0" lang="es-PE" sz="1800" b="1" i="0" u="none" strike="noStrike" kern="1200" cap="none" spc="0" normalizeH="0" baseline="0" noProof="0" dirty="0">
               <a:ln>
@@ -33888,7 +35660,7 @@
                 </a:solidFill>
                 <a:latin typeface="Abadi ExtraLight" panose="020B0204020104020204" pitchFamily="34" charset="0"/>
               </a:rPr>
-              <a:t>{{#F165}}</a:t>
+              <a:t>{{#F183}}</a:t>
             </a:r>
             <a:endParaRPr kumimoji="0" lang="es-PE" sz="1800" b="1" i="0" u="none" strike="noStrike" kern="1200" cap="none" spc="0" normalizeH="0" baseline="0" noProof="0" dirty="0">
               <a:ln>
@@ -33959,7 +35731,7 @@
                 </a:solidFill>
                 <a:latin typeface="Abadi ExtraLight" panose="020B0204020104020204" pitchFamily="34" charset="0"/>
               </a:rPr>
-              <a:t>{{#F166}}</a:t>
+              <a:t>{{#F184}}</a:t>
             </a:r>
             <a:endParaRPr kumimoji="0" lang="es-PE" sz="1800" b="1" i="0" u="none" strike="noStrike" kern="1200" cap="none" spc="0" normalizeH="0" baseline="0" noProof="0" dirty="0">
               <a:ln>
@@ -34030,7 +35802,7 @@
                 </a:solidFill>
                 <a:latin typeface="Abadi ExtraLight" panose="020B0204020104020204" pitchFamily="34" charset="0"/>
               </a:rPr>
-              <a:t>{{#F167}}</a:t>
+              <a:t>{{#F185}}</a:t>
             </a:r>
             <a:endParaRPr kumimoji="0" lang="es-PE" sz="1800" b="1" i="0" u="none" strike="noStrike" kern="1200" cap="none" spc="0" normalizeH="0" baseline="0" noProof="0" dirty="0">
               <a:ln>
@@ -34101,7 +35873,7 @@
                 </a:solidFill>
                 <a:latin typeface="Abadi ExtraLight" panose="020B0204020104020204" pitchFamily="34" charset="0"/>
               </a:rPr>
-              <a:t>{{#F168}}</a:t>
+              <a:t>{{#F186}}</a:t>
             </a:r>
             <a:endParaRPr kumimoji="0" lang="es-PE" sz="1800" b="1" i="0" u="none" strike="noStrike" kern="1200" cap="none" spc="0" normalizeH="0" baseline="0" noProof="0" dirty="0">
               <a:ln>
@@ -34182,7 +35954,7 @@
                 <a:ea typeface="+mn-ea"/>
                 <a:cs typeface="+mn-cs"/>
               </a:rPr>
-              <a:t>{{#F169}}</a:t>
+              <a:t>{{#F187}}</a:t>
             </a:r>
           </a:p>
         </p:txBody>
@@ -34315,7 +36087,7 @@
                 </a:solidFill>
                 <a:latin typeface="Abadi ExtraLight" panose="020B0204020104020204" pitchFamily="34" charset="0"/>
               </a:rPr>
-              <a:t>{{#F180}}</a:t>
+              <a:t>{{#F198}}</a:t>
             </a:r>
             <a:endParaRPr kumimoji="0" lang="es-PE" sz="1400" b="0" i="0" u="sng" strike="noStrike" kern="1200" cap="none" spc="0" normalizeH="0" baseline="0" noProof="0" dirty="0">
               <a:ln>
@@ -34470,7 +36242,7 @@
                 <a:ea typeface="+mn-ea"/>
                 <a:cs typeface="+mn-cs"/>
               </a:rPr>
-              <a:t>{{#F181}}</a:t>
+              <a:t>{{#F199}}</a:t>
             </a:r>
             <a:endParaRPr kumimoji="0" lang="es-PE" sz="1400" b="0" i="0" u="sng" strike="noStrike" kern="1200" cap="none" spc="0" normalizeH="0" baseline="0" noProof="0" dirty="0">
               <a:ln>
@@ -34617,7 +36389,7 @@
                 </a:solidFill>
                 <a:latin typeface="Abadi ExtraLight" panose="020B0204020104020204" pitchFamily="34" charset="0"/>
               </a:rPr>
-              <a:t>{{#F182}}</a:t>
+              <a:t>{{#F200}}</a:t>
             </a:r>
             <a:endParaRPr kumimoji="0" lang="es-PE" sz="1400" b="0" i="0" u="sng" strike="noStrike" kern="1200" cap="none" spc="0" normalizeH="0" baseline="0" noProof="0" dirty="0">
               <a:ln>
@@ -34691,7 +36463,7 @@
                 </a:solidFill>
                 <a:latin typeface="Century Gothic" panose="020B0502020202020204" pitchFamily="34" charset="0"/>
               </a:rPr>
-              <a:t>{{#F183}}</a:t>
+              <a:t>{{#F201}}</a:t>
             </a:r>
             <a:endParaRPr kumimoji="0" lang="es-PE" sz="1200" b="1" i="0" u="none" strike="noStrike" kern="1200" cap="none" spc="0" normalizeH="0" baseline="0" noProof="0" dirty="0">
               <a:ln>
@@ -34775,7 +36547,7 @@
                 <a:ea typeface="+mn-ea"/>
                 <a:cs typeface="+mn-cs"/>
               </a:rPr>
-              <a:t>{{#F170}}</a:t>
+              <a:t>{{#F188}}</a:t>
             </a:r>
           </a:p>
         </p:txBody>
@@ -34835,7 +36607,7 @@
                 </a:solidFill>
                 <a:latin typeface="Century Gothic" panose="020B0502020202020204" pitchFamily="34" charset="0"/>
               </a:rPr>
-              <a:t>{{#F184}}</a:t>
+              <a:t>{{#F202}}</a:t>
             </a:r>
             <a:endParaRPr kumimoji="0" lang="es-PE" sz="1200" b="1" i="0" u="none" strike="noStrike" kern="1200" cap="none" spc="0" normalizeH="0" baseline="0" noProof="0" dirty="0">
               <a:ln>
@@ -34911,7 +36683,7 @@
                 </a:solidFill>
                 <a:latin typeface="Century Gothic" panose="020B0502020202020204" pitchFamily="34" charset="0"/>
               </a:rPr>
-              <a:t>{{#F171}}</a:t>
+              <a:t>{{#F189}}</a:t>
             </a:r>
           </a:p>
         </p:txBody>
@@ -34971,7 +36743,7 @@
                 </a:solidFill>
                 <a:latin typeface="Century Gothic" panose="020B0502020202020204" pitchFamily="34" charset="0"/>
               </a:rPr>
-              <a:t>{{#F185}}</a:t>
+              <a:t>{{#F203}}</a:t>
             </a:r>
             <a:endParaRPr kumimoji="0" lang="es-PE" sz="1200" b="1" i="0" u="none" strike="noStrike" kern="1200" cap="none" spc="0" normalizeH="0" baseline="0" noProof="0" dirty="0">
               <a:ln>
@@ -35055,7 +36827,7 @@
                 <a:ea typeface="+mn-ea"/>
                 <a:cs typeface="+mn-cs"/>
               </a:rPr>
-              <a:t>{{#F172}}</a:t>
+              <a:t>{{#F190}}</a:t>
             </a:r>
           </a:p>
         </p:txBody>
@@ -35115,7 +36887,7 @@
                 </a:solidFill>
                 <a:latin typeface="Century Gothic" panose="020B0502020202020204" pitchFamily="34" charset="0"/>
               </a:rPr>
-              <a:t>{{#F186}}</a:t>
+              <a:t>{{#F204}}</a:t>
             </a:r>
             <a:endParaRPr kumimoji="0" lang="es-PE" sz="1200" b="1" i="0" u="none" strike="noStrike" kern="1200" cap="none" spc="0" normalizeH="0" baseline="0" noProof="0" dirty="0">
               <a:ln>
@@ -35199,7 +36971,7 @@
                 <a:ea typeface="+mn-ea"/>
                 <a:cs typeface="+mn-cs"/>
               </a:rPr>
-              <a:t>{{#F173}}</a:t>
+              <a:t>{{#F191}}</a:t>
             </a:r>
           </a:p>
         </p:txBody>
@@ -35259,7 +37031,7 @@
                 </a:solidFill>
                 <a:latin typeface="Century Gothic" panose="020B0502020202020204" pitchFamily="34" charset="0"/>
               </a:rPr>
-              <a:t>{{#F187}}</a:t>
+              <a:t>{{#F205}}</a:t>
             </a:r>
             <a:endParaRPr kumimoji="0" lang="es-PE" sz="1200" b="1" i="0" u="none" strike="noStrike" kern="1200" cap="none" spc="0" normalizeH="0" baseline="0" noProof="0" dirty="0">
               <a:ln>
@@ -35343,7 +37115,7 @@
                 <a:ea typeface="+mn-ea"/>
                 <a:cs typeface="+mn-cs"/>
               </a:rPr>
-              <a:t>{{#F174}}</a:t>
+              <a:t>{{#F192}}</a:t>
             </a:r>
           </a:p>
         </p:txBody>
@@ -35403,7 +37175,7 @@
                 </a:solidFill>
                 <a:latin typeface="Century Gothic" panose="020B0502020202020204" pitchFamily="34" charset="0"/>
               </a:rPr>
-              <a:t>{{#F188}}</a:t>
+              <a:t>{{#F206}}</a:t>
             </a:r>
             <a:endParaRPr kumimoji="0" lang="es-PE" sz="1200" b="1" i="0" u="none" strike="noStrike" kern="1200" cap="none" spc="0" normalizeH="0" baseline="0" noProof="0" dirty="0">
               <a:ln>
@@ -35561,7 +37333,7 @@
                 <a:ea typeface="+mn-ea"/>
                 <a:cs typeface="+mn-cs"/>
               </a:rPr>
-              <a:t>{{#F189}}</a:t>
+              <a:t>{{#F207}}</a:t>
             </a:r>
             <a:endParaRPr kumimoji="0" lang="es-PE" sz="1100" b="1" i="0" u="sng" strike="noStrike" kern="1200" cap="none" spc="0" normalizeH="0" baseline="0" noProof="0" dirty="0">
               <a:ln>
@@ -35716,7 +37488,7 @@
                 <a:ea typeface="+mn-ea"/>
                 <a:cs typeface="+mn-cs"/>
               </a:rPr>
-              <a:t>{{#F190}}</a:t>
+              <a:t>{{#F208}}</a:t>
             </a:r>
             <a:endParaRPr kumimoji="0" lang="es-PE" sz="1100" b="1" i="0" u="sng" strike="noStrike" kern="1200" cap="none" spc="0" normalizeH="0" baseline="0" noProof="0" dirty="0">
               <a:ln>
@@ -35871,7 +37643,7 @@
                 <a:ea typeface="+mn-ea"/>
                 <a:cs typeface="+mn-cs"/>
               </a:rPr>
-              <a:t>{{#F191}}</a:t>
+              <a:t>{{#F209}}</a:t>
             </a:r>
             <a:endParaRPr kumimoji="0" lang="es-PE" sz="1100" b="1" i="0" u="sng" strike="noStrike" kern="1200" cap="none" spc="0" normalizeH="0" baseline="0" noProof="0" dirty="0">
               <a:ln>
@@ -36026,7 +37798,7 @@
                 <a:ea typeface="+mn-ea"/>
                 <a:cs typeface="+mn-cs"/>
               </a:rPr>
-              <a:t>{{#F192}}</a:t>
+              <a:t>{{#F210}}</a:t>
             </a:r>
             <a:endParaRPr kumimoji="0" lang="es-PE" sz="1100" b="1" i="0" u="sng" strike="noStrike" kern="1200" cap="none" spc="0" normalizeH="0" baseline="0" noProof="0" dirty="0">
               <a:ln>
@@ -36047,7 +37819,7 @@
       </p:sp>
       <p:sp>
         <p:nvSpPr>
-          <p:cNvPr id="1093" name="Lineas 1093">
+          <p:cNvPr id="1111" name="Lineas 1111">
             <a:extLst>
               <a:ext uri="{FF2B5EF4-FFF2-40B4-BE49-F238E27FC236}">
                 <a16:creationId xmlns:a16="http://schemas.microsoft.com/office/drawing/2014/main" id="{B63E2792-6AF6-56E3-0D5E-3C4DAA9FAED3}"/>
@@ -36095,7 +37867,7 @@
                 </a:solidFill>
                 <a:latin typeface="Abadi ExtraLight" panose="020B0204020104020204" pitchFamily="34" charset="0"/>
               </a:rPr>
-              <a:t>{{#F193}}</a:t>
+              <a:t>{{#F211}}</a:t>
             </a:r>
             <a:endParaRPr kumimoji="0" lang="es-PE" sz="1800" b="1" i="0" u="none" strike="noStrike" kern="1200" cap="none" spc="0" normalizeH="0" baseline="0" noProof="0" dirty="0">
               <a:ln>
@@ -36116,7 +37888,7 @@
       </p:sp>
       <p:sp>
         <p:nvSpPr>
-          <p:cNvPr id="1094" name="Lineas 1094">
+          <p:cNvPr id="1112" name="Lineas 1112">
             <a:extLst>
               <a:ext uri="{FF2B5EF4-FFF2-40B4-BE49-F238E27FC236}">
                 <a16:creationId xmlns:a16="http://schemas.microsoft.com/office/drawing/2014/main" id="{B63E2792-6AF6-56E3-0D5E-3C4DAA9FAED3}"/>
@@ -36164,7 +37936,7 @@
                 </a:solidFill>
                 <a:latin typeface="Abadi ExtraLight" panose="020B0204020104020204" pitchFamily="34" charset="0"/>
               </a:rPr>
-              <a:t>{{#F194}}</a:t>
+              <a:t>{{#F212}}</a:t>
             </a:r>
             <a:endParaRPr kumimoji="0" lang="es-PE" sz="1800" b="1" i="0" u="none" strike="noStrike" kern="1200" cap="none" spc="0" normalizeH="0" baseline="0" noProof="0" dirty="0">
               <a:ln>
@@ -36185,7 +37957,7 @@
       </p:sp>
       <p:sp>
         <p:nvSpPr>
-          <p:cNvPr id="1095" name="Lineas 1095">
+          <p:cNvPr id="1113" name="Lineas 1113">
             <a:extLst>
               <a:ext uri="{FF2B5EF4-FFF2-40B4-BE49-F238E27FC236}">
                 <a16:creationId xmlns:a16="http://schemas.microsoft.com/office/drawing/2014/main" id="{B63E2792-6AF6-56E3-0D5E-3C4DAA9FAED3}"/>
@@ -36233,7 +38005,7 @@
                 </a:solidFill>
                 <a:latin typeface="Abadi ExtraLight" panose="020B0204020104020204" pitchFamily="34" charset="0"/>
               </a:rPr>
-              <a:t>{{#F195}}</a:t>
+              <a:t>{{#F213}}</a:t>
             </a:r>
             <a:endParaRPr kumimoji="0" lang="es-PE" sz="1800" b="1" i="0" u="none" strike="noStrike" kern="1200" cap="none" spc="0" normalizeH="0" baseline="0" noProof="0" dirty="0">
               <a:ln>
@@ -36254,7 +38026,7 @@
       </p:sp>
       <p:sp>
         <p:nvSpPr>
-          <p:cNvPr id="1096" name="Lineas 1096">
+          <p:cNvPr id="1114" name="Lineas 1114">
             <a:extLst>
               <a:ext uri="{FF2B5EF4-FFF2-40B4-BE49-F238E27FC236}">
                 <a16:creationId xmlns:a16="http://schemas.microsoft.com/office/drawing/2014/main" id="{B63E2792-6AF6-56E3-0D5E-3C4DAA9FAED3}"/>
@@ -36302,7 +38074,7 @@
                 </a:solidFill>
                 <a:latin typeface="Abadi ExtraLight" panose="020B0204020104020204" pitchFamily="34" charset="0"/>
               </a:rPr>
-              <a:t>{{#F196}}</a:t>
+              <a:t>{{#F214}}</a:t>
             </a:r>
             <a:endParaRPr kumimoji="0" lang="es-PE" sz="1800" b="1" i="0" u="none" strike="noStrike" kern="1200" cap="none" spc="0" normalizeH="0" baseline="0" noProof="0" dirty="0">
               <a:ln>

</xml_diff>

<commit_message>
Reporte: sin «Próximas secciones», «Seleccionar Excel» y rótulos de calidades en verde oscuro negrita
</commit_message>
<xml_diff>
--- a/lib/plantilla_reporte.pptx
+++ b/lib/plantilla_reporte.pptx
@@ -10510,10 +10510,7 @@
             <a:r>
               <a:rPr lang="es-ES" sz="1200" b="1" dirty="0">
                 <a:solidFill>
-                  <a:schemeClr val="accent5">
-                    <a:lumMod val="60000"/>
-                    <a:lumOff val="40000"/>
-                  </a:schemeClr>
+                  <a:srgbClr val="1E5631"/>
                 </a:solidFill>
                 <a:latin typeface="Century Gothic" panose="020B0502020202020204" pitchFamily="34" charset="0"/>
               </a:rPr>
@@ -10654,10 +10651,7 @@
             <a:r>
               <a:rPr lang="es-ES" sz="1200" b="1" dirty="0">
                 <a:solidFill>
-                  <a:schemeClr val="accent5">
-                    <a:lumMod val="60000"/>
-                    <a:lumOff val="40000"/>
-                  </a:schemeClr>
+                  <a:srgbClr val="1E5631"/>
                 </a:solidFill>
                 <a:latin typeface="Century Gothic" panose="020B0502020202020204" pitchFamily="34" charset="0"/>
               </a:rPr>
@@ -10798,10 +10792,7 @@
             <a:r>
               <a:rPr lang="es-ES" sz="1200" b="1" dirty="0">
                 <a:solidFill>
-                  <a:schemeClr val="accent5">
-                    <a:lumMod val="60000"/>
-                    <a:lumOff val="40000"/>
-                  </a:schemeClr>
+                  <a:srgbClr val="1E5631"/>
                 </a:solidFill>
                 <a:latin typeface="Century Gothic" panose="020B0502020202020204" pitchFamily="34" charset="0"/>
               </a:rPr>
@@ -10942,10 +10933,7 @@
             <a:r>
               <a:rPr lang="es-ES" sz="1200" b="1" dirty="0">
                 <a:solidFill>
-                  <a:schemeClr val="accent5">
-                    <a:lumMod val="60000"/>
-                    <a:lumOff val="40000"/>
-                  </a:schemeClr>
+                  <a:srgbClr val="1E5631"/>
                 </a:solidFill>
                 <a:latin typeface="Century Gothic" panose="020B0502020202020204" pitchFamily="34" charset="0"/>
               </a:rPr>
@@ -11086,10 +11074,7 @@
             <a:r>
               <a:rPr lang="es-ES" sz="1200" b="1" dirty="0">
                 <a:solidFill>
-                  <a:schemeClr val="accent5">
-                    <a:lumMod val="60000"/>
-                    <a:lumOff val="40000"/>
-                  </a:schemeClr>
+                  <a:srgbClr val="1E5631"/>
                 </a:solidFill>
                 <a:latin typeface="Century Gothic" panose="020B0502020202020204" pitchFamily="34" charset="0"/>
               </a:rPr>
@@ -11230,10 +11215,7 @@
             <a:r>
               <a:rPr lang="es-ES" sz="1200" b="1" dirty="0">
                 <a:solidFill>
-                  <a:schemeClr val="accent5">
-                    <a:lumMod val="60000"/>
-                    <a:lumOff val="40000"/>
-                  </a:schemeClr>
+                  <a:srgbClr val="1E5631"/>
                 </a:solidFill>
                 <a:latin typeface="Century Gothic" panose="020B0502020202020204" pitchFamily="34" charset="0"/>
               </a:rPr>
@@ -13846,10 +13828,7 @@
             <a:r>
               <a:rPr lang="es-ES" sz="1200" b="1" dirty="0">
                 <a:solidFill>
-                  <a:schemeClr val="accent5">
-                    <a:lumMod val="60000"/>
-                    <a:lumOff val="40000"/>
-                  </a:schemeClr>
+                  <a:srgbClr val="1E5631"/>
                 </a:solidFill>
                 <a:latin typeface="Century Gothic" panose="020B0502020202020204" pitchFamily="34" charset="0"/>
               </a:rPr>
@@ -13990,10 +13969,7 @@
             <a:r>
               <a:rPr lang="es-ES" sz="1200" b="1" dirty="0">
                 <a:solidFill>
-                  <a:schemeClr val="accent5">
-                    <a:lumMod val="60000"/>
-                    <a:lumOff val="40000"/>
-                  </a:schemeClr>
+                  <a:srgbClr val="1E5631"/>
                 </a:solidFill>
                 <a:latin typeface="Century Gothic" panose="020B0502020202020204" pitchFamily="34" charset="0"/>
               </a:rPr>
@@ -14134,10 +14110,7 @@
             <a:r>
               <a:rPr lang="es-ES" sz="1200" b="1" dirty="0">
                 <a:solidFill>
-                  <a:schemeClr val="accent5">
-                    <a:lumMod val="60000"/>
-                    <a:lumOff val="40000"/>
-                  </a:schemeClr>
+                  <a:srgbClr val="1E5631"/>
                 </a:solidFill>
                 <a:latin typeface="Century Gothic" panose="020B0502020202020204" pitchFamily="34" charset="0"/>
               </a:rPr>
@@ -14278,10 +14251,7 @@
             <a:r>
               <a:rPr lang="es-ES" sz="1200" b="1" dirty="0">
                 <a:solidFill>
-                  <a:schemeClr val="accent5">
-                    <a:lumMod val="60000"/>
-                    <a:lumOff val="40000"/>
-                  </a:schemeClr>
+                  <a:srgbClr val="1E5631"/>
                 </a:solidFill>
                 <a:latin typeface="Century Gothic" panose="020B0502020202020204" pitchFamily="34" charset="0"/>
               </a:rPr>
@@ -14422,10 +14392,7 @@
             <a:r>
               <a:rPr lang="es-ES" sz="1200" b="1" dirty="0">
                 <a:solidFill>
-                  <a:schemeClr val="accent5">
-                    <a:lumMod val="60000"/>
-                    <a:lumOff val="40000"/>
-                  </a:schemeClr>
+                  <a:srgbClr val="1E5631"/>
                 </a:solidFill>
                 <a:latin typeface="Century Gothic" panose="020B0502020202020204" pitchFamily="34" charset="0"/>
               </a:rPr>
@@ -14566,10 +14533,7 @@
             <a:r>
               <a:rPr lang="es-ES" sz="1200" b="1" dirty="0">
                 <a:solidFill>
-                  <a:schemeClr val="accent5">
-                    <a:lumMod val="60000"/>
-                    <a:lumOff val="40000"/>
-                  </a:schemeClr>
+                  <a:srgbClr val="1E5631"/>
                 </a:solidFill>
                 <a:latin typeface="Century Gothic" panose="020B0502020202020204" pitchFamily="34" charset="0"/>
               </a:rPr>
@@ -36456,10 +36420,7 @@
             <a:r>
               <a:rPr lang="es-ES" sz="1200" b="1" dirty="0">
                 <a:solidFill>
-                  <a:schemeClr val="accent5">
-                    <a:lumMod val="60000"/>
-                    <a:lumOff val="40000"/>
-                  </a:schemeClr>
+                  <a:srgbClr val="1E5631"/>
                 </a:solidFill>
                 <a:latin typeface="Century Gothic" panose="020B0502020202020204" pitchFamily="34" charset="0"/>
               </a:rPr>
@@ -36600,10 +36561,7 @@
             <a:r>
               <a:rPr lang="es-ES" sz="1200" b="1" dirty="0">
                 <a:solidFill>
-                  <a:schemeClr val="accent5">
-                    <a:lumMod val="60000"/>
-                    <a:lumOff val="40000"/>
-                  </a:schemeClr>
+                  <a:srgbClr val="1E5631"/>
                 </a:solidFill>
                 <a:latin typeface="Century Gothic" panose="020B0502020202020204" pitchFamily="34" charset="0"/>
               </a:rPr>
@@ -36736,10 +36694,7 @@
             <a:r>
               <a:rPr lang="es-ES" sz="1200" b="1" dirty="0">
                 <a:solidFill>
-                  <a:schemeClr val="accent5">
-                    <a:lumMod val="60000"/>
-                    <a:lumOff val="40000"/>
-                  </a:schemeClr>
+                  <a:srgbClr val="1E5631"/>
                 </a:solidFill>
                 <a:latin typeface="Century Gothic" panose="020B0502020202020204" pitchFamily="34" charset="0"/>
               </a:rPr>
@@ -36880,10 +36835,7 @@
             <a:r>
               <a:rPr lang="es-ES" sz="1200" b="1" dirty="0">
                 <a:solidFill>
-                  <a:schemeClr val="accent5">
-                    <a:lumMod val="60000"/>
-                    <a:lumOff val="40000"/>
-                  </a:schemeClr>
+                  <a:srgbClr val="1E5631"/>
                 </a:solidFill>
                 <a:latin typeface="Century Gothic" panose="020B0502020202020204" pitchFamily="34" charset="0"/>
               </a:rPr>
@@ -37024,10 +36976,7 @@
             <a:r>
               <a:rPr lang="es-ES" sz="1200" b="1" dirty="0">
                 <a:solidFill>
-                  <a:schemeClr val="accent5">
-                    <a:lumMod val="60000"/>
-                    <a:lumOff val="40000"/>
-                  </a:schemeClr>
+                  <a:srgbClr val="1E5631"/>
                 </a:solidFill>
                 <a:latin typeface="Century Gothic" panose="020B0502020202020204" pitchFamily="34" charset="0"/>
               </a:rPr>
@@ -37168,10 +37117,7 @@
             <a:r>
               <a:rPr lang="es-ES" sz="1200" b="1" dirty="0">
                 <a:solidFill>
-                  <a:schemeClr val="accent5">
-                    <a:lumMod val="60000"/>
-                    <a:lumOff val="40000"/>
-                  </a:schemeClr>
+                  <a:srgbClr val="1E5631"/>
                 </a:solidFill>
                 <a:latin typeface="Century Gothic" panose="020B0502020202020204" pitchFamily="34" charset="0"/>
               </a:rPr>

</xml_diff>

<commit_message>
Diapositivas 2 y 4: valores en Century Gothic y P.T. observado de la semana con 1 decimal
</commit_message>
<xml_diff>
--- a/lib/plantilla_reporte.pptx
+++ b/lib/plantilla_reporte.pptx
@@ -22572,10 +22572,11 @@
                     <a:defRPr/>
                   </a:pPr>
                   <a:r>
-                    <a:rPr lang="es-MX" sz="3600" dirty="0">
+                    <a:rPr lang="es-MX" sz="3600" dirty="0" b="0">
                       <a:solidFill>
                         <a:srgbClr val="002060"/>
                       </a:solidFill>
+                      <a:latin typeface="Century Gothic"/>
                     </a:rPr>
                     <a:t>{{#F60}}</a:t>
                   </a:r>
@@ -25396,10 +25397,11 @@
                     </a:lstStyle>
                     <a:p>
                       <a:r>
-                        <a:rPr lang="es-PE" sz="3600" dirty="0">
+                        <a:rPr lang="es-PE" sz="3600" dirty="0" b="0">
                           <a:solidFill>
                             <a:srgbClr val="FF0000"/>
                           </a:solidFill>
+                          <a:latin typeface="Century Gothic"/>
                         </a:rPr>
                         <a:t>{{#F68}}</a:t>
                       </a:r>
@@ -25569,10 +25571,11 @@
                     </a:lstStyle>
                     <a:p>
                       <a:r>
-                        <a:rPr lang="es-PE" sz="3600" dirty="0">
+                        <a:rPr lang="es-PE" sz="3600" dirty="0" b="0">
                           <a:solidFill>
                             <a:srgbClr val="00B050"/>
                           </a:solidFill>
+                          <a:latin typeface="Century Gothic"/>
                         </a:rPr>
                         <a:t>{{#F70}}</a:t>
                       </a:r>
@@ -31714,10 +31717,11 @@
                   <a:defRPr/>
                 </a:pPr>
                 <a:r>
-                  <a:rPr lang="es-PE" sz="3600" dirty="0">
+                  <a:rPr lang="es-PE" sz="3600" dirty="0" b="0">
                     <a:solidFill>
                       <a:srgbClr val="FF0000"/>
                     </a:solidFill>
+                    <a:latin typeface="Century Gothic"/>
                   </a:rPr>
                   <a:t>{{#F138}}</a:t>
                 </a:r>
@@ -31782,7 +31786,9 @@
                   <a:defRPr/>
                 </a:pPr>
                 <a:r>
-                  <a:rPr lang="es-PE" sz="3200" dirty="0"/>
+                  <a:rPr lang="es-PE" sz="2800" dirty="0" b="0">
+                    <a:latin typeface="Century Gothic"/>
+                  </a:rPr>
                   <a:t>{{#F139}}</a:t>
                 </a:r>
               </a:p>

</xml_diff>

<commit_message>
Notas en gris #525252, «*Corte semana» en #4472C4, título verde e íconos ✓/! en Indicadores de Producción
</commit_message>
<xml_diff>
--- a/lib/plantilla_reporte.pptx
+++ b/lib/plantilla_reporte.pptx
@@ -9193,7 +9193,7 @@
             <a:r>
               <a:rPr kumimoji="0" lang="es-MX" sz="1300" b="0" i="0" strike="noStrike" kern="1200" cap="none" spc="0" normalizeH="0" baseline="0" noProof="0" dirty="0">
                 <a:solidFill>
-                  <a:srgbClr val="000000"/>
+                  <a:srgbClr val="525252"/>
                 </a:solidFill>
                 <a:ln>
                   <a:noFill/>
@@ -9347,7 +9347,7 @@
             <a:r>
               <a:rPr kumimoji="0" lang="es-MX" sz="1300" b="0" i="0" strike="noStrike" kern="1200" cap="none" spc="0" normalizeH="0" baseline="0" noProof="0" dirty="0">
                 <a:solidFill>
-                  <a:srgbClr val="000000"/>
+                  <a:srgbClr val="525252"/>
                 </a:solidFill>
                 <a:ln>
                   <a:noFill/>
@@ -12511,7 +12511,7 @@
             <a:r>
               <a:rPr kumimoji="0" lang="es-MX" sz="1300" b="0" i="0" strike="noStrike" kern="1200" cap="none" spc="0" normalizeH="0" baseline="0" noProof="0" dirty="0">
                 <a:solidFill>
-                  <a:srgbClr val="000000"/>
+                  <a:srgbClr val="525252"/>
                 </a:solidFill>
                 <a:ln>
                   <a:noFill/>
@@ -12665,7 +12665,7 @@
             <a:r>
               <a:rPr kumimoji="0" lang="es-MX" sz="1300" b="0" i="0" strike="noStrike" kern="1200" cap="none" spc="0" normalizeH="0" baseline="0" noProof="0" dirty="0">
                 <a:solidFill>
-                  <a:srgbClr val="000000"/>
+                  <a:srgbClr val="525252"/>
                 </a:solidFill>
                 <a:ln>
                   <a:noFill/>
@@ -17873,7 +17873,7 @@
                   <a:noFill/>
                 </a:ln>
                 <a:solidFill>
-                  <a:srgbClr val="6F3B55"/>
+                  <a:srgbClr val="12781C"/>
                 </a:solidFill>
                 <a:effectLst/>
                 <a:uLnTx/>
@@ -20824,7 +20824,7 @@
             <a:r>
               <a:rPr lang="es-MX" sz="1300" dirty="0" b="0" i="0">
                 <a:solidFill>
-                  <a:srgbClr val="000000"/>
+                  <a:srgbClr val="4472C4"/>
                 </a:solidFill>
                 <a:latin typeface="Arial"/>
               </a:rPr>
@@ -20867,7 +20867,7 @@
             <a:r>
               <a:rPr lang="es-MX" sz="1300" dirty="0" b="0" i="0">
                 <a:solidFill>
-                  <a:srgbClr val="000000"/>
+                  <a:srgbClr val="4472C4"/>
                 </a:solidFill>
                 <a:latin typeface="Arial"/>
               </a:rPr>
@@ -20910,7 +20910,7 @@
             <a:r>
               <a:rPr lang="es-MX" sz="1300" dirty="0" b="0" i="0">
                 <a:solidFill>
-                  <a:srgbClr val="000000"/>
+                  <a:srgbClr val="4472C4"/>
                 </a:solidFill>
                 <a:latin typeface="Arial"/>
               </a:rPr>
@@ -20955,7 +20955,7 @@
             <a:r>
               <a:rPr lang="es-MX" sz="1300" dirty="0" b="0" i="0">
                 <a:solidFill>
-                  <a:srgbClr val="000000"/>
+                  <a:srgbClr val="4472C4"/>
                 </a:solidFill>
                 <a:latin typeface="Arial"/>
               </a:rPr>
@@ -21000,7 +21000,7 @@
             <a:r>
               <a:rPr lang="es-MX" sz="1300" dirty="0" b="0" i="0">
                 <a:solidFill>
-                  <a:srgbClr val="000000"/>
+                  <a:srgbClr val="4472C4"/>
                 </a:solidFill>
                 <a:latin typeface="Arial"/>
               </a:rPr>
@@ -21043,7 +21043,11 @@
           <a:lstStyle/>
           <a:p>
             <a:r>
-              <a:rPr lang="es-MX" sz="1300" dirty="0"/>
+              <a:rPr lang="es-MX" sz="1300" dirty="0">
+                <a:solidFill>
+                  <a:srgbClr val="525252"/>
+                </a:solidFill>
+              </a:rPr>
               <a:t>{{#F53}}</a:t>
             </a:r>
           </a:p>
@@ -23799,7 +23803,7 @@
             <a:r>
               <a:rPr lang="es-MX" sz="1300" dirty="0" b="0" i="0">
                 <a:solidFill>
-                  <a:srgbClr val="000000"/>
+                  <a:srgbClr val="525252"/>
                 </a:solidFill>
                 <a:latin typeface="Arial"/>
               </a:rPr>
@@ -25833,7 +25837,7 @@
             <a:r>
               <a:rPr lang="es-MX" sz="1300" dirty="0" b="0" i="0">
                 <a:solidFill>
-                  <a:srgbClr val="000000"/>
+                  <a:srgbClr val="525252"/>
                 </a:solidFill>
                 <a:latin typeface="Arial"/>
               </a:rPr>
@@ -25878,7 +25882,7 @@
             <a:r>
               <a:rPr lang="es-MX" sz="1300" dirty="0" b="0" i="0">
                 <a:solidFill>
-                  <a:srgbClr val="000000"/>
+                  <a:srgbClr val="525252"/>
                 </a:solidFill>
                 <a:latin typeface="Arial"/>
               </a:rPr>
@@ -25923,7 +25927,7 @@
             <a:r>
               <a:rPr lang="es-MX" sz="1300" dirty="0" b="0" i="0">
                 <a:solidFill>
-                  <a:srgbClr val="000000"/>
+                  <a:srgbClr val="525252"/>
                 </a:solidFill>
                 <a:latin typeface="Arial"/>
               </a:rPr>
@@ -26846,7 +26850,7 @@
             <a:r>
               <a:rPr lang="es-MX" sz="1300" dirty="0" b="0" i="0">
                 <a:solidFill>
-                  <a:srgbClr val="000000"/>
+                  <a:srgbClr val="525252"/>
                 </a:solidFill>
                 <a:latin typeface="Arial"/>
               </a:rPr>
@@ -26889,7 +26893,7 @@
             <a:r>
               <a:rPr lang="es-MX" sz="1300" dirty="0" b="0" i="0">
                 <a:solidFill>
-                  <a:srgbClr val="000000"/>
+                  <a:srgbClr val="525252"/>
                 </a:solidFill>
                 <a:latin typeface="Arial"/>
               </a:rPr>
@@ -32036,7 +32040,7 @@
             <a:r>
               <a:rPr lang="es-MX" sz="1300" dirty="0" b="0" i="0">
                 <a:solidFill>
-                  <a:srgbClr val="000000"/>
+                  <a:srgbClr val="525252"/>
                 </a:solidFill>
                 <a:latin typeface="Arial"/>
               </a:rPr>
@@ -32081,7 +32085,7 @@
             <a:r>
               <a:rPr lang="es-MX" sz="1300" dirty="0" b="0" i="0">
                 <a:solidFill>
-                  <a:srgbClr val="000000"/>
+                  <a:srgbClr val="525252"/>
                 </a:solidFill>
                 <a:latin typeface="Arial"/>
               </a:rPr>
@@ -35109,7 +35113,7 @@
             <a:r>
               <a:rPr kumimoji="0" lang="es-MX" sz="1300" b="0" i="0" strike="noStrike" kern="1200" cap="none" spc="0" normalizeH="0" baseline="0" noProof="0" dirty="0">
                 <a:solidFill>
-                  <a:srgbClr val="000000"/>
+                  <a:srgbClr val="525252"/>
                 </a:solidFill>
                 <a:ln>
                   <a:noFill/>
@@ -35263,7 +35267,7 @@
             <a:r>
               <a:rPr kumimoji="0" lang="es-MX" sz="1300" b="0" i="0" strike="noStrike" kern="1200" cap="none" spc="0" normalizeH="0" baseline="0" noProof="0" dirty="0">
                 <a:solidFill>
-                  <a:srgbClr val="000000"/>
+                  <a:srgbClr val="525252"/>
                 </a:solidFill>
                 <a:ln>
                   <a:noFill/>

</xml_diff>

<commit_message>
Descarga «Reporte Espárrago dd-mm-aaaa», objetivos y diferencias en negro suave, % sin rayita, botón Presentar y archivo de ventas en su sección
</commit_message>
<xml_diff>
--- a/lib/plantilla_reporte.pptx
+++ b/lib/plantilla_reporte.pptx
@@ -19401,7 +19401,7 @@
                         <a:noFill/>
                       </a:ln>
                       <a:solidFill>
-                        <a:srgbClr val="000000"/>
+                        <a:srgbClr val="262626"/>
                       </a:solidFill>
                       <a:effectLst/>
                       <a:uLnTx/>
@@ -19464,7 +19464,7 @@
                         <a:noFill/>
                       </a:ln>
                       <a:solidFill>
-                        <a:srgbClr val="000000"/>
+                        <a:srgbClr val="262626"/>
                       </a:solidFill>
                       <a:effectLst/>
                       <a:uLnTx/>
@@ -19765,7 +19765,7 @@
                         <a:noFill/>
                       </a:ln>
                       <a:solidFill>
-                        <a:srgbClr val="000000"/>
+                        <a:srgbClr val="262626"/>
                       </a:solidFill>
                       <a:effectLst/>
                       <a:uLnTx/>
@@ -19828,7 +19828,7 @@
                         <a:noFill/>
                       </a:ln>
                       <a:solidFill>
-                        <a:srgbClr val="000000"/>
+                        <a:srgbClr val="262626"/>
                       </a:solidFill>
                       <a:effectLst/>
                       <a:uLnTx/>
@@ -20265,7 +20265,7 @@
                       <a:noFill/>
                     </a:ln>
                     <a:solidFill>
-                      <a:srgbClr val="000000"/>
+                      <a:srgbClr val="262626"/>
                     </a:solidFill>
                     <a:effectLst/>
                     <a:uLnTx/>
@@ -20328,7 +20328,7 @@
                       <a:noFill/>
                     </a:ln>
                     <a:solidFill>
-                      <a:srgbClr val="000000"/>
+                      <a:srgbClr val="262626"/>
                     </a:solidFill>
                     <a:effectLst/>
                     <a:uLnTx/>
@@ -20716,7 +20716,7 @@
                       <a:noFill/>
                     </a:ln>
                     <a:solidFill>
-                      <a:srgbClr val="000000"/>
+                      <a:srgbClr val="262626"/>
                     </a:solidFill>
                     <a:effectLst/>
                     <a:uLnTx/>
@@ -20779,7 +20779,7 @@
                       <a:noFill/>
                     </a:ln>
                     <a:solidFill>
-                      <a:srgbClr val="000000"/>
+                      <a:srgbClr val="262626"/>
                     </a:solidFill>
                     <a:effectLst/>
                     <a:uLnTx/>
@@ -21881,7 +21881,7 @@
                   <a:noFill/>
                 </a:ln>
                 <a:solidFill>
-                  <a:srgbClr val="000000"/>
+                  <a:srgbClr val="262626"/>
                 </a:solidFill>
                 <a:effectLst/>
                 <a:uLnTx/>
@@ -21944,7 +21944,7 @@
                   <a:noFill/>
                 </a:ln>
                 <a:solidFill>
-                  <a:srgbClr val="000000"/>
+                  <a:srgbClr val="262626"/>
                 </a:solidFill>
                 <a:effectLst/>
                 <a:uLnTx/>
@@ -22071,7 +22071,7 @@
                   <a:noFill/>
                 </a:ln>
                 <a:solidFill>
-                  <a:srgbClr val="000000"/>
+                  <a:srgbClr val="262626"/>
                 </a:solidFill>
                 <a:effectLst/>
                 <a:uLnTx/>
@@ -22134,7 +22134,7 @@
                   <a:noFill/>
                 </a:ln>
                 <a:solidFill>
-                  <a:srgbClr val="000000"/>
+                  <a:srgbClr val="262626"/>
                 </a:solidFill>
                 <a:effectLst/>
                 <a:uLnTx/>
@@ -25331,7 +25331,7 @@
                     <a:r>
                       <a:rPr lang="es-PE" b="1" dirty="0">
                         <a:solidFill>
-                          <a:srgbClr val="000000"/>
+                          <a:srgbClr val="262626"/>
                         </a:solidFill>
                         <a:latin typeface="Abadi ExtraLight" panose="020B0204020104020204" pitchFamily="34" charset="0"/>
                       </a:rPr>
@@ -25443,7 +25443,7 @@
                       <a:r>
                         <a:rPr lang="es-PE" b="1" dirty="0">
                           <a:solidFill>
-                            <a:srgbClr val="000000"/>
+                            <a:srgbClr val="262626"/>
                           </a:solidFill>
                           <a:latin typeface="Abadi ExtraLight" panose="020B0204020104020204" pitchFamily="34" charset="0"/>
                         </a:rPr>
@@ -25505,7 +25505,7 @@
                     <a:r>
                       <a:rPr lang="es-PE" b="1" dirty="0">
                         <a:solidFill>
-                          <a:srgbClr val="000000"/>
+                          <a:srgbClr val="262626"/>
                         </a:solidFill>
                         <a:latin typeface="Abadi ExtraLight" panose="020B0204020104020204" pitchFamily="34" charset="0"/>
                       </a:rPr>
@@ -25617,7 +25617,7 @@
                       <a:r>
                         <a:rPr lang="es-PE" b="1" dirty="0">
                           <a:solidFill>
-                            <a:srgbClr val="000000"/>
+                            <a:srgbClr val="262626"/>
                           </a:solidFill>
                           <a:latin typeface="Abadi ExtraLight" panose="020B0204020104020204" pitchFamily="34" charset="0"/>
                         </a:rPr>

</xml_diff>